<commit_message>
Add R&D roadmap and training-content service to the solution
Slide 3 now leads with "a retired expert teaching beside you": the
company records and structures expert know-how, then produces the
training material itself (audio programme, short videos, manuals),
with a hand-off roadmap (hazard pop-ups, 3D virtual factory, voice-to-
CAD) and R&D items (haptic training, robot hand-off). The commute
podcast pipeline in this repo is cited as the working prototype.
Purpose/Mission/Vision now name preserving Japan's manufacturing
quality know-how as a heritage that does not depend on individuals.

Co-Authored-By: Claude Opus 5.5 <noreply@anthropic.com>
Claude-Session: https://claude.ai/code/session_01Lvjvqoc8h4yHt4F4M6n1V9
</commit_message>
<xml_diff>
--- a/deck/セルフマネジメント課題_事業構想プレゼン.pptx
+++ b/deck/セルフマネジメント課題_事業構想プレゼン.pptx
@@ -2045,8 +2045,8 @@
             <a:r>
               <a:rPr lang="en-US" dirty="0"/>
               <a:t>【0:00 - 0:50】
-要約：人が減っても現場が迷わず回る仕組みをつくる。それが三現ワークスの存在意義（設問③）
-株式会社三現ワークスの事業構想を発表します。三現とは、現場・現物・現実のことです。工場でも施工現場でも、熟練者の勘が記録に残らないまま失われつつあります。この会社の存在意義は「現場の勘を、次の担い手へ。」です。使命は、熟練者の判断を記録して、次の人と機械に渡すこと。5年後には85の拠点でそれが当たり前になっている状態を目指します。行動指針は社名のとおり、現場に立つ、現物に触れる、現実で判断する、の三つです。ここから、なぜこの事業が必要か、何をするのか、どう稼ぐのかを順にご説明します。</a:t>
+要約：人が減っても現場が迷わず回る仕組みをつくり、日本の品質を支える現場の勘を遺産として残す（設問③）
+株式会社三現ワークスの事業構想を発表します。三現とは、現場・現物・現実のことです。メイド・イン・ジャパンの品質を支えてきたのは、現場の熟練者の勘です。ところがその勘は、記録に残らないまま、退職とともに失われつつあります。この会社の存在意義は「現場の勘を、次の担い手へ。」です。使命は、熟練者の勘を言葉にし、教材と仕組みにして次の担い手に渡すこと。5年後には85の拠点で、勘どころが教材として残り、誰でも迷わず判断できる状態を目指します。人に依存しない形で、日本の品質を遺産として残す会社です。ここから、課題、解決策、稼ぎ方の順にご説明します。</a:t>
             </a:r>
             <a:endParaRPr lang="en-US" dirty="0"/>
           </a:p>
@@ -2225,8 +2225,8 @@
             <a:r>
               <a:rPr lang="en-US" dirty="0"/>
               <a:t>【2:00 - 3:30】
-要約：熟練者の一言をタブレットで記録し、生成AIで整理して、次の人の画面に出す
-設問①、解決策です。具体的には三つの段階で動きます。一つ目は記録です。熟練者は異常に対処したら、タブレットに音声で一言だけ残します。たとえば「湿度が高いので押出温度を2℃下げた」。写真と、MESから取った設備データが自動で紐づきます。二つ目は整理です。生成AIがその一言を、条件・処置・理由に分けて文章にし、ロットや設備のデータと合わせて事例として蓄えます。三つ目は引き継ぎです。似た条件になると、若手のタブレットに過去の事例と推奨値が出ます。搬送ロボットや検査AIには、条件を直接渡します。ただ、道具を渡すだけでは現場に定着しません。そこで最初の2か月は、当社の担当者が現場に入り、熟練者に聞き取りをして判断を棚卸しし、研修まで行います。機能は、記録と検索の基盤から始め、推奨値の提示、ロット追跡、計画の試算、ロボット連携と、年に一つずつ増やしていきます。</a:t>
+要約：引退した熟練者が、隣で教えてくれる現場をつくる。データ集めで終わらせず、教材まで当社が作る
+設問①、解決策です。目指すのは、引退した熟練者が隣で教えてくれるような現場です。仕組みは三段階です。熟練者は、異常に対処したらタブレットに音声で一言残します。生成AIがそれを条件・処置・理由に分けて事例にします。そして三つ目が大事で、当社はデータを集めて終わりにしません。現場は忙しく、研修資料や教材を作る時間がありません。そこで当社が、勘どころを言葉にし、通勤中に聞ける音声番組、短い動画、研修資料まで作って届けます。音声の自動配信は、私が個人で、ニュースを要約して音声合成し毎朝配信する仕組みとしてすでに作っています。渡し方は年ごとに増やし、3年目は手順書を開くと過去の事故やヒヤリの場所が出る機能、4年目は3Dの仮想工場、5年目は音声の指示でCAD図面を描く機能です。触覚の訓練シミュレーターは研究開発として進めます。最初の2か月は、当社の担当者が現場に入って定着まで支えます。</a:t>
             </a:r>
             <a:endParaRPr lang="en-US" dirty="0"/>
           </a:p>
@@ -2316,7 +2316,7 @@
               <a:rPr lang="en-US" dirty="0"/>
               <a:t>【3:30 - 4:40】
 要約：顧客は1拠点あたり年300万円を払い、約2か月で元を取る
-次に、お金の流れです。お客様の工場1拠点が払うのは、左の帯のとおりです。毎年払うのは、アプリと基盤の利用料100万円、記録するラインの数に応じた登録料が20万円×5ラインで100万円、選んだ追加機能が50万円×2本で100万円、合わせて年300万円です。初年度だけ、当社の担当者が現場に入る導入支援200万円が加わり、500万円になります。お客様から見ると、右のグラフのとおり、対象者100名の拠点で毎月240万円分の工数が浮き、約2.1か月で500万円を上回ります。ただし月6時間の削減は、建設業の書類電子化の実績を当てはめた仮定です。当社から見ると、利用料は粗利率85%で毎年積み上がり、導入支援は粗利率40%で一度きりです。お客様が増えるほど、利用料が積み上がっていく構造です。</a:t>
+次に、お金の流れです。お客様の工場1拠点が毎年払うのは、アプリと基盤の利用料100万円、記録するラインの数に応じた登録料100万円、そして教材制作や危険表示など選んだ機能の料金100万円、合わせて年300万円です。初年度だけ、当社の担当者が現場に入る導入支援200万円が加わり、500万円になります。お客様から見ると、右のグラフのとおり、対象者100名の拠点で毎月240万円分の工数が浮き、約2.1か月で500万円を上回ります。ただし月6時間の削減は、建設業の書類電子化の実績を当てはめた仮定です。当社から見ると、利用料は粗利率85%で毎年積み上がり、導入支援は粗利率40%で一度きりです。お客様が増えるほど、利用料が積み上がっていく構造です。</a:t>
             </a:r>
             <a:endParaRPr lang="en-US" dirty="0"/>
           </a:p>
@@ -3390,8 +3390,8 @@
         </p:nvSpPr>
         <p:spPr>
           <a:xfrm>
-            <a:off x="320040" y="3154680"/>
-            <a:ext cx="2651760" cy="274320"/>
+            <a:off x="320040" y="2971800"/>
+            <a:ext cx="2514600" cy="457200"/>
           </a:xfrm>
           <a:prstGeom prst="rect">
             <a:avLst/>
@@ -3410,7 +3410,7 @@
               <a:buNone/>
             </a:pPr>
             <a:r>
-              <a:rPr lang="en-US" sz="1100" dirty="0">
+              <a:rPr lang="en-US" sz="950" dirty="0">
                 <a:solidFill>
                   <a:srgbClr val="FFFFFF"/>
                 </a:solidFill>
@@ -3418,9 +3418,9 @@
                 <a:ea typeface="Meiryo" pitchFamily="34" charset="-122"/>
                 <a:cs typeface="Meiryo" pitchFamily="34" charset="-120"/>
               </a:rPr>
-              <a:t>株式会社三現ワークス（事業構想）</a:t>
-            </a:r>
-            <a:endParaRPr lang="en-US" sz="1100" dirty="0"/>
+              <a:t>日本の品質を支える現場の勘を、人に依存しない遺産として残す</a:t>
+            </a:r>
+            <a:endParaRPr lang="en-US" sz="950" dirty="0"/>
           </a:p>
         </p:txBody>
       </p:sp>
@@ -3432,8 +3432,8 @@
         </p:nvSpPr>
         <p:spPr>
           <a:xfrm>
-            <a:off x="320040" y="3447288"/>
-            <a:ext cx="2651760" cy="256032"/>
+            <a:off x="320040" y="3520440"/>
+            <a:ext cx="2651760" cy="274320"/>
           </a:xfrm>
           <a:prstGeom prst="rect">
             <a:avLst/>
@@ -3452,7 +3452,7 @@
               <a:buNone/>
             </a:pPr>
             <a:r>
-              <a:rPr lang="en-US" sz="950" dirty="0">
+              <a:rPr lang="en-US" sz="1100" dirty="0">
                 <a:solidFill>
                   <a:srgbClr val="FFFFFF"/>
                 </a:solidFill>
@@ -3460,9 +3460,9 @@
                 <a:ea typeface="Meiryo" pitchFamily="34" charset="-122"/>
                 <a:cs typeface="Meiryo" pitchFamily="34" charset="-120"/>
               </a:rPr>
-              <a:t>三現＝現場・現物・現実</a:t>
-            </a:r>
-            <a:endParaRPr lang="en-US" sz="950" dirty="0"/>
+              <a:t>株式会社三現ワークス（事業構想）</a:t>
+            </a:r>
+            <a:endParaRPr lang="en-US" sz="1100" dirty="0"/>
           </a:p>
         </p:txBody>
       </p:sp>
@@ -3474,6 +3474,48 @@
         </p:nvSpPr>
         <p:spPr>
           <a:xfrm>
+            <a:off x="320040" y="3813048"/>
+            <a:ext cx="2651760" cy="256032"/>
+          </a:xfrm>
+          <a:prstGeom prst="rect">
+            <a:avLst/>
+          </a:prstGeom>
+          <a:noFill/>
+          <a:ln/>
+        </p:spPr>
+        <p:txBody>
+          <a:bodyPr wrap="square" lIns="0" tIns="0" rIns="0" bIns="0" rtlCol="0" anchor="t"/>
+          <a:lstStyle/>
+          <a:p>
+            <a:pPr algn="l" indent="0" marL="0">
+              <a:lnSpc>
+                <a:spcPct val="115000"/>
+              </a:lnSpc>
+              <a:buNone/>
+            </a:pPr>
+            <a:r>
+              <a:rPr lang="en-US" sz="950" dirty="0">
+                <a:solidFill>
+                  <a:srgbClr val="FFFFFF"/>
+                </a:solidFill>
+                <a:latin typeface="Meiryo" pitchFamily="34" charset="0"/>
+                <a:ea typeface="Meiryo" pitchFamily="34" charset="-122"/>
+                <a:cs typeface="Meiryo" pitchFamily="34" charset="-120"/>
+              </a:rPr>
+              <a:t>三現＝現場・現物・現実</a:t>
+            </a:r>
+            <a:endParaRPr lang="en-US" sz="950" dirty="0"/>
+          </a:p>
+        </p:txBody>
+      </p:sp>
+      <p:sp>
+        <p:nvSpPr>
+          <p:cNvPr id="10" name="Text 6"/>
+          <p:cNvSpPr txBox="1"/>
+          <p:nvPr/>
+        </p:nvSpPr>
+        <p:spPr>
+          <a:xfrm>
             <a:off x="3429000" y="457200"/>
             <a:ext cx="5074920" cy="256032"/>
           </a:xfrm>
@@ -3510,7 +3552,7 @@
       </p:sp>
       <p:sp>
         <p:nvSpPr>
-          <p:cNvPr id="10" name="Text 6"/>
+          <p:cNvPr id="11" name="Text 7"/>
           <p:cNvSpPr txBox="1"/>
           <p:nvPr/>
         </p:nvSpPr>
@@ -3572,7 +3614,7 @@
       </p:sp>
       <p:sp>
         <p:nvSpPr>
-          <p:cNvPr id="11" name="Text 7"/>
+          <p:cNvPr id="12" name="Text 8"/>
           <p:cNvSpPr txBox="1"/>
           <p:nvPr/>
         </p:nvSpPr>
@@ -3614,7 +3656,7 @@
       </p:sp>
       <p:sp>
         <p:nvSpPr>
-          <p:cNvPr id="12" name="Shape 8"/>
+          <p:cNvPr id="13" name="Shape 9"/>
           <p:cNvSpPr/>
           <p:nvPr/>
         </p:nvSpPr>
@@ -3637,7 +3679,7 @@
       </p:sp>
       <p:sp>
         <p:nvSpPr>
-          <p:cNvPr id="13" name="Text 9"/>
+          <p:cNvPr id="14" name="Text 10"/>
           <p:cNvSpPr txBox="1"/>
           <p:nvPr/>
         </p:nvSpPr>
@@ -3699,7 +3741,7 @@
       </p:sp>
       <p:sp>
         <p:nvSpPr>
-          <p:cNvPr id="14" name="Text 10"/>
+          <p:cNvPr id="15" name="Text 11"/>
           <p:cNvSpPr txBox="1"/>
           <p:nvPr/>
         </p:nvSpPr>
@@ -3733,7 +3775,7 @@
                 <a:ea typeface="Meiryo" pitchFamily="34" charset="-122"/>
                 <a:cs typeface="Meiryo" pitchFamily="34" charset="-120"/>
               </a:rPr>
-              <a:t>熟練者の判断を記録し、次の担い手と機械に渡す</a:t>
+              <a:t>熟練者の勘を言語化し、教材と仕組みで次の人へ渡す</a:t>
             </a:r>
             <a:endParaRPr lang="en-US" sz="1150" dirty="0"/>
           </a:p>
@@ -3741,7 +3783,7 @@
       </p:sp>
       <p:sp>
         <p:nvSpPr>
-          <p:cNvPr id="15" name="Shape 11"/>
+          <p:cNvPr id="16" name="Shape 12"/>
           <p:cNvSpPr/>
           <p:nvPr/>
         </p:nvSpPr>
@@ -3764,7 +3806,7 @@
       </p:sp>
       <p:sp>
         <p:nvSpPr>
-          <p:cNvPr id="16" name="Text 12"/>
+          <p:cNvPr id="17" name="Text 13"/>
           <p:cNvSpPr txBox="1"/>
           <p:nvPr/>
         </p:nvSpPr>
@@ -3826,7 +3868,7 @@
       </p:sp>
       <p:sp>
         <p:nvSpPr>
-          <p:cNvPr id="17" name="Text 13"/>
+          <p:cNvPr id="18" name="Text 14"/>
           <p:cNvSpPr txBox="1"/>
           <p:nvPr/>
         </p:nvSpPr>
@@ -3860,7 +3902,7 @@
                 <a:ea typeface="Meiryo" pitchFamily="34" charset="-122"/>
                 <a:cs typeface="Meiryo" pitchFamily="34" charset="-120"/>
               </a:rPr>
-              <a:t>85拠点で、熟練者がいなくても迷わず判断できている</a:t>
+              <a:t>85拠点で、勘どころが教材として残っている</a:t>
             </a:r>
             <a:endParaRPr lang="en-US" sz="1150" dirty="0"/>
           </a:p>
@@ -3868,7 +3910,7 @@
       </p:sp>
       <p:sp>
         <p:nvSpPr>
-          <p:cNvPr id="18" name="Shape 14"/>
+          <p:cNvPr id="19" name="Shape 15"/>
           <p:cNvSpPr/>
           <p:nvPr/>
         </p:nvSpPr>
@@ -3891,7 +3933,7 @@
       </p:sp>
       <p:sp>
         <p:nvSpPr>
-          <p:cNvPr id="19" name="Text 15"/>
+          <p:cNvPr id="20" name="Text 16"/>
           <p:cNvSpPr txBox="1"/>
           <p:nvPr/>
         </p:nvSpPr>
@@ -3953,7 +3995,7 @@
       </p:sp>
       <p:sp>
         <p:nvSpPr>
-          <p:cNvPr id="20" name="Text 16"/>
+          <p:cNvPr id="21" name="Text 17"/>
           <p:cNvSpPr txBox="1"/>
           <p:nvPr/>
         </p:nvSpPr>
@@ -3995,7 +4037,7 @@
       </p:sp>
       <p:sp>
         <p:nvSpPr>
-          <p:cNvPr id="21" name="Shape 17"/>
+          <p:cNvPr id="22" name="Shape 18"/>
           <p:cNvSpPr/>
           <p:nvPr/>
         </p:nvSpPr>
@@ -4018,7 +4060,7 @@
       </p:sp>
       <p:sp>
         <p:nvSpPr>
-          <p:cNvPr id="22" name="Text 18"/>
+          <p:cNvPr id="23" name="Text 19"/>
           <p:cNvSpPr txBox="1"/>
           <p:nvPr/>
         </p:nvSpPr>
@@ -4060,7 +4102,7 @@
       </p:sp>
       <p:sp>
         <p:nvSpPr>
-          <p:cNvPr id="23" name="Text 19"/>
+          <p:cNvPr id="24" name="Text 20"/>
           <p:cNvSpPr txBox="1"/>
           <p:nvPr/>
         </p:nvSpPr>
@@ -5250,7 +5292,7 @@
                 <a:ea typeface="Meiryo" pitchFamily="34" charset="-122"/>
                 <a:cs typeface="Meiryo" pitchFamily="34" charset="-120"/>
               </a:rPr>
-              <a:t>設問①　解決策 ─ 熟練者の一言を記録し、次の人の画面に出す</a:t>
+              <a:t>設問①　解決策 ─ 引退した熟練者が、隣で教えてくれる現場</a:t>
             </a:r>
             <a:endParaRPr lang="en-US" sz="2000" dirty="0"/>
           </a:p>
@@ -5292,7 +5334,7 @@
                 <a:ea typeface="Meiryo" pitchFamily="34" charset="-122"/>
                 <a:cs typeface="Meiryo" pitchFamily="34" charset="-120"/>
               </a:rPr>
-              <a:t>道具はタブレットアプリと生成AI。道具だけでは定着しないため、最初の2か月は当社が現場に入る</a:t>
+              <a:t>データを集めて終わらせない。勘どころを言語化し、研修資料・音声番組・動画まで当社が作って届ける</a:t>
             </a:r>
             <a:endParaRPr lang="en-US" sz="1200" dirty="0"/>
           </a:p>
@@ -5306,8 +5348,8 @@
         </p:nvSpPr>
         <p:spPr>
           <a:xfrm>
-            <a:off x="365760" y="1051560"/>
-            <a:ext cx="2578608" cy="1828800"/>
+            <a:off x="365760" y="1024128"/>
+            <a:ext cx="2578608" cy="1371600"/>
           </a:xfrm>
           <a:prstGeom prst="rect">
             <a:avLst/>
@@ -5331,8 +5373,8 @@
         </p:nvSpPr>
         <p:spPr>
           <a:xfrm>
-            <a:off x="365760" y="1051560"/>
-            <a:ext cx="2578608" cy="310896"/>
+            <a:off x="365760" y="1024128"/>
+            <a:ext cx="2578608" cy="274320"/>
           </a:xfrm>
           <a:prstGeom prst="rect">
             <a:avLst/>
@@ -5351,8 +5393,8 @@
         </p:nvSpPr>
         <p:spPr>
           <a:xfrm>
-            <a:off x="475488" y="1051560"/>
-            <a:ext cx="2359152" cy="310896"/>
+            <a:off x="475488" y="1024128"/>
+            <a:ext cx="2359152" cy="274320"/>
           </a:xfrm>
           <a:prstGeom prst="rect">
             <a:avLst/>
@@ -5371,7 +5413,7 @@
               <a:buNone/>
             </a:pPr>
             <a:r>
-              <a:rPr lang="en-US" sz="1150" b="1" dirty="0">
+              <a:rPr lang="en-US" sz="1100" b="1" dirty="0">
                 <a:solidFill>
                   <a:srgbClr val="FFFFFF"/>
                 </a:solidFill>
@@ -5398,7 +5440,7 @@
               </a:rPr>
               <a:t>　熟練者</a:t>
             </a:r>
-            <a:endParaRPr lang="en-US" sz="1150" dirty="0"/>
+            <a:endParaRPr lang="en-US" sz="1100" dirty="0"/>
           </a:p>
         </p:txBody>
       </p:sp>
@@ -5410,8 +5452,8 @@
         </p:nvSpPr>
         <p:spPr>
           <a:xfrm>
-            <a:off x="475488" y="1435608"/>
-            <a:ext cx="2359152" cy="804672"/>
+            <a:off x="475488" y="1353312"/>
+            <a:ext cx="2359152" cy="603504"/>
           </a:xfrm>
           <a:prstGeom prst="rect">
             <a:avLst/>
@@ -5430,7 +5472,7 @@
               <a:buNone/>
             </a:pPr>
             <a:r>
-              <a:rPr lang="en-US" sz="1000" dirty="0">
+              <a:rPr lang="en-US" sz="950" dirty="0">
                 <a:solidFill>
                   <a:srgbClr val="1A1A1A"/>
                 </a:solidFill>
@@ -5438,54 +5480,70 @@
                 <a:ea typeface="Meiryo" pitchFamily="34" charset="-122"/>
                 <a:cs typeface="Meiryo" pitchFamily="34" charset="-120"/>
               </a:rPr>
-              <a:t>異常に対処したら、タブレットに音声で一言残す。</a:t>
-            </a:r>
-            <a:endParaRPr lang="en-US" sz="1000" dirty="0"/>
-          </a:p>
-          <a:p>
-            <a:pPr algn="l" indent="0" marL="0">
-              <a:lnSpc>
-                <a:spcPct val="115000"/>
-              </a:lnSpc>
-              <a:buNone/>
-            </a:pPr>
-            <a:r>
-              <a:rPr lang="en-US" sz="1000" dirty="0">
-                <a:solidFill>
-                  <a:srgbClr val="1A1A1A"/>
-                </a:solidFill>
-                <a:latin typeface="Meiryo" pitchFamily="34" charset="0"/>
-                <a:ea typeface="Meiryo" pitchFamily="34" charset="-122"/>
-                <a:cs typeface="Meiryo" pitchFamily="34" charset="-120"/>
-              </a:rPr>
-              <a:t>例「湿度が高いので温度を2℃下げた」</a:t>
-            </a:r>
-            <a:endParaRPr lang="en-US" sz="1000" dirty="0"/>
-          </a:p>
-        </p:txBody>
-      </p:sp>
-      <p:sp>
-        <p:nvSpPr>
-          <p:cNvPr id="9" name="Shape 6"/>
-          <p:cNvSpPr/>
-          <p:nvPr/>
-        </p:nvSpPr>
-        <p:spPr>
-          <a:xfrm>
-            <a:off x="475488" y="2295144"/>
-            <a:ext cx="2359152" cy="0"/>
-          </a:xfrm>
-          <a:prstGeom prst="line">
-            <a:avLst/>
-          </a:prstGeom>
-          <a:noFill/>
-          <a:ln w="9525">
-            <a:solidFill>
-              <a:srgbClr val="BFBFBF"/>
-            </a:solidFill>
-            <a:prstDash val="solid"/>
-          </a:ln>
-        </p:spPr>
+              <a:t>異常に対処したら、タブレットに音声で一言残す。例「湿度が高いので温度を2℃下げた」</a:t>
+            </a:r>
+            <a:endParaRPr lang="en-US" sz="950" dirty="0"/>
+          </a:p>
+        </p:txBody>
+      </p:sp>
+      <p:sp>
+        <p:nvSpPr>
+          <p:cNvPr id="9" name="Text 6"/>
+          <p:cNvSpPr txBox="1"/>
+          <p:nvPr/>
+        </p:nvSpPr>
+        <p:spPr>
+          <a:xfrm>
+            <a:off x="475488" y="2029968"/>
+            <a:ext cx="2359152" cy="310896"/>
+          </a:xfrm>
+          <a:prstGeom prst="rect">
+            <a:avLst/>
+          </a:prstGeom>
+          <a:noFill/>
+          <a:ln/>
+        </p:spPr>
+        <p:txBody>
+          <a:bodyPr wrap="square" lIns="0" tIns="0" rIns="0" bIns="0" rtlCol="0" anchor="t"/>
+          <a:lstStyle/>
+          <a:p>
+            <a:pPr algn="l" indent="0" marL="0">
+              <a:lnSpc>
+                <a:spcPct val="115000"/>
+              </a:lnSpc>
+              <a:buNone/>
+            </a:pPr>
+            <a:r>
+              <a:rPr lang="en-US" sz="850" b="1" dirty="0">
+                <a:solidFill>
+                  <a:srgbClr val="4D4D4D"/>
+                </a:solidFill>
+                <a:latin typeface="Meiryo" pitchFamily="34" charset="0"/>
+                <a:ea typeface="Meiryo" pitchFamily="34" charset="-122"/>
+                <a:cs typeface="Meiryo" pitchFamily="34" charset="-120"/>
+              </a:rPr>
+              <a:t>道具：</a:t>
+            </a:r>
+            <a:pPr algn="l" indent="0" marL="0">
+              <a:lnSpc>
+                <a:spcPct val="115000"/>
+              </a:lnSpc>
+              <a:buNone/>
+            </a:pPr>
+            <a:r>
+              <a:rPr lang="en-US" sz="850" dirty="0">
+                <a:solidFill>
+                  <a:srgbClr val="4D4D4D"/>
+                </a:solidFill>
+                <a:latin typeface="Meiryo" pitchFamily="34" charset="0"/>
+                <a:ea typeface="Meiryo" pitchFamily="34" charset="-122"/>
+                <a:cs typeface="Meiryo" pitchFamily="34" charset="-120"/>
+              </a:rPr>
+              <a:t>記録アプリ（音声・写真）＋MES連携</a:t>
+            </a:r>
+            <a:endParaRPr lang="en-US" sz="850" dirty="0"/>
+          </a:p>
+        </p:txBody>
       </p:sp>
       <p:sp>
         <p:nvSpPr>
@@ -5495,27 +5553,27 @@
         </p:nvSpPr>
         <p:spPr>
           <a:xfrm>
-            <a:off x="475488" y="2350008"/>
-            <a:ext cx="2359152" cy="475488"/>
-          </a:xfrm>
-          <a:prstGeom prst="rect">
-            <a:avLst/>
-          </a:prstGeom>
-          <a:noFill/>
-          <a:ln/>
-        </p:spPr>
-        <p:txBody>
-          <a:bodyPr wrap="square" lIns="0" tIns="0" rIns="0" bIns="0" rtlCol="0" anchor="t"/>
-          <a:lstStyle/>
-          <a:p>
-            <a:pPr algn="l" indent="0" marL="0">
-              <a:lnSpc>
-                <a:spcPct val="115000"/>
-              </a:lnSpc>
-              <a:buNone/>
-            </a:pPr>
-            <a:r>
-              <a:rPr lang="en-US" sz="900" b="1" dirty="0">
+            <a:off x="2944368" y="1545336"/>
+            <a:ext cx="338328" cy="329184"/>
+          </a:xfrm>
+          <a:prstGeom prst="rect">
+            <a:avLst/>
+          </a:prstGeom>
+          <a:noFill/>
+          <a:ln/>
+        </p:spPr>
+        <p:txBody>
+          <a:bodyPr wrap="square" lIns="0" tIns="0" rIns="0" bIns="0" rtlCol="0" anchor="ctr"/>
+          <a:lstStyle/>
+          <a:p>
+            <a:pPr algn="ctr" indent="0" marL="0">
+              <a:lnSpc>
+                <a:spcPct val="115000"/>
+              </a:lnSpc>
+              <a:buNone/>
+            </a:pPr>
+            <a:r>
+              <a:rPr lang="en-US" sz="1400" dirty="0">
                 <a:solidFill>
                   <a:srgbClr val="1A1A1A"/>
                 </a:solidFill>
@@ -5523,65 +5581,6 @@
                 <a:ea typeface="Meiryo" pitchFamily="34" charset="-122"/>
                 <a:cs typeface="Meiryo" pitchFamily="34" charset="-120"/>
               </a:rPr>
-              <a:t>道具：</a:t>
-            </a:r>
-            <a:pPr algn="l" indent="0" marL="0">
-              <a:lnSpc>
-                <a:spcPct val="115000"/>
-              </a:lnSpc>
-              <a:buNone/>
-            </a:pPr>
-            <a:r>
-              <a:rPr lang="en-US" sz="900" dirty="0">
-                <a:solidFill>
-                  <a:srgbClr val="1A1A1A"/>
-                </a:solidFill>
-                <a:latin typeface="Meiryo" pitchFamily="34" charset="0"/>
-                <a:ea typeface="Meiryo" pitchFamily="34" charset="-122"/>
-                <a:cs typeface="Meiryo" pitchFamily="34" charset="-120"/>
-              </a:rPr>
-              <a:t>現場記録アプリ（音声・写真）＋MESから設備データを自動取得</a:t>
-            </a:r>
-            <a:endParaRPr lang="en-US" sz="900" dirty="0"/>
-          </a:p>
-        </p:txBody>
-      </p:sp>
-      <p:sp>
-        <p:nvSpPr>
-          <p:cNvPr id="11" name="Text 8"/>
-          <p:cNvSpPr txBox="1"/>
-          <p:nvPr/>
-        </p:nvSpPr>
-        <p:spPr>
-          <a:xfrm>
-            <a:off x="2944368" y="1801368"/>
-            <a:ext cx="338328" cy="329184"/>
-          </a:xfrm>
-          <a:prstGeom prst="rect">
-            <a:avLst/>
-          </a:prstGeom>
-          <a:noFill/>
-          <a:ln/>
-        </p:spPr>
-        <p:txBody>
-          <a:bodyPr wrap="square" lIns="0" tIns="0" rIns="0" bIns="0" rtlCol="0" anchor="ctr"/>
-          <a:lstStyle/>
-          <a:p>
-            <a:pPr algn="ctr" indent="0" marL="0">
-              <a:lnSpc>
-                <a:spcPct val="115000"/>
-              </a:lnSpc>
-              <a:buNone/>
-            </a:pPr>
-            <a:r>
-              <a:rPr lang="en-US" sz="1400" dirty="0">
-                <a:solidFill>
-                  <a:srgbClr val="1A1A1A"/>
-                </a:solidFill>
-                <a:latin typeface="Meiryo" pitchFamily="34" charset="0"/>
-                <a:ea typeface="Meiryo" pitchFamily="34" charset="-122"/>
-                <a:cs typeface="Meiryo" pitchFamily="34" charset="-120"/>
-              </a:rPr>
               <a:t>▶</a:t>
             </a:r>
             <a:endParaRPr lang="en-US" sz="1400" dirty="0"/>
@@ -5590,14 +5589,14 @@
       </p:sp>
       <p:sp>
         <p:nvSpPr>
-          <p:cNvPr id="12" name="step-2"/>
+          <p:cNvPr id="11" name="step-2"/>
           <p:cNvSpPr/>
           <p:nvPr/>
         </p:nvSpPr>
         <p:spPr>
           <a:xfrm>
-            <a:off x="3282696" y="1051560"/>
-            <a:ext cx="2578608" cy="1828800"/>
+            <a:off x="3282696" y="1024128"/>
+            <a:ext cx="2578608" cy="1371600"/>
           </a:xfrm>
           <a:prstGeom prst="rect">
             <a:avLst/>
@@ -5615,14 +5614,14 @@
       </p:sp>
       <p:sp>
         <p:nvSpPr>
-          <p:cNvPr id="13" name="Shape 10"/>
+          <p:cNvPr id="12" name="Shape 9"/>
           <p:cNvSpPr/>
           <p:nvPr/>
         </p:nvSpPr>
         <p:spPr>
           <a:xfrm>
-            <a:off x="3282696" y="1051560"/>
-            <a:ext cx="2578608" cy="310896"/>
+            <a:off x="3282696" y="1024128"/>
+            <a:ext cx="2578608" cy="274320"/>
           </a:xfrm>
           <a:prstGeom prst="rect">
             <a:avLst/>
@@ -5635,60 +5634,102 @@
       </p:sp>
       <p:sp>
         <p:nvSpPr>
+          <p:cNvPr id="13" name="Text 10"/>
+          <p:cNvSpPr txBox="1"/>
+          <p:nvPr/>
+        </p:nvSpPr>
+        <p:spPr>
+          <a:xfrm>
+            <a:off x="3392424" y="1024128"/>
+            <a:ext cx="2359152" cy="274320"/>
+          </a:xfrm>
+          <a:prstGeom prst="rect">
+            <a:avLst/>
+          </a:prstGeom>
+          <a:noFill/>
+          <a:ln/>
+        </p:spPr>
+        <p:txBody>
+          <a:bodyPr wrap="square" lIns="0" tIns="0" rIns="0" bIns="0" rtlCol="0" anchor="ctr"/>
+          <a:lstStyle/>
+          <a:p>
+            <a:pPr algn="l" indent="0" marL="0">
+              <a:lnSpc>
+                <a:spcPct val="115000"/>
+              </a:lnSpc>
+              <a:buNone/>
+            </a:pPr>
+            <a:r>
+              <a:rPr lang="en-US" sz="1100" b="1" dirty="0">
+                <a:solidFill>
+                  <a:srgbClr val="FFFFFF"/>
+                </a:solidFill>
+                <a:latin typeface="Meiryo" pitchFamily="34" charset="0"/>
+                <a:ea typeface="Meiryo" pitchFamily="34" charset="-122"/>
+                <a:cs typeface="Meiryo" pitchFamily="34" charset="-120"/>
+              </a:rPr>
+              <a:t>② 整理する</a:t>
+            </a:r>
+            <a:pPr algn="l" indent="0" marL="0">
+              <a:lnSpc>
+                <a:spcPct val="115000"/>
+              </a:lnSpc>
+              <a:buNone/>
+            </a:pPr>
+            <a:r>
+              <a:rPr lang="en-US" sz="900" dirty="0">
+                <a:solidFill>
+                  <a:srgbClr val="FFFFFF"/>
+                </a:solidFill>
+                <a:latin typeface="Meiryo" pitchFamily="34" charset="0"/>
+                <a:ea typeface="Meiryo" pitchFamily="34" charset="-122"/>
+                <a:cs typeface="Meiryo" pitchFamily="34" charset="-120"/>
+              </a:rPr>
+              <a:t>　生成AI</a:t>
+            </a:r>
+            <a:endParaRPr lang="en-US" sz="1100" dirty="0"/>
+          </a:p>
+        </p:txBody>
+      </p:sp>
+      <p:sp>
+        <p:nvSpPr>
           <p:cNvPr id="14" name="Text 11"/>
           <p:cNvSpPr txBox="1"/>
           <p:nvPr/>
         </p:nvSpPr>
         <p:spPr>
           <a:xfrm>
-            <a:off x="3392424" y="1051560"/>
-            <a:ext cx="2359152" cy="310896"/>
-          </a:xfrm>
-          <a:prstGeom prst="rect">
-            <a:avLst/>
-          </a:prstGeom>
-          <a:noFill/>
-          <a:ln/>
-        </p:spPr>
-        <p:txBody>
-          <a:bodyPr wrap="square" lIns="0" tIns="0" rIns="0" bIns="0" rtlCol="0" anchor="ctr"/>
-          <a:lstStyle/>
-          <a:p>
-            <a:pPr algn="l" indent="0" marL="0">
-              <a:lnSpc>
-                <a:spcPct val="115000"/>
-              </a:lnSpc>
-              <a:buNone/>
-            </a:pPr>
-            <a:r>
-              <a:rPr lang="en-US" sz="1150" b="1" dirty="0">
-                <a:solidFill>
-                  <a:srgbClr val="FFFFFF"/>
-                </a:solidFill>
-                <a:latin typeface="Meiryo" pitchFamily="34" charset="0"/>
-                <a:ea typeface="Meiryo" pitchFamily="34" charset="-122"/>
-                <a:cs typeface="Meiryo" pitchFamily="34" charset="-120"/>
-              </a:rPr>
-              <a:t>② 整理する</a:t>
-            </a:r>
-            <a:pPr algn="l" indent="0" marL="0">
-              <a:lnSpc>
-                <a:spcPct val="115000"/>
-              </a:lnSpc>
-              <a:buNone/>
-            </a:pPr>
-            <a:r>
-              <a:rPr lang="en-US" sz="900" dirty="0">
-                <a:solidFill>
-                  <a:srgbClr val="FFFFFF"/>
-                </a:solidFill>
-                <a:latin typeface="Meiryo" pitchFamily="34" charset="0"/>
-                <a:ea typeface="Meiryo" pitchFamily="34" charset="-122"/>
-                <a:cs typeface="Meiryo" pitchFamily="34" charset="-120"/>
-              </a:rPr>
-              <a:t>　生成AI</a:t>
-            </a:r>
-            <a:endParaRPr lang="en-US" sz="1150" dirty="0"/>
+            <a:off x="3392424" y="1353312"/>
+            <a:ext cx="2359152" cy="603504"/>
+          </a:xfrm>
+          <a:prstGeom prst="rect">
+            <a:avLst/>
+          </a:prstGeom>
+          <a:noFill/>
+          <a:ln/>
+        </p:spPr>
+        <p:txBody>
+          <a:bodyPr wrap="square" lIns="0" tIns="0" rIns="0" bIns="0" rtlCol="0" anchor="t"/>
+          <a:lstStyle/>
+          <a:p>
+            <a:pPr algn="l" indent="0" marL="0">
+              <a:lnSpc>
+                <a:spcPct val="115000"/>
+              </a:lnSpc>
+              <a:buNone/>
+            </a:pPr>
+            <a:r>
+              <a:rPr lang="en-US" sz="950" dirty="0">
+                <a:solidFill>
+                  <a:srgbClr val="1A1A1A"/>
+                </a:solidFill>
+                <a:latin typeface="Meiryo" pitchFamily="34" charset="0"/>
+                <a:ea typeface="Meiryo" pitchFamily="34" charset="-122"/>
+                <a:cs typeface="Meiryo" pitchFamily="34" charset="-120"/>
+              </a:rPr>
+              <a:t>一言を「条件・処置・理由」に分けて文章化し、ロット・設備データと紐づけて事例にする</a:t>
+            </a:r>
+            <a:endParaRPr lang="en-US" sz="950" dirty="0"/>
           </a:p>
         </p:txBody>
       </p:sp>
@@ -5700,8 +5741,8 @@
         </p:nvSpPr>
         <p:spPr>
           <a:xfrm>
-            <a:off x="3392424" y="1435608"/>
-            <a:ext cx="2359152" cy="804672"/>
+            <a:off x="3392424" y="2029968"/>
+            <a:ext cx="2359152" cy="310896"/>
           </a:xfrm>
           <a:prstGeom prst="rect">
             <a:avLst/>
@@ -5720,7 +5761,66 @@
               <a:buNone/>
             </a:pPr>
             <a:r>
-              <a:rPr lang="en-US" sz="1000" dirty="0">
+              <a:rPr lang="en-US" sz="850" b="1" dirty="0">
+                <a:solidFill>
+                  <a:srgbClr val="4D4D4D"/>
+                </a:solidFill>
+                <a:latin typeface="Meiryo" pitchFamily="34" charset="0"/>
+                <a:ea typeface="Meiryo" pitchFamily="34" charset="-122"/>
+                <a:cs typeface="Meiryo" pitchFamily="34" charset="-120"/>
+              </a:rPr>
+              <a:t>道具：</a:t>
+            </a:r>
+            <a:pPr algn="l" indent="0" marL="0">
+              <a:lnSpc>
+                <a:spcPct val="115000"/>
+              </a:lnSpc>
+              <a:buNone/>
+            </a:pPr>
+            <a:r>
+              <a:rPr lang="en-US" sz="850" dirty="0">
+                <a:solidFill>
+                  <a:srgbClr val="4D4D4D"/>
+                </a:solidFill>
+                <a:latin typeface="Meiryo" pitchFamily="34" charset="0"/>
+                <a:ea typeface="Meiryo" pitchFamily="34" charset="-122"/>
+                <a:cs typeface="Meiryo" pitchFamily="34" charset="-120"/>
+              </a:rPr>
+              <a:t>生成AI＋現場データ基盤（クラウド）</a:t>
+            </a:r>
+            <a:endParaRPr lang="en-US" sz="850" dirty="0"/>
+          </a:p>
+        </p:txBody>
+      </p:sp>
+      <p:sp>
+        <p:nvSpPr>
+          <p:cNvPr id="16" name="Text 13"/>
+          <p:cNvSpPr txBox="1"/>
+          <p:nvPr/>
+        </p:nvSpPr>
+        <p:spPr>
+          <a:xfrm>
+            <a:off x="5861304" y="1545336"/>
+            <a:ext cx="338328" cy="329184"/>
+          </a:xfrm>
+          <a:prstGeom prst="rect">
+            <a:avLst/>
+          </a:prstGeom>
+          <a:noFill/>
+          <a:ln/>
+        </p:spPr>
+        <p:txBody>
+          <a:bodyPr wrap="square" lIns="0" tIns="0" rIns="0" bIns="0" rtlCol="0" anchor="ctr"/>
+          <a:lstStyle/>
+          <a:p>
+            <a:pPr algn="ctr" indent="0" marL="0">
+              <a:lnSpc>
+                <a:spcPct val="115000"/>
+              </a:lnSpc>
+              <a:buNone/>
+            </a:pPr>
+            <a:r>
+              <a:rPr lang="en-US" sz="1400" dirty="0">
                 <a:solidFill>
                   <a:srgbClr val="1A1A1A"/>
                 </a:solidFill>
@@ -5728,146 +5828,22 @@
                 <a:ea typeface="Meiryo" pitchFamily="34" charset="-122"/>
                 <a:cs typeface="Meiryo" pitchFamily="34" charset="-120"/>
               </a:rPr>
-              <a:t>一言を「条件・処置・理由」に分けて文章化し、ロット・設備データと紐づけて事例として蓄積</a:t>
-            </a:r>
-            <a:endParaRPr lang="en-US" sz="1000" dirty="0"/>
-          </a:p>
-        </p:txBody>
-      </p:sp>
-      <p:sp>
-        <p:nvSpPr>
-          <p:cNvPr id="16" name="Shape 13"/>
+              <a:t>▶</a:t>
+            </a:r>
+            <a:endParaRPr lang="en-US" sz="1400" dirty="0"/>
+          </a:p>
+        </p:txBody>
+      </p:sp>
+      <p:sp>
+        <p:nvSpPr>
+          <p:cNvPr id="17" name="step-3"/>
           <p:cNvSpPr/>
           <p:nvPr/>
         </p:nvSpPr>
         <p:spPr>
           <a:xfrm>
-            <a:off x="3392424" y="2295144"/>
-            <a:ext cx="2359152" cy="0"/>
-          </a:xfrm>
-          <a:prstGeom prst="line">
-            <a:avLst/>
-          </a:prstGeom>
-          <a:noFill/>
-          <a:ln w="9525">
-            <a:solidFill>
-              <a:srgbClr val="BFBFBF"/>
-            </a:solidFill>
-            <a:prstDash val="solid"/>
-          </a:ln>
-        </p:spPr>
-      </p:sp>
-      <p:sp>
-        <p:nvSpPr>
-          <p:cNvPr id="17" name="Text 14"/>
-          <p:cNvSpPr txBox="1"/>
-          <p:nvPr/>
-        </p:nvSpPr>
-        <p:spPr>
-          <a:xfrm>
-            <a:off x="3392424" y="2350008"/>
-            <a:ext cx="2359152" cy="475488"/>
-          </a:xfrm>
-          <a:prstGeom prst="rect">
-            <a:avLst/>
-          </a:prstGeom>
-          <a:noFill/>
-          <a:ln/>
-        </p:spPr>
-        <p:txBody>
-          <a:bodyPr wrap="square" lIns="0" tIns="0" rIns="0" bIns="0" rtlCol="0" anchor="t"/>
-          <a:lstStyle/>
-          <a:p>
-            <a:pPr algn="l" indent="0" marL="0">
-              <a:lnSpc>
-                <a:spcPct val="115000"/>
-              </a:lnSpc>
-              <a:buNone/>
-            </a:pPr>
-            <a:r>
-              <a:rPr lang="en-US" sz="900" b="1" dirty="0">
-                <a:solidFill>
-                  <a:srgbClr val="1A1A1A"/>
-                </a:solidFill>
-                <a:latin typeface="Meiryo" pitchFamily="34" charset="0"/>
-                <a:ea typeface="Meiryo" pitchFamily="34" charset="-122"/>
-                <a:cs typeface="Meiryo" pitchFamily="34" charset="-120"/>
-              </a:rPr>
-              <a:t>道具：</a:t>
-            </a:r>
-            <a:pPr algn="l" indent="0" marL="0">
-              <a:lnSpc>
-                <a:spcPct val="115000"/>
-              </a:lnSpc>
-              <a:buNone/>
-            </a:pPr>
-            <a:r>
-              <a:rPr lang="en-US" sz="900" dirty="0">
-                <a:solidFill>
-                  <a:srgbClr val="1A1A1A"/>
-                </a:solidFill>
-                <a:latin typeface="Meiryo" pitchFamily="34" charset="0"/>
-                <a:ea typeface="Meiryo" pitchFamily="34" charset="-122"/>
-                <a:cs typeface="Meiryo" pitchFamily="34" charset="-120"/>
-              </a:rPr>
-              <a:t>生成AI＋現場データ基盤（クラウド）</a:t>
-            </a:r>
-            <a:endParaRPr lang="en-US" sz="900" dirty="0"/>
-          </a:p>
-        </p:txBody>
-      </p:sp>
-      <p:sp>
-        <p:nvSpPr>
-          <p:cNvPr id="18" name="Text 15"/>
-          <p:cNvSpPr txBox="1"/>
-          <p:nvPr/>
-        </p:nvSpPr>
-        <p:spPr>
-          <a:xfrm>
-            <a:off x="5861304" y="1801368"/>
-            <a:ext cx="338328" cy="329184"/>
-          </a:xfrm>
-          <a:prstGeom prst="rect">
-            <a:avLst/>
-          </a:prstGeom>
-          <a:noFill/>
-          <a:ln/>
-        </p:spPr>
-        <p:txBody>
-          <a:bodyPr wrap="square" lIns="0" tIns="0" rIns="0" bIns="0" rtlCol="0" anchor="ctr"/>
-          <a:lstStyle/>
-          <a:p>
-            <a:pPr algn="ctr" indent="0" marL="0">
-              <a:lnSpc>
-                <a:spcPct val="115000"/>
-              </a:lnSpc>
-              <a:buNone/>
-            </a:pPr>
-            <a:r>
-              <a:rPr lang="en-US" sz="1400" dirty="0">
-                <a:solidFill>
-                  <a:srgbClr val="1A1A1A"/>
-                </a:solidFill>
-                <a:latin typeface="Meiryo" pitchFamily="34" charset="0"/>
-                <a:ea typeface="Meiryo" pitchFamily="34" charset="-122"/>
-                <a:cs typeface="Meiryo" pitchFamily="34" charset="-120"/>
-              </a:rPr>
-              <a:t>▶</a:t>
-            </a:r>
-            <a:endParaRPr lang="en-US" sz="1400" dirty="0"/>
-          </a:p>
-        </p:txBody>
-      </p:sp>
-      <p:sp>
-        <p:nvSpPr>
-          <p:cNvPr id="19" name="step-3"/>
-          <p:cNvSpPr/>
-          <p:nvPr/>
-        </p:nvSpPr>
-        <p:spPr>
-          <a:xfrm>
-            <a:off x="6199632" y="1051560"/>
-            <a:ext cx="2578608" cy="1828800"/>
+            <a:off x="6199632" y="1024128"/>
+            <a:ext cx="2578608" cy="1371600"/>
           </a:xfrm>
           <a:prstGeom prst="rect">
             <a:avLst/>
@@ -5885,14 +5861,14 @@
       </p:sp>
       <p:sp>
         <p:nvSpPr>
-          <p:cNvPr id="20" name="Shape 17"/>
+          <p:cNvPr id="18" name="Shape 15"/>
           <p:cNvSpPr/>
           <p:nvPr/>
         </p:nvSpPr>
         <p:spPr>
           <a:xfrm>
-            <a:off x="6199632" y="1051560"/>
-            <a:ext cx="2578608" cy="310896"/>
+            <a:off x="6199632" y="1024128"/>
+            <a:ext cx="2578608" cy="274320"/>
           </a:xfrm>
           <a:prstGeom prst="rect">
             <a:avLst/>
@@ -5905,13 +5881,114 @@
       </p:sp>
       <p:sp>
         <p:nvSpPr>
+          <p:cNvPr id="19" name="Text 16"/>
+          <p:cNvSpPr txBox="1"/>
+          <p:nvPr/>
+        </p:nvSpPr>
+        <p:spPr>
+          <a:xfrm>
+            <a:off x="6309360" y="1024128"/>
+            <a:ext cx="2359152" cy="274320"/>
+          </a:xfrm>
+          <a:prstGeom prst="rect">
+            <a:avLst/>
+          </a:prstGeom>
+          <a:noFill/>
+          <a:ln/>
+        </p:spPr>
+        <p:txBody>
+          <a:bodyPr wrap="square" lIns="0" tIns="0" rIns="0" bIns="0" rtlCol="0" anchor="ctr"/>
+          <a:lstStyle/>
+          <a:p>
+            <a:pPr algn="l" indent="0" marL="0">
+              <a:lnSpc>
+                <a:spcPct val="115000"/>
+              </a:lnSpc>
+              <a:buNone/>
+            </a:pPr>
+            <a:r>
+              <a:rPr lang="en-US" sz="1100" b="1" dirty="0">
+                <a:solidFill>
+                  <a:srgbClr val="FFFFFF"/>
+                </a:solidFill>
+                <a:latin typeface="Meiryo" pitchFamily="34" charset="0"/>
+                <a:ea typeface="Meiryo" pitchFamily="34" charset="-122"/>
+                <a:cs typeface="Meiryo" pitchFamily="34" charset="-120"/>
+              </a:rPr>
+              <a:t>③ 教材にして渡す</a:t>
+            </a:r>
+            <a:pPr algn="l" indent="0" marL="0">
+              <a:lnSpc>
+                <a:spcPct val="115000"/>
+              </a:lnSpc>
+              <a:buNone/>
+            </a:pPr>
+            <a:r>
+              <a:rPr lang="en-US" sz="900" dirty="0">
+                <a:solidFill>
+                  <a:srgbClr val="FFFFFF"/>
+                </a:solidFill>
+                <a:latin typeface="Meiryo" pitchFamily="34" charset="0"/>
+                <a:ea typeface="Meiryo" pitchFamily="34" charset="-122"/>
+                <a:cs typeface="Meiryo" pitchFamily="34" charset="-120"/>
+              </a:rPr>
+              <a:t>　当社</a:t>
+            </a:r>
+            <a:endParaRPr lang="en-US" sz="1100" dirty="0"/>
+          </a:p>
+        </p:txBody>
+      </p:sp>
+      <p:sp>
+        <p:nvSpPr>
+          <p:cNvPr id="20" name="Text 17"/>
+          <p:cNvSpPr txBox="1"/>
+          <p:nvPr/>
+        </p:nvSpPr>
+        <p:spPr>
+          <a:xfrm>
+            <a:off x="6309360" y="1353312"/>
+            <a:ext cx="2359152" cy="603504"/>
+          </a:xfrm>
+          <a:prstGeom prst="rect">
+            <a:avLst/>
+          </a:prstGeom>
+          <a:noFill/>
+          <a:ln/>
+        </p:spPr>
+        <p:txBody>
+          <a:bodyPr wrap="square" lIns="0" tIns="0" rIns="0" bIns="0" rtlCol="0" anchor="t"/>
+          <a:lstStyle/>
+          <a:p>
+            <a:pPr algn="l" indent="0" marL="0">
+              <a:lnSpc>
+                <a:spcPct val="115000"/>
+              </a:lnSpc>
+              <a:buNone/>
+            </a:pPr>
+            <a:r>
+              <a:rPr lang="en-US" sz="950" dirty="0">
+                <a:solidFill>
+                  <a:srgbClr val="1A1A1A"/>
+                </a:solidFill>
+                <a:latin typeface="Meiryo" pitchFamily="34" charset="0"/>
+                <a:ea typeface="Meiryo" pitchFamily="34" charset="-122"/>
+                <a:cs typeface="Meiryo" pitchFamily="34" charset="-120"/>
+              </a:rPr>
+              <a:t>現場が忙しくて作れない研修資料・音声番組・動画を当社が制作し、現場に届ける</a:t>
+            </a:r>
+            <a:endParaRPr lang="en-US" sz="950" dirty="0"/>
+          </a:p>
+        </p:txBody>
+      </p:sp>
+      <p:sp>
+        <p:nvSpPr>
           <p:cNvPr id="21" name="Text 18"/>
           <p:cNvSpPr txBox="1"/>
           <p:nvPr/>
         </p:nvSpPr>
         <p:spPr>
           <a:xfrm>
-            <a:off x="6309360" y="1051560"/>
+            <a:off x="6309360" y="2029968"/>
             <a:ext cx="2359152" cy="310896"/>
           </a:xfrm>
           <a:prstGeom prst="rect">
@@ -5921,44 +5998,44 @@
           <a:ln/>
         </p:spPr>
         <p:txBody>
-          <a:bodyPr wrap="square" lIns="0" tIns="0" rIns="0" bIns="0" rtlCol="0" anchor="ctr"/>
-          <a:lstStyle/>
-          <a:p>
-            <a:pPr algn="l" indent="0" marL="0">
-              <a:lnSpc>
-                <a:spcPct val="115000"/>
-              </a:lnSpc>
-              <a:buNone/>
-            </a:pPr>
-            <a:r>
-              <a:rPr lang="en-US" sz="1150" b="1" dirty="0">
-                <a:solidFill>
-                  <a:srgbClr val="FFFFFF"/>
-                </a:solidFill>
-                <a:latin typeface="Meiryo" pitchFamily="34" charset="0"/>
-                <a:ea typeface="Meiryo" pitchFamily="34" charset="-122"/>
-                <a:cs typeface="Meiryo" pitchFamily="34" charset="-120"/>
-              </a:rPr>
-              <a:t>③ 引き継ぐ</a:t>
-            </a:r>
-            <a:pPr algn="l" indent="0" marL="0">
-              <a:lnSpc>
-                <a:spcPct val="115000"/>
-              </a:lnSpc>
-              <a:buNone/>
-            </a:pPr>
-            <a:r>
-              <a:rPr lang="en-US" sz="900" dirty="0">
-                <a:solidFill>
-                  <a:srgbClr val="FFFFFF"/>
-                </a:solidFill>
-                <a:latin typeface="Meiryo" pitchFamily="34" charset="0"/>
-                <a:ea typeface="Meiryo" pitchFamily="34" charset="-122"/>
-                <a:cs typeface="Meiryo" pitchFamily="34" charset="-120"/>
-              </a:rPr>
-              <a:t>　若手・機械</a:t>
-            </a:r>
-            <a:endParaRPr lang="en-US" sz="1150" dirty="0"/>
+          <a:bodyPr wrap="square" lIns="0" tIns="0" rIns="0" bIns="0" rtlCol="0" anchor="t"/>
+          <a:lstStyle/>
+          <a:p>
+            <a:pPr algn="l" indent="0" marL="0">
+              <a:lnSpc>
+                <a:spcPct val="115000"/>
+              </a:lnSpc>
+              <a:buNone/>
+            </a:pPr>
+            <a:r>
+              <a:rPr lang="en-US" sz="850" b="1" dirty="0">
+                <a:solidFill>
+                  <a:srgbClr val="4D4D4D"/>
+                </a:solidFill>
+                <a:latin typeface="Meiryo" pitchFamily="34" charset="0"/>
+                <a:ea typeface="Meiryo" pitchFamily="34" charset="-122"/>
+                <a:cs typeface="Meiryo" pitchFamily="34" charset="-120"/>
+              </a:rPr>
+              <a:t>道具：</a:t>
+            </a:r>
+            <a:pPr algn="l" indent="0" marL="0">
+              <a:lnSpc>
+                <a:spcPct val="115000"/>
+              </a:lnSpc>
+              <a:buNone/>
+            </a:pPr>
+            <a:r>
+              <a:rPr lang="en-US" sz="850" dirty="0">
+                <a:solidFill>
+                  <a:srgbClr val="4D4D4D"/>
+                </a:solidFill>
+                <a:latin typeface="Meiryo" pitchFamily="34" charset="0"/>
+                <a:ea typeface="Meiryo" pitchFamily="34" charset="-122"/>
+                <a:cs typeface="Meiryo" pitchFamily="34" charset="-120"/>
+              </a:rPr>
+              <a:t>生成AIで台本→当社が監修→配信</a:t>
+            </a:r>
+            <a:endParaRPr lang="en-US" sz="850" dirty="0"/>
           </a:p>
         </p:txBody>
       </p:sp>
@@ -5970,8 +6047,8 @@
         </p:nvSpPr>
         <p:spPr>
           <a:xfrm>
-            <a:off x="6309360" y="1435608"/>
-            <a:ext cx="2359152" cy="804672"/>
+            <a:off x="365760" y="2542032"/>
+            <a:ext cx="4572000" cy="219456"/>
           </a:xfrm>
           <a:prstGeom prst="rect">
             <a:avLst/>
@@ -5990,7 +6067,7 @@
               <a:buNone/>
             </a:pPr>
             <a:r>
-              <a:rPr lang="en-US" sz="1000" dirty="0">
+              <a:rPr lang="en-US" sz="950" b="1" dirty="0">
                 <a:solidFill>
                   <a:srgbClr val="1A1A1A"/>
                 </a:solidFill>
@@ -5998,9 +6075,9 @@
                 <a:ea typeface="Meiryo" pitchFamily="34" charset="-122"/>
                 <a:cs typeface="Meiryo" pitchFamily="34" charset="-120"/>
               </a:rPr>
-              <a:t>似た条件になると、若手の画面に過去事例と推奨値を表示。ロボット・検査AIには条件を直接渡す</a:t>
-            </a:r>
-            <a:endParaRPr lang="en-US" sz="1000" dirty="0"/>
+              <a:t>渡し方を増やす（製品戦略：基盤が先、追加機能は年1本ずつ）</a:t>
+            </a:r>
+            <a:endParaRPr lang="en-US" sz="950" dirty="0"/>
           </a:p>
         </p:txBody>
       </p:sp>
@@ -6012,8 +6089,8 @@
         </p:nvSpPr>
         <p:spPr>
           <a:xfrm>
-            <a:off x="6309360" y="2295144"/>
-            <a:ext cx="2359152" cy="0"/>
+            <a:off x="365760" y="2788920"/>
+            <a:ext cx="4572000" cy="0"/>
           </a:xfrm>
           <a:prstGeom prst="line">
             <a:avLst/>
@@ -6035,27 +6112,69 @@
         </p:nvSpPr>
         <p:spPr>
           <a:xfrm>
-            <a:off x="6309360" y="2350008"/>
-            <a:ext cx="2359152" cy="475488"/>
-          </a:xfrm>
-          <a:prstGeom prst="rect">
-            <a:avLst/>
-          </a:prstGeom>
-          <a:noFill/>
-          <a:ln/>
-        </p:spPr>
-        <p:txBody>
-          <a:bodyPr wrap="square" lIns="0" tIns="0" rIns="0" bIns="0" rtlCol="0" anchor="t"/>
-          <a:lstStyle/>
-          <a:p>
-            <a:pPr algn="l" indent="0" marL="0">
-              <a:lnSpc>
-                <a:spcPct val="115000"/>
-              </a:lnSpc>
-              <a:buNone/>
-            </a:pPr>
-            <a:r>
-              <a:rPr lang="en-US" sz="900" b="1" dirty="0">
+            <a:off x="402336" y="2788920"/>
+            <a:ext cx="420624" cy="228600"/>
+          </a:xfrm>
+          <a:prstGeom prst="rect">
+            <a:avLst/>
+          </a:prstGeom>
+          <a:noFill/>
+          <a:ln/>
+        </p:spPr>
+        <p:txBody>
+          <a:bodyPr wrap="square" lIns="0" tIns="0" rIns="0" bIns="0" rtlCol="0" anchor="ctr"/>
+          <a:lstStyle/>
+          <a:p>
+            <a:pPr algn="l" indent="0" marL="0">
+              <a:lnSpc>
+                <a:spcPct val="115000"/>
+              </a:lnSpc>
+              <a:buNone/>
+            </a:pPr>
+            <a:r>
+              <a:rPr lang="en-US" sz="800" dirty="0">
+                <a:solidFill>
+                  <a:srgbClr val="4D4D4D"/>
+                </a:solidFill>
+                <a:latin typeface="Meiryo" pitchFamily="34" charset="0"/>
+                <a:ea typeface="Meiryo" pitchFamily="34" charset="-122"/>
+                <a:cs typeface="Meiryo" pitchFamily="34" charset="-120"/>
+              </a:rPr>
+              <a:t>1年目</a:t>
+            </a:r>
+            <a:endParaRPr lang="en-US" sz="800" dirty="0"/>
+          </a:p>
+        </p:txBody>
+      </p:sp>
+      <p:sp>
+        <p:nvSpPr>
+          <p:cNvPr id="25" name="Text 22"/>
+          <p:cNvSpPr txBox="1"/>
+          <p:nvPr/>
+        </p:nvSpPr>
+        <p:spPr>
+          <a:xfrm>
+            <a:off x="822960" y="2788920"/>
+            <a:ext cx="621792" cy="228600"/>
+          </a:xfrm>
+          <a:prstGeom prst="rect">
+            <a:avLst/>
+          </a:prstGeom>
+          <a:noFill/>
+          <a:ln/>
+        </p:spPr>
+        <p:txBody>
+          <a:bodyPr wrap="square" lIns="0" tIns="0" rIns="0" bIns="0" rtlCol="0" anchor="ctr"/>
+          <a:lstStyle/>
+          <a:p>
+            <a:pPr algn="l" indent="0" marL="0">
+              <a:lnSpc>
+                <a:spcPct val="115000"/>
+              </a:lnSpc>
+              <a:buNone/>
+            </a:pPr>
+            <a:r>
+              <a:rPr lang="en-US" sz="850" b="1" dirty="0">
                 <a:solidFill>
                   <a:srgbClr val="1A1A1A"/>
                 </a:solidFill>
@@ -6063,48 +6182,11 @@
                 <a:ea typeface="Meiryo" pitchFamily="34" charset="-122"/>
                 <a:cs typeface="Meiryo" pitchFamily="34" charset="-120"/>
               </a:rPr>
-              <a:t>道具：</a:t>
-            </a:r>
-            <a:pPr algn="l" indent="0" marL="0">
-              <a:lnSpc>
-                <a:spcPct val="115000"/>
-              </a:lnSpc>
-              <a:buNone/>
-            </a:pPr>
-            <a:r>
-              <a:rPr lang="en-US" sz="900" dirty="0">
-                <a:solidFill>
-                  <a:srgbClr val="1A1A1A"/>
-                </a:solidFill>
-                <a:latin typeface="Meiryo" pitchFamily="34" charset="0"/>
-                <a:ea typeface="Meiryo" pitchFamily="34" charset="-122"/>
-                <a:cs typeface="Meiryo" pitchFamily="34" charset="-120"/>
-              </a:rPr>
-              <a:t>アプリの通知＋API連携</a:t>
-            </a:r>
-            <a:endParaRPr lang="en-US" sz="900" dirty="0"/>
-          </a:p>
-        </p:txBody>
-      </p:sp>
-      <p:sp>
-        <p:nvSpPr>
-          <p:cNvPr id="25" name="onboarding"/>
-          <p:cNvSpPr/>
-          <p:nvPr/>
-        </p:nvSpPr>
-        <p:spPr>
-          <a:xfrm>
-            <a:off x="365760" y="3035808"/>
-            <a:ext cx="4023360" cy="1371600"/>
-          </a:xfrm>
-          <a:prstGeom prst="rect">
-            <a:avLst/>
-          </a:prstGeom>
-          <a:solidFill>
-            <a:srgbClr val="F2F2F2"/>
-          </a:solidFill>
-          <a:ln/>
-        </p:spPr>
+              <a:t>基盤</a:t>
+            </a:r>
+            <a:endParaRPr lang="en-US" sz="850" dirty="0"/>
+          </a:p>
+        </p:txBody>
       </p:sp>
       <p:sp>
         <p:nvSpPr>
@@ -6114,37 +6196,37 @@
         </p:nvSpPr>
         <p:spPr>
           <a:xfrm>
-            <a:off x="502920" y="3108960"/>
-            <a:ext cx="3749040" cy="256032"/>
-          </a:xfrm>
-          <a:prstGeom prst="rect">
-            <a:avLst/>
-          </a:prstGeom>
-          <a:noFill/>
-          <a:ln/>
-        </p:spPr>
-        <p:txBody>
-          <a:bodyPr wrap="square" lIns="0" tIns="0" rIns="0" bIns="0" rtlCol="0" anchor="t"/>
-          <a:lstStyle/>
-          <a:p>
-            <a:pPr algn="l" indent="0" marL="0">
-              <a:lnSpc>
-                <a:spcPct val="115000"/>
-              </a:lnSpc>
-              <a:buNone/>
-            </a:pPr>
-            <a:r>
-              <a:rPr lang="en-US" sz="1100" b="1" dirty="0">
-                <a:solidFill>
-                  <a:srgbClr val="1A1A1A"/>
-                </a:solidFill>
-                <a:latin typeface="Meiryo" pitchFamily="34" charset="0"/>
-                <a:ea typeface="Meiryo" pitchFamily="34" charset="-122"/>
-                <a:cs typeface="Meiryo" pitchFamily="34" charset="-120"/>
-              </a:rPr>
-              <a:t>道具以外：導入支援（初年度・約2か月）</a:t>
-            </a:r>
-            <a:endParaRPr lang="en-US" sz="1100" dirty="0"/>
+            <a:off x="1444752" y="2788920"/>
+            <a:ext cx="603504" cy="228600"/>
+          </a:xfrm>
+          <a:prstGeom prst="rect">
+            <a:avLst/>
+          </a:prstGeom>
+          <a:noFill/>
+          <a:ln/>
+        </p:spPr>
+        <p:txBody>
+          <a:bodyPr wrap="square" lIns="0" tIns="0" rIns="0" bIns="0" rtlCol="0" anchor="ctr"/>
+          <a:lstStyle/>
+          <a:p>
+            <a:pPr algn="l" indent="0" marL="0">
+              <a:lnSpc>
+                <a:spcPct val="115000"/>
+              </a:lnSpc>
+              <a:buNone/>
+            </a:pPr>
+            <a:r>
+              <a:rPr lang="en-US" sz="800" dirty="0">
+                <a:solidFill>
+                  <a:srgbClr val="4D4D4D"/>
+                </a:solidFill>
+                <a:latin typeface="Meiryo" pitchFamily="34" charset="0"/>
+                <a:ea typeface="Meiryo" pitchFamily="34" charset="-122"/>
+                <a:cs typeface="Meiryo" pitchFamily="34" charset="-120"/>
+              </a:rPr>
+              <a:t>画面</a:t>
+            </a:r>
+            <a:endParaRPr lang="en-US" sz="800" dirty="0"/>
           </a:p>
         </p:txBody>
       </p:sp>
@@ -6156,30 +6238,27 @@
         </p:nvSpPr>
         <p:spPr>
           <a:xfrm>
-            <a:off x="502920" y="3419856"/>
-            <a:ext cx="3749040" cy="932688"/>
-          </a:xfrm>
-          <a:prstGeom prst="rect">
-            <a:avLst/>
-          </a:prstGeom>
-          <a:noFill/>
-          <a:ln/>
-        </p:spPr>
-        <p:txBody>
-          <a:bodyPr wrap="square" lIns="0" tIns="0" rIns="0" bIns="0" rtlCol="0" anchor="t"/>
-          <a:lstStyle/>
-          <a:p>
-            <a:pPr algn="l" indent="0" marL="0">
-              <a:lnSpc>
-                <a:spcPct val="115000"/>
-              </a:lnSpc>
-              <a:spcAft>
-                <a:spcPts val="300"/>
-              </a:spcAft>
-              <a:buNone/>
-            </a:pPr>
-            <a:r>
-              <a:rPr lang="en-US" sz="950" dirty="0">
+            <a:off x="2048256" y="2788920"/>
+            <a:ext cx="2468880" cy="228600"/>
+          </a:xfrm>
+          <a:prstGeom prst="rect">
+            <a:avLst/>
+          </a:prstGeom>
+          <a:noFill/>
+          <a:ln/>
+        </p:spPr>
+        <p:txBody>
+          <a:bodyPr wrap="square" lIns="0" tIns="0" rIns="0" bIns="0" rtlCol="0" anchor="ctr"/>
+          <a:lstStyle/>
+          <a:p>
+            <a:pPr algn="l" indent="0" marL="0">
+              <a:lnSpc>
+                <a:spcPct val="115000"/>
+              </a:lnSpc>
+              <a:buNone/>
+            </a:pPr>
+            <a:r>
+              <a:rPr lang="en-US" sz="800" dirty="0">
                 <a:solidFill>
                   <a:srgbClr val="1A1A1A"/>
                 </a:solidFill>
@@ -6187,55 +6266,9 @@
                 <a:ea typeface="Meiryo" pitchFamily="34" charset="-122"/>
                 <a:cs typeface="Meiryo" pitchFamily="34" charset="-120"/>
               </a:rPr>
-              <a:t>当社の担当者が現場に入り、熟練者に聞き取りして判断を棚卸し</a:t>
-            </a:r>
-            <a:endParaRPr lang="en-US" sz="950" dirty="0"/>
-          </a:p>
-          <a:p>
-            <a:pPr algn="l" indent="0" marL="0">
-              <a:lnSpc>
-                <a:spcPct val="115000"/>
-              </a:lnSpc>
-              <a:spcAft>
-                <a:spcPts val="300"/>
-              </a:spcAft>
-              <a:buNone/>
-            </a:pPr>
-            <a:r>
-              <a:rPr lang="en-US" sz="950" dirty="0">
-                <a:solidFill>
-                  <a:srgbClr val="1A1A1A"/>
-                </a:solidFill>
-                <a:latin typeface="Meiryo" pitchFamily="34" charset="0"/>
-                <a:ea typeface="Meiryo" pitchFamily="34" charset="-122"/>
-                <a:cs typeface="Meiryo" pitchFamily="34" charset="-120"/>
-              </a:rPr>
-              <a:t>既存の帳票・試験記録をデータとして移行</a:t>
-            </a:r>
-            <a:endParaRPr lang="en-US" sz="950" dirty="0"/>
-          </a:p>
-          <a:p>
-            <a:pPr algn="l" indent="0" marL="0">
-              <a:lnSpc>
-                <a:spcPct val="115000"/>
-              </a:lnSpc>
-              <a:spcAft>
-                <a:spcPts val="300"/>
-              </a:spcAft>
-              <a:buNone/>
-            </a:pPr>
-            <a:r>
-              <a:rPr lang="en-US" sz="950" dirty="0">
-                <a:solidFill>
-                  <a:srgbClr val="1A1A1A"/>
-                </a:solidFill>
-                <a:latin typeface="Meiryo" pitchFamily="34" charset="0"/>
-                <a:ea typeface="Meiryo" pitchFamily="34" charset="-122"/>
-                <a:cs typeface="Meiryo" pitchFamily="34" charset="-120"/>
-              </a:rPr>
-              <a:t>現場研修で、記録が「いつもの作業の延長」になるまで定着させる</a:t>
-            </a:r>
-            <a:endParaRPr lang="en-US" sz="950" dirty="0"/>
+              <a:t>記録・過去事例の検索（全顧客）</a:t>
+            </a:r>
+            <a:endParaRPr lang="en-US" sz="800" dirty="0"/>
           </a:p>
         </p:txBody>
       </p:sp>
@@ -6247,27 +6280,27 @@
         </p:nvSpPr>
         <p:spPr>
           <a:xfrm>
-            <a:off x="4572000" y="3035808"/>
-            <a:ext cx="4206240" cy="237744"/>
-          </a:xfrm>
-          <a:prstGeom prst="rect">
-            <a:avLst/>
-          </a:prstGeom>
-          <a:noFill/>
-          <a:ln/>
-        </p:spPr>
-        <p:txBody>
-          <a:bodyPr wrap="square" lIns="0" tIns="0" rIns="0" bIns="0" rtlCol="0" anchor="t"/>
-          <a:lstStyle/>
-          <a:p>
-            <a:pPr algn="l" indent="0" marL="0">
-              <a:lnSpc>
-                <a:spcPct val="115000"/>
-              </a:lnSpc>
-              <a:buNone/>
-            </a:pPr>
-            <a:r>
-              <a:rPr lang="en-US" sz="1000" b="1" dirty="0">
+            <a:off x="4517136" y="2788920"/>
+            <a:ext cx="384048" cy="228600"/>
+          </a:xfrm>
+          <a:prstGeom prst="rect">
+            <a:avLst/>
+          </a:prstGeom>
+          <a:noFill/>
+          <a:ln/>
+        </p:spPr>
+        <p:txBody>
+          <a:bodyPr wrap="square" lIns="0" tIns="0" rIns="0" bIns="0" rtlCol="0" anchor="ctr"/>
+          <a:lstStyle/>
+          <a:p>
+            <a:pPr algn="r" indent="0" marL="0">
+              <a:lnSpc>
+                <a:spcPct val="115000"/>
+              </a:lnSpc>
+              <a:buNone/>
+            </a:pPr>
+            <a:r>
+              <a:rPr lang="en-US" sz="800" dirty="0">
                 <a:solidFill>
                   <a:srgbClr val="1A1A1A"/>
                 </a:solidFill>
@@ -6275,9 +6308,9 @@
                 <a:ea typeface="Meiryo" pitchFamily="34" charset="-122"/>
                 <a:cs typeface="Meiryo" pitchFamily="34" charset="-120"/>
               </a:rPr>
-              <a:t>機能の広げ方（製品戦略：基盤が先、追加機能は年1本ずつ）</a:t>
-            </a:r>
-            <a:endParaRPr lang="en-US" sz="1000" dirty="0"/>
+              <a:t>製品</a:t>
+            </a:r>
+            <a:endParaRPr lang="en-US" sz="800" dirty="0"/>
           </a:p>
         </p:txBody>
       </p:sp>
@@ -6289,8 +6322,8 @@
         </p:nvSpPr>
         <p:spPr>
           <a:xfrm>
-            <a:off x="4572000" y="3310128"/>
-            <a:ext cx="4206240" cy="0"/>
+            <a:off x="365760" y="3017520"/>
+            <a:ext cx="4572000" cy="0"/>
           </a:xfrm>
           <a:prstGeom prst="line">
             <a:avLst/>
@@ -6312,8 +6345,8 @@
         </p:nvSpPr>
         <p:spPr>
           <a:xfrm>
-            <a:off x="4572000" y="3310128"/>
-            <a:ext cx="502920" cy="219456"/>
+            <a:off x="402336" y="3017520"/>
+            <a:ext cx="420624" cy="228600"/>
           </a:xfrm>
           <a:prstGeom prst="rect">
             <a:avLst/>
@@ -6332,7 +6365,7 @@
               <a:buNone/>
             </a:pPr>
             <a:r>
-              <a:rPr lang="en-US" sz="850" dirty="0">
+              <a:rPr lang="en-US" sz="800" dirty="0">
                 <a:solidFill>
                   <a:srgbClr val="4D4D4D"/>
                 </a:solidFill>
@@ -6340,9 +6373,9 @@
                 <a:ea typeface="Meiryo" pitchFamily="34" charset="-122"/>
                 <a:cs typeface="Meiryo" pitchFamily="34" charset="-120"/>
               </a:rPr>
-              <a:t>1年目</a:t>
-            </a:r>
-            <a:endParaRPr lang="en-US" sz="850" dirty="0"/>
+              <a:t>2年目</a:t>
+            </a:r>
+            <a:endParaRPr lang="en-US" sz="800" dirty="0"/>
           </a:p>
         </p:txBody>
       </p:sp>
@@ -6354,8 +6387,8 @@
         </p:nvSpPr>
         <p:spPr>
           <a:xfrm>
-            <a:off x="5074920" y="3310128"/>
-            <a:ext cx="685800" cy="219456"/>
+            <a:off x="822960" y="3017520"/>
+            <a:ext cx="621792" cy="228600"/>
           </a:xfrm>
           <a:prstGeom prst="rect">
             <a:avLst/>
@@ -6374,7 +6407,7 @@
               <a:buNone/>
             </a:pPr>
             <a:r>
-              <a:rPr lang="en-US" sz="900" b="1" dirty="0">
+              <a:rPr lang="en-US" sz="850" b="1" dirty="0">
                 <a:solidFill>
                   <a:srgbClr val="1A1A1A"/>
                 </a:solidFill>
@@ -6382,9 +6415,9 @@
                 <a:ea typeface="Meiryo" pitchFamily="34" charset="-122"/>
                 <a:cs typeface="Meiryo" pitchFamily="34" charset="-120"/>
               </a:rPr>
-              <a:t>基盤</a:t>
-            </a:r>
-            <a:endParaRPr lang="en-US" sz="900" dirty="0"/>
+              <a:t>KNACK</a:t>
+            </a:r>
+            <a:endParaRPr lang="en-US" sz="850" dirty="0"/>
           </a:p>
         </p:txBody>
       </p:sp>
@@ -6396,8 +6429,8 @@
         </p:nvSpPr>
         <p:spPr>
           <a:xfrm>
-            <a:off x="5760720" y="3310128"/>
-            <a:ext cx="3017520" cy="219456"/>
+            <a:off x="1444752" y="3017520"/>
+            <a:ext cx="603504" cy="228600"/>
           </a:xfrm>
           <a:prstGeom prst="rect">
             <a:avLst/>
@@ -6416,7 +6449,49 @@
               <a:buNone/>
             </a:pPr>
             <a:r>
-              <a:rPr lang="en-US" sz="850" dirty="0">
+              <a:rPr lang="en-US" sz="800" dirty="0">
+                <a:solidFill>
+                  <a:srgbClr val="4D4D4D"/>
+                </a:solidFill>
+                <a:latin typeface="Meiryo" pitchFamily="34" charset="0"/>
+                <a:ea typeface="Meiryo" pitchFamily="34" charset="-122"/>
+                <a:cs typeface="Meiryo" pitchFamily="34" charset="-120"/>
+              </a:rPr>
+              <a:t>教材</a:t>
+            </a:r>
+            <a:endParaRPr lang="en-US" sz="800" dirty="0"/>
+          </a:p>
+        </p:txBody>
+      </p:sp>
+      <p:sp>
+        <p:nvSpPr>
+          <p:cNvPr id="33" name="Text 30"/>
+          <p:cNvSpPr txBox="1"/>
+          <p:nvPr/>
+        </p:nvSpPr>
+        <p:spPr>
+          <a:xfrm>
+            <a:off x="2048256" y="3017520"/>
+            <a:ext cx="2468880" cy="228600"/>
+          </a:xfrm>
+          <a:prstGeom prst="rect">
+            <a:avLst/>
+          </a:prstGeom>
+          <a:noFill/>
+          <a:ln/>
+        </p:spPr>
+        <p:txBody>
+          <a:bodyPr wrap="square" lIns="0" tIns="0" rIns="0" bIns="0" rtlCol="0" anchor="ctr"/>
+          <a:lstStyle/>
+          <a:p>
+            <a:pPr algn="l" indent="0" marL="0">
+              <a:lnSpc>
+                <a:spcPct val="115000"/>
+              </a:lnSpc>
+              <a:buNone/>
+            </a:pPr>
+            <a:r>
+              <a:rPr lang="en-US" sz="800" dirty="0">
                 <a:solidFill>
                   <a:srgbClr val="1A1A1A"/>
                 </a:solidFill>
@@ -6424,22 +6499,64 @@
                 <a:ea typeface="Meiryo" pitchFamily="34" charset="-122"/>
                 <a:cs typeface="Meiryo" pitchFamily="34" charset="-120"/>
               </a:rPr>
-              <a:t>記録・検索（①②と過去事例の検索）。全顧客が使う</a:t>
-            </a:r>
-            <a:endParaRPr lang="en-US" sz="850" dirty="0"/>
-          </a:p>
-        </p:txBody>
-      </p:sp>
-      <p:sp>
-        <p:nvSpPr>
-          <p:cNvPr id="33" name="Shape 30"/>
+              <a:t>勘どころの音声番組・動画・研修資料を制作</a:t>
+            </a:r>
+            <a:endParaRPr lang="en-US" sz="800" dirty="0"/>
+          </a:p>
+        </p:txBody>
+      </p:sp>
+      <p:sp>
+        <p:nvSpPr>
+          <p:cNvPr id="34" name="Text 31"/>
+          <p:cNvSpPr txBox="1"/>
+          <p:nvPr/>
+        </p:nvSpPr>
+        <p:spPr>
+          <a:xfrm>
+            <a:off x="4517136" y="3017520"/>
+            <a:ext cx="384048" cy="228600"/>
+          </a:xfrm>
+          <a:prstGeom prst="rect">
+            <a:avLst/>
+          </a:prstGeom>
+          <a:noFill/>
+          <a:ln/>
+        </p:spPr>
+        <p:txBody>
+          <a:bodyPr wrap="square" lIns="0" tIns="0" rIns="0" bIns="0" rtlCol="0" anchor="ctr"/>
+          <a:lstStyle/>
+          <a:p>
+            <a:pPr algn="r" indent="0" marL="0">
+              <a:lnSpc>
+                <a:spcPct val="115000"/>
+              </a:lnSpc>
+              <a:buNone/>
+            </a:pPr>
+            <a:r>
+              <a:rPr lang="en-US" sz="800" dirty="0">
+                <a:solidFill>
+                  <a:srgbClr val="1A1A1A"/>
+                </a:solidFill>
+                <a:latin typeface="Meiryo" pitchFamily="34" charset="0"/>
+                <a:ea typeface="Meiryo" pitchFamily="34" charset="-122"/>
+                <a:cs typeface="Meiryo" pitchFamily="34" charset="-120"/>
+              </a:rPr>
+              <a:t>製品</a:t>
+            </a:r>
+            <a:endParaRPr lang="en-US" sz="800" dirty="0"/>
+          </a:p>
+        </p:txBody>
+      </p:sp>
+      <p:sp>
+        <p:nvSpPr>
+          <p:cNvPr id="35" name="Shape 32"/>
           <p:cNvSpPr/>
           <p:nvPr/>
         </p:nvSpPr>
         <p:spPr>
           <a:xfrm>
-            <a:off x="4572000" y="3529584"/>
-            <a:ext cx="4206240" cy="0"/>
+            <a:off x="365760" y="3246120"/>
+            <a:ext cx="4572000" cy="0"/>
           </a:xfrm>
           <a:prstGeom prst="line">
             <a:avLst/>
@@ -6455,98 +6572,14 @@
       </p:sp>
       <p:sp>
         <p:nvSpPr>
-          <p:cNvPr id="34" name="Text 31"/>
-          <p:cNvSpPr txBox="1"/>
-          <p:nvPr/>
-        </p:nvSpPr>
-        <p:spPr>
-          <a:xfrm>
-            <a:off x="4572000" y="3529584"/>
-            <a:ext cx="502920" cy="219456"/>
-          </a:xfrm>
-          <a:prstGeom prst="rect">
-            <a:avLst/>
-          </a:prstGeom>
-          <a:noFill/>
-          <a:ln/>
-        </p:spPr>
-        <p:txBody>
-          <a:bodyPr wrap="square" lIns="0" tIns="0" rIns="0" bIns="0" rtlCol="0" anchor="ctr"/>
-          <a:lstStyle/>
-          <a:p>
-            <a:pPr algn="l" indent="0" marL="0">
-              <a:lnSpc>
-                <a:spcPct val="115000"/>
-              </a:lnSpc>
-              <a:buNone/>
-            </a:pPr>
-            <a:r>
-              <a:rPr lang="en-US" sz="850" dirty="0">
-                <a:solidFill>
-                  <a:srgbClr val="4D4D4D"/>
-                </a:solidFill>
-                <a:latin typeface="Meiryo" pitchFamily="34" charset="0"/>
-                <a:ea typeface="Meiryo" pitchFamily="34" charset="-122"/>
-                <a:cs typeface="Meiryo" pitchFamily="34" charset="-120"/>
-              </a:rPr>
-              <a:t>2年目</a:t>
-            </a:r>
-            <a:endParaRPr lang="en-US" sz="850" dirty="0"/>
-          </a:p>
-        </p:txBody>
-      </p:sp>
-      <p:sp>
-        <p:nvSpPr>
-          <p:cNvPr id="35" name="Text 32"/>
-          <p:cNvSpPr txBox="1"/>
-          <p:nvPr/>
-        </p:nvSpPr>
-        <p:spPr>
-          <a:xfrm>
-            <a:off x="5074920" y="3529584"/>
-            <a:ext cx="685800" cy="219456"/>
-          </a:xfrm>
-          <a:prstGeom prst="rect">
-            <a:avLst/>
-          </a:prstGeom>
-          <a:noFill/>
-          <a:ln/>
-        </p:spPr>
-        <p:txBody>
-          <a:bodyPr wrap="square" lIns="0" tIns="0" rIns="0" bIns="0" rtlCol="0" anchor="ctr"/>
-          <a:lstStyle/>
-          <a:p>
-            <a:pPr algn="l" indent="0" marL="0">
-              <a:lnSpc>
-                <a:spcPct val="115000"/>
-              </a:lnSpc>
-              <a:buNone/>
-            </a:pPr>
-            <a:r>
-              <a:rPr lang="en-US" sz="900" b="1" dirty="0">
-                <a:solidFill>
-                  <a:srgbClr val="1A1A1A"/>
-                </a:solidFill>
-                <a:latin typeface="Meiryo" pitchFamily="34" charset="0"/>
-                <a:ea typeface="Meiryo" pitchFamily="34" charset="-122"/>
-                <a:cs typeface="Meiryo" pitchFamily="34" charset="-120"/>
-              </a:rPr>
-              <a:t>KNACK</a:t>
-            </a:r>
-            <a:endParaRPr lang="en-US" sz="900" dirty="0"/>
-          </a:p>
-        </p:txBody>
-      </p:sp>
-      <p:sp>
-        <p:nvSpPr>
           <p:cNvPr id="36" name="Text 33"/>
           <p:cNvSpPr txBox="1"/>
           <p:nvPr/>
         </p:nvSpPr>
         <p:spPr>
           <a:xfrm>
-            <a:off x="5760720" y="3529584"/>
-            <a:ext cx="3017520" cy="219456"/>
+            <a:off x="402336" y="3246120"/>
+            <a:ext cx="420624" cy="228600"/>
           </a:xfrm>
           <a:prstGeom prst="rect">
             <a:avLst/>
@@ -6565,7 +6598,49 @@
               <a:buNone/>
             </a:pPr>
             <a:r>
-              <a:rPr lang="en-US" sz="850" dirty="0">
+              <a:rPr lang="en-US" sz="800" dirty="0">
+                <a:solidFill>
+                  <a:srgbClr val="4D4D4D"/>
+                </a:solidFill>
+                <a:latin typeface="Meiryo" pitchFamily="34" charset="0"/>
+                <a:ea typeface="Meiryo" pitchFamily="34" charset="-122"/>
+                <a:cs typeface="Meiryo" pitchFamily="34" charset="-120"/>
+              </a:rPr>
+              <a:t>3年目</a:t>
+            </a:r>
+            <a:endParaRPr lang="en-US" sz="800" dirty="0"/>
+          </a:p>
+        </p:txBody>
+      </p:sp>
+      <p:sp>
+        <p:nvSpPr>
+          <p:cNvPr id="37" name="Text 34"/>
+          <p:cNvSpPr txBox="1"/>
+          <p:nvPr/>
+        </p:nvSpPr>
+        <p:spPr>
+          <a:xfrm>
+            <a:off x="822960" y="3246120"/>
+            <a:ext cx="621792" cy="228600"/>
+          </a:xfrm>
+          <a:prstGeom prst="rect">
+            <a:avLst/>
+          </a:prstGeom>
+          <a:noFill/>
+          <a:ln/>
+        </p:spPr>
+        <p:txBody>
+          <a:bodyPr wrap="square" lIns="0" tIns="0" rIns="0" bIns="0" rtlCol="0" anchor="ctr"/>
+          <a:lstStyle/>
+          <a:p>
+            <a:pPr algn="l" indent="0" marL="0">
+              <a:lnSpc>
+                <a:spcPct val="115000"/>
+              </a:lnSpc>
+              <a:buNone/>
+            </a:pPr>
+            <a:r>
+              <a:rPr lang="en-US" sz="850" b="1" dirty="0">
                 <a:solidFill>
                   <a:srgbClr val="1A1A1A"/>
                 </a:solidFill>
@@ -6573,7 +6648,7 @@
                 <a:ea typeface="Meiryo" pitchFamily="34" charset="-122"/>
                 <a:cs typeface="Meiryo" pitchFamily="34" charset="-120"/>
               </a:rPr>
-              <a:t>推奨値の自動提示（③）</a:t>
+              <a:t>SAFE</a:t>
             </a:r>
             <a:endParaRPr lang="en-US" sz="850" dirty="0"/>
           </a:p>
@@ -6581,14 +6656,140 @@
       </p:sp>
       <p:sp>
         <p:nvSpPr>
-          <p:cNvPr id="37" name="Shape 34"/>
+          <p:cNvPr id="38" name="Text 35"/>
+          <p:cNvSpPr txBox="1"/>
+          <p:nvPr/>
+        </p:nvSpPr>
+        <p:spPr>
+          <a:xfrm>
+            <a:off x="1444752" y="3246120"/>
+            <a:ext cx="603504" cy="228600"/>
+          </a:xfrm>
+          <a:prstGeom prst="rect">
+            <a:avLst/>
+          </a:prstGeom>
+          <a:noFill/>
+          <a:ln/>
+        </p:spPr>
+        <p:txBody>
+          <a:bodyPr wrap="square" lIns="0" tIns="0" rIns="0" bIns="0" rtlCol="0" anchor="ctr"/>
+          <a:lstStyle/>
+          <a:p>
+            <a:pPr algn="l" indent="0" marL="0">
+              <a:lnSpc>
+                <a:spcPct val="115000"/>
+              </a:lnSpc>
+              <a:buNone/>
+            </a:pPr>
+            <a:r>
+              <a:rPr lang="en-US" sz="800" dirty="0">
+                <a:solidFill>
+                  <a:srgbClr val="4D4D4D"/>
+                </a:solidFill>
+                <a:latin typeface="Meiryo" pitchFamily="34" charset="0"/>
+                <a:ea typeface="Meiryo" pitchFamily="34" charset="-122"/>
+                <a:cs typeface="Meiryo" pitchFamily="34" charset="-120"/>
+              </a:rPr>
+              <a:t>警告</a:t>
+            </a:r>
+            <a:endParaRPr lang="en-US" sz="800" dirty="0"/>
+          </a:p>
+        </p:txBody>
+      </p:sp>
+      <p:sp>
+        <p:nvSpPr>
+          <p:cNvPr id="39" name="Text 36"/>
+          <p:cNvSpPr txBox="1"/>
+          <p:nvPr/>
+        </p:nvSpPr>
+        <p:spPr>
+          <a:xfrm>
+            <a:off x="2048256" y="3246120"/>
+            <a:ext cx="2468880" cy="228600"/>
+          </a:xfrm>
+          <a:prstGeom prst="rect">
+            <a:avLst/>
+          </a:prstGeom>
+          <a:noFill/>
+          <a:ln/>
+        </p:spPr>
+        <p:txBody>
+          <a:bodyPr wrap="square" lIns="0" tIns="0" rIns="0" bIns="0" rtlCol="0" anchor="ctr"/>
+          <a:lstStyle/>
+          <a:p>
+            <a:pPr algn="l" indent="0" marL="0">
+              <a:lnSpc>
+                <a:spcPct val="115000"/>
+              </a:lnSpc>
+              <a:buNone/>
+            </a:pPr>
+            <a:r>
+              <a:rPr lang="en-US" sz="800" dirty="0">
+                <a:solidFill>
+                  <a:srgbClr val="1A1A1A"/>
+                </a:solidFill>
+                <a:latin typeface="Meiryo" pitchFamily="34" charset="0"/>
+                <a:ea typeface="Meiryo" pitchFamily="34" charset="-122"/>
+                <a:cs typeface="Meiryo" pitchFamily="34" charset="-120"/>
+              </a:rPr>
+              <a:t>手順書を開くと過去の事故・ヒヤリ地点を表示</a:t>
+            </a:r>
+            <a:endParaRPr lang="en-US" sz="800" dirty="0"/>
+          </a:p>
+        </p:txBody>
+      </p:sp>
+      <p:sp>
+        <p:nvSpPr>
+          <p:cNvPr id="40" name="Text 37"/>
+          <p:cNvSpPr txBox="1"/>
+          <p:nvPr/>
+        </p:nvSpPr>
+        <p:spPr>
+          <a:xfrm>
+            <a:off x="4517136" y="3246120"/>
+            <a:ext cx="384048" cy="228600"/>
+          </a:xfrm>
+          <a:prstGeom prst="rect">
+            <a:avLst/>
+          </a:prstGeom>
+          <a:noFill/>
+          <a:ln/>
+        </p:spPr>
+        <p:txBody>
+          <a:bodyPr wrap="square" lIns="0" tIns="0" rIns="0" bIns="0" rtlCol="0" anchor="ctr"/>
+          <a:lstStyle/>
+          <a:p>
+            <a:pPr algn="r" indent="0" marL="0">
+              <a:lnSpc>
+                <a:spcPct val="115000"/>
+              </a:lnSpc>
+              <a:buNone/>
+            </a:pPr>
+            <a:r>
+              <a:rPr lang="en-US" sz="800" dirty="0">
+                <a:solidFill>
+                  <a:srgbClr val="1A1A1A"/>
+                </a:solidFill>
+                <a:latin typeface="Meiryo" pitchFamily="34" charset="0"/>
+                <a:ea typeface="Meiryo" pitchFamily="34" charset="-122"/>
+                <a:cs typeface="Meiryo" pitchFamily="34" charset="-120"/>
+              </a:rPr>
+              <a:t>製品</a:t>
+            </a:r>
+            <a:endParaRPr lang="en-US" sz="800" dirty="0"/>
+          </a:p>
+        </p:txBody>
+      </p:sp>
+      <p:sp>
+        <p:nvSpPr>
+          <p:cNvPr id="41" name="Shape 38"/>
           <p:cNvSpPr/>
           <p:nvPr/>
         </p:nvSpPr>
         <p:spPr>
           <a:xfrm>
-            <a:off x="4572000" y="3749040"/>
-            <a:ext cx="4206240" cy="0"/>
+            <a:off x="365760" y="3474720"/>
+            <a:ext cx="4572000" cy="0"/>
           </a:xfrm>
           <a:prstGeom prst="line">
             <a:avLst/>
@@ -6604,14 +6805,14 @@
       </p:sp>
       <p:sp>
         <p:nvSpPr>
-          <p:cNvPr id="38" name="Text 35"/>
+          <p:cNvPr id="42" name="Text 39"/>
           <p:cNvSpPr txBox="1"/>
           <p:nvPr/>
         </p:nvSpPr>
         <p:spPr>
           <a:xfrm>
-            <a:off x="4572000" y="3749040"/>
-            <a:ext cx="502920" cy="219456"/>
+            <a:off x="402336" y="3474720"/>
+            <a:ext cx="420624" cy="228600"/>
           </a:xfrm>
           <a:prstGeom prst="rect">
             <a:avLst/>
@@ -6630,7 +6831,7 @@
               <a:buNone/>
             </a:pPr>
             <a:r>
-              <a:rPr lang="en-US" sz="850" dirty="0">
+              <a:rPr lang="en-US" sz="800" dirty="0">
                 <a:solidFill>
                   <a:srgbClr val="4D4D4D"/>
                 </a:solidFill>
@@ -6638,7 +6839,49 @@
                 <a:ea typeface="Meiryo" pitchFamily="34" charset="-122"/>
                 <a:cs typeface="Meiryo" pitchFamily="34" charset="-120"/>
               </a:rPr>
-              <a:t>3年目</a:t>
+              <a:t>4年目</a:t>
+            </a:r>
+            <a:endParaRPr lang="en-US" sz="800" dirty="0"/>
+          </a:p>
+        </p:txBody>
+      </p:sp>
+      <p:sp>
+        <p:nvSpPr>
+          <p:cNvPr id="43" name="Text 40"/>
+          <p:cNvSpPr txBox="1"/>
+          <p:nvPr/>
+        </p:nvSpPr>
+        <p:spPr>
+          <a:xfrm>
+            <a:off x="822960" y="3474720"/>
+            <a:ext cx="621792" cy="228600"/>
+          </a:xfrm>
+          <a:prstGeom prst="rect">
+            <a:avLst/>
+          </a:prstGeom>
+          <a:noFill/>
+          <a:ln/>
+        </p:spPr>
+        <p:txBody>
+          <a:bodyPr wrap="square" lIns="0" tIns="0" rIns="0" bIns="0" rtlCol="0" anchor="ctr"/>
+          <a:lstStyle/>
+          <a:p>
+            <a:pPr algn="l" indent="0" marL="0">
+              <a:lnSpc>
+                <a:spcPct val="115000"/>
+              </a:lnSpc>
+              <a:buNone/>
+            </a:pPr>
+            <a:r>
+              <a:rPr lang="en-US" sz="850" b="1" dirty="0">
+                <a:solidFill>
+                  <a:srgbClr val="1A1A1A"/>
+                </a:solidFill>
+                <a:latin typeface="Meiryo" pitchFamily="34" charset="0"/>
+                <a:ea typeface="Meiryo" pitchFamily="34" charset="-122"/>
+                <a:cs typeface="Meiryo" pitchFamily="34" charset="-120"/>
+              </a:rPr>
+              <a:t>TWIN</a:t>
             </a:r>
             <a:endParaRPr lang="en-US" sz="850" dirty="0"/>
           </a:p>
@@ -6646,14 +6889,14 @@
       </p:sp>
       <p:sp>
         <p:nvSpPr>
-          <p:cNvPr id="39" name="Text 36"/>
+          <p:cNvPr id="44" name="Text 41"/>
           <p:cNvSpPr txBox="1"/>
           <p:nvPr/>
         </p:nvSpPr>
         <p:spPr>
           <a:xfrm>
-            <a:off x="5074920" y="3749040"/>
-            <a:ext cx="685800" cy="219456"/>
+            <a:off x="1444752" y="3474720"/>
+            <a:ext cx="603504" cy="228600"/>
           </a:xfrm>
           <a:prstGeom prst="rect">
             <a:avLst/>
@@ -6672,7 +6915,49 @@
               <a:buNone/>
             </a:pPr>
             <a:r>
-              <a:rPr lang="en-US" sz="900" b="1" dirty="0">
+              <a:rPr lang="en-US" sz="800" dirty="0">
+                <a:solidFill>
+                  <a:srgbClr val="4D4D4D"/>
+                </a:solidFill>
+                <a:latin typeface="Meiryo" pitchFamily="34" charset="0"/>
+                <a:ea typeface="Meiryo" pitchFamily="34" charset="-122"/>
+                <a:cs typeface="Meiryo" pitchFamily="34" charset="-120"/>
+              </a:rPr>
+              <a:t>3D</a:t>
+            </a:r>
+            <a:endParaRPr lang="en-US" sz="800" dirty="0"/>
+          </a:p>
+        </p:txBody>
+      </p:sp>
+      <p:sp>
+        <p:nvSpPr>
+          <p:cNvPr id="45" name="Text 42"/>
+          <p:cNvSpPr txBox="1"/>
+          <p:nvPr/>
+        </p:nvSpPr>
+        <p:spPr>
+          <a:xfrm>
+            <a:off x="2048256" y="3474720"/>
+            <a:ext cx="2468880" cy="228600"/>
+          </a:xfrm>
+          <a:prstGeom prst="rect">
+            <a:avLst/>
+          </a:prstGeom>
+          <a:noFill/>
+          <a:ln/>
+        </p:spPr>
+        <p:txBody>
+          <a:bodyPr wrap="square" lIns="0" tIns="0" rIns="0" bIns="0" rtlCol="0" anchor="ctr"/>
+          <a:lstStyle/>
+          <a:p>
+            <a:pPr algn="l" indent="0" marL="0">
+              <a:lnSpc>
+                <a:spcPct val="115000"/>
+              </a:lnSpc>
+              <a:buNone/>
+            </a:pPr>
+            <a:r>
+              <a:rPr lang="en-US" sz="800" dirty="0">
                 <a:solidFill>
                   <a:srgbClr val="1A1A1A"/>
                 </a:solidFill>
@@ -6680,22 +6965,22 @@
                 <a:ea typeface="Meiryo" pitchFamily="34" charset="-122"/>
                 <a:cs typeface="Meiryo" pitchFamily="34" charset="-120"/>
               </a:rPr>
-              <a:t>TRACE</a:t>
-            </a:r>
-            <a:endParaRPr lang="en-US" sz="900" dirty="0"/>
-          </a:p>
-        </p:txBody>
-      </p:sp>
-      <p:sp>
-        <p:nvSpPr>
-          <p:cNvPr id="40" name="Text 37"/>
+              <a:t>3D仮想工場でレイアウト・ラインの流れを試算</a:t>
+            </a:r>
+            <a:endParaRPr lang="en-US" sz="800" dirty="0"/>
+          </a:p>
+        </p:txBody>
+      </p:sp>
+      <p:sp>
+        <p:nvSpPr>
+          <p:cNvPr id="46" name="Text 43"/>
           <p:cNvSpPr txBox="1"/>
           <p:nvPr/>
         </p:nvSpPr>
         <p:spPr>
           <a:xfrm>
-            <a:off x="5760720" y="3749040"/>
-            <a:ext cx="3017520" cy="219456"/>
+            <a:off x="4517136" y="3474720"/>
+            <a:ext cx="384048" cy="228600"/>
           </a:xfrm>
           <a:prstGeom prst="rect">
             <a:avLst/>
@@ -6707,14 +6992,14 @@
           <a:bodyPr wrap="square" lIns="0" tIns="0" rIns="0" bIns="0" rtlCol="0" anchor="ctr"/>
           <a:lstStyle/>
           <a:p>
-            <a:pPr algn="l" indent="0" marL="0">
-              <a:lnSpc>
-                <a:spcPct val="115000"/>
-              </a:lnSpc>
-              <a:buNone/>
-            </a:pPr>
-            <a:r>
-              <a:rPr lang="en-US" sz="850" dirty="0">
+            <a:pPr algn="r" indent="0" marL="0">
+              <a:lnSpc>
+                <a:spcPct val="115000"/>
+              </a:lnSpc>
+              <a:buNone/>
+            </a:pPr>
+            <a:r>
+              <a:rPr lang="en-US" sz="800" dirty="0">
                 <a:solidFill>
                   <a:srgbClr val="1A1A1A"/>
                 </a:solidFill>
@@ -6722,22 +7007,22 @@
                 <a:ea typeface="Meiryo" pitchFamily="34" charset="-122"/>
                 <a:cs typeface="Meiryo" pitchFamily="34" charset="-120"/>
               </a:rPr>
-              <a:t>不具合時に、材料ロットから納入先まで追跡</a:t>
-            </a:r>
-            <a:endParaRPr lang="en-US" sz="850" dirty="0"/>
-          </a:p>
-        </p:txBody>
-      </p:sp>
-      <p:sp>
-        <p:nvSpPr>
-          <p:cNvPr id="41" name="Shape 38"/>
+              <a:t>製品</a:t>
+            </a:r>
+            <a:endParaRPr lang="en-US" sz="800" dirty="0"/>
+          </a:p>
+        </p:txBody>
+      </p:sp>
+      <p:sp>
+        <p:nvSpPr>
+          <p:cNvPr id="47" name="Shape 44"/>
           <p:cNvSpPr/>
           <p:nvPr/>
         </p:nvSpPr>
         <p:spPr>
           <a:xfrm>
-            <a:off x="4572000" y="3968496"/>
-            <a:ext cx="4206240" cy="0"/>
+            <a:off x="365760" y="3703320"/>
+            <a:ext cx="4572000" cy="0"/>
           </a:xfrm>
           <a:prstGeom prst="line">
             <a:avLst/>
@@ -6753,14 +7038,14 @@
       </p:sp>
       <p:sp>
         <p:nvSpPr>
-          <p:cNvPr id="42" name="Text 39"/>
+          <p:cNvPr id="48" name="Text 45"/>
           <p:cNvSpPr txBox="1"/>
           <p:nvPr/>
         </p:nvSpPr>
         <p:spPr>
           <a:xfrm>
-            <a:off x="4572000" y="3968496"/>
-            <a:ext cx="502920" cy="219456"/>
+            <a:off x="402336" y="3703320"/>
+            <a:ext cx="420624" cy="228600"/>
           </a:xfrm>
           <a:prstGeom prst="rect">
             <a:avLst/>
@@ -6779,7 +7064,7 @@
               <a:buNone/>
             </a:pPr>
             <a:r>
-              <a:rPr lang="en-US" sz="850" dirty="0">
+              <a:rPr lang="en-US" sz="800" dirty="0">
                 <a:solidFill>
                   <a:srgbClr val="4D4D4D"/>
                 </a:solidFill>
@@ -6787,7 +7072,49 @@
                 <a:ea typeface="Meiryo" pitchFamily="34" charset="-122"/>
                 <a:cs typeface="Meiryo" pitchFamily="34" charset="-120"/>
               </a:rPr>
-              <a:t>4年目</a:t>
+              <a:t>5年目</a:t>
+            </a:r>
+            <a:endParaRPr lang="en-US" sz="800" dirty="0"/>
+          </a:p>
+        </p:txBody>
+      </p:sp>
+      <p:sp>
+        <p:nvSpPr>
+          <p:cNvPr id="49" name="Text 46"/>
+          <p:cNvSpPr txBox="1"/>
+          <p:nvPr/>
+        </p:nvSpPr>
+        <p:spPr>
+          <a:xfrm>
+            <a:off x="822960" y="3703320"/>
+            <a:ext cx="621792" cy="228600"/>
+          </a:xfrm>
+          <a:prstGeom prst="rect">
+            <a:avLst/>
+          </a:prstGeom>
+          <a:noFill/>
+          <a:ln/>
+        </p:spPr>
+        <p:txBody>
+          <a:bodyPr wrap="square" lIns="0" tIns="0" rIns="0" bIns="0" rtlCol="0" anchor="ctr"/>
+          <a:lstStyle/>
+          <a:p>
+            <a:pPr algn="l" indent="0" marL="0">
+              <a:lnSpc>
+                <a:spcPct val="115000"/>
+              </a:lnSpc>
+              <a:buNone/>
+            </a:pPr>
+            <a:r>
+              <a:rPr lang="en-US" sz="850" b="1" dirty="0">
+                <a:solidFill>
+                  <a:srgbClr val="1A1A1A"/>
+                </a:solidFill>
+                <a:latin typeface="Meiryo" pitchFamily="34" charset="0"/>
+                <a:ea typeface="Meiryo" pitchFamily="34" charset="-122"/>
+                <a:cs typeface="Meiryo" pitchFamily="34" charset="-120"/>
+              </a:rPr>
+              <a:t>DRAW</a:t>
             </a:r>
             <a:endParaRPr lang="en-US" sz="850" dirty="0"/>
           </a:p>
@@ -6795,14 +7122,14 @@
       </p:sp>
       <p:sp>
         <p:nvSpPr>
-          <p:cNvPr id="43" name="Text 40"/>
+          <p:cNvPr id="50" name="Text 47"/>
           <p:cNvSpPr txBox="1"/>
           <p:nvPr/>
         </p:nvSpPr>
         <p:spPr>
           <a:xfrm>
-            <a:off x="5074920" y="3968496"/>
-            <a:ext cx="685800" cy="219456"/>
+            <a:off x="1444752" y="3703320"/>
+            <a:ext cx="603504" cy="228600"/>
           </a:xfrm>
           <a:prstGeom prst="rect">
             <a:avLst/>
@@ -6821,7 +7148,49 @@
               <a:buNone/>
             </a:pPr>
             <a:r>
-              <a:rPr lang="en-US" sz="900" b="1" dirty="0">
+              <a:rPr lang="en-US" sz="800" dirty="0">
+                <a:solidFill>
+                  <a:srgbClr val="4D4D4D"/>
+                </a:solidFill>
+                <a:latin typeface="Meiryo" pitchFamily="34" charset="0"/>
+                <a:ea typeface="Meiryo" pitchFamily="34" charset="-122"/>
+                <a:cs typeface="Meiryo" pitchFamily="34" charset="-120"/>
+              </a:rPr>
+              <a:t>図面</a:t>
+            </a:r>
+            <a:endParaRPr lang="en-US" sz="800" dirty="0"/>
+          </a:p>
+        </p:txBody>
+      </p:sp>
+      <p:sp>
+        <p:nvSpPr>
+          <p:cNvPr id="51" name="Text 48"/>
+          <p:cNvSpPr txBox="1"/>
+          <p:nvPr/>
+        </p:nvSpPr>
+        <p:spPr>
+          <a:xfrm>
+            <a:off x="2048256" y="3703320"/>
+            <a:ext cx="2468880" cy="228600"/>
+          </a:xfrm>
+          <a:prstGeom prst="rect">
+            <a:avLst/>
+          </a:prstGeom>
+          <a:noFill/>
+          <a:ln/>
+        </p:spPr>
+        <p:txBody>
+          <a:bodyPr wrap="square" lIns="0" tIns="0" rIns="0" bIns="0" rtlCol="0" anchor="ctr"/>
+          <a:lstStyle/>
+          <a:p>
+            <a:pPr algn="l" indent="0" marL="0">
+              <a:lnSpc>
+                <a:spcPct val="115000"/>
+              </a:lnSpc>
+              <a:buNone/>
+            </a:pPr>
+            <a:r>
+              <a:rPr lang="en-US" sz="800" dirty="0">
                 <a:solidFill>
                   <a:srgbClr val="1A1A1A"/>
                 </a:solidFill>
@@ -6829,22 +7198,22 @@
                 <a:ea typeface="Meiryo" pitchFamily="34" charset="-122"/>
                 <a:cs typeface="Meiryo" pitchFamily="34" charset="-120"/>
               </a:rPr>
-              <a:t>TWIN</a:t>
-            </a:r>
-            <a:endParaRPr lang="en-US" sz="900" dirty="0"/>
-          </a:p>
-        </p:txBody>
-      </p:sp>
-      <p:sp>
-        <p:nvSpPr>
-          <p:cNvPr id="44" name="Text 41"/>
+              <a:t>登録したパターンを音声指示でCAD作図</a:t>
+            </a:r>
+            <a:endParaRPr lang="en-US" sz="800" dirty="0"/>
+          </a:p>
+        </p:txBody>
+      </p:sp>
+      <p:sp>
+        <p:nvSpPr>
+          <p:cNvPr id="52" name="Text 49"/>
           <p:cNvSpPr txBox="1"/>
           <p:nvPr/>
         </p:nvSpPr>
         <p:spPr>
           <a:xfrm>
-            <a:off x="5760720" y="3968496"/>
-            <a:ext cx="3017520" cy="219456"/>
+            <a:off x="4517136" y="3703320"/>
+            <a:ext cx="384048" cy="228600"/>
           </a:xfrm>
           <a:prstGeom prst="rect">
             <a:avLst/>
@@ -6856,14 +7225,14 @@
           <a:bodyPr wrap="square" lIns="0" tIns="0" rIns="0" bIns="0" rtlCol="0" anchor="ctr"/>
           <a:lstStyle/>
           <a:p>
-            <a:pPr algn="l" indent="0" marL="0">
-              <a:lnSpc>
-                <a:spcPct val="115000"/>
-              </a:lnSpc>
-              <a:buNone/>
-            </a:pPr>
-            <a:r>
-              <a:rPr lang="en-US" sz="850" dirty="0">
+            <a:pPr algn="r" indent="0" marL="0">
+              <a:lnSpc>
+                <a:spcPct val="115000"/>
+              </a:lnSpc>
+              <a:buNone/>
+            </a:pPr>
+            <a:r>
+              <a:rPr lang="en-US" sz="800" dirty="0">
                 <a:solidFill>
                   <a:srgbClr val="1A1A1A"/>
                 </a:solidFill>
@@ -6871,22 +7240,42 @@
                 <a:ea typeface="Meiryo" pitchFamily="34" charset="-122"/>
                 <a:cs typeface="Meiryo" pitchFamily="34" charset="-120"/>
               </a:rPr>
-              <a:t>欠員・設備停止時の計画組み替えを試算</a:t>
-            </a:r>
-            <a:endParaRPr lang="en-US" sz="850" dirty="0"/>
-          </a:p>
-        </p:txBody>
-      </p:sp>
-      <p:sp>
-        <p:nvSpPr>
-          <p:cNvPr id="45" name="Shape 42"/>
+              <a:t>製品</a:t>
+            </a:r>
+            <a:endParaRPr lang="en-US" sz="800" dirty="0"/>
+          </a:p>
+        </p:txBody>
+      </p:sp>
+      <p:sp>
+        <p:nvSpPr>
+          <p:cNvPr id="53" name="Shape 50"/>
           <p:cNvSpPr/>
           <p:nvPr/>
         </p:nvSpPr>
         <p:spPr>
           <a:xfrm>
-            <a:off x="4572000" y="4187952"/>
-            <a:ext cx="4206240" cy="0"/>
+            <a:off x="365760" y="3931920"/>
+            <a:ext cx="4572000" cy="228600"/>
+          </a:xfrm>
+          <a:prstGeom prst="rect">
+            <a:avLst/>
+          </a:prstGeom>
+          <a:solidFill>
+            <a:srgbClr val="F2F2F2"/>
+          </a:solidFill>
+          <a:ln/>
+        </p:spPr>
+      </p:sp>
+      <p:sp>
+        <p:nvSpPr>
+          <p:cNvPr id="54" name="Shape 51"/>
+          <p:cNvSpPr/>
+          <p:nvPr/>
+        </p:nvSpPr>
+        <p:spPr>
+          <a:xfrm>
+            <a:off x="365760" y="3931920"/>
+            <a:ext cx="4572000" cy="0"/>
           </a:xfrm>
           <a:prstGeom prst="line">
             <a:avLst/>
@@ -6902,14 +7291,14 @@
       </p:sp>
       <p:sp>
         <p:nvSpPr>
-          <p:cNvPr id="46" name="Text 43"/>
+          <p:cNvPr id="55" name="Text 52"/>
           <p:cNvSpPr txBox="1"/>
           <p:nvPr/>
         </p:nvSpPr>
         <p:spPr>
           <a:xfrm>
-            <a:off x="4572000" y="4187952"/>
-            <a:ext cx="502920" cy="219456"/>
+            <a:off x="402336" y="3931920"/>
+            <a:ext cx="420624" cy="228600"/>
           </a:xfrm>
           <a:prstGeom prst="rect">
             <a:avLst/>
@@ -6928,7 +7317,7 @@
               <a:buNone/>
             </a:pPr>
             <a:r>
-              <a:rPr lang="en-US" sz="850" dirty="0">
+              <a:rPr lang="en-US" sz="800" dirty="0">
                 <a:solidFill>
                   <a:srgbClr val="4D4D4D"/>
                 </a:solidFill>
@@ -6936,7 +7325,49 @@
                 <a:ea typeface="Meiryo" pitchFamily="34" charset="-122"/>
                 <a:cs typeface="Meiryo" pitchFamily="34" charset="-120"/>
               </a:rPr>
-              <a:t>5年目</a:t>
+              <a:t>研究</a:t>
+            </a:r>
+            <a:endParaRPr lang="en-US" sz="800" dirty="0"/>
+          </a:p>
+        </p:txBody>
+      </p:sp>
+      <p:sp>
+        <p:nvSpPr>
+          <p:cNvPr id="56" name="Text 53"/>
+          <p:cNvSpPr txBox="1"/>
+          <p:nvPr/>
+        </p:nvSpPr>
+        <p:spPr>
+          <a:xfrm>
+            <a:off x="822960" y="3931920"/>
+            <a:ext cx="621792" cy="228600"/>
+          </a:xfrm>
+          <a:prstGeom prst="rect">
+            <a:avLst/>
+          </a:prstGeom>
+          <a:noFill/>
+          <a:ln/>
+        </p:spPr>
+        <p:txBody>
+          <a:bodyPr wrap="square" lIns="0" tIns="0" rIns="0" bIns="0" rtlCol="0" anchor="ctr"/>
+          <a:lstStyle/>
+          <a:p>
+            <a:pPr algn="l" indent="0" marL="0">
+              <a:lnSpc>
+                <a:spcPct val="115000"/>
+              </a:lnSpc>
+              <a:buNone/>
+            </a:pPr>
+            <a:r>
+              <a:rPr lang="en-US" sz="850" b="1" dirty="0">
+                <a:solidFill>
+                  <a:srgbClr val="1A1A1A"/>
+                </a:solidFill>
+                <a:latin typeface="Meiryo" pitchFamily="34" charset="0"/>
+                <a:ea typeface="Meiryo" pitchFamily="34" charset="-122"/>
+                <a:cs typeface="Meiryo" pitchFamily="34" charset="-120"/>
+              </a:rPr>
+              <a:t>HAPTIC</a:t>
             </a:r>
             <a:endParaRPr lang="en-US" sz="850" dirty="0"/>
           </a:p>
@@ -6944,14 +7375,14 @@
       </p:sp>
       <p:sp>
         <p:nvSpPr>
-          <p:cNvPr id="47" name="Text 44"/>
+          <p:cNvPr id="57" name="Text 54"/>
           <p:cNvSpPr txBox="1"/>
           <p:nvPr/>
         </p:nvSpPr>
         <p:spPr>
           <a:xfrm>
-            <a:off x="5074920" y="4187952"/>
-            <a:ext cx="685800" cy="219456"/>
+            <a:off x="1444752" y="3931920"/>
+            <a:ext cx="603504" cy="228600"/>
           </a:xfrm>
           <a:prstGeom prst="rect">
             <a:avLst/>
@@ -6970,7 +7401,49 @@
               <a:buNone/>
             </a:pPr>
             <a:r>
-              <a:rPr lang="en-US" sz="900" b="1" dirty="0">
+              <a:rPr lang="en-US" sz="800" dirty="0">
+                <a:solidFill>
+                  <a:srgbClr val="4D4D4D"/>
+                </a:solidFill>
+                <a:latin typeface="Meiryo" pitchFamily="34" charset="0"/>
+                <a:ea typeface="Meiryo" pitchFamily="34" charset="-122"/>
+                <a:cs typeface="Meiryo" pitchFamily="34" charset="-120"/>
+              </a:rPr>
+              <a:t>触覚</a:t>
+            </a:r>
+            <a:endParaRPr lang="en-US" sz="800" dirty="0"/>
+          </a:p>
+        </p:txBody>
+      </p:sp>
+      <p:sp>
+        <p:nvSpPr>
+          <p:cNvPr id="58" name="Text 55"/>
+          <p:cNvSpPr txBox="1"/>
+          <p:nvPr/>
+        </p:nvSpPr>
+        <p:spPr>
+          <a:xfrm>
+            <a:off x="2048256" y="3931920"/>
+            <a:ext cx="2468880" cy="228600"/>
+          </a:xfrm>
+          <a:prstGeom prst="rect">
+            <a:avLst/>
+          </a:prstGeom>
+          <a:noFill/>
+          <a:ln/>
+        </p:spPr>
+        <p:txBody>
+          <a:bodyPr wrap="square" lIns="0" tIns="0" rIns="0" bIns="0" rtlCol="0" anchor="ctr"/>
+          <a:lstStyle/>
+          <a:p>
+            <a:pPr algn="l" indent="0" marL="0">
+              <a:lnSpc>
+                <a:spcPct val="115000"/>
+              </a:lnSpc>
+              <a:buNone/>
+            </a:pPr>
+            <a:r>
+              <a:rPr lang="en-US" sz="800" dirty="0">
                 <a:solidFill>
                   <a:srgbClr val="1A1A1A"/>
                 </a:solidFill>
@@ -6978,22 +7451,22 @@
                 <a:ea typeface="Meiryo" pitchFamily="34" charset="-122"/>
                 <a:cs typeface="Meiryo" pitchFamily="34" charset="-120"/>
               </a:rPr>
-              <a:t>FLOW</a:t>
-            </a:r>
-            <a:endParaRPr lang="en-US" sz="900" dirty="0"/>
-          </a:p>
-        </p:txBody>
-      </p:sp>
-      <p:sp>
-        <p:nvSpPr>
-          <p:cNvPr id="48" name="Text 45"/>
+              <a:t>力加減を体験できる訓練シミュレーター</a:t>
+            </a:r>
+            <a:endParaRPr lang="en-US" sz="800" dirty="0"/>
+          </a:p>
+        </p:txBody>
+      </p:sp>
+      <p:sp>
+        <p:nvSpPr>
+          <p:cNvPr id="59" name="Text 56"/>
           <p:cNvSpPr txBox="1"/>
           <p:nvPr/>
         </p:nvSpPr>
         <p:spPr>
           <a:xfrm>
-            <a:off x="5760720" y="4187952"/>
-            <a:ext cx="3017520" cy="219456"/>
+            <a:off x="4517136" y="3931920"/>
+            <a:ext cx="384048" cy="228600"/>
           </a:xfrm>
           <a:prstGeom prst="rect">
             <a:avLst/>
@@ -7005,14 +7478,14 @@
           <a:bodyPr wrap="square" lIns="0" tIns="0" rIns="0" bIns="0" rtlCol="0" anchor="ctr"/>
           <a:lstStyle/>
           <a:p>
-            <a:pPr algn="l" indent="0" marL="0">
-              <a:lnSpc>
-                <a:spcPct val="115000"/>
-              </a:lnSpc>
-              <a:buNone/>
-            </a:pPr>
-            <a:r>
-              <a:rPr lang="en-US" sz="850" dirty="0">
+            <a:pPr algn="r" indent="0" marL="0">
+              <a:lnSpc>
+                <a:spcPct val="115000"/>
+              </a:lnSpc>
+              <a:buNone/>
+            </a:pPr>
+            <a:r>
+              <a:rPr lang="en-US" sz="800" b="1" dirty="0">
                 <a:solidFill>
                   <a:srgbClr val="1A1A1A"/>
                 </a:solidFill>
@@ -7020,22 +7493,42 @@
                 <a:ea typeface="Meiryo" pitchFamily="34" charset="-122"/>
                 <a:cs typeface="Meiryo" pitchFamily="34" charset="-120"/>
               </a:rPr>
-              <a:t>搬送ロボット・検査AIと連携</a:t>
-            </a:r>
-            <a:endParaRPr lang="en-US" sz="850" dirty="0"/>
-          </a:p>
-        </p:txBody>
-      </p:sp>
-      <p:sp>
-        <p:nvSpPr>
-          <p:cNvPr id="49" name="Shape 46"/>
+              <a:t>R&amp;D</a:t>
+            </a:r>
+            <a:endParaRPr lang="en-US" sz="800" dirty="0"/>
+          </a:p>
+        </p:txBody>
+      </p:sp>
+      <p:sp>
+        <p:nvSpPr>
+          <p:cNvPr id="60" name="Shape 57"/>
           <p:cNvSpPr/>
           <p:nvPr/>
         </p:nvSpPr>
         <p:spPr>
           <a:xfrm>
-            <a:off x="4572000" y="4407408"/>
-            <a:ext cx="4206240" cy="0"/>
+            <a:off x="365760" y="4160520"/>
+            <a:ext cx="4572000" cy="228600"/>
+          </a:xfrm>
+          <a:prstGeom prst="rect">
+            <a:avLst/>
+          </a:prstGeom>
+          <a:solidFill>
+            <a:srgbClr val="F2F2F2"/>
+          </a:solidFill>
+          <a:ln/>
+        </p:spPr>
+      </p:sp>
+      <p:sp>
+        <p:nvSpPr>
+          <p:cNvPr id="61" name="Shape 58"/>
+          <p:cNvSpPr/>
+          <p:nvPr/>
+        </p:nvSpPr>
+        <p:spPr>
+          <a:xfrm>
+            <a:off x="365760" y="4160520"/>
+            <a:ext cx="4572000" cy="0"/>
           </a:xfrm>
           <a:prstGeom prst="line">
             <a:avLst/>
@@ -7051,13 +7544,606 @@
       </p:sp>
       <p:sp>
         <p:nvSpPr>
-          <p:cNvPr id="50" name="Text 47"/>
+          <p:cNvPr id="62" name="Text 59"/>
           <p:cNvSpPr txBox="1"/>
           <p:nvPr/>
         </p:nvSpPr>
         <p:spPr>
           <a:xfrm>
-            <a:off x="365760" y="4498848"/>
+            <a:off x="402336" y="4160520"/>
+            <a:ext cx="420624" cy="228600"/>
+          </a:xfrm>
+          <a:prstGeom prst="rect">
+            <a:avLst/>
+          </a:prstGeom>
+          <a:noFill/>
+          <a:ln/>
+        </p:spPr>
+        <p:txBody>
+          <a:bodyPr wrap="square" lIns="0" tIns="0" rIns="0" bIns="0" rtlCol="0" anchor="ctr"/>
+          <a:lstStyle/>
+          <a:p>
+            <a:pPr algn="l" indent="0" marL="0">
+              <a:lnSpc>
+                <a:spcPct val="115000"/>
+              </a:lnSpc>
+              <a:buNone/>
+            </a:pPr>
+            <a:r>
+              <a:rPr lang="en-US" sz="800" dirty="0">
+                <a:solidFill>
+                  <a:srgbClr val="4D4D4D"/>
+                </a:solidFill>
+                <a:latin typeface="Meiryo" pitchFamily="34" charset="0"/>
+                <a:ea typeface="Meiryo" pitchFamily="34" charset="-122"/>
+                <a:cs typeface="Meiryo" pitchFamily="34" charset="-120"/>
+              </a:rPr>
+              <a:t>研究</a:t>
+            </a:r>
+            <a:endParaRPr lang="en-US" sz="800" dirty="0"/>
+          </a:p>
+        </p:txBody>
+      </p:sp>
+      <p:sp>
+        <p:nvSpPr>
+          <p:cNvPr id="63" name="Text 60"/>
+          <p:cNvSpPr txBox="1"/>
+          <p:nvPr/>
+        </p:nvSpPr>
+        <p:spPr>
+          <a:xfrm>
+            <a:off x="822960" y="4160520"/>
+            <a:ext cx="621792" cy="228600"/>
+          </a:xfrm>
+          <a:prstGeom prst="rect">
+            <a:avLst/>
+          </a:prstGeom>
+          <a:noFill/>
+          <a:ln/>
+        </p:spPr>
+        <p:txBody>
+          <a:bodyPr wrap="square" lIns="0" tIns="0" rIns="0" bIns="0" rtlCol="0" anchor="ctr"/>
+          <a:lstStyle/>
+          <a:p>
+            <a:pPr algn="l" indent="0" marL="0">
+              <a:lnSpc>
+                <a:spcPct val="115000"/>
+              </a:lnSpc>
+              <a:buNone/>
+            </a:pPr>
+            <a:r>
+              <a:rPr lang="en-US" sz="850" b="1" dirty="0">
+                <a:solidFill>
+                  <a:srgbClr val="1A1A1A"/>
+                </a:solidFill>
+                <a:latin typeface="Meiryo" pitchFamily="34" charset="0"/>
+                <a:ea typeface="Meiryo" pitchFamily="34" charset="-122"/>
+                <a:cs typeface="Meiryo" pitchFamily="34" charset="-120"/>
+              </a:rPr>
+              <a:t>FLOW</a:t>
+            </a:r>
+            <a:endParaRPr lang="en-US" sz="850" dirty="0"/>
+          </a:p>
+        </p:txBody>
+      </p:sp>
+      <p:sp>
+        <p:nvSpPr>
+          <p:cNvPr id="64" name="Text 61"/>
+          <p:cNvSpPr txBox="1"/>
+          <p:nvPr/>
+        </p:nvSpPr>
+        <p:spPr>
+          <a:xfrm>
+            <a:off x="1444752" y="4160520"/>
+            <a:ext cx="603504" cy="228600"/>
+          </a:xfrm>
+          <a:prstGeom prst="rect">
+            <a:avLst/>
+          </a:prstGeom>
+          <a:noFill/>
+          <a:ln/>
+        </p:spPr>
+        <p:txBody>
+          <a:bodyPr wrap="square" lIns="0" tIns="0" rIns="0" bIns="0" rtlCol="0" anchor="ctr"/>
+          <a:lstStyle/>
+          <a:p>
+            <a:pPr algn="l" indent="0" marL="0">
+              <a:lnSpc>
+                <a:spcPct val="115000"/>
+              </a:lnSpc>
+              <a:buNone/>
+            </a:pPr>
+            <a:r>
+              <a:rPr lang="en-US" sz="800" dirty="0">
+                <a:solidFill>
+                  <a:srgbClr val="4D4D4D"/>
+                </a:solidFill>
+                <a:latin typeface="Meiryo" pitchFamily="34" charset="0"/>
+                <a:ea typeface="Meiryo" pitchFamily="34" charset="-122"/>
+                <a:cs typeface="Meiryo" pitchFamily="34" charset="-120"/>
+              </a:rPr>
+              <a:t>機械</a:t>
+            </a:r>
+            <a:endParaRPr lang="en-US" sz="800" dirty="0"/>
+          </a:p>
+        </p:txBody>
+      </p:sp>
+      <p:sp>
+        <p:nvSpPr>
+          <p:cNvPr id="65" name="Text 62"/>
+          <p:cNvSpPr txBox="1"/>
+          <p:nvPr/>
+        </p:nvSpPr>
+        <p:spPr>
+          <a:xfrm>
+            <a:off x="2048256" y="4160520"/>
+            <a:ext cx="2468880" cy="228600"/>
+          </a:xfrm>
+          <a:prstGeom prst="rect">
+            <a:avLst/>
+          </a:prstGeom>
+          <a:noFill/>
+          <a:ln/>
+        </p:spPr>
+        <p:txBody>
+          <a:bodyPr wrap="square" lIns="0" tIns="0" rIns="0" bIns="0" rtlCol="0" anchor="ctr"/>
+          <a:lstStyle/>
+          <a:p>
+            <a:pPr algn="l" indent="0" marL="0">
+              <a:lnSpc>
+                <a:spcPct val="115000"/>
+              </a:lnSpc>
+              <a:buNone/>
+            </a:pPr>
+            <a:r>
+              <a:rPr lang="en-US" sz="800" dirty="0">
+                <a:solidFill>
+                  <a:srgbClr val="1A1A1A"/>
+                </a:solidFill>
+                <a:latin typeface="Meiryo" pitchFamily="34" charset="0"/>
+                <a:ea typeface="Meiryo" pitchFamily="34" charset="-122"/>
+                <a:cs typeface="Meiryo" pitchFamily="34" charset="-120"/>
+              </a:rPr>
+              <a:t>搬送ロボット・検査AIへ条件を直接渡す</a:t>
+            </a:r>
+            <a:endParaRPr lang="en-US" sz="800" dirty="0"/>
+          </a:p>
+        </p:txBody>
+      </p:sp>
+      <p:sp>
+        <p:nvSpPr>
+          <p:cNvPr id="66" name="Text 63"/>
+          <p:cNvSpPr txBox="1"/>
+          <p:nvPr/>
+        </p:nvSpPr>
+        <p:spPr>
+          <a:xfrm>
+            <a:off x="4517136" y="4160520"/>
+            <a:ext cx="384048" cy="228600"/>
+          </a:xfrm>
+          <a:prstGeom prst="rect">
+            <a:avLst/>
+          </a:prstGeom>
+          <a:noFill/>
+          <a:ln/>
+        </p:spPr>
+        <p:txBody>
+          <a:bodyPr wrap="square" lIns="0" tIns="0" rIns="0" bIns="0" rtlCol="0" anchor="ctr"/>
+          <a:lstStyle/>
+          <a:p>
+            <a:pPr algn="r" indent="0" marL="0">
+              <a:lnSpc>
+                <a:spcPct val="115000"/>
+              </a:lnSpc>
+              <a:buNone/>
+            </a:pPr>
+            <a:r>
+              <a:rPr lang="en-US" sz="800" b="1" dirty="0">
+                <a:solidFill>
+                  <a:srgbClr val="1A1A1A"/>
+                </a:solidFill>
+                <a:latin typeface="Meiryo" pitchFamily="34" charset="0"/>
+                <a:ea typeface="Meiryo" pitchFamily="34" charset="-122"/>
+                <a:cs typeface="Meiryo" pitchFamily="34" charset="-120"/>
+              </a:rPr>
+              <a:t>R&amp;D</a:t>
+            </a:r>
+            <a:endParaRPr lang="en-US" sz="800" dirty="0"/>
+          </a:p>
+        </p:txBody>
+      </p:sp>
+      <p:sp>
+        <p:nvSpPr>
+          <p:cNvPr id="67" name="Shape 64"/>
+          <p:cNvSpPr/>
+          <p:nvPr/>
+        </p:nvSpPr>
+        <p:spPr>
+          <a:xfrm>
+            <a:off x="365760" y="4389120"/>
+            <a:ext cx="4572000" cy="0"/>
+          </a:xfrm>
+          <a:prstGeom prst="line">
+            <a:avLst/>
+          </a:prstGeom>
+          <a:noFill/>
+          <a:ln w="9525">
+            <a:solidFill>
+              <a:srgbClr val="BFBFBF"/>
+            </a:solidFill>
+            <a:prstDash val="solid"/>
+          </a:ln>
+        </p:spPr>
+      </p:sp>
+      <p:sp>
+        <p:nvSpPr>
+          <p:cNvPr id="68" name="rnd"/>
+          <p:cNvSpPr/>
+          <p:nvPr/>
+        </p:nvSpPr>
+        <p:spPr>
+          <a:xfrm>
+            <a:off x="5120640" y="2542032"/>
+            <a:ext cx="3657600" cy="1207008"/>
+          </a:xfrm>
+          <a:prstGeom prst="rect">
+            <a:avLst/>
+          </a:prstGeom>
+          <a:solidFill>
+            <a:srgbClr val="1A1A1A"/>
+          </a:solidFill>
+          <a:ln/>
+        </p:spPr>
+      </p:sp>
+      <p:sp>
+        <p:nvSpPr>
+          <p:cNvPr id="69" name="Text 66"/>
+          <p:cNvSpPr txBox="1"/>
+          <p:nvPr/>
+        </p:nvSpPr>
+        <p:spPr>
+          <a:xfrm>
+            <a:off x="5230368" y="2587752"/>
+            <a:ext cx="3438144" cy="237744"/>
+          </a:xfrm>
+          <a:prstGeom prst="rect">
+            <a:avLst/>
+          </a:prstGeom>
+          <a:noFill/>
+          <a:ln/>
+        </p:spPr>
+        <p:txBody>
+          <a:bodyPr wrap="square" lIns="0" tIns="0" rIns="0" bIns="0" rtlCol="0" anchor="t"/>
+          <a:lstStyle/>
+          <a:p>
+            <a:pPr algn="l" indent="0" marL="0">
+              <a:lnSpc>
+                <a:spcPct val="115000"/>
+              </a:lnSpc>
+              <a:buNone/>
+            </a:pPr>
+            <a:r>
+              <a:rPr lang="en-US" sz="1050" b="1" dirty="0">
+                <a:solidFill>
+                  <a:srgbClr val="FFFFFF"/>
+                </a:solidFill>
+                <a:latin typeface="Meiryo" pitchFamily="34" charset="0"/>
+                <a:ea typeface="Meiryo" pitchFamily="34" charset="-122"/>
+                <a:cs typeface="Meiryo" pitchFamily="34" charset="-120"/>
+              </a:rPr>
+              <a:t>R&amp;D戦略（技術開発）</a:t>
+            </a:r>
+            <a:endParaRPr lang="en-US" sz="1050" dirty="0"/>
+          </a:p>
+        </p:txBody>
+      </p:sp>
+      <p:sp>
+        <p:nvSpPr>
+          <p:cNvPr id="70" name="Text 67"/>
+          <p:cNvSpPr txBox="1"/>
+          <p:nvPr/>
+        </p:nvSpPr>
+        <p:spPr>
+          <a:xfrm>
+            <a:off x="5230368" y="2834640"/>
+            <a:ext cx="3438144" cy="896112"/>
+          </a:xfrm>
+          <a:prstGeom prst="rect">
+            <a:avLst/>
+          </a:prstGeom>
+          <a:noFill/>
+          <a:ln/>
+        </p:spPr>
+        <p:txBody>
+          <a:bodyPr wrap="square" lIns="0" tIns="0" rIns="0" bIns="0" rtlCol="0" anchor="t"/>
+          <a:lstStyle/>
+          <a:p>
+            <a:pPr algn="l" indent="0" marL="0">
+              <a:lnSpc>
+                <a:spcPct val="115000"/>
+              </a:lnSpc>
+              <a:spcAft>
+                <a:spcPts val="100"/>
+              </a:spcAft>
+              <a:buNone/>
+            </a:pPr>
+            <a:r>
+              <a:rPr lang="en-US" sz="850" b="1" dirty="0">
+                <a:solidFill>
+                  <a:srgbClr val="FFFFFF"/>
+                </a:solidFill>
+                <a:latin typeface="Meiryo" pitchFamily="34" charset="0"/>
+                <a:ea typeface="Meiryo" pitchFamily="34" charset="-122"/>
+                <a:cs typeface="Meiryo" pitchFamily="34" charset="-120"/>
+              </a:rPr>
+              <a:t>作る：</a:t>
+            </a:r>
+            <a:pPr algn="l" indent="0" marL="0">
+              <a:lnSpc>
+                <a:spcPct val="115000"/>
+              </a:lnSpc>
+              <a:spcAft>
+                <a:spcPts val="100"/>
+              </a:spcAft>
+              <a:buNone/>
+            </a:pPr>
+            <a:r>
+              <a:rPr lang="en-US" sz="850" dirty="0">
+                <a:solidFill>
+                  <a:srgbClr val="FFFFFF"/>
+                </a:solidFill>
+                <a:latin typeface="Meiryo" pitchFamily="34" charset="0"/>
+                <a:ea typeface="Meiryo" pitchFamily="34" charset="-122"/>
+                <a:cs typeface="Meiryo" pitchFamily="34" charset="-120"/>
+              </a:rPr>
+              <a:t>記録の構造化（生成AI）と、渡し方の設計</a:t>
+            </a:r>
+            <a:endParaRPr lang="en-US" sz="850" dirty="0"/>
+          </a:p>
+          <a:p>
+            <a:pPr algn="l" indent="0" marL="0">
+              <a:lnSpc>
+                <a:spcPct val="115000"/>
+              </a:lnSpc>
+              <a:spcAft>
+                <a:spcPts val="100"/>
+              </a:spcAft>
+              <a:buNone/>
+            </a:pPr>
+            <a:r>
+              <a:rPr lang="en-US" sz="850" b="1" dirty="0">
+                <a:solidFill>
+                  <a:srgbClr val="FFFFFF"/>
+                </a:solidFill>
+                <a:latin typeface="Meiryo" pitchFamily="34" charset="0"/>
+                <a:ea typeface="Meiryo" pitchFamily="34" charset="-122"/>
+                <a:cs typeface="Meiryo" pitchFamily="34" charset="-120"/>
+              </a:rPr>
+              <a:t>組む：</a:t>
+            </a:r>
+            <a:pPr algn="l" indent="0" marL="0">
+              <a:lnSpc>
+                <a:spcPct val="115000"/>
+              </a:lnSpc>
+              <a:spcAft>
+                <a:spcPts val="100"/>
+              </a:spcAft>
+              <a:buNone/>
+            </a:pPr>
+            <a:r>
+              <a:rPr lang="en-US" sz="850" dirty="0">
+                <a:solidFill>
+                  <a:srgbClr val="FFFFFF"/>
+                </a:solidFill>
+                <a:latin typeface="Meiryo" pitchFamily="34" charset="0"/>
+                <a:ea typeface="Meiryo" pitchFamily="34" charset="-122"/>
+                <a:cs typeface="Meiryo" pitchFamily="34" charset="-120"/>
+              </a:rPr>
+              <a:t>CAD・3D・触覚デバイスはベンダー・大学と共同研究</a:t>
+            </a:r>
+            <a:endParaRPr lang="en-US" sz="850" dirty="0"/>
+          </a:p>
+          <a:p>
+            <a:pPr algn="l" indent="0" marL="0">
+              <a:lnSpc>
+                <a:spcPct val="115000"/>
+              </a:lnSpc>
+              <a:spcAft>
+                <a:spcPts val="100"/>
+              </a:spcAft>
+              <a:buNone/>
+            </a:pPr>
+            <a:r>
+              <a:rPr lang="en-US" sz="850" b="1" dirty="0">
+                <a:solidFill>
+                  <a:srgbClr val="FFFFFF"/>
+                </a:solidFill>
+                <a:latin typeface="Meiryo" pitchFamily="34" charset="0"/>
+                <a:ea typeface="Meiryo" pitchFamily="34" charset="-122"/>
+                <a:cs typeface="Meiryo" pitchFamily="34" charset="-120"/>
+              </a:rPr>
+              <a:t>試す：</a:t>
+            </a:r>
+            <a:pPr algn="l" indent="0" marL="0">
+              <a:lnSpc>
+                <a:spcPct val="115000"/>
+              </a:lnSpc>
+              <a:spcAft>
+                <a:spcPts val="100"/>
+              </a:spcAft>
+              <a:buNone/>
+            </a:pPr>
+            <a:r>
+              <a:rPr lang="en-US" sz="850" dirty="0">
+                <a:solidFill>
+                  <a:srgbClr val="FFFFFF"/>
+                </a:solidFill>
+                <a:latin typeface="Meiryo" pitchFamily="34" charset="0"/>
+                <a:ea typeface="Meiryo" pitchFamily="34" charset="-122"/>
+                <a:cs typeface="Meiryo" pitchFamily="34" charset="-120"/>
+              </a:rPr>
+              <a:t>CVC出資元の工場を実証の場にする</a:t>
+            </a:r>
+            <a:endParaRPr lang="en-US" sz="850" dirty="0"/>
+          </a:p>
+          <a:p>
+            <a:pPr algn="l" indent="0" marL="0">
+              <a:lnSpc>
+                <a:spcPct val="115000"/>
+              </a:lnSpc>
+              <a:spcAft>
+                <a:spcPts val="100"/>
+              </a:spcAft>
+              <a:buNone/>
+            </a:pPr>
+            <a:r>
+              <a:rPr lang="en-US" sz="850" b="1" dirty="0">
+                <a:solidFill>
+                  <a:srgbClr val="FFFFFF"/>
+                </a:solidFill>
+                <a:latin typeface="Meiryo" pitchFamily="34" charset="0"/>
+                <a:ea typeface="Meiryo" pitchFamily="34" charset="-122"/>
+                <a:cs typeface="Meiryo" pitchFamily="34" charset="-120"/>
+              </a:rPr>
+              <a:t>試作済み：</a:t>
+            </a:r>
+            <a:pPr algn="l" indent="0" marL="0">
+              <a:lnSpc>
+                <a:spcPct val="115000"/>
+              </a:lnSpc>
+              <a:spcAft>
+                <a:spcPts val="100"/>
+              </a:spcAft>
+              <a:buNone/>
+            </a:pPr>
+            <a:r>
+              <a:rPr lang="en-US" sz="850" dirty="0">
+                <a:solidFill>
+                  <a:srgbClr val="FFFFFF"/>
+                </a:solidFill>
+                <a:latin typeface="Meiryo" pitchFamily="34" charset="0"/>
+                <a:ea typeface="Meiryo" pitchFamily="34" charset="-122"/>
+                <a:cs typeface="Meiryo" pitchFamily="34" charset="-120"/>
+              </a:rPr>
+              <a:t>ニュース要約→音声合成→ポッドキャスト自動配信を個人で実装</a:t>
+            </a:r>
+            <a:endParaRPr lang="en-US" sz="850" dirty="0"/>
+          </a:p>
+        </p:txBody>
+      </p:sp>
+      <p:sp>
+        <p:nvSpPr>
+          <p:cNvPr id="71" name="onboarding"/>
+          <p:cNvSpPr/>
+          <p:nvPr/>
+        </p:nvSpPr>
+        <p:spPr>
+          <a:xfrm>
+            <a:off x="5120640" y="3840480"/>
+            <a:ext cx="3657600" cy="658368"/>
+          </a:xfrm>
+          <a:prstGeom prst="rect">
+            <a:avLst/>
+          </a:prstGeom>
+          <a:solidFill>
+            <a:srgbClr val="F2F2F2"/>
+          </a:solidFill>
+          <a:ln/>
+        </p:spPr>
+      </p:sp>
+      <p:sp>
+        <p:nvSpPr>
+          <p:cNvPr id="72" name="Text 69"/>
+          <p:cNvSpPr txBox="1"/>
+          <p:nvPr/>
+        </p:nvSpPr>
+        <p:spPr>
+          <a:xfrm>
+            <a:off x="5230368" y="3877056"/>
+            <a:ext cx="3438144" cy="237744"/>
+          </a:xfrm>
+          <a:prstGeom prst="rect">
+            <a:avLst/>
+          </a:prstGeom>
+          <a:noFill/>
+          <a:ln/>
+        </p:spPr>
+        <p:txBody>
+          <a:bodyPr wrap="square" lIns="0" tIns="0" rIns="0" bIns="0" rtlCol="0" anchor="t"/>
+          <a:lstStyle/>
+          <a:p>
+            <a:pPr algn="l" indent="0" marL="0">
+              <a:lnSpc>
+                <a:spcPct val="115000"/>
+              </a:lnSpc>
+              <a:buNone/>
+            </a:pPr>
+            <a:r>
+              <a:rPr lang="en-US" sz="1000" b="1" dirty="0">
+                <a:solidFill>
+                  <a:srgbClr val="1A1A1A"/>
+                </a:solidFill>
+                <a:latin typeface="Meiryo" pitchFamily="34" charset="0"/>
+                <a:ea typeface="Meiryo" pitchFamily="34" charset="-122"/>
+                <a:cs typeface="Meiryo" pitchFamily="34" charset="-120"/>
+              </a:rPr>
+              <a:t>道具以外：導入支援（初年度・約2か月）</a:t>
+            </a:r>
+            <a:endParaRPr lang="en-US" sz="1000" dirty="0"/>
+          </a:p>
+        </p:txBody>
+      </p:sp>
+      <p:sp>
+        <p:nvSpPr>
+          <p:cNvPr id="73" name="Text 70"/>
+          <p:cNvSpPr txBox="1"/>
+          <p:nvPr/>
+        </p:nvSpPr>
+        <p:spPr>
+          <a:xfrm>
+            <a:off x="5230368" y="4114800"/>
+            <a:ext cx="3438144" cy="365760"/>
+          </a:xfrm>
+          <a:prstGeom prst="rect">
+            <a:avLst/>
+          </a:prstGeom>
+          <a:noFill/>
+          <a:ln/>
+        </p:spPr>
+        <p:txBody>
+          <a:bodyPr wrap="square" lIns="0" tIns="0" rIns="0" bIns="0" rtlCol="0" anchor="t"/>
+          <a:lstStyle/>
+          <a:p>
+            <a:pPr algn="l" indent="0" marL="0">
+              <a:lnSpc>
+                <a:spcPct val="115000"/>
+              </a:lnSpc>
+              <a:buNone/>
+            </a:pPr>
+            <a:r>
+              <a:rPr lang="en-US" sz="850" dirty="0">
+                <a:solidFill>
+                  <a:srgbClr val="1A1A1A"/>
+                </a:solidFill>
+                <a:latin typeface="Meiryo" pitchFamily="34" charset="0"/>
+                <a:ea typeface="Meiryo" pitchFamily="34" charset="-122"/>
+                <a:cs typeface="Meiryo" pitchFamily="34" charset="-120"/>
+              </a:rPr>
+              <a:t>当社の担当者が現場に入り、熟練者への聞き取り・帳票の移行・現場研修まで行う</a:t>
+            </a:r>
+            <a:endParaRPr lang="en-US" sz="850" dirty="0"/>
+          </a:p>
+        </p:txBody>
+      </p:sp>
+      <p:sp>
+        <p:nvSpPr>
+          <p:cNvPr id="74" name="Text 71"/>
+          <p:cNvSpPr txBox="1"/>
+          <p:nvPr/>
+        </p:nvSpPr>
+        <p:spPr>
+          <a:xfrm>
+            <a:off x="365760" y="4517136"/>
             <a:ext cx="8412480" cy="274320"/>
           </a:xfrm>
           <a:prstGeom prst="rect">
@@ -7085,7 +8171,7 @@
                 <a:ea typeface="Meiryo" pitchFamily="34" charset="-122"/>
                 <a:cs typeface="Meiryo" pitchFamily="34" charset="-120"/>
               </a:rPr>
-              <a:t>対象：電線・ケーブル工場の生産技術・製造部門（のちに、その製品を施工する工事会社）</a:t>
+              <a:t>対象：電線・ケーブル工場の生産技術・製造部門（のちに、その製品を施工する工事会社）。R&amp;D行はエンジニア2→9名の範囲で進め、製品化前の売上は計画に含めない</a:t>
             </a:r>
             <a:endParaRPr lang="en-US" sz="800" dirty="0"/>
           </a:p>
@@ -8302,7 +9388,7 @@
                 <a:ea typeface="Meiryo" pitchFamily="34" charset="-122"/>
                 <a:cs typeface="Meiryo" pitchFamily="34" charset="-120"/>
               </a:rPr>
-              <a:t>KNACK・TRACEなど、選んだ機能の数に比例</a:t>
+              <a:t>教材制作（KNACK）・危険表示（SAFE）など、選んだ数に比例</a:t>
             </a:r>
             <a:endParaRPr lang="en-US" sz="900" dirty="0"/>
           </a:p>
@@ -9879,7 +10965,7 @@
                 <a:ea typeface="Meiryo" pitchFamily="34" charset="-122"/>
                 <a:cs typeface="Meiryo" pitchFamily="34" charset="-120"/>
               </a:rPr>
-              <a:t>実績はMES・ERP、動作はロボットに任せ、判断の理由を人と機械に渡す層</a:t>
+              <a:t>実績はMES・ERPに任せ、判断の理由を教材と仕組みにして渡す層</a:t>
             </a:r>
             <a:endParaRPr lang="en-US" sz="850" dirty="0"/>
           </a:p>

</xml_diff>

<commit_message>
Rework competition slide around in-house precedents
Retitle slide 5 to say that companies which systematized experts'
judgment in-house are rare, and back it with public precedents
(Daikin x Hitachi, Sumitomo Rubber x NEC, Lion x NTT Data, Hitachi
Omika, Kawasaki Heavy x NTT Data): all large firms with large SIers,
none public in power infrastructure. STP now targets mid-sized cable
plants. Sources and the full precedent table go in the supplementary
note.

Co-Authored-By: Claude Opus 5.5 <noreply@anthropic.com>
Claude-Session: https://claude.ai/code/session_01Lvjvqoc8h4yHt4F4M6n1V9
</commit_message>
<xml_diff>
--- a/deck/セルフマネジメント課題_事業構想プレゼン.pptx
+++ b/deck/セルフマネジメント課題_事業構想プレゼン.pptx
@@ -2405,8 +2405,8 @@
             <a:r>
               <a:rPr lang="en-US" dirty="0"/>
               <a:t>【4:40 - 5:50】
-要約：判断の理由を仕組みで扱う会社は、まだない
-最初に自分で自分に突きつけた問いが三つありました。コンサルと何が違うのか、MESや大手SIerと何が違うのか、ロボットやAIが来たら人の判断は要らなくなるのではないか、です。左の図は、横軸が扱う情報、つまり何が起きたかという実績か、なぜそうしたかという判断の理由か。縦軸が、人の時間で提供するか、仕組みで提供するかです。MESやロボットは実績と動作を仕組みで扱います。コンサルや社内の熟練者は判断の理由を扱いますが、人に依存します。判断の理由を仕組みで扱う右上は、まだ空いています。ここを、熟練者の判断が品質を左右する電線・ケーブル工場に絞って取ります。大手が採算に乗せにくい専門領域に集中する、ニッチャーの戦い方です。弱みとして、製造現場の経験が浅いことと、営業・資金調達が未経験であることを正直に挙げています。</a:t>
+要約：判断の理由を内製で仕組み化した事業会社は希少。大手だけで、電力インフラでは公開事例が見当たらない
+最初に自分で自分に突きつけた問いが三つありました。コンサルと何が違うのか、MESや大手SIerと何が違うのか、そして、すでに自社で同じことをしている会社があるのではないか、です。三つ目について調べると、先行事例はあります。ダイキンと日立のろう付け技能のデジタル化、ライオンとNTTデータの勘所集の生成AI検索、日立の大みか事業所でのトラブル事例検索などです。ただし共通点があり、いずれも大手が大手SIerと組んだ個別開発です。中堅の工場には、その予算も人手も届きません。そして、電線・送配電・電気工事といった電力インフラの分野では、公開された事例は見当たりませんでした。私の勤務先でも、スマートグラスでの技術伝承は構想の段階です。左の図の右上、判断の理由を仕組みで扱う場所には、大手の内製しかいません。当社は、大手が内製で行っていることを、教材の制作まで含めたサービスとして中堅の電線工場に届けます。ニッチャーとして差別化集中で戦います。弱みは、製造現場の経験が浅いことと、営業・資金調達が未経験であることです。</a:t>
             </a:r>
             <a:endParaRPr lang="en-US" dirty="0"/>
           </a:p>
@@ -9958,7 +9958,7 @@
                 <a:ea typeface="Meiryo" pitchFamily="34" charset="-122"/>
                 <a:cs typeface="Meiryo" pitchFamily="34" charset="-120"/>
               </a:rPr>
-              <a:t>競合 ─ 判断の理由を仕組みで扱う会社は、まだない</a:t>
+              <a:t>競合 ─ 判断の理由を内製で仕組み化した事業会社は、希少</a:t>
             </a:r>
             <a:endParaRPr lang="en-US" sz="2000" dirty="0"/>
           </a:p>
@@ -10000,7 +10000,7 @@
                 <a:ea typeface="Meiryo" pitchFamily="34" charset="-122"/>
                 <a:cs typeface="Meiryo" pitchFamily="34" charset="-120"/>
               </a:rPr>
-              <a:t>空いている右上を、電線工場に絞って取る（ニッチャー・差別化集中）</a:t>
+              <a:t>製造業では大手がSIerと組んで始めたが、電力インフラ（電線・送配電・電気工事）では公開事例が見当たらない</a:t>
             </a:r>
             <a:endParaRPr lang="en-US" sz="1200" dirty="0"/>
           </a:p>
@@ -10552,13 +10552,147 @@
       </p:sp>
       <p:sp>
         <p:nvSpPr>
-          <p:cNvPr id="21" name="pos-三現ワークス"/>
+          <p:cNvPr id="21" name="pos-大手の内製（＋大手SIer）"/>
           <p:cNvSpPr/>
           <p:nvPr/>
         </p:nvSpPr>
         <p:spPr>
           <a:xfrm>
-            <a:off x="3511296" y="1828800"/>
+            <a:off x="2880360" y="2251253"/>
+            <a:ext cx="146304" cy="146304"/>
+          </a:xfrm>
+          <a:prstGeom prst="ellipse">
+            <a:avLst/>
+          </a:prstGeom>
+          <a:solidFill>
+            <a:srgbClr val="FFFFFF"/>
+          </a:solidFill>
+          <a:ln w="15875">
+            <a:solidFill>
+              <a:srgbClr val="1A1A1A"/>
+            </a:solidFill>
+            <a:prstDash val="solid"/>
+          </a:ln>
+        </p:spPr>
+      </p:sp>
+      <p:sp>
+        <p:nvSpPr>
+          <p:cNvPr id="22" name="Text 19"/>
+          <p:cNvSpPr txBox="1"/>
+          <p:nvPr/>
+        </p:nvSpPr>
+        <p:spPr>
+          <a:xfrm>
+            <a:off x="3072384" y="2214677"/>
+            <a:ext cx="1463040" cy="219456"/>
+          </a:xfrm>
+          <a:prstGeom prst="rect">
+            <a:avLst/>
+          </a:prstGeom>
+          <a:noFill/>
+          <a:ln/>
+        </p:spPr>
+        <p:txBody>
+          <a:bodyPr wrap="square" lIns="0" tIns="0" rIns="0" bIns="0" rtlCol="0" anchor="ctr"/>
+          <a:lstStyle/>
+          <a:p>
+            <a:pPr algn="l" indent="0" marL="0">
+              <a:lnSpc>
+                <a:spcPct val="115000"/>
+              </a:lnSpc>
+              <a:buNone/>
+            </a:pPr>
+            <a:r>
+              <a:rPr lang="en-US" sz="850" dirty="0">
+                <a:solidFill>
+                  <a:srgbClr val="1A1A1A"/>
+                </a:solidFill>
+                <a:latin typeface="Meiryo" pitchFamily="34" charset="0"/>
+                <a:ea typeface="Meiryo" pitchFamily="34" charset="-122"/>
+                <a:cs typeface="Meiryo" pitchFamily="34" charset="-120"/>
+              </a:rPr>
+              <a:t>大手の内製（＋大手SIer）</a:t>
+            </a:r>
+            <a:endParaRPr lang="en-US" sz="850" dirty="0"/>
+          </a:p>
+        </p:txBody>
+      </p:sp>
+      <p:sp>
+        <p:nvSpPr>
+          <p:cNvPr id="23" name="pos-動画マニュアルSaaS"/>
+          <p:cNvSpPr/>
+          <p:nvPr/>
+        </p:nvSpPr>
+        <p:spPr>
+          <a:xfrm>
+            <a:off x="2295144" y="1485900"/>
+            <a:ext cx="146304" cy="146304"/>
+          </a:xfrm>
+          <a:prstGeom prst="ellipse">
+            <a:avLst/>
+          </a:prstGeom>
+          <a:solidFill>
+            <a:srgbClr val="FFFFFF"/>
+          </a:solidFill>
+          <a:ln w="15875">
+            <a:solidFill>
+              <a:srgbClr val="1A1A1A"/>
+            </a:solidFill>
+            <a:prstDash val="solid"/>
+          </a:ln>
+        </p:spPr>
+      </p:sp>
+      <p:sp>
+        <p:nvSpPr>
+          <p:cNvPr id="24" name="Text 21"/>
+          <p:cNvSpPr txBox="1"/>
+          <p:nvPr/>
+        </p:nvSpPr>
+        <p:spPr>
+          <a:xfrm>
+            <a:off x="786384" y="1449324"/>
+            <a:ext cx="1463040" cy="219456"/>
+          </a:xfrm>
+          <a:prstGeom prst="rect">
+            <a:avLst/>
+          </a:prstGeom>
+          <a:noFill/>
+          <a:ln/>
+        </p:spPr>
+        <p:txBody>
+          <a:bodyPr wrap="square" lIns="0" tIns="0" rIns="0" bIns="0" rtlCol="0" anchor="ctr"/>
+          <a:lstStyle/>
+          <a:p>
+            <a:pPr algn="r" indent="0" marL="0">
+              <a:lnSpc>
+                <a:spcPct val="115000"/>
+              </a:lnSpc>
+              <a:buNone/>
+            </a:pPr>
+            <a:r>
+              <a:rPr lang="en-US" sz="850" dirty="0">
+                <a:solidFill>
+                  <a:srgbClr val="1A1A1A"/>
+                </a:solidFill>
+                <a:latin typeface="Meiryo" pitchFamily="34" charset="0"/>
+                <a:ea typeface="Meiryo" pitchFamily="34" charset="-122"/>
+                <a:cs typeface="Meiryo" pitchFamily="34" charset="-120"/>
+              </a:rPr>
+              <a:t>動画マニュアルSaaS</a:t>
+            </a:r>
+            <a:endParaRPr lang="en-US" sz="850" dirty="0"/>
+          </a:p>
+        </p:txBody>
+      </p:sp>
+      <p:sp>
+        <p:nvSpPr>
+          <p:cNvPr id="25" name="pos-三現ワークス"/>
+          <p:cNvSpPr/>
+          <p:nvPr/>
+        </p:nvSpPr>
+        <p:spPr>
+          <a:xfrm>
+            <a:off x="3511296" y="1730045"/>
             <a:ext cx="201168" cy="201168"/>
           </a:xfrm>
           <a:prstGeom prst="ellipse">
@@ -10577,13 +10711,13 @@
       </p:sp>
       <p:sp>
         <p:nvSpPr>
-          <p:cNvPr id="22" name="Text 19"/>
+          <p:cNvPr id="26" name="Text 23"/>
           <p:cNvSpPr txBox="1"/>
           <p:nvPr/>
         </p:nvSpPr>
         <p:spPr>
           <a:xfrm>
-            <a:off x="2002536" y="1819656"/>
+            <a:off x="2002536" y="1720901"/>
             <a:ext cx="1463040" cy="219456"/>
           </a:xfrm>
           <a:prstGeom prst="rect">
@@ -10619,7 +10753,7 @@
       </p:sp>
       <p:sp>
         <p:nvSpPr>
-          <p:cNvPr id="23" name="Text 20"/>
+          <p:cNvPr id="27" name="Text 24"/>
           <p:cNvSpPr txBox="1"/>
           <p:nvPr/>
         </p:nvSpPr>
@@ -10653,7 +10787,7 @@
                 <a:ea typeface="Meiryo" pitchFamily="34" charset="-122"/>
                 <a:cs typeface="Meiryo" pitchFamily="34" charset="-120"/>
               </a:rPr>
-              <a:t>STP</a:t>
+              <a:t>内製化の先行事例（公開情報）</a:t>
             </a:r>
             <a:endParaRPr lang="en-US" sz="1050" dirty="0"/>
           </a:p>
@@ -10661,14 +10795,782 @@
       </p:sp>
       <p:sp>
         <p:nvSpPr>
-          <p:cNvPr id="24" name="Shape 21"/>
+          <p:cNvPr id="28" name="Shape 25"/>
           <p:cNvSpPr/>
           <p:nvPr/>
         </p:nvSpPr>
         <p:spPr>
           <a:xfrm>
-            <a:off x="4617720" y="1335024"/>
-            <a:ext cx="274320" cy="274320"/>
+            <a:off x="4617720" y="1307592"/>
+            <a:ext cx="4160520" cy="0"/>
+          </a:xfrm>
+          <a:prstGeom prst="line">
+            <a:avLst/>
+          </a:prstGeom>
+          <a:noFill/>
+          <a:ln w="9525">
+            <a:solidFill>
+              <a:srgbClr val="BFBFBF"/>
+            </a:solidFill>
+            <a:prstDash val="solid"/>
+          </a:ln>
+        </p:spPr>
+      </p:sp>
+      <p:sp>
+        <p:nvSpPr>
+          <p:cNvPr id="29" name="Text 26"/>
+          <p:cNvSpPr txBox="1"/>
+          <p:nvPr/>
+        </p:nvSpPr>
+        <p:spPr>
+          <a:xfrm>
+            <a:off x="4617720" y="1307592"/>
+            <a:ext cx="1325880" cy="228600"/>
+          </a:xfrm>
+          <a:prstGeom prst="rect">
+            <a:avLst/>
+          </a:prstGeom>
+          <a:noFill/>
+          <a:ln/>
+        </p:spPr>
+        <p:txBody>
+          <a:bodyPr wrap="square" lIns="0" tIns="0" rIns="0" bIns="0" rtlCol="0" anchor="ctr"/>
+          <a:lstStyle/>
+          <a:p>
+            <a:pPr algn="l" indent="0" marL="0">
+              <a:lnSpc>
+                <a:spcPct val="115000"/>
+              </a:lnSpc>
+              <a:buNone/>
+            </a:pPr>
+            <a:r>
+              <a:rPr lang="en-US" sz="850" b="1" dirty="0">
+                <a:solidFill>
+                  <a:srgbClr val="1A1A1A"/>
+                </a:solidFill>
+                <a:latin typeface="Meiryo" pitchFamily="34" charset="0"/>
+                <a:ea typeface="Meiryo" pitchFamily="34" charset="-122"/>
+                <a:cs typeface="Meiryo" pitchFamily="34" charset="-120"/>
+              </a:rPr>
+              <a:t>ダイキン×日立</a:t>
+            </a:r>
+            <a:endParaRPr lang="en-US" sz="850" dirty="0"/>
+          </a:p>
+        </p:txBody>
+      </p:sp>
+      <p:sp>
+        <p:nvSpPr>
+          <p:cNvPr id="30" name="Text 27"/>
+          <p:cNvSpPr txBox="1"/>
+          <p:nvPr/>
+        </p:nvSpPr>
+        <p:spPr>
+          <a:xfrm>
+            <a:off x="5943600" y="1307592"/>
+            <a:ext cx="2468880" cy="228600"/>
+          </a:xfrm>
+          <a:prstGeom prst="rect">
+            <a:avLst/>
+          </a:prstGeom>
+          <a:noFill/>
+          <a:ln/>
+        </p:spPr>
+        <p:txBody>
+          <a:bodyPr wrap="square" lIns="0" tIns="0" rIns="0" bIns="0" rtlCol="0" anchor="ctr"/>
+          <a:lstStyle/>
+          <a:p>
+            <a:pPr algn="l" indent="0" marL="0">
+              <a:lnSpc>
+                <a:spcPct val="115000"/>
+              </a:lnSpc>
+              <a:buNone/>
+            </a:pPr>
+            <a:r>
+              <a:rPr lang="en-US" sz="800" dirty="0">
+                <a:solidFill>
+                  <a:srgbClr val="1A1A1A"/>
+                </a:solidFill>
+                <a:latin typeface="Meiryo" pitchFamily="34" charset="0"/>
+                <a:ea typeface="Meiryo" pitchFamily="34" charset="-122"/>
+                <a:cs typeface="Meiryo" pitchFamily="34" charset="-120"/>
+              </a:rPr>
+              <a:t>ろう付け技能をIoT・画像解析でデジタル化</a:t>
+            </a:r>
+            <a:endParaRPr lang="en-US" sz="800" dirty="0"/>
+          </a:p>
+        </p:txBody>
+      </p:sp>
+      <p:sp>
+        <p:nvSpPr>
+          <p:cNvPr id="31" name="Text 28"/>
+          <p:cNvSpPr txBox="1"/>
+          <p:nvPr/>
+        </p:nvSpPr>
+        <p:spPr>
+          <a:xfrm>
+            <a:off x="8412480" y="1307592"/>
+            <a:ext cx="365760" cy="228600"/>
+          </a:xfrm>
+          <a:prstGeom prst="rect">
+            <a:avLst/>
+          </a:prstGeom>
+          <a:noFill/>
+          <a:ln/>
+        </p:spPr>
+        <p:txBody>
+          <a:bodyPr wrap="square" lIns="0" tIns="0" rIns="0" bIns="0" rtlCol="0" anchor="ctr"/>
+          <a:lstStyle/>
+          <a:p>
+            <a:pPr algn="r" indent="0" marL="0">
+              <a:lnSpc>
+                <a:spcPct val="115000"/>
+              </a:lnSpc>
+              <a:buNone/>
+            </a:pPr>
+            <a:r>
+              <a:rPr lang="en-US" sz="800" dirty="0">
+                <a:solidFill>
+                  <a:srgbClr val="4D4D4D"/>
+                </a:solidFill>
+                <a:latin typeface="Meiryo" pitchFamily="34" charset="0"/>
+                <a:ea typeface="Meiryo" pitchFamily="34" charset="-122"/>
+                <a:cs typeface="Meiryo" pitchFamily="34" charset="-120"/>
+              </a:rPr>
+              <a:t>2017</a:t>
+            </a:r>
+            <a:endParaRPr lang="en-US" sz="800" dirty="0"/>
+          </a:p>
+        </p:txBody>
+      </p:sp>
+      <p:sp>
+        <p:nvSpPr>
+          <p:cNvPr id="32" name="Shape 29"/>
+          <p:cNvSpPr/>
+          <p:nvPr/>
+        </p:nvSpPr>
+        <p:spPr>
+          <a:xfrm>
+            <a:off x="4617720" y="1536192"/>
+            <a:ext cx="4160520" cy="0"/>
+          </a:xfrm>
+          <a:prstGeom prst="line">
+            <a:avLst/>
+          </a:prstGeom>
+          <a:noFill/>
+          <a:ln w="9525">
+            <a:solidFill>
+              <a:srgbClr val="BFBFBF"/>
+            </a:solidFill>
+            <a:prstDash val="solid"/>
+          </a:ln>
+        </p:spPr>
+      </p:sp>
+      <p:sp>
+        <p:nvSpPr>
+          <p:cNvPr id="33" name="Text 30"/>
+          <p:cNvSpPr txBox="1"/>
+          <p:nvPr/>
+        </p:nvSpPr>
+        <p:spPr>
+          <a:xfrm>
+            <a:off x="4617720" y="1536192"/>
+            <a:ext cx="1325880" cy="228600"/>
+          </a:xfrm>
+          <a:prstGeom prst="rect">
+            <a:avLst/>
+          </a:prstGeom>
+          <a:noFill/>
+          <a:ln/>
+        </p:spPr>
+        <p:txBody>
+          <a:bodyPr wrap="square" lIns="0" tIns="0" rIns="0" bIns="0" rtlCol="0" anchor="ctr"/>
+          <a:lstStyle/>
+          <a:p>
+            <a:pPr algn="l" indent="0" marL="0">
+              <a:lnSpc>
+                <a:spcPct val="115000"/>
+              </a:lnSpc>
+              <a:buNone/>
+            </a:pPr>
+            <a:r>
+              <a:rPr lang="en-US" sz="850" b="1" dirty="0">
+                <a:solidFill>
+                  <a:srgbClr val="1A1A1A"/>
+                </a:solidFill>
+                <a:latin typeface="Meiryo" pitchFamily="34" charset="0"/>
+                <a:ea typeface="Meiryo" pitchFamily="34" charset="-122"/>
+                <a:cs typeface="Meiryo" pitchFamily="34" charset="-120"/>
+              </a:rPr>
+              <a:t>住友ゴム×NEC</a:t>
+            </a:r>
+            <a:endParaRPr lang="en-US" sz="850" dirty="0"/>
+          </a:p>
+        </p:txBody>
+      </p:sp>
+      <p:sp>
+        <p:nvSpPr>
+          <p:cNvPr id="34" name="Text 31"/>
+          <p:cNvSpPr txBox="1"/>
+          <p:nvPr/>
+        </p:nvSpPr>
+        <p:spPr>
+          <a:xfrm>
+            <a:off x="5943600" y="1536192"/>
+            <a:ext cx="2468880" cy="228600"/>
+          </a:xfrm>
+          <a:prstGeom prst="rect">
+            <a:avLst/>
+          </a:prstGeom>
+          <a:noFill/>
+          <a:ln/>
+        </p:spPr>
+        <p:txBody>
+          <a:bodyPr wrap="square" lIns="0" tIns="0" rIns="0" bIns="0" rtlCol="0" anchor="ctr"/>
+          <a:lstStyle/>
+          <a:p>
+            <a:pPr algn="l" indent="0" marL="0">
+              <a:lnSpc>
+                <a:spcPct val="115000"/>
+              </a:lnSpc>
+              <a:buNone/>
+            </a:pPr>
+            <a:r>
+              <a:rPr lang="en-US" sz="800" dirty="0">
+                <a:solidFill>
+                  <a:srgbClr val="1A1A1A"/>
+                </a:solidFill>
+                <a:latin typeface="Meiryo" pitchFamily="34" charset="0"/>
+                <a:ea typeface="Meiryo" pitchFamily="34" charset="-122"/>
+                <a:cs typeface="Meiryo" pitchFamily="34" charset="-120"/>
+              </a:rPr>
+              <a:t>タイヤ設計の熟練者ノウハウをAI化</a:t>
+            </a:r>
+            <a:endParaRPr lang="en-US" sz="800" dirty="0"/>
+          </a:p>
+        </p:txBody>
+      </p:sp>
+      <p:sp>
+        <p:nvSpPr>
+          <p:cNvPr id="35" name="Text 32"/>
+          <p:cNvSpPr txBox="1"/>
+          <p:nvPr/>
+        </p:nvSpPr>
+        <p:spPr>
+          <a:xfrm>
+            <a:off x="8412480" y="1536192"/>
+            <a:ext cx="365760" cy="228600"/>
+          </a:xfrm>
+          <a:prstGeom prst="rect">
+            <a:avLst/>
+          </a:prstGeom>
+          <a:noFill/>
+          <a:ln/>
+        </p:spPr>
+        <p:txBody>
+          <a:bodyPr wrap="square" lIns="0" tIns="0" rIns="0" bIns="0" rtlCol="0" anchor="ctr"/>
+          <a:lstStyle/>
+          <a:p>
+            <a:pPr algn="r" indent="0" marL="0">
+              <a:lnSpc>
+                <a:spcPct val="115000"/>
+              </a:lnSpc>
+              <a:buNone/>
+            </a:pPr>
+            <a:r>
+              <a:rPr lang="en-US" sz="800" dirty="0">
+                <a:solidFill>
+                  <a:srgbClr val="4D4D4D"/>
+                </a:solidFill>
+                <a:latin typeface="Meiryo" pitchFamily="34" charset="0"/>
+                <a:ea typeface="Meiryo" pitchFamily="34" charset="-122"/>
+                <a:cs typeface="Meiryo" pitchFamily="34" charset="-120"/>
+              </a:rPr>
+              <a:t>2022</a:t>
+            </a:r>
+            <a:endParaRPr lang="en-US" sz="800" dirty="0"/>
+          </a:p>
+        </p:txBody>
+      </p:sp>
+      <p:sp>
+        <p:nvSpPr>
+          <p:cNvPr id="36" name="Shape 33"/>
+          <p:cNvSpPr/>
+          <p:nvPr/>
+        </p:nvSpPr>
+        <p:spPr>
+          <a:xfrm>
+            <a:off x="4617720" y="1764792"/>
+            <a:ext cx="4160520" cy="0"/>
+          </a:xfrm>
+          <a:prstGeom prst="line">
+            <a:avLst/>
+          </a:prstGeom>
+          <a:noFill/>
+          <a:ln w="9525">
+            <a:solidFill>
+              <a:srgbClr val="BFBFBF"/>
+            </a:solidFill>
+            <a:prstDash val="solid"/>
+          </a:ln>
+        </p:spPr>
+      </p:sp>
+      <p:sp>
+        <p:nvSpPr>
+          <p:cNvPr id="37" name="Text 34"/>
+          <p:cNvSpPr txBox="1"/>
+          <p:nvPr/>
+        </p:nvSpPr>
+        <p:spPr>
+          <a:xfrm>
+            <a:off x="4617720" y="1764792"/>
+            <a:ext cx="1325880" cy="228600"/>
+          </a:xfrm>
+          <a:prstGeom prst="rect">
+            <a:avLst/>
+          </a:prstGeom>
+          <a:noFill/>
+          <a:ln/>
+        </p:spPr>
+        <p:txBody>
+          <a:bodyPr wrap="square" lIns="0" tIns="0" rIns="0" bIns="0" rtlCol="0" anchor="ctr"/>
+          <a:lstStyle/>
+          <a:p>
+            <a:pPr algn="l" indent="0" marL="0">
+              <a:lnSpc>
+                <a:spcPct val="115000"/>
+              </a:lnSpc>
+              <a:buNone/>
+            </a:pPr>
+            <a:r>
+              <a:rPr lang="en-US" sz="850" b="1" dirty="0">
+                <a:solidFill>
+                  <a:srgbClr val="1A1A1A"/>
+                </a:solidFill>
+                <a:latin typeface="Meiryo" pitchFamily="34" charset="0"/>
+                <a:ea typeface="Meiryo" pitchFamily="34" charset="-122"/>
+                <a:cs typeface="Meiryo" pitchFamily="34" charset="-120"/>
+              </a:rPr>
+              <a:t>ライオン×NTTデータ</a:t>
+            </a:r>
+            <a:endParaRPr lang="en-US" sz="850" dirty="0"/>
+          </a:p>
+        </p:txBody>
+      </p:sp>
+      <p:sp>
+        <p:nvSpPr>
+          <p:cNvPr id="38" name="Text 35"/>
+          <p:cNvSpPr txBox="1"/>
+          <p:nvPr/>
+        </p:nvSpPr>
+        <p:spPr>
+          <a:xfrm>
+            <a:off x="5943600" y="1764792"/>
+            <a:ext cx="2468880" cy="228600"/>
+          </a:xfrm>
+          <a:prstGeom prst="rect">
+            <a:avLst/>
+          </a:prstGeom>
+          <a:noFill/>
+          <a:ln/>
+        </p:spPr>
+        <p:txBody>
+          <a:bodyPr wrap="square" lIns="0" tIns="0" rIns="0" bIns="0" rtlCol="0" anchor="ctr"/>
+          <a:lstStyle/>
+          <a:p>
+            <a:pPr algn="l" indent="0" marL="0">
+              <a:lnSpc>
+                <a:spcPct val="115000"/>
+              </a:lnSpc>
+              <a:buNone/>
+            </a:pPr>
+            <a:r>
+              <a:rPr lang="en-US" sz="800" dirty="0">
+                <a:solidFill>
+                  <a:srgbClr val="1A1A1A"/>
+                </a:solidFill>
+                <a:latin typeface="Meiryo" pitchFamily="34" charset="0"/>
+                <a:ea typeface="Meiryo" pitchFamily="34" charset="-122"/>
+                <a:cs typeface="Meiryo" pitchFamily="34" charset="-120"/>
+              </a:rPr>
+              <a:t>製造プロセスの勘所集を生成AIで検索</a:t>
+            </a:r>
+            <a:endParaRPr lang="en-US" sz="800" dirty="0"/>
+          </a:p>
+        </p:txBody>
+      </p:sp>
+      <p:sp>
+        <p:nvSpPr>
+          <p:cNvPr id="39" name="Text 36"/>
+          <p:cNvSpPr txBox="1"/>
+          <p:nvPr/>
+        </p:nvSpPr>
+        <p:spPr>
+          <a:xfrm>
+            <a:off x="8412480" y="1764792"/>
+            <a:ext cx="365760" cy="228600"/>
+          </a:xfrm>
+          <a:prstGeom prst="rect">
+            <a:avLst/>
+          </a:prstGeom>
+          <a:noFill/>
+          <a:ln/>
+        </p:spPr>
+        <p:txBody>
+          <a:bodyPr wrap="square" lIns="0" tIns="0" rIns="0" bIns="0" rtlCol="0" anchor="ctr"/>
+          <a:lstStyle/>
+          <a:p>
+            <a:pPr algn="r" indent="0" marL="0">
+              <a:lnSpc>
+                <a:spcPct val="115000"/>
+              </a:lnSpc>
+              <a:buNone/>
+            </a:pPr>
+            <a:r>
+              <a:rPr lang="en-US" sz="800" dirty="0">
+                <a:solidFill>
+                  <a:srgbClr val="4D4D4D"/>
+                </a:solidFill>
+                <a:latin typeface="Meiryo" pitchFamily="34" charset="0"/>
+                <a:ea typeface="Meiryo" pitchFamily="34" charset="-122"/>
+                <a:cs typeface="Meiryo" pitchFamily="34" charset="-120"/>
+              </a:rPr>
+              <a:t>2024</a:t>
+            </a:r>
+            <a:endParaRPr lang="en-US" sz="800" dirty="0"/>
+          </a:p>
+        </p:txBody>
+      </p:sp>
+      <p:sp>
+        <p:nvSpPr>
+          <p:cNvPr id="40" name="Shape 37"/>
+          <p:cNvSpPr/>
+          <p:nvPr/>
+        </p:nvSpPr>
+        <p:spPr>
+          <a:xfrm>
+            <a:off x="4617720" y="1993392"/>
+            <a:ext cx="4160520" cy="0"/>
+          </a:xfrm>
+          <a:prstGeom prst="line">
+            <a:avLst/>
+          </a:prstGeom>
+          <a:noFill/>
+          <a:ln w="9525">
+            <a:solidFill>
+              <a:srgbClr val="BFBFBF"/>
+            </a:solidFill>
+            <a:prstDash val="solid"/>
+          </a:ln>
+        </p:spPr>
+      </p:sp>
+      <p:sp>
+        <p:nvSpPr>
+          <p:cNvPr id="41" name="Text 38"/>
+          <p:cNvSpPr txBox="1"/>
+          <p:nvPr/>
+        </p:nvSpPr>
+        <p:spPr>
+          <a:xfrm>
+            <a:off x="4617720" y="1993392"/>
+            <a:ext cx="1325880" cy="228600"/>
+          </a:xfrm>
+          <a:prstGeom prst="rect">
+            <a:avLst/>
+          </a:prstGeom>
+          <a:noFill/>
+          <a:ln/>
+        </p:spPr>
+        <p:txBody>
+          <a:bodyPr wrap="square" lIns="0" tIns="0" rIns="0" bIns="0" rtlCol="0" anchor="ctr"/>
+          <a:lstStyle/>
+          <a:p>
+            <a:pPr algn="l" indent="0" marL="0">
+              <a:lnSpc>
+                <a:spcPct val="115000"/>
+              </a:lnSpc>
+              <a:buNone/>
+            </a:pPr>
+            <a:r>
+              <a:rPr lang="en-US" sz="850" b="1" dirty="0">
+                <a:solidFill>
+                  <a:srgbClr val="1A1A1A"/>
+                </a:solidFill>
+                <a:latin typeface="Meiryo" pitchFamily="34" charset="0"/>
+                <a:ea typeface="Meiryo" pitchFamily="34" charset="-122"/>
+                <a:cs typeface="Meiryo" pitchFamily="34" charset="-120"/>
+              </a:rPr>
+              <a:t>日立 大みか事業所</a:t>
+            </a:r>
+            <a:endParaRPr lang="en-US" sz="850" dirty="0"/>
+          </a:p>
+        </p:txBody>
+      </p:sp>
+      <p:sp>
+        <p:nvSpPr>
+          <p:cNvPr id="42" name="Text 39"/>
+          <p:cNvSpPr txBox="1"/>
+          <p:nvPr/>
+        </p:nvSpPr>
+        <p:spPr>
+          <a:xfrm>
+            <a:off x="5943600" y="1993392"/>
+            <a:ext cx="2468880" cy="228600"/>
+          </a:xfrm>
+          <a:prstGeom prst="rect">
+            <a:avLst/>
+          </a:prstGeom>
+          <a:noFill/>
+          <a:ln/>
+        </p:spPr>
+        <p:txBody>
+          <a:bodyPr wrap="square" lIns="0" tIns="0" rIns="0" bIns="0" rtlCol="0" anchor="ctr"/>
+          <a:lstStyle/>
+          <a:p>
+            <a:pPr algn="l" indent="0" marL="0">
+              <a:lnSpc>
+                <a:spcPct val="115000"/>
+              </a:lnSpc>
+              <a:buNone/>
+            </a:pPr>
+            <a:r>
+              <a:rPr lang="en-US" sz="800" dirty="0">
+                <a:solidFill>
+                  <a:srgbClr val="1A1A1A"/>
+                </a:solidFill>
+                <a:latin typeface="Meiryo" pitchFamily="34" charset="0"/>
+                <a:ea typeface="Meiryo" pitchFamily="34" charset="-122"/>
+                <a:cs typeface="Meiryo" pitchFamily="34" charset="-120"/>
+              </a:rPr>
+              <a:t>熟練者の知見で、事例検索を約9割短縮</a:t>
+            </a:r>
+            <a:endParaRPr lang="en-US" sz="800" dirty="0"/>
+          </a:p>
+        </p:txBody>
+      </p:sp>
+      <p:sp>
+        <p:nvSpPr>
+          <p:cNvPr id="43" name="Text 40"/>
+          <p:cNvSpPr txBox="1"/>
+          <p:nvPr/>
+        </p:nvSpPr>
+        <p:spPr>
+          <a:xfrm>
+            <a:off x="8412480" y="1993392"/>
+            <a:ext cx="365760" cy="228600"/>
+          </a:xfrm>
+          <a:prstGeom prst="rect">
+            <a:avLst/>
+          </a:prstGeom>
+          <a:noFill/>
+          <a:ln/>
+        </p:spPr>
+        <p:txBody>
+          <a:bodyPr wrap="square" lIns="0" tIns="0" rIns="0" bIns="0" rtlCol="0" anchor="ctr"/>
+          <a:lstStyle/>
+          <a:p>
+            <a:pPr algn="r" indent="0" marL="0">
+              <a:lnSpc>
+                <a:spcPct val="115000"/>
+              </a:lnSpc>
+              <a:buNone/>
+            </a:pPr>
+            <a:r>
+              <a:rPr lang="en-US" sz="800" dirty="0">
+                <a:solidFill>
+                  <a:srgbClr val="4D4D4D"/>
+                </a:solidFill>
+                <a:latin typeface="Meiryo" pitchFamily="34" charset="0"/>
+                <a:ea typeface="Meiryo" pitchFamily="34" charset="-122"/>
+                <a:cs typeface="Meiryo" pitchFamily="34" charset="-120"/>
+              </a:rPr>
+              <a:t>2025</a:t>
+            </a:r>
+            <a:endParaRPr lang="en-US" sz="800" dirty="0"/>
+          </a:p>
+        </p:txBody>
+      </p:sp>
+      <p:sp>
+        <p:nvSpPr>
+          <p:cNvPr id="44" name="Shape 41"/>
+          <p:cNvSpPr/>
+          <p:nvPr/>
+        </p:nvSpPr>
+        <p:spPr>
+          <a:xfrm>
+            <a:off x="4617720" y="2221992"/>
+            <a:ext cx="4160520" cy="0"/>
+          </a:xfrm>
+          <a:prstGeom prst="line">
+            <a:avLst/>
+          </a:prstGeom>
+          <a:noFill/>
+          <a:ln w="9525">
+            <a:solidFill>
+              <a:srgbClr val="BFBFBF"/>
+            </a:solidFill>
+            <a:prstDash val="solid"/>
+          </a:ln>
+        </p:spPr>
+      </p:sp>
+      <p:sp>
+        <p:nvSpPr>
+          <p:cNvPr id="45" name="Text 42"/>
+          <p:cNvSpPr txBox="1"/>
+          <p:nvPr/>
+        </p:nvSpPr>
+        <p:spPr>
+          <a:xfrm>
+            <a:off x="4617720" y="2221992"/>
+            <a:ext cx="1325880" cy="228600"/>
+          </a:xfrm>
+          <a:prstGeom prst="rect">
+            <a:avLst/>
+          </a:prstGeom>
+          <a:noFill/>
+          <a:ln/>
+        </p:spPr>
+        <p:txBody>
+          <a:bodyPr wrap="square" lIns="0" tIns="0" rIns="0" bIns="0" rtlCol="0" anchor="ctr"/>
+          <a:lstStyle/>
+          <a:p>
+            <a:pPr algn="l" indent="0" marL="0">
+              <a:lnSpc>
+                <a:spcPct val="115000"/>
+              </a:lnSpc>
+              <a:buNone/>
+            </a:pPr>
+            <a:r>
+              <a:rPr lang="en-US" sz="850" b="1" dirty="0">
+                <a:solidFill>
+                  <a:srgbClr val="1A1A1A"/>
+                </a:solidFill>
+                <a:latin typeface="Meiryo" pitchFamily="34" charset="0"/>
+                <a:ea typeface="Meiryo" pitchFamily="34" charset="-122"/>
+                <a:cs typeface="Meiryo" pitchFamily="34" charset="-120"/>
+              </a:rPr>
+              <a:t>川崎重工×NTTデータ</a:t>
+            </a:r>
+            <a:endParaRPr lang="en-US" sz="850" dirty="0"/>
+          </a:p>
+        </p:txBody>
+      </p:sp>
+      <p:sp>
+        <p:nvSpPr>
+          <p:cNvPr id="46" name="Text 43"/>
+          <p:cNvSpPr txBox="1"/>
+          <p:nvPr/>
+        </p:nvSpPr>
+        <p:spPr>
+          <a:xfrm>
+            <a:off x="5943600" y="2221992"/>
+            <a:ext cx="2468880" cy="228600"/>
+          </a:xfrm>
+          <a:prstGeom prst="rect">
+            <a:avLst/>
+          </a:prstGeom>
+          <a:noFill/>
+          <a:ln/>
+        </p:spPr>
+        <p:txBody>
+          <a:bodyPr wrap="square" lIns="0" tIns="0" rIns="0" bIns="0" rtlCol="0" anchor="ctr"/>
+          <a:lstStyle/>
+          <a:p>
+            <a:pPr algn="l" indent="0" marL="0">
+              <a:lnSpc>
+                <a:spcPct val="115000"/>
+              </a:lnSpc>
+              <a:buNone/>
+            </a:pPr>
+            <a:r>
+              <a:rPr lang="en-US" sz="800" dirty="0">
+                <a:solidFill>
+                  <a:srgbClr val="1A1A1A"/>
+                </a:solidFill>
+                <a:latin typeface="Meiryo" pitchFamily="34" charset="0"/>
+                <a:ea typeface="Meiryo" pitchFamily="34" charset="-122"/>
+                <a:cs typeface="Meiryo" pitchFamily="34" charset="-120"/>
+              </a:rPr>
+              <a:t>生成AIによる暗黙知伝承</a:t>
+            </a:r>
+            <a:endParaRPr lang="en-US" sz="800" dirty="0"/>
+          </a:p>
+        </p:txBody>
+      </p:sp>
+      <p:sp>
+        <p:nvSpPr>
+          <p:cNvPr id="47" name="Text 44"/>
+          <p:cNvSpPr txBox="1"/>
+          <p:nvPr/>
+        </p:nvSpPr>
+        <p:spPr>
+          <a:xfrm>
+            <a:off x="8412480" y="2221992"/>
+            <a:ext cx="365760" cy="228600"/>
+          </a:xfrm>
+          <a:prstGeom prst="rect">
+            <a:avLst/>
+          </a:prstGeom>
+          <a:noFill/>
+          <a:ln/>
+        </p:spPr>
+        <p:txBody>
+          <a:bodyPr wrap="square" lIns="0" tIns="0" rIns="0" bIns="0" rtlCol="0" anchor="ctr"/>
+          <a:lstStyle/>
+          <a:p>
+            <a:pPr algn="r" indent="0" marL="0">
+              <a:lnSpc>
+                <a:spcPct val="115000"/>
+              </a:lnSpc>
+              <a:buNone/>
+            </a:pPr>
+            <a:r>
+              <a:rPr lang="en-US" sz="800" dirty="0">
+                <a:solidFill>
+                  <a:srgbClr val="4D4D4D"/>
+                </a:solidFill>
+                <a:latin typeface="Meiryo" pitchFamily="34" charset="0"/>
+                <a:ea typeface="Meiryo" pitchFamily="34" charset="-122"/>
+                <a:cs typeface="Meiryo" pitchFamily="34" charset="-120"/>
+              </a:rPr>
+              <a:t>2025</a:t>
+            </a:r>
+            <a:endParaRPr lang="en-US" sz="800" dirty="0"/>
+          </a:p>
+        </p:txBody>
+      </p:sp>
+      <p:sp>
+        <p:nvSpPr>
+          <p:cNvPr id="48" name="Shape 45"/>
+          <p:cNvSpPr/>
+          <p:nvPr/>
+        </p:nvSpPr>
+        <p:spPr>
+          <a:xfrm>
+            <a:off x="4617720" y="2450592"/>
+            <a:ext cx="4160520" cy="0"/>
+          </a:xfrm>
+          <a:prstGeom prst="line">
+            <a:avLst/>
+          </a:prstGeom>
+          <a:noFill/>
+          <a:ln w="9525">
+            <a:solidFill>
+              <a:srgbClr val="BFBFBF"/>
+            </a:solidFill>
+            <a:prstDash val="solid"/>
+          </a:ln>
+        </p:spPr>
+      </p:sp>
+      <p:sp>
+        <p:nvSpPr>
+          <p:cNvPr id="49" name="precedent-summary"/>
+          <p:cNvSpPr/>
+          <p:nvPr/>
+        </p:nvSpPr>
+        <p:spPr>
+          <a:xfrm>
+            <a:off x="4617720" y="2514600"/>
+            <a:ext cx="4160520" cy="457200"/>
           </a:xfrm>
           <a:prstGeom prst="rect">
             <a:avLst/>
@@ -10681,14 +11583,14 @@
       </p:sp>
       <p:sp>
         <p:nvSpPr>
-          <p:cNvPr id="25" name="Text 22"/>
+          <p:cNvPr id="50" name="Text 47"/>
           <p:cNvSpPr txBox="1"/>
           <p:nvPr/>
         </p:nvSpPr>
         <p:spPr>
           <a:xfrm>
-            <a:off x="4617720" y="1335024"/>
-            <a:ext cx="274320" cy="274320"/>
+            <a:off x="4727448" y="2514600"/>
+            <a:ext cx="3941064" cy="457200"/>
           </a:xfrm>
           <a:prstGeom prst="rect">
             <a:avLst/>
@@ -10700,14 +11602,14 @@
           <a:bodyPr wrap="square" lIns="0" tIns="0" rIns="0" bIns="0" rtlCol="0" anchor="ctr"/>
           <a:lstStyle/>
           <a:p>
-            <a:pPr algn="ctr" indent="0" marL="0">
-              <a:lnSpc>
-                <a:spcPct val="115000"/>
-              </a:lnSpc>
-              <a:buNone/>
-            </a:pPr>
-            <a:r>
-              <a:rPr lang="en-US" sz="900" b="1" dirty="0">
+            <a:pPr algn="l" indent="0" marL="0">
+              <a:lnSpc>
+                <a:spcPct val="115000"/>
+              </a:lnSpc>
+              <a:buNone/>
+            </a:pPr>
+            <a:r>
+              <a:rPr lang="en-US" sz="850" b="1" dirty="0">
                 <a:solidFill>
                   <a:srgbClr val="FFFFFF"/>
                 </a:solidFill>
@@ -10715,41 +11617,58 @@
                 <a:ea typeface="Meiryo" pitchFamily="34" charset="-122"/>
                 <a:cs typeface="Meiryo" pitchFamily="34" charset="-120"/>
               </a:rPr>
-              <a:t>S</a:t>
-            </a:r>
-            <a:endParaRPr lang="en-US" sz="900" dirty="0"/>
-          </a:p>
-        </p:txBody>
-      </p:sp>
-      <p:sp>
-        <p:nvSpPr>
-          <p:cNvPr id="26" name="Text 23"/>
+              <a:t>共通点：</a:t>
+            </a:r>
+            <a:pPr algn="l" indent="0" marL="0">
+              <a:lnSpc>
+                <a:spcPct val="115000"/>
+              </a:lnSpc>
+              <a:buNone/>
+            </a:pPr>
+            <a:r>
+              <a:rPr lang="en-US" sz="850" dirty="0">
+                <a:solidFill>
+                  <a:srgbClr val="FFFFFF"/>
+                </a:solidFill>
+                <a:latin typeface="Meiryo" pitchFamily="34" charset="0"/>
+                <a:ea typeface="Meiryo" pitchFamily="34" charset="-122"/>
+                <a:cs typeface="Meiryo" pitchFamily="34" charset="-120"/>
+              </a:rPr>
+              <a:t>大手が大手SIerと個別開発。中堅の工場には予算も人手も届かない。電力インフラでは、古河電工がスマートグラスでの技術伝承を構想する段階</a:t>
+            </a:r>
+            <a:endParaRPr lang="en-US" sz="850" dirty="0"/>
+          </a:p>
+        </p:txBody>
+      </p:sp>
+      <p:sp>
+        <p:nvSpPr>
+          <p:cNvPr id="51" name="Text 48"/>
           <p:cNvSpPr txBox="1"/>
           <p:nvPr/>
         </p:nvSpPr>
         <p:spPr>
           <a:xfrm>
-            <a:off x="4983480" y="1307592"/>
-            <a:ext cx="3794760" cy="329184"/>
-          </a:xfrm>
-          <a:prstGeom prst="rect">
-            <a:avLst/>
-          </a:prstGeom>
-          <a:noFill/>
-          <a:ln/>
-        </p:spPr>
-        <p:txBody>
-          <a:bodyPr wrap="square" lIns="0" tIns="0" rIns="0" bIns="0" rtlCol="0" anchor="ctr"/>
-          <a:lstStyle/>
-          <a:p>
-            <a:pPr algn="l" indent="0" marL="0">
-              <a:lnSpc>
-                <a:spcPct val="115000"/>
-              </a:lnSpc>
-              <a:buNone/>
-            </a:pPr>
-            <a:r>
-              <a:rPr lang="en-US" sz="850" dirty="0">
+            <a:off x="4617720" y="3063240"/>
+            <a:ext cx="4160520" cy="237744"/>
+          </a:xfrm>
+          <a:prstGeom prst="rect">
+            <a:avLst/>
+          </a:prstGeom>
+          <a:noFill/>
+          <a:ln/>
+        </p:spPr>
+        <p:txBody>
+          <a:bodyPr wrap="square" lIns="0" tIns="0" rIns="0" bIns="0" rtlCol="0" anchor="t"/>
+          <a:lstStyle/>
+          <a:p>
+            <a:pPr algn="l" indent="0" marL="0">
+              <a:lnSpc>
+                <a:spcPct val="115000"/>
+              </a:lnSpc>
+              <a:buNone/>
+            </a:pPr>
+            <a:r>
+              <a:rPr lang="en-US" sz="1050" b="1" dirty="0">
                 <a:solidFill>
                   <a:srgbClr val="1A1A1A"/>
                 </a:solidFill>
@@ -10757,22 +11676,22 @@
                 <a:ea typeface="Meiryo" pitchFamily="34" charset="-122"/>
                 <a:cs typeface="Meiryo" pitchFamily="34" charset="-120"/>
               </a:rPr>
-              <a:t>製造業を工程の形で区分：連続工程（電線・素材）／組立／施工現場</a:t>
-            </a:r>
-            <a:endParaRPr lang="en-US" sz="850" dirty="0"/>
-          </a:p>
-        </p:txBody>
-      </p:sp>
-      <p:sp>
-        <p:nvSpPr>
-          <p:cNvPr id="27" name="Shape 24"/>
+              <a:t>STP と競争戦略</a:t>
+            </a:r>
+            <a:endParaRPr lang="en-US" sz="1050" dirty="0"/>
+          </a:p>
+        </p:txBody>
+      </p:sp>
+      <p:sp>
+        <p:nvSpPr>
+          <p:cNvPr id="52" name="Shape 49"/>
           <p:cNvSpPr/>
           <p:nvPr/>
         </p:nvSpPr>
         <p:spPr>
           <a:xfrm>
-            <a:off x="4617720" y="1682496"/>
-            <a:ext cx="274320" cy="274320"/>
+            <a:off x="4617720" y="3328416"/>
+            <a:ext cx="274320" cy="201168"/>
           </a:xfrm>
           <a:prstGeom prst="rect">
             <a:avLst/>
@@ -10785,14 +11704,14 @@
       </p:sp>
       <p:sp>
         <p:nvSpPr>
-          <p:cNvPr id="28" name="Text 25"/>
+          <p:cNvPr id="53" name="Text 50"/>
           <p:cNvSpPr txBox="1"/>
           <p:nvPr/>
         </p:nvSpPr>
         <p:spPr>
           <a:xfrm>
-            <a:off x="4617720" y="1682496"/>
-            <a:ext cx="274320" cy="274320"/>
+            <a:off x="4617720" y="3328416"/>
+            <a:ext cx="274320" cy="201168"/>
           </a:xfrm>
           <a:prstGeom prst="rect">
             <a:avLst/>
@@ -10819,7 +11738,7 @@
                 <a:ea typeface="Meiryo" pitchFamily="34" charset="-122"/>
                 <a:cs typeface="Meiryo" pitchFamily="34" charset="-120"/>
               </a:rPr>
-              <a:t>T</a:t>
+              <a:t>S</a:t>
             </a:r>
             <a:endParaRPr lang="en-US" sz="900" dirty="0"/>
           </a:p>
@@ -10827,14 +11746,14 @@
       </p:sp>
       <p:sp>
         <p:nvSpPr>
-          <p:cNvPr id="29" name="Text 26"/>
+          <p:cNvPr id="54" name="Text 51"/>
           <p:cNvSpPr txBox="1"/>
           <p:nvPr/>
         </p:nvSpPr>
         <p:spPr>
           <a:xfrm>
-            <a:off x="4983480" y="1655064"/>
-            <a:ext cx="3794760" cy="329184"/>
+            <a:off x="4983480" y="3300984"/>
+            <a:ext cx="3794760" cy="256032"/>
           </a:xfrm>
           <a:prstGeom prst="rect">
             <a:avLst/>
@@ -10861,7 +11780,7 @@
                 <a:ea typeface="Meiryo" pitchFamily="34" charset="-122"/>
                 <a:cs typeface="Meiryo" pitchFamily="34" charset="-120"/>
               </a:rPr>
-              <a:t>電線・ケーブル工場。長尺・ロット・試験値が揃い、熟練者の判断が品質を左右</a:t>
+              <a:t>製造業を工程と規模で区分：大手（内製できる）／中堅（できない）</a:t>
             </a:r>
             <a:endParaRPr lang="en-US" sz="850" dirty="0"/>
           </a:p>
@@ -10869,14 +11788,14 @@
       </p:sp>
       <p:sp>
         <p:nvSpPr>
-          <p:cNvPr id="30" name="Shape 27"/>
+          <p:cNvPr id="55" name="Shape 52"/>
           <p:cNvSpPr/>
           <p:nvPr/>
         </p:nvSpPr>
         <p:spPr>
           <a:xfrm>
-            <a:off x="4617720" y="2029968"/>
-            <a:ext cx="274320" cy="274320"/>
+            <a:off x="4617720" y="3593592"/>
+            <a:ext cx="274320" cy="201168"/>
           </a:xfrm>
           <a:prstGeom prst="rect">
             <a:avLst/>
@@ -10889,14 +11808,14 @@
       </p:sp>
       <p:sp>
         <p:nvSpPr>
-          <p:cNvPr id="31" name="Text 28"/>
+          <p:cNvPr id="56" name="Text 53"/>
           <p:cNvSpPr txBox="1"/>
           <p:nvPr/>
         </p:nvSpPr>
         <p:spPr>
           <a:xfrm>
-            <a:off x="4617720" y="2029968"/>
-            <a:ext cx="274320" cy="274320"/>
+            <a:off x="4617720" y="3593592"/>
+            <a:ext cx="274320" cy="201168"/>
           </a:xfrm>
           <a:prstGeom prst="rect">
             <a:avLst/>
@@ -10923,7 +11842,7 @@
                 <a:ea typeface="Meiryo" pitchFamily="34" charset="-122"/>
                 <a:cs typeface="Meiryo" pitchFamily="34" charset="-120"/>
               </a:rPr>
-              <a:t>P</a:t>
+              <a:t>T</a:t>
             </a:r>
             <a:endParaRPr lang="en-US" sz="900" dirty="0"/>
           </a:p>
@@ -10931,14 +11850,14 @@
       </p:sp>
       <p:sp>
         <p:nvSpPr>
-          <p:cNvPr id="32" name="Text 29"/>
+          <p:cNvPr id="57" name="Text 54"/>
           <p:cNvSpPr txBox="1"/>
           <p:nvPr/>
         </p:nvSpPr>
         <p:spPr>
           <a:xfrm>
-            <a:off x="4983480" y="2002536"/>
-            <a:ext cx="3794760" cy="329184"/>
+            <a:off x="4983480" y="3566160"/>
+            <a:ext cx="3794760" cy="256032"/>
           </a:xfrm>
           <a:prstGeom prst="rect">
             <a:avLst/>
@@ -10965,7 +11884,7 @@
                 <a:ea typeface="Meiryo" pitchFamily="34" charset="-122"/>
                 <a:cs typeface="Meiryo" pitchFamily="34" charset="-120"/>
               </a:rPr>
-              <a:t>実績はMES・ERPに任せ、判断の理由を教材と仕組みにして渡す層</a:t>
+              <a:t>中堅の電線・ケーブル工場。熟練者の判断が品質を左右する</a:t>
             </a:r>
             <a:endParaRPr lang="en-US" sz="850" dirty="0"/>
           </a:p>
@@ -10973,205 +11892,13 @@
       </p:sp>
       <p:sp>
         <p:nvSpPr>
-          <p:cNvPr id="33" name="Text 30"/>
-          <p:cNvSpPr txBox="1"/>
-          <p:nvPr/>
-        </p:nvSpPr>
-        <p:spPr>
-          <a:xfrm>
-            <a:off x="4617720" y="2404872"/>
-            <a:ext cx="4160520" cy="237744"/>
-          </a:xfrm>
-          <a:prstGeom prst="rect">
-            <a:avLst/>
-          </a:prstGeom>
-          <a:noFill/>
-          <a:ln/>
-        </p:spPr>
-        <p:txBody>
-          <a:bodyPr wrap="square" lIns="0" tIns="0" rIns="0" bIns="0" rtlCol="0" anchor="t"/>
-          <a:lstStyle/>
-          <a:p>
-            <a:pPr algn="l" indent="0" marL="0">
-              <a:lnSpc>
-                <a:spcPct val="115000"/>
-              </a:lnSpc>
-              <a:buNone/>
-            </a:pPr>
-            <a:r>
-              <a:rPr lang="en-US" sz="1050" b="1" dirty="0">
-                <a:solidFill>
-                  <a:srgbClr val="1A1A1A"/>
-                </a:solidFill>
-                <a:latin typeface="Meiryo" pitchFamily="34" charset="0"/>
-                <a:ea typeface="Meiryo" pitchFamily="34" charset="-122"/>
-                <a:cs typeface="Meiryo" pitchFamily="34" charset="-120"/>
-              </a:rPr>
-              <a:t>競争戦略</a:t>
-            </a:r>
-            <a:endParaRPr lang="en-US" sz="1050" dirty="0"/>
-          </a:p>
-        </p:txBody>
-      </p:sp>
-      <p:sp>
-        <p:nvSpPr>
-          <p:cNvPr id="34" name="Text 31"/>
-          <p:cNvSpPr txBox="1"/>
-          <p:nvPr/>
-        </p:nvSpPr>
-        <p:spPr>
-          <a:xfrm>
-            <a:off x="4617720" y="2660904"/>
-            <a:ext cx="4160520" cy="457200"/>
-          </a:xfrm>
-          <a:prstGeom prst="rect">
-            <a:avLst/>
-          </a:prstGeom>
-          <a:noFill/>
-          <a:ln/>
-        </p:spPr>
-        <p:txBody>
-          <a:bodyPr wrap="square" lIns="0" tIns="0" rIns="0" bIns="0" rtlCol="0" anchor="t"/>
-          <a:lstStyle/>
-          <a:p>
-            <a:pPr algn="l" indent="0" marL="0">
-              <a:lnSpc>
-                <a:spcPct val="115000"/>
-              </a:lnSpc>
-              <a:spcAft>
-                <a:spcPts val="200"/>
-              </a:spcAft>
-              <a:buNone/>
-            </a:pPr>
-            <a:r>
-              <a:rPr lang="en-US" sz="850" b="1" dirty="0">
-                <a:solidFill>
-                  <a:srgbClr val="1A1A1A"/>
-                </a:solidFill>
-                <a:latin typeface="Meiryo" pitchFamily="34" charset="0"/>
-                <a:ea typeface="Meiryo" pitchFamily="34" charset="-122"/>
-                <a:cs typeface="Meiryo" pitchFamily="34" charset="-120"/>
-              </a:rPr>
-              <a:t>コトラーの競争地位：</a:t>
-            </a:r>
-            <a:pPr algn="l" indent="0" marL="0">
-              <a:lnSpc>
-                <a:spcPct val="115000"/>
-              </a:lnSpc>
-              <a:spcAft>
-                <a:spcPts val="200"/>
-              </a:spcAft>
-              <a:buNone/>
-            </a:pPr>
-            <a:r>
-              <a:rPr lang="en-US" sz="850" dirty="0">
-                <a:solidFill>
-                  <a:srgbClr val="1A1A1A"/>
-                </a:solidFill>
-                <a:latin typeface="Meiryo" pitchFamily="34" charset="0"/>
-                <a:ea typeface="Meiryo" pitchFamily="34" charset="-122"/>
-                <a:cs typeface="Meiryo" pitchFamily="34" charset="-120"/>
-              </a:rPr>
-              <a:t>ニッチャー。大手が採算に乗せにくい専門領域に絞る</a:t>
-            </a:r>
-            <a:endParaRPr lang="en-US" sz="850" dirty="0"/>
-          </a:p>
-          <a:p>
-            <a:pPr algn="l" indent="0" marL="0">
-              <a:lnSpc>
-                <a:spcPct val="115000"/>
-              </a:lnSpc>
-              <a:spcAft>
-                <a:spcPts val="200"/>
-              </a:spcAft>
-              <a:buNone/>
-            </a:pPr>
-            <a:r>
-              <a:rPr lang="en-US" sz="850" b="1" dirty="0">
-                <a:solidFill>
-                  <a:srgbClr val="1A1A1A"/>
-                </a:solidFill>
-                <a:latin typeface="Meiryo" pitchFamily="34" charset="0"/>
-                <a:ea typeface="Meiryo" pitchFamily="34" charset="-122"/>
-                <a:cs typeface="Meiryo" pitchFamily="34" charset="-120"/>
-              </a:rPr>
-              <a:t>ポーターの基本戦略：</a:t>
-            </a:r>
-            <a:pPr algn="l" indent="0" marL="0">
-              <a:lnSpc>
-                <a:spcPct val="115000"/>
-              </a:lnSpc>
-              <a:spcAft>
-                <a:spcPts val="200"/>
-              </a:spcAft>
-              <a:buNone/>
-            </a:pPr>
-            <a:r>
-              <a:rPr lang="en-US" sz="850" dirty="0">
-                <a:solidFill>
-                  <a:srgbClr val="1A1A1A"/>
-                </a:solidFill>
-                <a:latin typeface="Meiryo" pitchFamily="34" charset="0"/>
-                <a:ea typeface="Meiryo" pitchFamily="34" charset="-122"/>
-                <a:cs typeface="Meiryo" pitchFamily="34" charset="-120"/>
-              </a:rPr>
-              <a:t>差別化集中。価格ではなく現場の知見で選ばれる</a:t>
-            </a:r>
-            <a:endParaRPr lang="en-US" sz="850" dirty="0"/>
-          </a:p>
-        </p:txBody>
-      </p:sp>
-      <p:sp>
-        <p:nvSpPr>
-          <p:cNvPr id="35" name="Text 32"/>
-          <p:cNvSpPr txBox="1"/>
-          <p:nvPr/>
-        </p:nvSpPr>
-        <p:spPr>
-          <a:xfrm>
-            <a:off x="4617720" y="3172968"/>
-            <a:ext cx="4160520" cy="237744"/>
-          </a:xfrm>
-          <a:prstGeom prst="rect">
-            <a:avLst/>
-          </a:prstGeom>
-          <a:noFill/>
-          <a:ln/>
-        </p:spPr>
-        <p:txBody>
-          <a:bodyPr wrap="square" lIns="0" tIns="0" rIns="0" bIns="0" rtlCol="0" anchor="t"/>
-          <a:lstStyle/>
-          <a:p>
-            <a:pPr algn="l" indent="0" marL="0">
-              <a:lnSpc>
-                <a:spcPct val="115000"/>
-              </a:lnSpc>
-              <a:buNone/>
-            </a:pPr>
-            <a:r>
-              <a:rPr lang="en-US" sz="1050" b="1" dirty="0">
-                <a:solidFill>
-                  <a:srgbClr val="1A1A1A"/>
-                </a:solidFill>
-                <a:latin typeface="Meiryo" pitchFamily="34" charset="0"/>
-                <a:ea typeface="Meiryo" pitchFamily="34" charset="-122"/>
-                <a:cs typeface="Meiryo" pitchFamily="34" charset="-120"/>
-              </a:rPr>
-              <a:t>SWOT</a:t>
-            </a:r>
-            <a:endParaRPr lang="en-US" sz="1050" dirty="0"/>
-          </a:p>
-        </p:txBody>
-      </p:sp>
-      <p:sp>
-        <p:nvSpPr>
-          <p:cNvPr id="36" name="Shape 33"/>
+          <p:cNvPr id="58" name="Shape 55"/>
           <p:cNvSpPr/>
           <p:nvPr/>
         </p:nvSpPr>
         <p:spPr>
           <a:xfrm>
-            <a:off x="4617720" y="3456432"/>
+            <a:off x="4617720" y="3858768"/>
             <a:ext cx="274320" cy="201168"/>
           </a:xfrm>
           <a:prstGeom prst="rect">
@@ -11185,13 +11912,13 @@
       </p:sp>
       <p:sp>
         <p:nvSpPr>
-          <p:cNvPr id="37" name="Text 34"/>
+          <p:cNvPr id="59" name="Text 56"/>
           <p:cNvSpPr txBox="1"/>
           <p:nvPr/>
         </p:nvSpPr>
         <p:spPr>
           <a:xfrm>
-            <a:off x="4617720" y="3456432"/>
+            <a:off x="4617720" y="3858768"/>
             <a:ext cx="274320" cy="201168"/>
           </a:xfrm>
           <a:prstGeom prst="rect">
@@ -11219,7 +11946,7 @@
                 <a:ea typeface="Meiryo" pitchFamily="34" charset="-122"/>
                 <a:cs typeface="Meiryo" pitchFamily="34" charset="-120"/>
               </a:rPr>
-              <a:t>S</a:t>
+              <a:t>P</a:t>
             </a:r>
             <a:endParaRPr lang="en-US" sz="900" dirty="0"/>
           </a:p>
@@ -11227,13 +11954,13 @@
       </p:sp>
       <p:sp>
         <p:nvSpPr>
-          <p:cNvPr id="38" name="Text 35"/>
+          <p:cNvPr id="60" name="Text 57"/>
           <p:cNvSpPr txBox="1"/>
           <p:nvPr/>
         </p:nvSpPr>
         <p:spPr>
           <a:xfrm>
-            <a:off x="4983480" y="3429000"/>
+            <a:off x="4983480" y="3831336"/>
             <a:ext cx="3794760" cy="256032"/>
           </a:xfrm>
           <a:prstGeom prst="rect">
@@ -11261,7 +11988,7 @@
                 <a:ea typeface="Meiryo" pitchFamily="34" charset="-122"/>
                 <a:cs typeface="Meiryo" pitchFamily="34" charset="-120"/>
               </a:rPr>
-              <a:t>施工管理5年と自作開発の両立／製品が使われる現場からの逆算</a:t>
+              <a:t>大手の内製と同じことを、教材制作込みのサービスで中堅に届ける</a:t>
             </a:r>
             <a:endParaRPr lang="en-US" sz="850" dirty="0"/>
           </a:p>
@@ -11269,325 +11996,121 @@
       </p:sp>
       <p:sp>
         <p:nvSpPr>
-          <p:cNvPr id="39" name="Shape 36"/>
-          <p:cNvSpPr/>
-          <p:nvPr/>
-        </p:nvSpPr>
-        <p:spPr>
-          <a:xfrm>
-            <a:off x="4617720" y="3721608"/>
-            <a:ext cx="274320" cy="201168"/>
-          </a:xfrm>
-          <a:prstGeom prst="rect">
-            <a:avLst/>
-          </a:prstGeom>
-          <a:solidFill>
-            <a:srgbClr val="1A1A1A"/>
-          </a:solidFill>
-          <a:ln/>
-        </p:spPr>
-      </p:sp>
-      <p:sp>
-        <p:nvSpPr>
-          <p:cNvPr id="40" name="Text 37"/>
+          <p:cNvPr id="61" name="Text 58"/>
           <p:cNvSpPr txBox="1"/>
           <p:nvPr/>
         </p:nvSpPr>
         <p:spPr>
           <a:xfrm>
-            <a:off x="4617720" y="3721608"/>
-            <a:ext cx="274320" cy="201168"/>
-          </a:xfrm>
-          <a:prstGeom prst="rect">
-            <a:avLst/>
-          </a:prstGeom>
-          <a:noFill/>
-          <a:ln/>
-        </p:spPr>
-        <p:txBody>
-          <a:bodyPr wrap="square" lIns="0" tIns="0" rIns="0" bIns="0" rtlCol="0" anchor="ctr"/>
-          <a:lstStyle/>
-          <a:p>
-            <a:pPr algn="ctr" indent="0" marL="0">
-              <a:lnSpc>
-                <a:spcPct val="115000"/>
-              </a:lnSpc>
-              <a:buNone/>
-            </a:pPr>
-            <a:r>
-              <a:rPr lang="en-US" sz="900" b="1" dirty="0">
-                <a:solidFill>
-                  <a:srgbClr val="FFFFFF"/>
-                </a:solidFill>
-                <a:latin typeface="Meiryo" pitchFamily="34" charset="0"/>
-                <a:ea typeface="Meiryo" pitchFamily="34" charset="-122"/>
-                <a:cs typeface="Meiryo" pitchFamily="34" charset="-120"/>
-              </a:rPr>
-              <a:t>W</a:t>
-            </a:r>
-            <a:endParaRPr lang="en-US" sz="900" dirty="0"/>
-          </a:p>
-        </p:txBody>
-      </p:sp>
-      <p:sp>
-        <p:nvSpPr>
-          <p:cNvPr id="41" name="Text 38"/>
+            <a:off x="4617720" y="4123944"/>
+            <a:ext cx="4160520" cy="329184"/>
+          </a:xfrm>
+          <a:prstGeom prst="rect">
+            <a:avLst/>
+          </a:prstGeom>
+          <a:noFill/>
+          <a:ln/>
+        </p:spPr>
+        <p:txBody>
+          <a:bodyPr wrap="square" lIns="0" tIns="0" rIns="0" bIns="0" rtlCol="0" anchor="t"/>
+          <a:lstStyle/>
+          <a:p>
+            <a:pPr algn="l" indent="0" marL="0">
+              <a:lnSpc>
+                <a:spcPct val="115000"/>
+              </a:lnSpc>
+              <a:spcAft>
+                <a:spcPts val="100"/>
+              </a:spcAft>
+              <a:buNone/>
+            </a:pPr>
+            <a:r>
+              <a:rPr lang="en-US" sz="850" b="1" dirty="0">
+                <a:solidFill>
+                  <a:srgbClr val="1A1A1A"/>
+                </a:solidFill>
+                <a:latin typeface="Meiryo" pitchFamily="34" charset="0"/>
+                <a:ea typeface="Meiryo" pitchFamily="34" charset="-122"/>
+                <a:cs typeface="Meiryo" pitchFamily="34" charset="-120"/>
+              </a:rPr>
+              <a:t>競争戦略：</a:t>
+            </a:r>
+            <a:pPr algn="l" indent="0" marL="0">
+              <a:lnSpc>
+                <a:spcPct val="115000"/>
+              </a:lnSpc>
+              <a:spcAft>
+                <a:spcPts val="100"/>
+              </a:spcAft>
+              <a:buNone/>
+            </a:pPr>
+            <a:r>
+              <a:rPr lang="en-US" sz="850" dirty="0">
+                <a:solidFill>
+                  <a:srgbClr val="1A1A1A"/>
+                </a:solidFill>
+                <a:latin typeface="Meiryo" pitchFamily="34" charset="0"/>
+                <a:ea typeface="Meiryo" pitchFamily="34" charset="-122"/>
+                <a:cs typeface="Meiryo" pitchFamily="34" charset="-120"/>
+              </a:rPr>
+              <a:t>ニッチャー（コトラー）×差別化集中（ポーター）</a:t>
+            </a:r>
+            <a:endParaRPr lang="en-US" sz="850" dirty="0"/>
+          </a:p>
+          <a:p>
+            <a:pPr algn="l" indent="0" marL="0">
+              <a:lnSpc>
+                <a:spcPct val="115000"/>
+              </a:lnSpc>
+              <a:spcAft>
+                <a:spcPts val="100"/>
+              </a:spcAft>
+              <a:buNone/>
+            </a:pPr>
+            <a:r>
+              <a:rPr lang="en-US" sz="850" b="1" dirty="0">
+                <a:solidFill>
+                  <a:srgbClr val="1A1A1A"/>
+                </a:solidFill>
+                <a:latin typeface="Meiryo" pitchFamily="34" charset="0"/>
+                <a:ea typeface="Meiryo" pitchFamily="34" charset="-122"/>
+                <a:cs typeface="Meiryo" pitchFamily="34" charset="-120"/>
+              </a:rPr>
+              <a:t>弱み：</a:t>
+            </a:r>
+            <a:pPr algn="l" indent="0" marL="0">
+              <a:lnSpc>
+                <a:spcPct val="115000"/>
+              </a:lnSpc>
+              <a:spcAft>
+                <a:spcPts val="100"/>
+              </a:spcAft>
+              <a:buNone/>
+            </a:pPr>
+            <a:r>
+              <a:rPr lang="en-US" sz="850" dirty="0">
+                <a:solidFill>
+                  <a:srgbClr val="1A1A1A"/>
+                </a:solidFill>
+                <a:latin typeface="Meiryo" pitchFamily="34" charset="0"/>
+                <a:ea typeface="Meiryo" pitchFamily="34" charset="-122"/>
+                <a:cs typeface="Meiryo" pitchFamily="34" charset="-120"/>
+              </a:rPr>
+              <a:t>製造現場の実務経験が浅い／営業・資金調達が未経験</a:t>
+            </a:r>
+            <a:endParaRPr lang="en-US" sz="850" dirty="0"/>
+          </a:p>
+        </p:txBody>
+      </p:sp>
+      <p:sp>
+        <p:nvSpPr>
+          <p:cNvPr id="62" name="Text 59"/>
           <p:cNvSpPr txBox="1"/>
           <p:nvPr/>
         </p:nvSpPr>
         <p:spPr>
           <a:xfrm>
-            <a:off x="4983480" y="3694176"/>
-            <a:ext cx="3794760" cy="256032"/>
-          </a:xfrm>
-          <a:prstGeom prst="rect">
-            <a:avLst/>
-          </a:prstGeom>
-          <a:noFill/>
-          <a:ln/>
-        </p:spPr>
-        <p:txBody>
-          <a:bodyPr wrap="square" lIns="0" tIns="0" rIns="0" bIns="0" rtlCol="0" anchor="ctr"/>
-          <a:lstStyle/>
-          <a:p>
-            <a:pPr algn="l" indent="0" marL="0">
-              <a:lnSpc>
-                <a:spcPct val="115000"/>
-              </a:lnSpc>
-              <a:buNone/>
-            </a:pPr>
-            <a:r>
-              <a:rPr lang="en-US" sz="850" dirty="0">
-                <a:solidFill>
-                  <a:srgbClr val="1A1A1A"/>
-                </a:solidFill>
-                <a:latin typeface="Meiryo" pitchFamily="34" charset="0"/>
-                <a:ea typeface="Meiryo" pitchFamily="34" charset="-122"/>
-                <a:cs typeface="Meiryo" pitchFamily="34" charset="-120"/>
-              </a:rPr>
-              <a:t>製造現場の実務経験が浅い／営業・資金調達が未経験／創業者依存</a:t>
-            </a:r>
-            <a:endParaRPr lang="en-US" sz="850" dirty="0"/>
-          </a:p>
-        </p:txBody>
-      </p:sp>
-      <p:sp>
-        <p:nvSpPr>
-          <p:cNvPr id="42" name="Shape 39"/>
-          <p:cNvSpPr/>
-          <p:nvPr/>
-        </p:nvSpPr>
-        <p:spPr>
-          <a:xfrm>
-            <a:off x="4617720" y="3986784"/>
-            <a:ext cx="274320" cy="201168"/>
-          </a:xfrm>
-          <a:prstGeom prst="rect">
-            <a:avLst/>
-          </a:prstGeom>
-          <a:solidFill>
-            <a:srgbClr val="1A1A1A"/>
-          </a:solidFill>
-          <a:ln/>
-        </p:spPr>
-      </p:sp>
-      <p:sp>
-        <p:nvSpPr>
-          <p:cNvPr id="43" name="Text 40"/>
-          <p:cNvSpPr txBox="1"/>
-          <p:nvPr/>
-        </p:nvSpPr>
-        <p:spPr>
-          <a:xfrm>
-            <a:off x="4617720" y="3986784"/>
-            <a:ext cx="274320" cy="201168"/>
-          </a:xfrm>
-          <a:prstGeom prst="rect">
-            <a:avLst/>
-          </a:prstGeom>
-          <a:noFill/>
-          <a:ln/>
-        </p:spPr>
-        <p:txBody>
-          <a:bodyPr wrap="square" lIns="0" tIns="0" rIns="0" bIns="0" rtlCol="0" anchor="ctr"/>
-          <a:lstStyle/>
-          <a:p>
-            <a:pPr algn="ctr" indent="0" marL="0">
-              <a:lnSpc>
-                <a:spcPct val="115000"/>
-              </a:lnSpc>
-              <a:buNone/>
-            </a:pPr>
-            <a:r>
-              <a:rPr lang="en-US" sz="900" b="1" dirty="0">
-                <a:solidFill>
-                  <a:srgbClr val="FFFFFF"/>
-                </a:solidFill>
-                <a:latin typeface="Meiryo" pitchFamily="34" charset="0"/>
-                <a:ea typeface="Meiryo" pitchFamily="34" charset="-122"/>
-                <a:cs typeface="Meiryo" pitchFamily="34" charset="-120"/>
-              </a:rPr>
-              <a:t>O</a:t>
-            </a:r>
-            <a:endParaRPr lang="en-US" sz="900" dirty="0"/>
-          </a:p>
-        </p:txBody>
-      </p:sp>
-      <p:sp>
-        <p:nvSpPr>
-          <p:cNvPr id="44" name="Text 41"/>
-          <p:cNvSpPr txBox="1"/>
-          <p:nvPr/>
-        </p:nvSpPr>
-        <p:spPr>
-          <a:xfrm>
-            <a:off x="4983480" y="3959352"/>
-            <a:ext cx="3794760" cy="256032"/>
-          </a:xfrm>
-          <a:prstGeom prst="rect">
-            <a:avLst/>
-          </a:prstGeom>
-          <a:noFill/>
-          <a:ln/>
-        </p:spPr>
-        <p:txBody>
-          <a:bodyPr wrap="square" lIns="0" tIns="0" rIns="0" bIns="0" rtlCol="0" anchor="ctr"/>
-          <a:lstStyle/>
-          <a:p>
-            <a:pPr algn="l" indent="0" marL="0">
-              <a:lnSpc>
-                <a:spcPct val="115000"/>
-              </a:lnSpc>
-              <a:buNone/>
-            </a:pPr>
-            <a:r>
-              <a:rPr lang="en-US" sz="850" dirty="0">
-                <a:solidFill>
-                  <a:srgbClr val="1A1A1A"/>
-                </a:solidFill>
-                <a:latin typeface="Meiryo" pitchFamily="34" charset="0"/>
-                <a:ea typeface="Meiryo" pitchFamily="34" charset="-122"/>
-                <a:cs typeface="Meiryo" pitchFamily="34" charset="-120"/>
-              </a:rPr>
-              <a:t>担い手の高齢化による技能継承需要／フィジカルAIの実用化</a:t>
-            </a:r>
-            <a:endParaRPr lang="en-US" sz="850" dirty="0"/>
-          </a:p>
-        </p:txBody>
-      </p:sp>
-      <p:sp>
-        <p:nvSpPr>
-          <p:cNvPr id="45" name="Shape 42"/>
-          <p:cNvSpPr/>
-          <p:nvPr/>
-        </p:nvSpPr>
-        <p:spPr>
-          <a:xfrm>
-            <a:off x="4617720" y="4251960"/>
-            <a:ext cx="274320" cy="201168"/>
-          </a:xfrm>
-          <a:prstGeom prst="rect">
-            <a:avLst/>
-          </a:prstGeom>
-          <a:solidFill>
-            <a:srgbClr val="1A1A1A"/>
-          </a:solidFill>
-          <a:ln/>
-        </p:spPr>
-      </p:sp>
-      <p:sp>
-        <p:nvSpPr>
-          <p:cNvPr id="46" name="Text 43"/>
-          <p:cNvSpPr txBox="1"/>
-          <p:nvPr/>
-        </p:nvSpPr>
-        <p:spPr>
-          <a:xfrm>
-            <a:off x="4617720" y="4251960"/>
-            <a:ext cx="274320" cy="201168"/>
-          </a:xfrm>
-          <a:prstGeom prst="rect">
-            <a:avLst/>
-          </a:prstGeom>
-          <a:noFill/>
-          <a:ln/>
-        </p:spPr>
-        <p:txBody>
-          <a:bodyPr wrap="square" lIns="0" tIns="0" rIns="0" bIns="0" rtlCol="0" anchor="ctr"/>
-          <a:lstStyle/>
-          <a:p>
-            <a:pPr algn="ctr" indent="0" marL="0">
-              <a:lnSpc>
-                <a:spcPct val="115000"/>
-              </a:lnSpc>
-              <a:buNone/>
-            </a:pPr>
-            <a:r>
-              <a:rPr lang="en-US" sz="900" b="1" dirty="0">
-                <a:solidFill>
-                  <a:srgbClr val="FFFFFF"/>
-                </a:solidFill>
-                <a:latin typeface="Meiryo" pitchFamily="34" charset="0"/>
-                <a:ea typeface="Meiryo" pitchFamily="34" charset="-122"/>
-                <a:cs typeface="Meiryo" pitchFamily="34" charset="-120"/>
-              </a:rPr>
-              <a:t>T</a:t>
-            </a:r>
-            <a:endParaRPr lang="en-US" sz="900" dirty="0"/>
-          </a:p>
-        </p:txBody>
-      </p:sp>
-      <p:sp>
-        <p:nvSpPr>
-          <p:cNvPr id="47" name="Text 44"/>
-          <p:cNvSpPr txBox="1"/>
-          <p:nvPr/>
-        </p:nvSpPr>
-        <p:spPr>
-          <a:xfrm>
-            <a:off x="4983480" y="4224528"/>
-            <a:ext cx="3794760" cy="256032"/>
-          </a:xfrm>
-          <a:prstGeom prst="rect">
-            <a:avLst/>
-          </a:prstGeom>
-          <a:noFill/>
-          <a:ln/>
-        </p:spPr>
-        <p:txBody>
-          <a:bodyPr wrap="square" lIns="0" tIns="0" rIns="0" bIns="0" rtlCol="0" anchor="ctr"/>
-          <a:lstStyle/>
-          <a:p>
-            <a:pPr algn="l" indent="0" marL="0">
-              <a:lnSpc>
-                <a:spcPct val="115000"/>
-              </a:lnSpc>
-              <a:buNone/>
-            </a:pPr>
-            <a:r>
-              <a:rPr lang="en-US" sz="850" dirty="0">
-                <a:solidFill>
-                  <a:srgbClr val="1A1A1A"/>
-                </a:solidFill>
-                <a:latin typeface="Meiryo" pitchFamily="34" charset="0"/>
-                <a:ea typeface="Meiryo" pitchFamily="34" charset="-122"/>
-                <a:cs typeface="Meiryo" pitchFamily="34" charset="-120"/>
-              </a:rPr>
-              <a:t>大手SIer・ロボットベンダーの参入／内製化／母数が小さい</a:t>
-            </a:r>
-            <a:endParaRPr lang="en-US" sz="850" dirty="0"/>
-          </a:p>
-        </p:txBody>
-      </p:sp>
-      <p:sp>
-        <p:nvSpPr>
-          <p:cNvPr id="48" name="Text 45"/>
-          <p:cNvSpPr txBox="1"/>
-          <p:nvPr/>
-        </p:nvSpPr>
-        <p:spPr>
-          <a:xfrm>
-            <a:off x="365760" y="4498848"/>
+            <a:off x="365760" y="4535424"/>
             <a:ext cx="8412480" cy="310896"/>
           </a:xfrm>
           <a:prstGeom prst="rect">
@@ -11615,7 +12138,7 @@
                 <a:ea typeface="Meiryo" pitchFamily="34" charset="-122"/>
                 <a:cs typeface="Meiryo" pitchFamily="34" charset="-120"/>
               </a:rPr>
-              <a:t>※ ERP・MES・SCMとはAPI連携で併存し、置き換えない。電線業界：353事業所・出荷額1兆8,822億円（経済構造実態調査 2024年、従業者10人以上）</a:t>
+              <a:t>出典：日立製作所・ダイキン工業（2017年9月）、NEC（2022年11月）、ライオン・NTTデータ（2024年6月）、日立（2025年6月）、NTTデータ（2025年12月）、MONOist 古河電工インタビュー（2021年3月）。※電力インフラに公開事例が見当たらないことは、存在しないことを意味しない</a:t>
             </a:r>
             <a:endParaRPr lang="en-US" sz="800" dirty="0"/>
           </a:p>

</xml_diff>

<commit_message>
Revise strategy after competitor research; use verified sources
Competitors already cover recording and structuring (Airion) and
discrete/drawing data (CADDi), so the deck now positions the company
on hand-off: turning continuous-process know-how into training
content, offered from year one. Slide 5 compares store vs hand-off
across Airion, CADDi, MRI, FRONTEO and tebiki/Teachme Biz and names
CADDi as the main threat. Slide 2 replaces unverifiable figures with
the Monozukuri White Paper 2026 and JILPT No.265/267 gap (77.2% vs
8.7%); slide 1 quotes the Cabinet Office AI Basic Plan.

Co-Authored-By: Claude Opus 5.5 <noreply@anthropic.com>
Claude-Session: https://claude.ai/code/session_01Lvjvqoc8h4yHt4F4M6n1V9
</commit_message>
<xml_diff>
--- a/deck/セルフマネジメント課題_事業構想プレゼン.pptx
+++ b/deck/セルフマネジメント課題_事業構想プレゼン.pptx
@@ -2046,7 +2046,7 @@
               <a:rPr lang="en-US" dirty="0"/>
               <a:t>【0:00 - 0:50】
 要約：人が減っても現場が迷わず回る仕組みをつくり、日本の品質を支える現場の勘を遺産として残す（設問③）
-株式会社三現ワークスの事業構想を発表します。三現とは、現場・現物・現実のことです。メイド・イン・ジャパンの品質を支えてきたのは、現場の熟練者の勘です。ところがその勘は、記録に残らないまま、退職とともに失われつつあります。この会社の存在意義は「現場の勘を、次の担い手へ。」です。使命は、熟練者の勘を言葉にし、教材と仕組みにして次の担い手に渡すこと。5年後には85の拠点で、勘どころが教材として残り、誰でも迷わず判断できる状態を目指します。人に依存しない形で、日本の品質を遺産として残す会社です。ここから、課題、解決策、稼ぎ方の順にご説明します。</a:t>
+株式会社三現ワークスの事業構想を発表します。三現とは、現場・現物・現実のことです。メイド・イン・ジャパンの品質を支えてきたのは、現場の熟練者の勘です。その勘は、記録に残らないまま、退職とともに失われつつあります。この会社の存在意義は「現場の勘を、次の担い手へ。」です。使命は、熟練者の勘を言葉にし、教材と仕組みで次の人へ渡すこと。5年後には85の拠点で、勘どころが教材として残っている状態を目指します。今年7月に閣議決定された国の人工知能基本計画も、暗黙知が豊富な現場へのAIの実装を推進すると明記しています。この会社は、その現場の側に立ちます。</a:t>
             </a:r>
             <a:endParaRPr lang="en-US" dirty="0"/>
           </a:p>
@@ -2135,8 +2135,8 @@
             <a:r>
               <a:rPr lang="en-US" dirty="0"/>
               <a:t>【0:50 - 2:00】
-要約：熟練者の勘が、記録に残らないまま消えていく
-まず、解きたい課題です。たとえば電線の押出ラインで外径が振れたとき、熟練者は音や湿度を見て、温度を少し下げて立て直します。ところが、この判断は手順書には書かれていません。数字で見ると、建設業の就業者は55歳以上が36.7%、29歳以下は11.7%です。製造業の就業者は2025年に1,033万人まで減り、技能継承がうまくいっていない企業は3社に2社にのぼります。それなのに、技能継承にデジタル技術を使っている企業は21.7%にとどまります。私は古河電気工業で地中送電線の施工管理を5年間担当し、ケーブルが使われる現場で不具合や試験値を見てきました。同時に、PythonやRAGなどを独学し、仕組みを自分で作ってきました。現場を知り、仕組みを作れる人間として、この課題に取り組みます。</a:t>
+要約：デジタル化は進んだのに、技能継承は人頼みのまま
+まず、解きたい課題です。たとえば押出ラインで外径が振れたとき、熟練者は音や湿度を見て温度を少し下げて立て直します。この判断は手順書に書かれていません。国の調査を見ると、製造業で業務改善にデジタル技術を使っている企業は77.2%にのぼります。ところが、その効果として技能継承が円滑になった企業は8.7%しかありません。デジタル化は進んだのに、技能継承にはほとんど効いていないのです。実際、技能継承の取り組みで最も多いのは、再雇用や勤務延長でベテランに居続けてもらうことで、54.8%です。継承は、いまも人に頼ったままです。さらに製造業の62.8%が、指導する人材が足りないと答えています。私は施工管理として製品が使われる現場を見てきました。そして、仕組みを自分で作れます。だからこの課題に取り組みます。</a:t>
             </a:r>
             <a:endParaRPr lang="en-US" dirty="0"/>
           </a:p>
@@ -2225,8 +2225,8 @@
             <a:r>
               <a:rPr lang="en-US" dirty="0"/>
               <a:t>【2:00 - 3:30】
-要約：引退した熟練者が、隣で教えてくれる現場をつくる。データ集めで終わらせず、教材まで当社が作る
-設問①、解決策です。目指すのは、引退した熟練者が隣で教えてくれるような現場です。仕組みは三段階です。熟練者は、異常に対処したらタブレットに音声で一言残します。生成AIがそれを条件・処置・理由に分けて事例にします。そして三つ目が大事で、当社はデータを集めて終わりにしません。現場は忙しく、研修資料や教材を作る時間がありません。そこで当社が、勘どころを言葉にし、通勤中に聞ける音声番組、短い動画、研修資料まで作って届けます。音声の自動配信は、私が個人で、ニュースを要約して音声合成し毎朝配信する仕組みとしてすでに作っています。渡し方は年ごとに増やし、3年目は手順書を開くと過去の事故やヒヤリの場所が出る機能、4年目は3Dの仮想工場、5年目は音声の指示でCAD図面を描く機能です。触覚の訓練シミュレーターは研究開発として進めます。最初の2か月は、当社の担当者が現場に入って定着まで支えます。</a:t>
+要約：引退した熟練者が隣で教えてくれる現場をつくる。差別化は、教材にして届けること
+設問①、解決策です。目指すのは、引退した熟練者が隣で教えてくれるような現場です。熟練者は、異常に対処したらタブレットに音声で一言残すだけです。構造化を現場に求めない設計で、これは国の人工知能基本計画の方針とも一致します。生成AIがそれを条件・処置・理由に分けて事例にします。ただ、記録と整理はすでに他社も手がけており、当社の差別化にはなりません。差別化は三つ目です。指導役が足りない事業所は59.5%、育成の時間がない事業所は47.4%あります。貯めたデータから教材を作る作業が現場に残ると、使われません。だから当社が、連続工程の勘どころを研修資料、通勤中に聞ける音声番組、短い動画にして届けます。教材化は初年度から提供し、その後、危険箇所の表示、3Dの仮想工場、音声での作図と渡し方を増やします。技術は作らない部分を決めています。音声記録やAIの構造化は汎用技術を使い、自前開発は工程データとの紐づけと教材化の手順に集中します。</a:t>
             </a:r>
             <a:endParaRPr lang="en-US" dirty="0"/>
           </a:p>
@@ -2405,8 +2405,8 @@
             <a:r>
               <a:rPr lang="en-US" dirty="0"/>
               <a:t>【4:40 - 5:50】
-要約：判断の理由を内製で仕組み化した事業会社は希少。大手だけで、電力インフラでは公開事例が見当たらない
-最初に自分で自分に突きつけた問いが三つありました。コンサルと何が違うのか、MESや大手SIerと何が違うのか、そして、すでに自社で同じことをしている会社があるのではないか、です。三つ目について調べると、先行事例はあります。ダイキンと日立のろう付け技能のデジタル化、ライオンとNTTデータの勘所集の生成AI検索、日立の大みか事業所でのトラブル事例検索などです。ただし共通点があり、いずれも大手が大手SIerと組んだ個別開発です。中堅の工場には、その予算も人手も届きません。そして、電線・送配電・電気工事といった電力インフラの分野では、公開された事例は見当たりませんでした。私の勤務先でも、スマートグラスでの技術伝承は構想の段階です。左の図の右上、判断の理由を仕組みで扱う場所には、大手の内製しかいません。当社は、大手が内製で行っていることを、教材の制作まで含めたサービスとして中堅の電線工場に届けます。ニッチャーとして差別化集中で戦います。弱みは、製造現場の経験が浅いことと、営業・資金調達が未経験であることです。</a:t>
+要約：「貯める」会社は現れた。当社は「渡す」で分かれる
+最初に自分で自分に突きつけた問いが三つありました。コンサルと何が違うのか、同じことをしている会社はないのか、大手が降りてきたらどうするのか、です。調べると、判断の理由を扱う会社はすでに現れています。東大発のAirionは、ベテランとAIの対話で知識を構造化します。キャディのCADDiは、設計意図や判断履歴をデータ化しています。正直に言えば、貯める部分は当社とほぼ同じ設計です。これは、この課題に市場があることの証明だと考えています。分かれるのは渡す部分です。どの会社も、貯めたものを教材にして届けるところまではやっていません。また、CADDiの対象は組立の製造業で、扱うのは図面とBOMです。電線のような連続工程の現場処置は、図面には現れません。最大の脅威は、CADDiが連続工程に降りてくることです。防御線は、図面に現れない現場処置の蓄積と、現場で監修できる人です。</a:t>
             </a:r>
             <a:endParaRPr lang="en-US" dirty="0"/>
           </a:p>
@@ -2675,8 +2675,8 @@
             <a:r>
               <a:rPr lang="en-US" dirty="0"/>
               <a:t>【8:30 - 9:50】
-要約：最大のリスクは自分。だから役割と判断基準を先に決めておく
-設問⑤、経営課題です。最大のリスクは競合ではなく、創業者である自分が律速になることです。準備期は、試験導入を3拠点に限定し、生産技術の経験者を迎えます。中期は、電線業界が353事業所と小さいため、製品の出口である施工会社へ同じ基盤を広げます。後期は、私がいなくても判断できる会社にします。そのための仕組みが下段のバランスト・スコアカードで、四つの指標を先に決めておきます。最後に、この事業の顧客・商品・収益は、すべて現在の勤務先の中にも存在します。顧客は社内の工場、商品は製造記録のデータ化と技能継承、収益は工数削減と品質不良の防止です。だから復職後は、生産技術と情報システムの領域で、現場と技術のあいだを訳す役割を担いたいと考えています。そして、自らの役割を定義しきること自体が、業務を際限なく抱え込まないための再発防止策でもあります。以上です。</a:t>
+要約：最大のリスクは自分。判断基準を先に決めておく
+設問⑤、経営課題です。最大のリスクは競合ではなく、創業者である自分が律速になることです。準備期は、試験導入を3拠点に限定し、生産技術の経験者を迎えます。中期は、電線業界が353事業所と小さいため、製品の出口である施工会社へ同じ基盤を広げます。後期は、大手のデータ基盤が連続工程に降りてくることへの備えと、私がいなくても判断できる会社にすることです。そのための仕組みが下段のバランスト・スコアカードで、四つの指標を先に決めておきます。最後に、この事業の顧客・商品・収益は、すべて現在の勤務先の中にも存在します。だから復職後は、生産技術と情報システムの領域で、現場と技術のあいだを訳す役割を担いたいと考えています。そして、自らの役割を定義しきること自体が、業務を際限なく抱え込まないための再発防止策でもあります。以上です。</a:t>
             </a:r>
             <a:endParaRPr lang="en-US" dirty="0"/>
           </a:p>
@@ -4060,14 +4060,34 @@
       </p:sp>
       <p:sp>
         <p:nvSpPr>
-          <p:cNvPr id="23" name="Text 19"/>
+          <p:cNvPr id="23" name="policy-quote"/>
+          <p:cNvSpPr/>
+          <p:nvPr/>
+        </p:nvSpPr>
+        <p:spPr>
+          <a:xfrm>
+            <a:off x="3429000" y="3456432"/>
+            <a:ext cx="5074920" cy="658368"/>
+          </a:xfrm>
+          <a:prstGeom prst="rect">
+            <a:avLst/>
+          </a:prstGeom>
+          <a:solidFill>
+            <a:srgbClr val="F2F2F2"/>
+          </a:solidFill>
+          <a:ln/>
+        </p:spPr>
+      </p:sp>
+      <p:sp>
+        <p:nvSpPr>
+          <p:cNvPr id="24" name="Text 20"/>
           <p:cNvSpPr txBox="1"/>
           <p:nvPr/>
         </p:nvSpPr>
         <p:spPr>
           <a:xfrm>
-            <a:off x="3429000" y="3520440"/>
-            <a:ext cx="5074920" cy="256032"/>
+            <a:off x="3538728" y="3456432"/>
+            <a:ext cx="4855464" cy="658368"/>
           </a:xfrm>
           <a:prstGeom prst="rect">
             <a:avLst/>
@@ -4076,17 +4096,43 @@
           <a:ln/>
         </p:spPr>
         <p:txBody>
-          <a:bodyPr wrap="square" lIns="0" tIns="0" rIns="0" bIns="0" rtlCol="0" anchor="t"/>
+          <a:bodyPr wrap="square" lIns="0" tIns="0" rIns="0" bIns="0" rtlCol="0" anchor="ctr"/>
           <a:lstStyle/>
           <a:p>
             <a:pPr algn="l" indent="0" marL="0">
               <a:lnSpc>
                 <a:spcPct val="115000"/>
               </a:lnSpc>
-              <a:buNone/>
-            </a:pPr>
-            <a:r>
-              <a:rPr lang="en-US" sz="950" dirty="0">
+              <a:spcAft>
+                <a:spcPts val="200"/>
+              </a:spcAft>
+              <a:buNone/>
+            </a:pPr>
+            <a:r>
+              <a:rPr lang="en-US" sz="950" b="1" dirty="0">
+                <a:solidFill>
+                  <a:srgbClr val="1A1A1A"/>
+                </a:solidFill>
+                <a:latin typeface="Meiryo" pitchFamily="34" charset="0"/>
+                <a:ea typeface="Meiryo" pitchFamily="34" charset="-122"/>
+                <a:cs typeface="Meiryo" pitchFamily="34" charset="-120"/>
+              </a:rPr>
+              <a:t>「暗黙知が豊富な現場へのバーティカルAIの開発・実装を推進し、輸出も促進する」</a:t>
+            </a:r>
+            <a:endParaRPr lang="en-US" sz="950" dirty="0"/>
+          </a:p>
+          <a:p>
+            <a:pPr algn="l" indent="0" marL="0">
+              <a:lnSpc>
+                <a:spcPct val="115000"/>
+              </a:lnSpc>
+              <a:spcAft>
+                <a:spcPts val="200"/>
+              </a:spcAft>
+              <a:buNone/>
+            </a:pPr>
+            <a:r>
+              <a:rPr lang="en-US" sz="800" dirty="0">
                 <a:solidFill>
                   <a:srgbClr val="4D4D4D"/>
                 </a:solidFill>
@@ -4094,7 +4140,7 @@
                 <a:ea typeface="Meiryo" pitchFamily="34" charset="-122"/>
                 <a:cs typeface="Meiryo" pitchFamily="34" charset="-120"/>
               </a:rPr>
-              <a:t>本日の流れ：課題 → 解決策 → 収益の仕組み → 競合 → 組織 → 計画 → リスク</a:t>
+              <a:t>─ 内閣府「人工知能基本計画 ～日本AX、より強く、より豊かに～」（令和8年7月14日 閣議決定）</a:t>
             </a:r>
             <a:endParaRPr lang="en-US" sz="950" dirty="0"/>
           </a:p>
@@ -4102,7 +4148,7 @@
       </p:sp>
       <p:sp>
         <p:nvSpPr>
-          <p:cNvPr id="24" name="Text 20"/>
+          <p:cNvPr id="25" name="Text 21"/>
           <p:cNvSpPr txBox="1"/>
           <p:nvPr/>
         </p:nvSpPr>
@@ -4251,7 +4297,7 @@
                 <a:ea typeface="Meiryo" pitchFamily="34" charset="-122"/>
                 <a:cs typeface="Meiryo" pitchFamily="34" charset="-120"/>
               </a:rPr>
-              <a:t>設問①　課題 ─ 熟練者の勘が、記録に残らないまま消えていく</a:t>
+              <a:t>設問①　課題 ─ デジタル化は進んだのに、技能継承は人頼みのまま</a:t>
             </a:r>
             <a:endParaRPr lang="en-US" sz="2000" dirty="0"/>
           </a:p>
@@ -4293,7 +4339,7 @@
                 <a:ea typeface="Meiryo" pitchFamily="34" charset="-122"/>
                 <a:cs typeface="Meiryo" pitchFamily="34" charset="-120"/>
               </a:rPr>
-              <a:t>担い手は高齢化して減っているのに、技能継承にデジタルを使う企業は2割にとどまる</a:t>
+              <a:t>技能継承の主流は「ベテランに居続けてもらう」。デジタル活用で継承が円滑になった企業は8.7%</a:t>
             </a:r>
             <a:endParaRPr lang="en-US" sz="1200" dirty="0"/>
           </a:p>
@@ -4308,7 +4354,7 @@
         <p:spPr>
           <a:xfrm>
             <a:off x="365760" y="1051560"/>
-            <a:ext cx="4343400" cy="1188720"/>
+            <a:ext cx="4206240" cy="1115568"/>
           </a:xfrm>
           <a:prstGeom prst="rect">
             <a:avLst/>
@@ -4328,7 +4374,7 @@
         <p:spPr>
           <a:xfrm>
             <a:off x="502920" y="1124712"/>
-            <a:ext cx="4069080" cy="256032"/>
+            <a:ext cx="3931920" cy="256032"/>
           </a:xfrm>
           <a:prstGeom prst="rect">
             <a:avLst/>
@@ -4369,8 +4415,8 @@
         </p:nvSpPr>
         <p:spPr>
           <a:xfrm>
-            <a:off x="502920" y="1435608"/>
-            <a:ext cx="4069080" cy="749808"/>
+            <a:off x="502920" y="1417320"/>
+            <a:ext cx="3931920" cy="713232"/>
           </a:xfrm>
           <a:prstGeom prst="rect">
             <a:avLst/>
@@ -4520,8 +4566,8 @@
         </p:nvSpPr>
         <p:spPr>
           <a:xfrm>
-            <a:off x="365760" y="2514600"/>
-            <a:ext cx="4343400" cy="256032"/>
+            <a:off x="365760" y="2423160"/>
+            <a:ext cx="4206240" cy="256032"/>
           </a:xfrm>
           <a:prstGeom prst="rect">
             <a:avLst/>
@@ -4562,8 +4608,8 @@
         </p:nvSpPr>
         <p:spPr>
           <a:xfrm>
-            <a:off x="365760" y="2788920"/>
-            <a:ext cx="4343400" cy="1371600"/>
+            <a:off x="365760" y="2697480"/>
+            <a:ext cx="4206240" cy="1371600"/>
           </a:xfrm>
           <a:prstGeom prst="rect">
             <a:avLst/>
@@ -4656,7 +4702,7 @@
                 <a:ea typeface="Meiryo" pitchFamily="34" charset="-122"/>
                 <a:cs typeface="Meiryo" pitchFamily="34" charset="-120"/>
               </a:rPr>
-              <a:t>Python・Power BI・FastAPI・Docker・LangChain・RAG を独学し業務に実装</a:t>
+              <a:t>Python・FastAPI・Docker・LangChain・RAG を独学し業務に実装。音声の自動配信も個人で構築</a:t>
             </a:r>
             <a:endParaRPr lang="en-US" sz="1000" dirty="0"/>
           </a:p>
@@ -4707,14 +4753,304 @@
       </p:sp>
       <p:sp>
         <p:nvSpPr>
-          <p:cNvPr id="10" name="stat-0"/>
+          <p:cNvPr id="10" name="Text 7"/>
+          <p:cNvSpPr txBox="1"/>
+          <p:nvPr/>
+        </p:nvSpPr>
+        <p:spPr>
+          <a:xfrm>
+            <a:off x="4800600" y="1051560"/>
+            <a:ext cx="3977640" cy="237744"/>
+          </a:xfrm>
+          <a:prstGeom prst="rect">
+            <a:avLst/>
+          </a:prstGeom>
+          <a:noFill/>
+          <a:ln/>
+        </p:spPr>
+        <p:txBody>
+          <a:bodyPr wrap="square" lIns="0" tIns="0" rIns="0" bIns="0" rtlCol="0" anchor="t"/>
+          <a:lstStyle/>
+          <a:p>
+            <a:pPr algn="l" indent="0" marL="0">
+              <a:lnSpc>
+                <a:spcPct val="115000"/>
+              </a:lnSpc>
+              <a:buNone/>
+            </a:pPr>
+            <a:r>
+              <a:rPr lang="en-US" sz="1050" b="1" dirty="0">
+                <a:solidFill>
+                  <a:srgbClr val="1A1A1A"/>
+                </a:solidFill>
+                <a:latin typeface="Meiryo" pitchFamily="34" charset="0"/>
+                <a:ea typeface="Meiryo" pitchFamily="34" charset="-122"/>
+                <a:cs typeface="Meiryo" pitchFamily="34" charset="-120"/>
+              </a:rPr>
+              <a:t>デジタル化と技能継承のギャップ（製造業）</a:t>
+            </a:r>
+            <a:endParaRPr lang="en-US" sz="1050" dirty="0"/>
+          </a:p>
+        </p:txBody>
+      </p:sp>
+      <p:sp>
+        <p:nvSpPr>
+          <p:cNvPr id="11" name="Text 8"/>
+          <p:cNvSpPr txBox="1"/>
+          <p:nvPr/>
+        </p:nvSpPr>
+        <p:spPr>
+          <a:xfrm>
+            <a:off x="4800600" y="1362456"/>
+            <a:ext cx="3977640" cy="201168"/>
+          </a:xfrm>
+          <a:prstGeom prst="rect">
+            <a:avLst/>
+          </a:prstGeom>
+          <a:noFill/>
+          <a:ln/>
+        </p:spPr>
+        <p:txBody>
+          <a:bodyPr wrap="square" lIns="0" tIns="0" rIns="0" bIns="0" rtlCol="0" anchor="t"/>
+          <a:lstStyle/>
+          <a:p>
+            <a:pPr algn="l" indent="0" marL="0">
+              <a:lnSpc>
+                <a:spcPct val="115000"/>
+              </a:lnSpc>
+              <a:buNone/>
+            </a:pPr>
+            <a:r>
+              <a:rPr lang="en-US" sz="850" dirty="0">
+                <a:solidFill>
+                  <a:srgbClr val="1A1A1A"/>
+                </a:solidFill>
+                <a:latin typeface="Meiryo" pitchFamily="34" charset="0"/>
+                <a:ea typeface="Meiryo" pitchFamily="34" charset="-122"/>
+                <a:cs typeface="Meiryo" pitchFamily="34" charset="-120"/>
+              </a:rPr>
+              <a:t>業務改善にデジタル技術を活用している企業 (1)</a:t>
+            </a:r>
+            <a:endParaRPr lang="en-US" sz="850" dirty="0"/>
+          </a:p>
+        </p:txBody>
+      </p:sp>
+      <p:sp>
+        <p:nvSpPr>
+          <p:cNvPr id="12" name="Shape 9"/>
           <p:cNvSpPr/>
           <p:nvPr/>
         </p:nvSpPr>
         <p:spPr>
           <a:xfrm>
-            <a:off x="4937760" y="1051560"/>
-            <a:ext cx="1874520" cy="1481328"/>
+            <a:off x="4846320" y="1581912"/>
+            <a:ext cx="3291840" cy="274320"/>
+          </a:xfrm>
+          <a:prstGeom prst="rect">
+            <a:avLst/>
+          </a:prstGeom>
+          <a:solidFill>
+            <a:srgbClr val="F2F2F2"/>
+          </a:solidFill>
+          <a:ln/>
+        </p:spPr>
+      </p:sp>
+      <p:sp>
+        <p:nvSpPr>
+          <p:cNvPr id="13" name="bar-0"/>
+          <p:cNvSpPr/>
+          <p:nvPr/>
+        </p:nvSpPr>
+        <p:spPr>
+          <a:xfrm>
+            <a:off x="4846320" y="1581912"/>
+            <a:ext cx="2541300" cy="274320"/>
+          </a:xfrm>
+          <a:prstGeom prst="rect">
+            <a:avLst/>
+          </a:prstGeom>
+          <a:solidFill>
+            <a:srgbClr val="1A1A1A"/>
+          </a:solidFill>
+          <a:ln/>
+        </p:spPr>
+      </p:sp>
+      <p:sp>
+        <p:nvSpPr>
+          <p:cNvPr id="14" name="Text 11"/>
+          <p:cNvSpPr txBox="1"/>
+          <p:nvPr/>
+        </p:nvSpPr>
+        <p:spPr>
+          <a:xfrm>
+            <a:off x="7442484" y="1563624"/>
+            <a:ext cx="685800" cy="310896"/>
+          </a:xfrm>
+          <a:prstGeom prst="rect">
+            <a:avLst/>
+          </a:prstGeom>
+          <a:noFill/>
+          <a:ln/>
+        </p:spPr>
+        <p:txBody>
+          <a:bodyPr wrap="square" lIns="0" tIns="0" rIns="0" bIns="0" rtlCol="0" anchor="ctr"/>
+          <a:lstStyle/>
+          <a:p>
+            <a:pPr algn="l" indent="0" marL="0">
+              <a:lnSpc>
+                <a:spcPct val="115000"/>
+              </a:lnSpc>
+              <a:buNone/>
+            </a:pPr>
+            <a:r>
+              <a:rPr lang="en-US" sz="1400" b="1" dirty="0">
+                <a:solidFill>
+                  <a:srgbClr val="1A1A1A"/>
+                </a:solidFill>
+                <a:latin typeface="Meiryo" pitchFamily="34" charset="0"/>
+                <a:ea typeface="Meiryo" pitchFamily="34" charset="-122"/>
+                <a:cs typeface="Meiryo" pitchFamily="34" charset="-120"/>
+              </a:rPr>
+              <a:t>77.2%</a:t>
+            </a:r>
+            <a:endParaRPr lang="en-US" sz="1400" dirty="0"/>
+          </a:p>
+        </p:txBody>
+      </p:sp>
+      <p:sp>
+        <p:nvSpPr>
+          <p:cNvPr id="15" name="Text 12"/>
+          <p:cNvSpPr txBox="1"/>
+          <p:nvPr/>
+        </p:nvSpPr>
+        <p:spPr>
+          <a:xfrm>
+            <a:off x="4800600" y="1984248"/>
+            <a:ext cx="3977640" cy="201168"/>
+          </a:xfrm>
+          <a:prstGeom prst="rect">
+            <a:avLst/>
+          </a:prstGeom>
+          <a:noFill/>
+          <a:ln/>
+        </p:spPr>
+        <p:txBody>
+          <a:bodyPr wrap="square" lIns="0" tIns="0" rIns="0" bIns="0" rtlCol="0" anchor="t"/>
+          <a:lstStyle/>
+          <a:p>
+            <a:pPr algn="l" indent="0" marL="0">
+              <a:lnSpc>
+                <a:spcPct val="115000"/>
+              </a:lnSpc>
+              <a:buNone/>
+            </a:pPr>
+            <a:r>
+              <a:rPr lang="en-US" sz="850" dirty="0">
+                <a:solidFill>
+                  <a:srgbClr val="1A1A1A"/>
+                </a:solidFill>
+                <a:latin typeface="Meiryo" pitchFamily="34" charset="0"/>
+                <a:ea typeface="Meiryo" pitchFamily="34" charset="-122"/>
+                <a:cs typeface="Meiryo" pitchFamily="34" charset="-120"/>
+              </a:rPr>
+              <a:t>その効果として、技能継承が円滑になった企業 (2)</a:t>
+            </a:r>
+            <a:endParaRPr lang="en-US" sz="850" dirty="0"/>
+          </a:p>
+        </p:txBody>
+      </p:sp>
+      <p:sp>
+        <p:nvSpPr>
+          <p:cNvPr id="16" name="Shape 13"/>
+          <p:cNvSpPr/>
+          <p:nvPr/>
+        </p:nvSpPr>
+        <p:spPr>
+          <a:xfrm>
+            <a:off x="4846320" y="2203704"/>
+            <a:ext cx="3291840" cy="274320"/>
+          </a:xfrm>
+          <a:prstGeom prst="rect">
+            <a:avLst/>
+          </a:prstGeom>
+          <a:solidFill>
+            <a:srgbClr val="F2F2F2"/>
+          </a:solidFill>
+          <a:ln/>
+        </p:spPr>
+      </p:sp>
+      <p:sp>
+        <p:nvSpPr>
+          <p:cNvPr id="17" name="bar-1"/>
+          <p:cNvSpPr/>
+          <p:nvPr/>
+        </p:nvSpPr>
+        <p:spPr>
+          <a:xfrm>
+            <a:off x="4846320" y="2203704"/>
+            <a:ext cx="286390" cy="274320"/>
+          </a:xfrm>
+          <a:prstGeom prst="rect">
+            <a:avLst/>
+          </a:prstGeom>
+          <a:solidFill>
+            <a:srgbClr val="4D4D4D"/>
+          </a:solidFill>
+          <a:ln/>
+        </p:spPr>
+      </p:sp>
+      <p:sp>
+        <p:nvSpPr>
+          <p:cNvPr id="18" name="Text 15"/>
+          <p:cNvSpPr txBox="1"/>
+          <p:nvPr/>
+        </p:nvSpPr>
+        <p:spPr>
+          <a:xfrm>
+            <a:off x="5187574" y="2185416"/>
+            <a:ext cx="685800" cy="310896"/>
+          </a:xfrm>
+          <a:prstGeom prst="rect">
+            <a:avLst/>
+          </a:prstGeom>
+          <a:noFill/>
+          <a:ln/>
+        </p:spPr>
+        <p:txBody>
+          <a:bodyPr wrap="square" lIns="0" tIns="0" rIns="0" bIns="0" rtlCol="0" anchor="ctr"/>
+          <a:lstStyle/>
+          <a:p>
+            <a:pPr algn="l" indent="0" marL="0">
+              <a:lnSpc>
+                <a:spcPct val="115000"/>
+              </a:lnSpc>
+              <a:buNone/>
+            </a:pPr>
+            <a:r>
+              <a:rPr lang="en-US" sz="1400" b="1" dirty="0">
+                <a:solidFill>
+                  <a:srgbClr val="1A1A1A"/>
+                </a:solidFill>
+                <a:latin typeface="Meiryo" pitchFamily="34" charset="0"/>
+                <a:ea typeface="Meiryo" pitchFamily="34" charset="-122"/>
+                <a:cs typeface="Meiryo" pitchFamily="34" charset="-120"/>
+              </a:rPr>
+              <a:t>8.7%</a:t>
+            </a:r>
+            <a:endParaRPr lang="en-US" sz="1400" dirty="0"/>
+          </a:p>
+        </p:txBody>
+      </p:sp>
+      <p:sp>
+        <p:nvSpPr>
+          <p:cNvPr id="19" name="stat-0"/>
+          <p:cNvSpPr/>
+          <p:nvPr/>
+        </p:nvSpPr>
+        <p:spPr>
+          <a:xfrm>
+            <a:off x="4800600" y="2715768"/>
+            <a:ext cx="1943100" cy="1325880"/>
           </a:xfrm>
           <a:prstGeom prst="rect">
             <a:avLst/>
@@ -4732,14 +5068,14 @@
       </p:sp>
       <p:sp>
         <p:nvSpPr>
-          <p:cNvPr id="11" name="Text 8"/>
+          <p:cNvPr id="20" name="Text 17"/>
           <p:cNvSpPr txBox="1"/>
           <p:nvPr/>
         </p:nvSpPr>
         <p:spPr>
           <a:xfrm>
-            <a:off x="5047488" y="1188720"/>
-            <a:ext cx="1655064" cy="457200"/>
+            <a:off x="4910328" y="2807208"/>
+            <a:ext cx="1723644" cy="411480"/>
           </a:xfrm>
           <a:prstGeom prst="rect">
             <a:avLst/>
@@ -4766,7 +5102,7 @@
                 <a:ea typeface="Meiryo" pitchFamily="34" charset="-122"/>
                 <a:cs typeface="Meiryo" pitchFamily="34" charset="-120"/>
               </a:rPr>
-              <a:t>36.7%</a:t>
+              <a:t>54.8%</a:t>
             </a:r>
             <a:endParaRPr lang="en-US" sz="2000" dirty="0"/>
           </a:p>
@@ -4774,14 +5110,14 @@
       </p:sp>
       <p:sp>
         <p:nvSpPr>
-          <p:cNvPr id="12" name="Text 9"/>
+          <p:cNvPr id="21" name="Text 18"/>
           <p:cNvSpPr txBox="1"/>
           <p:nvPr/>
         </p:nvSpPr>
         <p:spPr>
           <a:xfrm>
-            <a:off x="5047488" y="1737360"/>
-            <a:ext cx="1655064" cy="731520"/>
+            <a:off x="4910328" y="3264408"/>
+            <a:ext cx="1723644" cy="731520"/>
           </a:xfrm>
           <a:prstGeom prst="rect">
             <a:avLst/>
@@ -4800,7 +5136,7 @@
               <a:buNone/>
             </a:pPr>
             <a:r>
-              <a:rPr lang="en-US" sz="950" dirty="0">
+              <a:rPr lang="en-US" sz="900" dirty="0">
                 <a:solidFill>
                   <a:srgbClr val="1A1A1A"/>
                 </a:solidFill>
@@ -4808,22 +5144,22 @@
                 <a:ea typeface="Meiryo" pitchFamily="34" charset="-122"/>
                 <a:cs typeface="Meiryo" pitchFamily="34" charset="-120"/>
               </a:rPr>
-              <a:t>建設業就業者のうち55歳以上（29歳以下は11.7%）</a:t>
-            </a:r>
-            <a:endParaRPr lang="en-US" sz="950" dirty="0"/>
-          </a:p>
-        </p:txBody>
-      </p:sp>
-      <p:sp>
-        <p:nvSpPr>
-          <p:cNvPr id="13" name="stat-1"/>
+              <a:t>技能継承の取組で最も多いのは「再雇用・勤務延長でベテランに居続けてもらう」(3)</a:t>
+            </a:r>
+            <a:endParaRPr lang="en-US" sz="900" dirty="0"/>
+          </a:p>
+        </p:txBody>
+      </p:sp>
+      <p:sp>
+        <p:nvSpPr>
+          <p:cNvPr id="22" name="stat-1"/>
           <p:cNvSpPr/>
           <p:nvPr/>
         </p:nvSpPr>
         <p:spPr>
           <a:xfrm>
-            <a:off x="6903720" y="1051560"/>
-            <a:ext cx="1874520" cy="1481328"/>
+            <a:off x="6835140" y="2715768"/>
+            <a:ext cx="1943100" cy="1325880"/>
           </a:xfrm>
           <a:prstGeom prst="rect">
             <a:avLst/>
@@ -4841,14 +5177,14 @@
       </p:sp>
       <p:sp>
         <p:nvSpPr>
-          <p:cNvPr id="14" name="Text 11"/>
+          <p:cNvPr id="23" name="Text 20"/>
           <p:cNvSpPr txBox="1"/>
           <p:nvPr/>
         </p:nvSpPr>
         <p:spPr>
           <a:xfrm>
-            <a:off x="7013448" y="1188720"/>
-            <a:ext cx="1655064" cy="457200"/>
+            <a:off x="6944868" y="2807208"/>
+            <a:ext cx="1723644" cy="411480"/>
           </a:xfrm>
           <a:prstGeom prst="rect">
             <a:avLst/>
@@ -4875,7 +5211,7 @@
                 <a:ea typeface="Meiryo" pitchFamily="34" charset="-122"/>
                 <a:cs typeface="Meiryo" pitchFamily="34" charset="-120"/>
               </a:rPr>
-              <a:t>1,033万人</a:t>
+              <a:t>62.8%</a:t>
             </a:r>
             <a:endParaRPr lang="en-US" sz="2000" dirty="0"/>
           </a:p>
@@ -4883,14 +5219,14 @@
       </p:sp>
       <p:sp>
         <p:nvSpPr>
-          <p:cNvPr id="15" name="Text 12"/>
+          <p:cNvPr id="24" name="Text 21"/>
           <p:cNvSpPr txBox="1"/>
           <p:nvPr/>
         </p:nvSpPr>
         <p:spPr>
           <a:xfrm>
-            <a:off x="7013448" y="1737360"/>
-            <a:ext cx="1655064" cy="731520"/>
+            <a:off x="6944868" y="3264408"/>
+            <a:ext cx="1723644" cy="731520"/>
           </a:xfrm>
           <a:prstGeom prst="rect">
             <a:avLst/>
@@ -4909,7 +5245,7 @@
               <a:buNone/>
             </a:pPr>
             <a:r>
-              <a:rPr lang="en-US" sz="950" dirty="0">
+              <a:rPr lang="en-US" sz="900" dirty="0">
                 <a:solidFill>
                   <a:srgbClr val="1A1A1A"/>
                 </a:solidFill>
@@ -4917,47 +5253,22 @@
                 <a:ea typeface="Meiryo" pitchFamily="34" charset="-122"/>
                 <a:cs typeface="Meiryo" pitchFamily="34" charset="-120"/>
               </a:rPr>
-              <a:t>製造業就業者数（2025年。2023年の1,055万人から減少）</a:t>
-            </a:r>
-            <a:endParaRPr lang="en-US" sz="950" dirty="0"/>
-          </a:p>
-        </p:txBody>
-      </p:sp>
-      <p:sp>
-        <p:nvSpPr>
-          <p:cNvPr id="16" name="stat-2"/>
-          <p:cNvSpPr/>
-          <p:nvPr/>
-        </p:nvSpPr>
-        <p:spPr>
-          <a:xfrm>
-            <a:off x="4937760" y="2624328"/>
-            <a:ext cx="1874520" cy="1481328"/>
-          </a:xfrm>
-          <a:prstGeom prst="rect">
-            <a:avLst/>
-          </a:prstGeom>
-          <a:solidFill>
-            <a:srgbClr val="FFFFFF"/>
-          </a:solidFill>
-          <a:ln w="9525">
-            <a:solidFill>
-              <a:srgbClr val="BFBFBF"/>
-            </a:solidFill>
-            <a:prstDash val="solid"/>
-          </a:ln>
-        </p:spPr>
-      </p:sp>
-      <p:sp>
-        <p:nvSpPr>
-          <p:cNvPr id="17" name="Text 14"/>
+              <a:t>製造業の育成上の問題「指導する人材が不足」。「育成する時間がない」も45.4% (3)</a:t>
+            </a:r>
+            <a:endParaRPr lang="en-US" sz="900" dirty="0"/>
+          </a:p>
+        </p:txBody>
+      </p:sp>
+      <p:sp>
+        <p:nvSpPr>
+          <p:cNvPr id="25" name="Text 22"/>
           <p:cNvSpPr txBox="1"/>
           <p:nvPr/>
         </p:nvSpPr>
         <p:spPr>
           <a:xfrm>
-            <a:off x="5047488" y="2761488"/>
-            <a:ext cx="1655064" cy="457200"/>
+            <a:off x="365760" y="4535424"/>
+            <a:ext cx="8412480" cy="274320"/>
           </a:xfrm>
           <a:prstGeom prst="rect">
             <a:avLst/>
@@ -4966,48 +5277,6 @@
           <a:ln/>
         </p:spPr>
         <p:txBody>
-          <a:bodyPr wrap="square" lIns="0" tIns="0" rIns="0" bIns="0" rtlCol="0" anchor="ctr"/>
-          <a:lstStyle/>
-          <a:p>
-            <a:pPr algn="l" indent="0" marL="0">
-              <a:lnSpc>
-                <a:spcPct val="115000"/>
-              </a:lnSpc>
-              <a:buNone/>
-            </a:pPr>
-            <a:r>
-              <a:rPr lang="en-US" sz="2000" b="1" dirty="0">
-                <a:solidFill>
-                  <a:srgbClr val="1A1A1A"/>
-                </a:solidFill>
-                <a:latin typeface="Meiryo" pitchFamily="34" charset="0"/>
-                <a:ea typeface="Meiryo" pitchFamily="34" charset="-122"/>
-                <a:cs typeface="Meiryo" pitchFamily="34" charset="-120"/>
-              </a:rPr>
-              <a:t>3社に2社</a:t>
-            </a:r>
-            <a:endParaRPr lang="en-US" sz="2000" dirty="0"/>
-          </a:p>
-        </p:txBody>
-      </p:sp>
-      <p:sp>
-        <p:nvSpPr>
-          <p:cNvPr id="18" name="Text 15"/>
-          <p:cNvSpPr txBox="1"/>
-          <p:nvPr/>
-        </p:nvSpPr>
-        <p:spPr>
-          <a:xfrm>
-            <a:off x="5047488" y="3310128"/>
-            <a:ext cx="1655064" cy="731520"/>
-          </a:xfrm>
-          <a:prstGeom prst="rect">
-            <a:avLst/>
-          </a:prstGeom>
-          <a:noFill/>
-          <a:ln/>
-        </p:spPr>
-        <p:txBody>
           <a:bodyPr wrap="square" lIns="0" tIns="0" rIns="0" bIns="0" rtlCol="0" anchor="t"/>
           <a:lstStyle/>
           <a:p>
@@ -5018,166 +5287,15 @@
               <a:buNone/>
             </a:pPr>
             <a:r>
-              <a:rPr lang="en-US" sz="950" dirty="0">
-                <a:solidFill>
-                  <a:srgbClr val="1A1A1A"/>
-                </a:solidFill>
-                <a:latin typeface="Meiryo" pitchFamily="34" charset="0"/>
-                <a:ea typeface="Meiryo" pitchFamily="34" charset="-122"/>
-                <a:cs typeface="Meiryo" pitchFamily="34" charset="-120"/>
-              </a:rPr>
-              <a:t>技能継承がうまくいっていない製造企業</a:t>
-            </a:r>
-            <a:endParaRPr lang="en-US" sz="950" dirty="0"/>
-          </a:p>
-        </p:txBody>
-      </p:sp>
-      <p:sp>
-        <p:nvSpPr>
-          <p:cNvPr id="19" name="stat-3"/>
-          <p:cNvSpPr/>
-          <p:nvPr/>
-        </p:nvSpPr>
-        <p:spPr>
-          <a:xfrm>
-            <a:off x="6903720" y="2624328"/>
-            <a:ext cx="1874520" cy="1481328"/>
-          </a:xfrm>
-          <a:prstGeom prst="rect">
-            <a:avLst/>
-          </a:prstGeom>
-          <a:solidFill>
-            <a:srgbClr val="FFFFFF"/>
-          </a:solidFill>
-          <a:ln w="9525">
-            <a:solidFill>
-              <a:srgbClr val="BFBFBF"/>
-            </a:solidFill>
-            <a:prstDash val="solid"/>
-          </a:ln>
-        </p:spPr>
-      </p:sp>
-      <p:sp>
-        <p:nvSpPr>
-          <p:cNvPr id="20" name="Text 17"/>
-          <p:cNvSpPr txBox="1"/>
-          <p:nvPr/>
-        </p:nvSpPr>
-        <p:spPr>
-          <a:xfrm>
-            <a:off x="7013448" y="2761488"/>
-            <a:ext cx="1655064" cy="457200"/>
-          </a:xfrm>
-          <a:prstGeom prst="rect">
-            <a:avLst/>
-          </a:prstGeom>
-          <a:noFill/>
-          <a:ln/>
-        </p:spPr>
-        <p:txBody>
-          <a:bodyPr wrap="square" lIns="0" tIns="0" rIns="0" bIns="0" rtlCol="0" anchor="ctr"/>
-          <a:lstStyle/>
-          <a:p>
-            <a:pPr algn="l" indent="0" marL="0">
-              <a:lnSpc>
-                <a:spcPct val="115000"/>
-              </a:lnSpc>
-              <a:buNone/>
-            </a:pPr>
-            <a:r>
-              <a:rPr lang="en-US" sz="2000" b="1" dirty="0">
-                <a:solidFill>
-                  <a:srgbClr val="1A1A1A"/>
-                </a:solidFill>
-                <a:latin typeface="Meiryo" pitchFamily="34" charset="0"/>
-                <a:ea typeface="Meiryo" pitchFamily="34" charset="-122"/>
-                <a:cs typeface="Meiryo" pitchFamily="34" charset="-120"/>
-              </a:rPr>
-              <a:t>21.7%</a:t>
-            </a:r>
-            <a:endParaRPr lang="en-US" sz="2000" dirty="0"/>
-          </a:p>
-        </p:txBody>
-      </p:sp>
-      <p:sp>
-        <p:nvSpPr>
-          <p:cNvPr id="21" name="Text 18"/>
-          <p:cNvSpPr txBox="1"/>
-          <p:nvPr/>
-        </p:nvSpPr>
-        <p:spPr>
-          <a:xfrm>
-            <a:off x="7013448" y="3310128"/>
-            <a:ext cx="1655064" cy="731520"/>
-          </a:xfrm>
-          <a:prstGeom prst="rect">
-            <a:avLst/>
-          </a:prstGeom>
-          <a:noFill/>
-          <a:ln/>
-        </p:spPr>
-        <p:txBody>
-          <a:bodyPr wrap="square" lIns="0" tIns="0" rIns="0" bIns="0" rtlCol="0" anchor="t"/>
-          <a:lstStyle/>
-          <a:p>
-            <a:pPr algn="l" indent="0" marL="0">
-              <a:lnSpc>
-                <a:spcPct val="115000"/>
-              </a:lnSpc>
-              <a:buNone/>
-            </a:pPr>
-            <a:r>
-              <a:rPr lang="en-US" sz="950" dirty="0">
-                <a:solidFill>
-                  <a:srgbClr val="1A1A1A"/>
-                </a:solidFill>
-                <a:latin typeface="Meiryo" pitchFamily="34" charset="0"/>
-                <a:ea typeface="Meiryo" pitchFamily="34" charset="-122"/>
-                <a:cs typeface="Meiryo" pitchFamily="34" charset="-120"/>
-              </a:rPr>
-              <a:t>技能継承にデジタル技術を活用している企業</a:t>
-            </a:r>
-            <a:endParaRPr lang="en-US" sz="950" dirty="0"/>
-          </a:p>
-        </p:txBody>
-      </p:sp>
-      <p:sp>
-        <p:nvSpPr>
-          <p:cNvPr id="22" name="Text 19"/>
-          <p:cNvSpPr txBox="1"/>
-          <p:nvPr/>
-        </p:nvSpPr>
-        <p:spPr>
-          <a:xfrm>
-            <a:off x="365760" y="4480560"/>
-            <a:ext cx="8412480" cy="347472"/>
-          </a:xfrm>
-          <a:prstGeom prst="rect">
-            <a:avLst/>
-          </a:prstGeom>
-          <a:noFill/>
-          <a:ln/>
-        </p:spPr>
-        <p:txBody>
-          <a:bodyPr wrap="square" lIns="0" tIns="0" rIns="0" bIns="0" rtlCol="0" anchor="t"/>
-          <a:lstStyle/>
-          <a:p>
-            <a:pPr algn="l" indent="0" marL="0">
-              <a:lnSpc>
-                <a:spcPct val="115000"/>
-              </a:lnSpc>
-              <a:buNone/>
-            </a:pPr>
-            <a:r>
               <a:rPr lang="en-US" sz="800" dirty="0">
                 <a:solidFill>
-                  <a:srgbClr val="4D4D4D"/>
-                </a:solidFill>
-                <a:latin typeface="Meiryo" pitchFamily="34" charset="0"/>
-                <a:ea typeface="Meiryo" pitchFamily="34" charset="-122"/>
-                <a:cs typeface="Meiryo" pitchFamily="34" charset="-120"/>
-              </a:rPr>
-              <a:t>出典：国土交通省（総務省「労働力調査」2024年）／経済産業省・厚生労働省・文部科学省「ものづくり白書」2026年版／労働政策研究・研修機構「ものづくり産業における人材確保・定着と技能継承に関する調査」（2026年5月）</a:t>
+                  <a:srgbClr val="8C8C8C"/>
+                </a:solidFill>
+                <a:latin typeface="Meiryo" pitchFamily="34" charset="0"/>
+                <a:ea typeface="Meiryo" pitchFamily="34" charset="-122"/>
+                <a:cs typeface="Meiryo" pitchFamily="34" charset="-120"/>
+              </a:rPr>
+              <a:t>(1) 労働政策研究・研修機構 調査シリーズNo.267（2026年4月）　(2) 同 No.265（2026年3月）　(3) 経済産業省・厚生労働省・文部科学省「2026年版 ものづくり白書」（令和8年5月）</a:t>
             </a:r>
             <a:endParaRPr lang="en-US" sz="800" dirty="0"/>
           </a:p>
@@ -5334,7 +5452,7 @@
                 <a:ea typeface="Meiryo" pitchFamily="34" charset="-122"/>
                 <a:cs typeface="Meiryo" pitchFamily="34" charset="-120"/>
               </a:rPr>
-              <a:t>データを集めて終わらせない。勘どころを言語化し、研修資料・音声番組・動画まで当社が作って届ける</a:t>
+              <a:t>記録と整理は手段。差別化は③：連続工程の勘どころを、研修資料・音声番組・動画にして当社が届ける</a:t>
             </a:r>
             <a:endParaRPr lang="en-US" sz="1200" dirty="0"/>
           </a:p>
@@ -5539,7 +5657,7 @@
                 <a:ea typeface="Meiryo" pitchFamily="34" charset="-122"/>
                 <a:cs typeface="Meiryo" pitchFamily="34" charset="-120"/>
               </a:rPr>
-              <a:t>記録アプリ（音声・写真）＋MES連携</a:t>
+              <a:t>記録アプリ（音声）。構造化を現場に求めない (1)</a:t>
             </a:r>
             <a:endParaRPr lang="en-US" sz="850" dirty="0"/>
           </a:p>
@@ -5974,7 +6092,7 @@
                 <a:ea typeface="Meiryo" pitchFamily="34" charset="-122"/>
                 <a:cs typeface="Meiryo" pitchFamily="34" charset="-120"/>
               </a:rPr>
-              <a:t>現場が忙しくて作れない研修資料・音声番組・動画を当社が制作し、現場に届ける</a:t>
+              <a:t>指導役が足りず（59.5%）、育成の時間もない（47.4%）(2)。だから教材は当社が作って届ける</a:t>
             </a:r>
             <a:endParaRPr lang="en-US" sz="950" dirty="0"/>
           </a:p>
@@ -6075,7 +6193,7 @@
                 <a:ea typeface="Meiryo" pitchFamily="34" charset="-122"/>
                 <a:cs typeface="Meiryo" pitchFamily="34" charset="-120"/>
               </a:rPr>
-              <a:t>渡し方を増やす（製品戦略：基盤が先、追加機能は年1本ずつ）</a:t>
+              <a:t>渡し方を増やす（製品戦略：教材化を初年度から、追加機能は年1本ずつ）</a:t>
             </a:r>
             <a:endParaRPr lang="en-US" sz="950" dirty="0"/>
           </a:p>
@@ -6373,7 +6491,7 @@
                 <a:ea typeface="Meiryo" pitchFamily="34" charset="-122"/>
                 <a:cs typeface="Meiryo" pitchFamily="34" charset="-120"/>
               </a:rPr>
-              <a:t>2年目</a:t>
+              <a:t>1年目</a:t>
             </a:r>
             <a:endParaRPr lang="en-US" sz="800" dirty="0"/>
           </a:p>
@@ -6606,7 +6724,7 @@
                 <a:ea typeface="Meiryo" pitchFamily="34" charset="-122"/>
                 <a:cs typeface="Meiryo" pitchFamily="34" charset="-120"/>
               </a:rPr>
-              <a:t>3年目</a:t>
+              <a:t>2年目</a:t>
             </a:r>
             <a:endParaRPr lang="en-US" sz="800" dirty="0"/>
           </a:p>
@@ -6839,7 +6957,7 @@
                 <a:ea typeface="Meiryo" pitchFamily="34" charset="-122"/>
                 <a:cs typeface="Meiryo" pitchFamily="34" charset="-120"/>
               </a:rPr>
-              <a:t>4年目</a:t>
+              <a:t>3年目</a:t>
             </a:r>
             <a:endParaRPr lang="en-US" sz="800" dirty="0"/>
           </a:p>
@@ -7072,7 +7190,7 @@
                 <a:ea typeface="Meiryo" pitchFamily="34" charset="-122"/>
                 <a:cs typeface="Meiryo" pitchFamily="34" charset="-120"/>
               </a:rPr>
-              <a:t>5年目</a:t>
+              <a:t>4年目</a:t>
             </a:r>
             <a:endParaRPr lang="en-US" sz="800" dirty="0"/>
           </a:p>
@@ -7876,7 +7994,7 @@
                 <a:ea typeface="Meiryo" pitchFamily="34" charset="-122"/>
                 <a:cs typeface="Meiryo" pitchFamily="34" charset="-120"/>
               </a:rPr>
-              <a:t>作る：</a:t>
+              <a:t>作らない：</a:t>
             </a:r>
             <a:pPr algn="l" indent="0" marL="0">
               <a:lnSpc>
@@ -7896,7 +8014,7 @@
                 <a:ea typeface="Meiryo" pitchFamily="34" charset="-122"/>
                 <a:cs typeface="Meiryo" pitchFamily="34" charset="-120"/>
               </a:rPr>
-              <a:t>記録の構造化（生成AI）と、渡し方の設計</a:t>
+              <a:t>音声記録・AI構造化は汎用技術。自前開発は最小限</a:t>
             </a:r>
             <a:endParaRPr lang="en-US" sz="850" dirty="0"/>
           </a:p>
@@ -7919,7 +8037,7 @@
                 <a:ea typeface="Meiryo" pitchFamily="34" charset="-122"/>
                 <a:cs typeface="Meiryo" pitchFamily="34" charset="-120"/>
               </a:rPr>
-              <a:t>組む：</a:t>
+              <a:t>作る：</a:t>
             </a:r>
             <a:pPr algn="l" indent="0" marL="0">
               <a:lnSpc>
@@ -7939,7 +8057,7 @@
                 <a:ea typeface="Meiryo" pitchFamily="34" charset="-122"/>
                 <a:cs typeface="Meiryo" pitchFamily="34" charset="-120"/>
               </a:rPr>
-              <a:t>CAD・3D・触覚デバイスはベンダー・大学と共同研究</a:t>
+              <a:t>連続工程の工程データとの紐づけ、教材化の手順</a:t>
             </a:r>
             <a:endParaRPr lang="en-US" sz="850" dirty="0"/>
           </a:p>
@@ -7962,7 +8080,7 @@
                 <a:ea typeface="Meiryo" pitchFamily="34" charset="-122"/>
                 <a:cs typeface="Meiryo" pitchFamily="34" charset="-120"/>
               </a:rPr>
-              <a:t>試す：</a:t>
+              <a:t>組む：</a:t>
             </a:r>
             <a:pPr algn="l" indent="0" marL="0">
               <a:lnSpc>
@@ -7982,7 +8100,7 @@
                 <a:ea typeface="Meiryo" pitchFamily="34" charset="-122"/>
                 <a:cs typeface="Meiryo" pitchFamily="34" charset="-120"/>
               </a:rPr>
-              <a:t>CVC出資元の工場を実証の場にする</a:t>
+              <a:t>CAD・3D・触覚デバイスはベンダー・大学と共同研究</a:t>
             </a:r>
             <a:endParaRPr lang="en-US" sz="850" dirty="0"/>
           </a:p>
@@ -8165,13 +8283,13 @@
             <a:r>
               <a:rPr lang="en-US" sz="800" dirty="0">
                 <a:solidFill>
-                  <a:srgbClr val="4D4D4D"/>
-                </a:solidFill>
-                <a:latin typeface="Meiryo" pitchFamily="34" charset="0"/>
-                <a:ea typeface="Meiryo" pitchFamily="34" charset="-122"/>
-                <a:cs typeface="Meiryo" pitchFamily="34" charset="-120"/>
-              </a:rPr>
-              <a:t>対象：電線・ケーブル工場の生産技術・製造部門（のちに、その製品を施工する工事会社）。R&amp;D行はエンジニア2→9名の範囲で進め、製品化前の売上は計画に含めない</a:t>
+                  <a:srgbClr val="8C8C8C"/>
+                </a:solidFill>
+                <a:latin typeface="Meiryo" pitchFamily="34" charset="0"/>
+                <a:ea typeface="Meiryo" pitchFamily="34" charset="-122"/>
+                <a:cs typeface="Meiryo" pitchFamily="34" charset="-120"/>
+              </a:rPr>
+              <a:t>(1) 内閣府「人工知能基本計画」（令和8年7月14日 閣議決定）「完全なデータの構造化をしない形での現場データの活用を推進する」　(2) 厚生労働省「令和6年度 能力開発基本調査」（2025年6月公表）。R&amp;D行は製品化前の売上を計画に含めない</a:t>
             </a:r>
             <a:endParaRPr lang="en-US" sz="800" dirty="0"/>
           </a:p>
@@ -9958,7 +10076,7 @@
                 <a:ea typeface="Meiryo" pitchFamily="34" charset="-122"/>
                 <a:cs typeface="Meiryo" pitchFamily="34" charset="-120"/>
               </a:rPr>
-              <a:t>競合 ─ 判断の理由を内製で仕組み化した事業会社は、希少</a:t>
+              <a:t>競合 ─ 「貯める」会社は現れた。当社は「渡す」で分かれる</a:t>
             </a:r>
             <a:endParaRPr lang="en-US" sz="2000" dirty="0"/>
           </a:p>
@@ -10000,7 +10118,7 @@
                 <a:ea typeface="Meiryo" pitchFamily="34" charset="-122"/>
                 <a:cs typeface="Meiryo" pitchFamily="34" charset="-120"/>
               </a:rPr>
-              <a:t>製造業では大手がSIerと組んで始めたが、電力インフラ（電線・送配電・電気工事）では公開事例が見当たらない</a:t>
+              <a:t>判断の理由を扱う会社は現れた。連続工程の現場処置を、教材にして届ける会社はまだない</a:t>
             </a:r>
             <a:endParaRPr lang="en-US" sz="1200" dirty="0"/>
           </a:p>
@@ -10015,7 +10133,7 @@
         <p:spPr>
           <a:xfrm>
             <a:off x="365760" y="1051560"/>
-            <a:ext cx="4114800" cy="237744"/>
+            <a:ext cx="3977640" cy="237744"/>
           </a:xfrm>
           <a:prstGeom prst="rect">
             <a:avLst/>
@@ -10056,8 +10174,8 @@
         </p:nvSpPr>
         <p:spPr>
           <a:xfrm>
-            <a:off x="2514600" y="1435608"/>
-            <a:ext cx="1828800" cy="1234440"/>
+            <a:off x="2446020" y="1435608"/>
+            <a:ext cx="1805940" cy="1234440"/>
           </a:xfrm>
           <a:prstGeom prst="rect">
             <a:avLst/>
@@ -10076,8 +10194,8 @@
         </p:nvSpPr>
         <p:spPr>
           <a:xfrm>
-            <a:off x="685800" y="2670048"/>
-            <a:ext cx="3657600" cy="0"/>
+            <a:off x="640080" y="2670048"/>
+            <a:ext cx="3611880" cy="0"/>
           </a:xfrm>
           <a:prstGeom prst="line">
             <a:avLst/>
@@ -10099,7 +10217,7 @@
         </p:nvSpPr>
         <p:spPr>
           <a:xfrm>
-            <a:off x="2514600" y="1435608"/>
+            <a:off x="2446020" y="1435608"/>
             <a:ext cx="0" cy="2468880"/>
           </a:xfrm>
           <a:prstGeom prst="line">
@@ -10122,7 +10240,7 @@
         </p:nvSpPr>
         <p:spPr>
           <a:xfrm>
-            <a:off x="1600200" y="1216152"/>
+            <a:off x="1531620" y="1216152"/>
             <a:ext cx="1828800" cy="182880"/>
           </a:xfrm>
           <a:prstGeom prst="rect">
@@ -10164,7 +10282,7 @@
         </p:nvSpPr>
         <p:spPr>
           <a:xfrm>
-            <a:off x="1600200" y="3941064"/>
+            <a:off x="1531620" y="3941064"/>
             <a:ext cx="1828800" cy="182880"/>
           </a:xfrm>
           <a:prstGeom prst="rect">
@@ -10206,8 +10324,8 @@
         </p:nvSpPr>
         <p:spPr>
           <a:xfrm>
-            <a:off x="685800" y="2697480"/>
-            <a:ext cx="1737360" cy="182880"/>
+            <a:off x="640080" y="2697480"/>
+            <a:ext cx="1280160" cy="182880"/>
           </a:xfrm>
           <a:prstGeom prst="rect">
             <a:avLst/>
@@ -10234,7 +10352,7 @@
                 <a:ea typeface="Meiryo" pitchFamily="34" charset="-122"/>
                 <a:cs typeface="Meiryo" pitchFamily="34" charset="-120"/>
               </a:rPr>
-              <a:t>← 実績（何が起きたか）</a:t>
+              <a:t>← 実績・手順</a:t>
             </a:r>
             <a:endParaRPr lang="en-US" sz="800" dirty="0"/>
           </a:p>
@@ -10248,8 +10366,8 @@
         </p:nvSpPr>
         <p:spPr>
           <a:xfrm>
-            <a:off x="2606040" y="2697480"/>
-            <a:ext cx="1737360" cy="182880"/>
+            <a:off x="2971800" y="2697480"/>
+            <a:ext cx="1280160" cy="182880"/>
           </a:xfrm>
           <a:prstGeom prst="rect">
             <a:avLst/>
@@ -10276,7 +10394,7 @@
                 <a:ea typeface="Meiryo" pitchFamily="34" charset="-122"/>
                 <a:cs typeface="Meiryo" pitchFamily="34" charset="-120"/>
               </a:rPr>
-              <a:t>判断の理由（なぜ）→</a:t>
+              <a:t>判断の理由 →</a:t>
             </a:r>
             <a:endParaRPr lang="en-US" sz="800" dirty="0"/>
           </a:p>
@@ -10290,8 +10408,8 @@
         </p:nvSpPr>
         <p:spPr>
           <a:xfrm>
-            <a:off x="1051560" y="1757477"/>
-            <a:ext cx="146304" cy="146304"/>
+            <a:off x="932688" y="1663294"/>
+            <a:ext cx="137160" cy="137160"/>
           </a:xfrm>
           <a:prstGeom prst="ellipse">
             <a:avLst/>
@@ -10315,8 +10433,8 @@
         </p:nvSpPr>
         <p:spPr>
           <a:xfrm>
-            <a:off x="1243584" y="1720901"/>
-            <a:ext cx="1463040" cy="219456"/>
+            <a:off x="1106424" y="1631290"/>
+            <a:ext cx="1554480" cy="201168"/>
           </a:xfrm>
           <a:prstGeom prst="rect">
             <a:avLst/>
@@ -10335,7 +10453,7 @@
               <a:buNone/>
             </a:pPr>
             <a:r>
-              <a:rPr lang="en-US" sz="850" dirty="0">
+              <a:rPr lang="en-US" sz="800" dirty="0">
                 <a:solidFill>
                   <a:srgbClr val="1A1A1A"/>
                 </a:solidFill>
@@ -10345,20 +10463,20 @@
               </a:rPr>
               <a:t>MES・ERP</a:t>
             </a:r>
-            <a:endParaRPr lang="en-US" sz="850" dirty="0"/>
-          </a:p>
-        </p:txBody>
-      </p:sp>
-      <p:sp>
-        <p:nvSpPr>
-          <p:cNvPr id="15" name="pos-搬送ロボット・検査AI"/>
+            <a:endParaRPr lang="en-US" sz="800" dirty="0"/>
+          </a:p>
+        </p:txBody>
+      </p:sp>
+      <p:sp>
+        <p:nvSpPr>
+          <p:cNvPr id="15" name="pos-tebiki・Teachme Biz（器）"/>
           <p:cNvSpPr/>
           <p:nvPr/>
         </p:nvSpPr>
         <p:spPr>
           <a:xfrm>
-            <a:off x="978408" y="2251253"/>
-            <a:ext cx="146304" cy="146304"/>
+            <a:off x="860450" y="2157070"/>
+            <a:ext cx="137160" cy="137160"/>
           </a:xfrm>
           <a:prstGeom prst="ellipse">
             <a:avLst/>
@@ -10382,8 +10500,8 @@
         </p:nvSpPr>
         <p:spPr>
           <a:xfrm>
-            <a:off x="1170432" y="2214677"/>
-            <a:ext cx="1463040" cy="219456"/>
+            <a:off x="1034186" y="2125066"/>
+            <a:ext cx="1554480" cy="201168"/>
           </a:xfrm>
           <a:prstGeom prst="rect">
             <a:avLst/>
@@ -10402,7 +10520,7 @@
               <a:buNone/>
             </a:pPr>
             <a:r>
-              <a:rPr lang="en-US" sz="850" dirty="0">
+              <a:rPr lang="en-US" sz="800" dirty="0">
                 <a:solidFill>
                   <a:srgbClr val="1A1A1A"/>
                 </a:solidFill>
@@ -10410,22 +10528,22 @@
                 <a:ea typeface="Meiryo" pitchFamily="34" charset="-122"/>
                 <a:cs typeface="Meiryo" pitchFamily="34" charset="-120"/>
               </a:rPr>
-              <a:t>搬送ロボット・検査AI</a:t>
-            </a:r>
-            <a:endParaRPr lang="en-US" sz="850" dirty="0"/>
-          </a:p>
-        </p:txBody>
-      </p:sp>
-      <p:sp>
-        <p:nvSpPr>
-          <p:cNvPr id="17" name="pos-コンサル（BPR）"/>
+              <a:t>tebiki・Teachme Biz（器）</a:t>
+            </a:r>
+            <a:endParaRPr lang="en-US" sz="800" dirty="0"/>
+          </a:p>
+        </p:txBody>
+      </p:sp>
+      <p:sp>
+        <p:nvSpPr>
+          <p:cNvPr id="17" name="pos-CADDi（組立・図面）"/>
           <p:cNvSpPr/>
           <p:nvPr/>
         </p:nvSpPr>
         <p:spPr>
           <a:xfrm>
-            <a:off x="2660904" y="3436315"/>
-            <a:ext cx="146304" cy="146304"/>
+            <a:off x="2666390" y="1613916"/>
+            <a:ext cx="137160" cy="137160"/>
           </a:xfrm>
           <a:prstGeom prst="ellipse">
             <a:avLst/>
@@ -10449,8 +10567,8 @@
         </p:nvSpPr>
         <p:spPr>
           <a:xfrm>
-            <a:off x="2852928" y="3399739"/>
-            <a:ext cx="1463040" cy="219456"/>
+            <a:off x="2840126" y="1581912"/>
+            <a:ext cx="1554480" cy="201168"/>
           </a:xfrm>
           <a:prstGeom prst="rect">
             <a:avLst/>
@@ -10469,7 +10587,7 @@
               <a:buNone/>
             </a:pPr>
             <a:r>
-              <a:rPr lang="en-US" sz="850" dirty="0">
+              <a:rPr lang="en-US" sz="800" dirty="0">
                 <a:solidFill>
                   <a:srgbClr val="1A1A1A"/>
                 </a:solidFill>
@@ -10477,22 +10595,22 @@
                 <a:ea typeface="Meiryo" pitchFamily="34" charset="-122"/>
                 <a:cs typeface="Meiryo" pitchFamily="34" charset="-120"/>
               </a:rPr>
-              <a:t>コンサル（BPR）</a:t>
-            </a:r>
-            <a:endParaRPr lang="en-US" sz="850" dirty="0"/>
-          </a:p>
-        </p:txBody>
-      </p:sp>
-      <p:sp>
-        <p:nvSpPr>
-          <p:cNvPr id="19" name="pos-社内の熟練者（属人）"/>
+              <a:t>CADDi（組立・図面）</a:t>
+            </a:r>
+            <a:endParaRPr lang="en-US" sz="800" dirty="0"/>
+          </a:p>
+        </p:txBody>
+      </p:sp>
+      <p:sp>
+        <p:nvSpPr>
+          <p:cNvPr id="19" name="pos-Airion（貯めるまで）"/>
           <p:cNvSpPr/>
           <p:nvPr/>
         </p:nvSpPr>
         <p:spPr>
           <a:xfrm>
-            <a:off x="3685032" y="2991917"/>
-            <a:ext cx="146304" cy="146304"/>
+            <a:off x="3099816" y="2255825"/>
+            <a:ext cx="137160" cy="137160"/>
           </a:xfrm>
           <a:prstGeom prst="ellipse">
             <a:avLst/>
@@ -10516,8 +10634,8 @@
         </p:nvSpPr>
         <p:spPr>
           <a:xfrm>
-            <a:off x="2660904" y="3156509"/>
-            <a:ext cx="1280160" cy="219456"/>
+            <a:off x="3273552" y="2223821"/>
+            <a:ext cx="1554480" cy="201168"/>
           </a:xfrm>
           <a:prstGeom prst="rect">
             <a:avLst/>
@@ -10529,6 +10647,73 @@
           <a:bodyPr wrap="square" lIns="0" tIns="0" rIns="0" bIns="0" rtlCol="0" anchor="ctr"/>
           <a:lstStyle/>
           <a:p>
+            <a:pPr algn="l" indent="0" marL="0">
+              <a:lnSpc>
+                <a:spcPct val="115000"/>
+              </a:lnSpc>
+              <a:buNone/>
+            </a:pPr>
+            <a:r>
+              <a:rPr lang="en-US" sz="800" dirty="0">
+                <a:solidFill>
+                  <a:srgbClr val="1A1A1A"/>
+                </a:solidFill>
+                <a:latin typeface="Meiryo" pitchFamily="34" charset="0"/>
+                <a:ea typeface="Meiryo" pitchFamily="34" charset="-122"/>
+                <a:cs typeface="Meiryo" pitchFamily="34" charset="-120"/>
+              </a:rPr>
+              <a:t>Airion（貯めるまで）</a:t>
+            </a:r>
+            <a:endParaRPr lang="en-US" sz="800" dirty="0"/>
+          </a:p>
+        </p:txBody>
+      </p:sp>
+      <p:sp>
+        <p:nvSpPr>
+          <p:cNvPr id="21" name="pos-三現ワークス"/>
+          <p:cNvSpPr/>
+          <p:nvPr/>
+        </p:nvSpPr>
+        <p:spPr>
+          <a:xfrm>
+            <a:off x="3790188" y="1927555"/>
+            <a:ext cx="201168" cy="201168"/>
+          </a:xfrm>
+          <a:prstGeom prst="ellipse">
+            <a:avLst/>
+          </a:prstGeom>
+          <a:solidFill>
+            <a:srgbClr val="1A1A1A"/>
+          </a:solidFill>
+          <a:ln w="15875">
+            <a:solidFill>
+              <a:srgbClr val="1A1A1A"/>
+            </a:solidFill>
+            <a:prstDash val="solid"/>
+          </a:ln>
+        </p:spPr>
+      </p:sp>
+      <p:sp>
+        <p:nvSpPr>
+          <p:cNvPr id="22" name="Text 19"/>
+          <p:cNvSpPr txBox="1"/>
+          <p:nvPr/>
+        </p:nvSpPr>
+        <p:spPr>
+          <a:xfrm>
+            <a:off x="2199132" y="1927555"/>
+            <a:ext cx="1554480" cy="201168"/>
+          </a:xfrm>
+          <a:prstGeom prst="rect">
+            <a:avLst/>
+          </a:prstGeom>
+          <a:noFill/>
+          <a:ln/>
+        </p:spPr>
+        <p:txBody>
+          <a:bodyPr wrap="square" lIns="0" tIns="0" rIns="0" bIns="0" rtlCol="0" anchor="ctr"/>
+          <a:lstStyle/>
+          <a:p>
             <a:pPr algn="r" indent="0" marL="0">
               <a:lnSpc>
                 <a:spcPct val="115000"/>
@@ -10536,7 +10721,7 @@
               <a:buNone/>
             </a:pPr>
             <a:r>
-              <a:rPr lang="en-US" sz="850" dirty="0">
+              <a:rPr lang="en-US" sz="1000" b="1" dirty="0">
                 <a:solidFill>
                   <a:srgbClr val="1A1A1A"/>
                 </a:solidFill>
@@ -10544,22 +10729,22 @@
                 <a:ea typeface="Meiryo" pitchFamily="34" charset="-122"/>
                 <a:cs typeface="Meiryo" pitchFamily="34" charset="-120"/>
               </a:rPr>
-              <a:t>社内の熟練者（属人）</a:t>
-            </a:r>
-            <a:endParaRPr lang="en-US" sz="850" dirty="0"/>
-          </a:p>
-        </p:txBody>
-      </p:sp>
-      <p:sp>
-        <p:nvSpPr>
-          <p:cNvPr id="21" name="pos-大手の内製（＋大手SIer）"/>
+              <a:t>三現ワークス</a:t>
+            </a:r>
+            <a:endParaRPr lang="en-US" sz="1000" dirty="0"/>
+          </a:p>
+        </p:txBody>
+      </p:sp>
+      <p:sp>
+        <p:nvSpPr>
+          <p:cNvPr id="23" name="pos-三菱総研 匠AI"/>
           <p:cNvSpPr/>
           <p:nvPr/>
         </p:nvSpPr>
         <p:spPr>
           <a:xfrm>
-            <a:off x="2880360" y="2251253"/>
-            <a:ext cx="146304" cy="146304"/>
+            <a:off x="2810866" y="3095244"/>
+            <a:ext cx="137160" cy="137160"/>
           </a:xfrm>
           <a:prstGeom prst="ellipse">
             <a:avLst/>
@@ -10577,14 +10762,14 @@
       </p:sp>
       <p:sp>
         <p:nvSpPr>
-          <p:cNvPr id="22" name="Text 19"/>
+          <p:cNvPr id="24" name="Text 21"/>
           <p:cNvSpPr txBox="1"/>
           <p:nvPr/>
         </p:nvSpPr>
         <p:spPr>
           <a:xfrm>
-            <a:off x="3072384" y="2214677"/>
-            <a:ext cx="1463040" cy="219456"/>
+            <a:off x="2984602" y="3063240"/>
+            <a:ext cx="1554480" cy="201168"/>
           </a:xfrm>
           <a:prstGeom prst="rect">
             <a:avLst/>
@@ -10603,7 +10788,7 @@
               <a:buNone/>
             </a:pPr>
             <a:r>
-              <a:rPr lang="en-US" sz="850" dirty="0">
+              <a:rPr lang="en-US" sz="800" dirty="0">
                 <a:solidFill>
                   <a:srgbClr val="1A1A1A"/>
                 </a:solidFill>
@@ -10611,22 +10796,22 @@
                 <a:ea typeface="Meiryo" pitchFamily="34" charset="-122"/>
                 <a:cs typeface="Meiryo" pitchFamily="34" charset="-120"/>
               </a:rPr>
-              <a:t>大手の内製（＋大手SIer）</a:t>
-            </a:r>
-            <a:endParaRPr lang="en-US" sz="850" dirty="0"/>
-          </a:p>
-        </p:txBody>
-      </p:sp>
-      <p:sp>
-        <p:nvSpPr>
-          <p:cNvPr id="23" name="pos-動画マニュアルSaaS"/>
+              <a:t>三菱総研 匠AI</a:t>
+            </a:r>
+            <a:endParaRPr lang="en-US" sz="800" dirty="0"/>
+          </a:p>
+        </p:txBody>
+      </p:sp>
+      <p:sp>
+        <p:nvSpPr>
+          <p:cNvPr id="25" name="pos-社内の熟練者（属人）"/>
           <p:cNvSpPr/>
           <p:nvPr/>
         </p:nvSpPr>
         <p:spPr>
           <a:xfrm>
-            <a:off x="2295144" y="1485900"/>
-            <a:ext cx="146304" cy="146304"/>
+            <a:off x="3677717" y="3539642"/>
+            <a:ext cx="137160" cy="137160"/>
           </a:xfrm>
           <a:prstGeom prst="ellipse">
             <a:avLst/>
@@ -10644,14 +10829,14 @@
       </p:sp>
       <p:sp>
         <p:nvSpPr>
-          <p:cNvPr id="24" name="Text 21"/>
+          <p:cNvPr id="26" name="Text 23"/>
           <p:cNvSpPr txBox="1"/>
           <p:nvPr/>
         </p:nvSpPr>
         <p:spPr>
           <a:xfrm>
-            <a:off x="786384" y="1449324"/>
-            <a:ext cx="1463040" cy="219456"/>
+            <a:off x="2086661" y="3507638"/>
+            <a:ext cx="1554480" cy="201168"/>
           </a:xfrm>
           <a:prstGeom prst="rect">
             <a:avLst/>
@@ -10670,7 +10855,7 @@
               <a:buNone/>
             </a:pPr>
             <a:r>
-              <a:rPr lang="en-US" sz="850" dirty="0">
+              <a:rPr lang="en-US" sz="800" dirty="0">
                 <a:solidFill>
                   <a:srgbClr val="1A1A1A"/>
                 </a:solidFill>
@@ -10678,47 +10863,22 @@
                 <a:ea typeface="Meiryo" pitchFamily="34" charset="-122"/>
                 <a:cs typeface="Meiryo" pitchFamily="34" charset="-120"/>
               </a:rPr>
-              <a:t>動画マニュアルSaaS</a:t>
-            </a:r>
-            <a:endParaRPr lang="en-US" sz="850" dirty="0"/>
-          </a:p>
-        </p:txBody>
-      </p:sp>
-      <p:sp>
-        <p:nvSpPr>
-          <p:cNvPr id="25" name="pos-三現ワークス"/>
-          <p:cNvSpPr/>
-          <p:nvPr/>
-        </p:nvSpPr>
-        <p:spPr>
-          <a:xfrm>
-            <a:off x="3511296" y="1730045"/>
-            <a:ext cx="201168" cy="201168"/>
-          </a:xfrm>
-          <a:prstGeom prst="ellipse">
-            <a:avLst/>
-          </a:prstGeom>
-          <a:solidFill>
-            <a:srgbClr val="1A1A1A"/>
-          </a:solidFill>
-          <a:ln w="15875">
-            <a:solidFill>
-              <a:srgbClr val="1A1A1A"/>
-            </a:solidFill>
-            <a:prstDash val="solid"/>
-          </a:ln>
-        </p:spPr>
-      </p:sp>
-      <p:sp>
-        <p:nvSpPr>
-          <p:cNvPr id="26" name="Text 23"/>
+              <a:t>社内の熟練者（属人）</a:t>
+            </a:r>
+            <a:endParaRPr lang="en-US" sz="800" dirty="0"/>
+          </a:p>
+        </p:txBody>
+      </p:sp>
+      <p:sp>
+        <p:nvSpPr>
+          <p:cNvPr id="27" name="Text 24"/>
           <p:cNvSpPr txBox="1"/>
           <p:nvPr/>
         </p:nvSpPr>
         <p:spPr>
           <a:xfrm>
-            <a:off x="2002536" y="1720901"/>
-            <a:ext cx="1463040" cy="219456"/>
+            <a:off x="4526280" y="1051560"/>
+            <a:ext cx="4251960" cy="237744"/>
           </a:xfrm>
           <a:prstGeom prst="rect">
             <a:avLst/>
@@ -10727,48 +10887,6 @@
           <a:ln/>
         </p:spPr>
         <p:txBody>
-          <a:bodyPr wrap="square" lIns="0" tIns="0" rIns="0" bIns="0" rtlCol="0" anchor="ctr"/>
-          <a:lstStyle/>
-          <a:p>
-            <a:pPr algn="r" indent="0" marL="0">
-              <a:lnSpc>
-                <a:spcPct val="115000"/>
-              </a:lnSpc>
-              <a:buNone/>
-            </a:pPr>
-            <a:r>
-              <a:rPr lang="en-US" sz="1000" b="1" dirty="0">
-                <a:solidFill>
-                  <a:srgbClr val="1A1A1A"/>
-                </a:solidFill>
-                <a:latin typeface="Meiryo" pitchFamily="34" charset="0"/>
-                <a:ea typeface="Meiryo" pitchFamily="34" charset="-122"/>
-                <a:cs typeface="Meiryo" pitchFamily="34" charset="-120"/>
-              </a:rPr>
-              <a:t>三現ワークス</a:t>
-            </a:r>
-            <a:endParaRPr lang="en-US" sz="1000" dirty="0"/>
-          </a:p>
-        </p:txBody>
-      </p:sp>
-      <p:sp>
-        <p:nvSpPr>
-          <p:cNvPr id="27" name="Text 24"/>
-          <p:cNvSpPr txBox="1"/>
-          <p:nvPr/>
-        </p:nvSpPr>
-        <p:spPr>
-          <a:xfrm>
-            <a:off x="4617720" y="1051560"/>
-            <a:ext cx="4160520" cy="237744"/>
-          </a:xfrm>
-          <a:prstGeom prst="rect">
-            <a:avLst/>
-          </a:prstGeom>
-          <a:noFill/>
-          <a:ln/>
-        </p:spPr>
-        <p:txBody>
           <a:bodyPr wrap="square" lIns="0" tIns="0" rIns="0" bIns="0" rtlCol="0" anchor="t"/>
           <a:lstStyle/>
           <a:p>
@@ -10787,790 +10905,1492 @@
                 <a:ea typeface="Meiryo" pitchFamily="34" charset="-122"/>
                 <a:cs typeface="Meiryo" pitchFamily="34" charset="-120"/>
               </a:rPr>
-              <a:t>内製化の先行事例（公開情報）</a:t>
+              <a:t>貯める（記録・構造化）と、渡す（教材にして届ける）</a:t>
             </a:r>
             <a:endParaRPr lang="en-US" sz="1050" dirty="0"/>
           </a:p>
         </p:txBody>
       </p:sp>
-      <p:sp>
-        <p:nvSpPr>
-          <p:cNvPr id="28" name="Shape 25"/>
+      <p:graphicFrame>
+        <p:nvGraphicFramePr>
+          <p:cNvPr id="6" name="store-handoff"/>
+          <p:cNvGraphicFramePr>
+            <a:graphicFrameLocks noGrp="1"/>
+          </p:cNvGraphicFramePr>
+          <p:nvPr>
+            <p:extLst>
+              <p:ext uri="{D42A27DB-BD31-4B8C-83A1-F6EECF244321}">
+                <p14:modId xmlns:p14="http://schemas.microsoft.com/office/powerpoint/2010/main" val="1579011935"/>
+              </p:ext>
+            </p:extLst>
+          </p:nvPr>
+        </p:nvGraphicFramePr>
+        <p:xfrm>
+          <a:off x="4526280" y="1325880"/>
+          <a:ext cx="4251960" cy="914400"/>
+        </p:xfrm>
+        <a:graphic>
+          <a:graphicData uri="http://schemas.openxmlformats.org/drawingml/2006/table">
+            <a:tbl>
+              <a:tblPr/>
+              <a:tblGrid>
+                <a:gridCol w="1371600"/>
+                <a:gridCol w="1005840"/>
+                <a:gridCol w="1005840"/>
+                <a:gridCol w="868680"/>
+              </a:tblGrid>
+              <a:tr h="246888">
+                <a:tc>
+                  <a:txBody>
+                    <a:bodyPr/>
+                    <a:lstStyle/>
+                    <a:p>
+                      <a:pPr algn="l" indent="0" marL="0">
+                        <a:buNone/>
+                      </a:pPr>
+                      <a:r>
+                        <a:rPr lang="en-US" sz="800" b="1" dirty="0">
+                          <a:solidFill>
+                            <a:srgbClr val="1A1A1A"/>
+                          </a:solidFill>
+                          <a:latin typeface="Meiryo" pitchFamily="34" charset="0"/>
+                          <a:ea typeface="Meiryo" pitchFamily="34" charset="-122"/>
+                          <a:cs typeface="Meiryo" pitchFamily="34" charset="-120"/>
+                        </a:rPr>
+                        <a:t>会社・サービス</a:t>
+                      </a:r>
+                      <a:endParaRPr lang="en-US" sz="800" dirty="0">
+                        <a:latin typeface="Meiryo" charset="0"/>
+                        <a:ea typeface="Meiryo" charset="0"/>
+                        <a:cs typeface="Meiryo" charset="0"/>
+                      </a:endParaRPr>
+                    </a:p>
+                  </a:txBody>
+                  <a:tcPr marL="54864" marR="54864" marT="18288" marB="18288" anchor="ctr">
+                    <a:lnL w="0" cap="flat" cmpd="sng" algn="ctr">
+                      <a:noFill/>
+                    </a:lnL>
+                    <a:lnR w="0" cap="flat" cmpd="sng" algn="ctr">
+                      <a:noFill/>
+                    </a:lnR>
+                    <a:lnT w="0" cap="flat" cmpd="sng" algn="ctr">
+                      <a:noFill/>
+                    </a:lnT>
+                    <a:lnB w="19050" cap="flat" cmpd="sng" algn="ctr">
+                      <a:solidFill>
+                        <a:srgbClr val="1A1A1A"/>
+                      </a:solidFill>
+                      <a:prstDash val="solid"/>
+                      <a:round/>
+                      <a:headEnd type="none" w="med" len="med"/>
+                      <a:tailEnd type="none" w="med" len="med"/>
+                    </a:lnB>
+                    <a:solidFill>
+                      <a:srgbClr val="F2F2F2"/>
+                    </a:solidFill>
+                  </a:tcPr>
+                </a:tc>
+                <a:tc>
+                  <a:txBody>
+                    <a:bodyPr/>
+                    <a:lstStyle/>
+                    <a:p>
+                      <a:pPr algn="l" indent="0" marL="0">
+                        <a:buNone/>
+                      </a:pPr>
+                      <a:r>
+                        <a:rPr lang="en-US" sz="800" b="1" dirty="0">
+                          <a:solidFill>
+                            <a:srgbClr val="1A1A1A"/>
+                          </a:solidFill>
+                          <a:latin typeface="Meiryo" pitchFamily="34" charset="0"/>
+                          <a:ea typeface="Meiryo" pitchFamily="34" charset="-122"/>
+                          <a:cs typeface="Meiryo" pitchFamily="34" charset="-120"/>
+                        </a:rPr>
+                        <a:t>貯める</a:t>
+                      </a:r>
+                      <a:endParaRPr lang="en-US" sz="800" dirty="0">
+                        <a:latin typeface="Meiryo" charset="0"/>
+                        <a:ea typeface="Meiryo" charset="0"/>
+                        <a:cs typeface="Meiryo" charset="0"/>
+                      </a:endParaRPr>
+                    </a:p>
+                  </a:txBody>
+                  <a:tcPr marL="54864" marR="54864" marT="18288" marB="18288" anchor="ctr">
+                    <a:lnL w="0" cap="flat" cmpd="sng" algn="ctr">
+                      <a:noFill/>
+                    </a:lnL>
+                    <a:lnR w="0" cap="flat" cmpd="sng" algn="ctr">
+                      <a:noFill/>
+                    </a:lnR>
+                    <a:lnT w="0" cap="flat" cmpd="sng" algn="ctr">
+                      <a:noFill/>
+                    </a:lnT>
+                    <a:lnB w="19050" cap="flat" cmpd="sng" algn="ctr">
+                      <a:solidFill>
+                        <a:srgbClr val="1A1A1A"/>
+                      </a:solidFill>
+                      <a:prstDash val="solid"/>
+                      <a:round/>
+                      <a:headEnd type="none" w="med" len="med"/>
+                      <a:tailEnd type="none" w="med" len="med"/>
+                    </a:lnB>
+                    <a:solidFill>
+                      <a:srgbClr val="F2F2F2"/>
+                    </a:solidFill>
+                  </a:tcPr>
+                </a:tc>
+                <a:tc>
+                  <a:txBody>
+                    <a:bodyPr/>
+                    <a:lstStyle/>
+                    <a:p>
+                      <a:pPr algn="l" indent="0" marL="0">
+                        <a:buNone/>
+                      </a:pPr>
+                      <a:r>
+                        <a:rPr lang="en-US" sz="800" b="1" dirty="0">
+                          <a:solidFill>
+                            <a:srgbClr val="1A1A1A"/>
+                          </a:solidFill>
+                          <a:latin typeface="Meiryo" pitchFamily="34" charset="0"/>
+                          <a:ea typeface="Meiryo" pitchFamily="34" charset="-122"/>
+                          <a:cs typeface="Meiryo" pitchFamily="34" charset="-120"/>
+                        </a:rPr>
+                        <a:t>渡す</a:t>
+                      </a:r>
+                      <a:endParaRPr lang="en-US" sz="800" dirty="0">
+                        <a:latin typeface="Meiryo" charset="0"/>
+                        <a:ea typeface="Meiryo" charset="0"/>
+                        <a:cs typeface="Meiryo" charset="0"/>
+                      </a:endParaRPr>
+                    </a:p>
+                  </a:txBody>
+                  <a:tcPr marL="54864" marR="54864" marT="18288" marB="18288" anchor="ctr">
+                    <a:lnL w="0" cap="flat" cmpd="sng" algn="ctr">
+                      <a:noFill/>
+                    </a:lnL>
+                    <a:lnR w="0" cap="flat" cmpd="sng" algn="ctr">
+                      <a:noFill/>
+                    </a:lnR>
+                    <a:lnT w="0" cap="flat" cmpd="sng" algn="ctr">
+                      <a:noFill/>
+                    </a:lnT>
+                    <a:lnB w="19050" cap="flat" cmpd="sng" algn="ctr">
+                      <a:solidFill>
+                        <a:srgbClr val="1A1A1A"/>
+                      </a:solidFill>
+                      <a:prstDash val="solid"/>
+                      <a:round/>
+                      <a:headEnd type="none" w="med" len="med"/>
+                      <a:tailEnd type="none" w="med" len="med"/>
+                    </a:lnB>
+                    <a:solidFill>
+                      <a:srgbClr val="F2F2F2"/>
+                    </a:solidFill>
+                  </a:tcPr>
+                </a:tc>
+                <a:tc>
+                  <a:txBody>
+                    <a:bodyPr/>
+                    <a:lstStyle/>
+                    <a:p>
+                      <a:pPr algn="l" indent="0" marL="0">
+                        <a:buNone/>
+                      </a:pPr>
+                      <a:r>
+                        <a:rPr lang="en-US" sz="800" b="1" dirty="0">
+                          <a:solidFill>
+                            <a:srgbClr val="1A1A1A"/>
+                          </a:solidFill>
+                          <a:latin typeface="Meiryo" pitchFamily="34" charset="0"/>
+                          <a:ea typeface="Meiryo" pitchFamily="34" charset="-122"/>
+                          <a:cs typeface="Meiryo" pitchFamily="34" charset="-120"/>
+                        </a:rPr>
+                        <a:t>対象</a:t>
+                      </a:r>
+                      <a:endParaRPr lang="en-US" sz="800" dirty="0">
+                        <a:latin typeface="Meiryo" charset="0"/>
+                        <a:ea typeface="Meiryo" charset="0"/>
+                        <a:cs typeface="Meiryo" charset="0"/>
+                      </a:endParaRPr>
+                    </a:p>
+                  </a:txBody>
+                  <a:tcPr marL="54864" marR="54864" marT="18288" marB="18288" anchor="ctr">
+                    <a:lnL w="0" cap="flat" cmpd="sng" algn="ctr">
+                      <a:noFill/>
+                    </a:lnL>
+                    <a:lnR w="0" cap="flat" cmpd="sng" algn="ctr">
+                      <a:noFill/>
+                    </a:lnR>
+                    <a:lnT w="0" cap="flat" cmpd="sng" algn="ctr">
+                      <a:noFill/>
+                    </a:lnT>
+                    <a:lnB w="19050" cap="flat" cmpd="sng" algn="ctr">
+                      <a:solidFill>
+                        <a:srgbClr val="1A1A1A"/>
+                      </a:solidFill>
+                      <a:prstDash val="solid"/>
+                      <a:round/>
+                      <a:headEnd type="none" w="med" len="med"/>
+                      <a:tailEnd type="none" w="med" len="med"/>
+                    </a:lnB>
+                    <a:solidFill>
+                      <a:srgbClr val="F2F2F2"/>
+                    </a:solidFill>
+                  </a:tcPr>
+                </a:tc>
+              </a:tr>
+              <a:tr h="246888">
+                <a:tc>
+                  <a:txBody>
+                    <a:bodyPr/>
+                    <a:lstStyle/>
+                    <a:p>
+                      <a:pPr algn="l" indent="0" marL="0">
+                        <a:buNone/>
+                      </a:pPr>
+                      <a:r>
+                        <a:rPr lang="en-US" sz="800" dirty="0">
+                          <a:solidFill>
+                            <a:srgbClr val="1A1A1A"/>
+                          </a:solidFill>
+                          <a:latin typeface="Meiryo" pitchFamily="34" charset="0"/>
+                          <a:ea typeface="Meiryo" pitchFamily="34" charset="-122"/>
+                          <a:cs typeface="Meiryo" pitchFamily="34" charset="-120"/>
+                        </a:rPr>
+                        <a:t>Airion 技能継承くん</a:t>
+                      </a:r>
+                      <a:endParaRPr lang="en-US" sz="800" dirty="0">
+                        <a:latin typeface="Meiryo" charset="0"/>
+                        <a:ea typeface="Meiryo" charset="0"/>
+                        <a:cs typeface="Meiryo" charset="0"/>
+                      </a:endParaRPr>
+                    </a:p>
+                  </a:txBody>
+                  <a:tcPr marL="54864" marR="54864" marT="18288" marB="18288" anchor="ctr">
+                    <a:lnL w="0" cap="flat" cmpd="sng" algn="ctr">
+                      <a:noFill/>
+                    </a:lnL>
+                    <a:lnR w="0" cap="flat" cmpd="sng" algn="ctr">
+                      <a:noFill/>
+                    </a:lnR>
+                    <a:lnT w="0" cap="flat" cmpd="sng" algn="ctr">
+                      <a:noFill/>
+                    </a:lnT>
+                    <a:lnB w="9525" cap="flat" cmpd="sng" algn="ctr">
+                      <a:solidFill>
+                        <a:srgbClr val="BFBFBF"/>
+                      </a:solidFill>
+                      <a:prstDash val="solid"/>
+                      <a:round/>
+                      <a:headEnd type="none" w="med" len="med"/>
+                      <a:tailEnd type="none" w="med" len="med"/>
+                    </a:lnB>
+                    <a:solidFill>
+                      <a:srgbClr val="FFFFFF"/>
+                    </a:solidFill>
+                  </a:tcPr>
+                </a:tc>
+                <a:tc>
+                  <a:txBody>
+                    <a:bodyPr/>
+                    <a:lstStyle/>
+                    <a:p>
+                      <a:pPr algn="l" indent="0" marL="0">
+                        <a:buNone/>
+                      </a:pPr>
+                      <a:r>
+                        <a:rPr lang="en-US" sz="800" dirty="0">
+                          <a:solidFill>
+                            <a:srgbClr val="1A1A1A"/>
+                          </a:solidFill>
+                          <a:latin typeface="Meiryo" pitchFamily="34" charset="0"/>
+                          <a:ea typeface="Meiryo" pitchFamily="34" charset="-122"/>
+                          <a:cs typeface="Meiryo" pitchFamily="34" charset="-120"/>
+                        </a:rPr>
+                        <a:t>○ AI対話</a:t>
+                      </a:r>
+                      <a:endParaRPr lang="en-US" sz="800" dirty="0">
+                        <a:latin typeface="Meiryo" charset="0"/>
+                        <a:ea typeface="Meiryo" charset="0"/>
+                        <a:cs typeface="Meiryo" charset="0"/>
+                      </a:endParaRPr>
+                    </a:p>
+                  </a:txBody>
+                  <a:tcPr marL="54864" marR="54864" marT="18288" marB="18288" anchor="ctr">
+                    <a:lnL w="0" cap="flat" cmpd="sng" algn="ctr">
+                      <a:noFill/>
+                    </a:lnL>
+                    <a:lnR w="0" cap="flat" cmpd="sng" algn="ctr">
+                      <a:noFill/>
+                    </a:lnR>
+                    <a:lnT w="0" cap="flat" cmpd="sng" algn="ctr">
+                      <a:noFill/>
+                    </a:lnT>
+                    <a:lnB w="9525" cap="flat" cmpd="sng" algn="ctr">
+                      <a:solidFill>
+                        <a:srgbClr val="BFBFBF"/>
+                      </a:solidFill>
+                      <a:prstDash val="solid"/>
+                      <a:round/>
+                      <a:headEnd type="none" w="med" len="med"/>
+                      <a:tailEnd type="none" w="med" len="med"/>
+                    </a:lnB>
+                    <a:solidFill>
+                      <a:srgbClr val="FFFFFF"/>
+                    </a:solidFill>
+                  </a:tcPr>
+                </a:tc>
+                <a:tc>
+                  <a:txBody>
+                    <a:bodyPr/>
+                    <a:lstStyle/>
+                    <a:p>
+                      <a:pPr algn="l" indent="0" marL="0">
+                        <a:buNone/>
+                      </a:pPr>
+                      <a:r>
+                        <a:rPr lang="en-US" sz="800" dirty="0">
+                          <a:solidFill>
+                            <a:srgbClr val="1A1A1A"/>
+                          </a:solidFill>
+                          <a:latin typeface="Meiryo" pitchFamily="34" charset="0"/>
+                          <a:ea typeface="Meiryo" pitchFamily="34" charset="-122"/>
+                          <a:cs typeface="Meiryo" pitchFamily="34" charset="-120"/>
+                        </a:rPr>
+                        <a:t>× 顧客任せ</a:t>
+                      </a:r>
+                      <a:endParaRPr lang="en-US" sz="800" dirty="0">
+                        <a:latin typeface="Meiryo" charset="0"/>
+                        <a:ea typeface="Meiryo" charset="0"/>
+                        <a:cs typeface="Meiryo" charset="0"/>
+                      </a:endParaRPr>
+                    </a:p>
+                  </a:txBody>
+                  <a:tcPr marL="54864" marR="54864" marT="18288" marB="18288" anchor="ctr">
+                    <a:lnL w="0" cap="flat" cmpd="sng" algn="ctr">
+                      <a:noFill/>
+                    </a:lnL>
+                    <a:lnR w="0" cap="flat" cmpd="sng" algn="ctr">
+                      <a:noFill/>
+                    </a:lnR>
+                    <a:lnT w="0" cap="flat" cmpd="sng" algn="ctr">
+                      <a:noFill/>
+                    </a:lnT>
+                    <a:lnB w="9525" cap="flat" cmpd="sng" algn="ctr">
+                      <a:solidFill>
+                        <a:srgbClr val="BFBFBF"/>
+                      </a:solidFill>
+                      <a:prstDash val="solid"/>
+                      <a:round/>
+                      <a:headEnd type="none" w="med" len="med"/>
+                      <a:tailEnd type="none" w="med" len="med"/>
+                    </a:lnB>
+                    <a:solidFill>
+                      <a:srgbClr val="FFFFFF"/>
+                    </a:solidFill>
+                  </a:tcPr>
+                </a:tc>
+                <a:tc>
+                  <a:txBody>
+                    <a:bodyPr/>
+                    <a:lstStyle/>
+                    <a:p>
+                      <a:pPr algn="l" indent="0" marL="0">
+                        <a:buNone/>
+                      </a:pPr>
+                      <a:r>
+                        <a:rPr lang="en-US" sz="800" dirty="0">
+                          <a:solidFill>
+                            <a:srgbClr val="1A1A1A"/>
+                          </a:solidFill>
+                          <a:latin typeface="Meiryo" pitchFamily="34" charset="0"/>
+                          <a:ea typeface="Meiryo" pitchFamily="34" charset="-122"/>
+                          <a:cs typeface="Meiryo" pitchFamily="34" charset="-120"/>
+                        </a:rPr>
+                        <a:t>業種横断</a:t>
+                      </a:r>
+                      <a:endParaRPr lang="en-US" sz="800" dirty="0">
+                        <a:latin typeface="Meiryo" charset="0"/>
+                        <a:ea typeface="Meiryo" charset="0"/>
+                        <a:cs typeface="Meiryo" charset="0"/>
+                      </a:endParaRPr>
+                    </a:p>
+                  </a:txBody>
+                  <a:tcPr marL="54864" marR="54864" marT="18288" marB="18288" anchor="ctr">
+                    <a:lnL w="0" cap="flat" cmpd="sng" algn="ctr">
+                      <a:noFill/>
+                    </a:lnL>
+                    <a:lnR w="0" cap="flat" cmpd="sng" algn="ctr">
+                      <a:noFill/>
+                    </a:lnR>
+                    <a:lnT w="0" cap="flat" cmpd="sng" algn="ctr">
+                      <a:noFill/>
+                    </a:lnT>
+                    <a:lnB w="9525" cap="flat" cmpd="sng" algn="ctr">
+                      <a:solidFill>
+                        <a:srgbClr val="BFBFBF"/>
+                      </a:solidFill>
+                      <a:prstDash val="solid"/>
+                      <a:round/>
+                      <a:headEnd type="none" w="med" len="med"/>
+                      <a:tailEnd type="none" w="med" len="med"/>
+                    </a:lnB>
+                    <a:solidFill>
+                      <a:srgbClr val="FFFFFF"/>
+                    </a:solidFill>
+                  </a:tcPr>
+                </a:tc>
+              </a:tr>
+              <a:tr h="246888">
+                <a:tc>
+                  <a:txBody>
+                    <a:bodyPr/>
+                    <a:lstStyle/>
+                    <a:p>
+                      <a:pPr algn="l" indent="0" marL="0">
+                        <a:buNone/>
+                      </a:pPr>
+                      <a:r>
+                        <a:rPr lang="en-US" sz="800" dirty="0">
+                          <a:solidFill>
+                            <a:srgbClr val="1A1A1A"/>
+                          </a:solidFill>
+                          <a:latin typeface="Meiryo" pitchFamily="34" charset="0"/>
+                          <a:ea typeface="Meiryo" pitchFamily="34" charset="-122"/>
+                          <a:cs typeface="Meiryo" pitchFamily="34" charset="-120"/>
+                        </a:rPr>
+                        <a:t>キャディ CADDi</a:t>
+                      </a:r>
+                      <a:endParaRPr lang="en-US" sz="800" dirty="0">
+                        <a:latin typeface="Meiryo" charset="0"/>
+                        <a:ea typeface="Meiryo" charset="0"/>
+                        <a:cs typeface="Meiryo" charset="0"/>
+                      </a:endParaRPr>
+                    </a:p>
+                  </a:txBody>
+                  <a:tcPr marL="54864" marR="54864" marT="18288" marB="18288" anchor="ctr">
+                    <a:lnL w="0" cap="flat" cmpd="sng" algn="ctr">
+                      <a:noFill/>
+                    </a:lnL>
+                    <a:lnR w="0" cap="flat" cmpd="sng" algn="ctr">
+                      <a:noFill/>
+                    </a:lnR>
+                    <a:lnT w="0" cap="flat" cmpd="sng" algn="ctr">
+                      <a:noFill/>
+                    </a:lnT>
+                    <a:lnB w="9525" cap="flat" cmpd="sng" algn="ctr">
+                      <a:solidFill>
+                        <a:srgbClr val="BFBFBF"/>
+                      </a:solidFill>
+                      <a:prstDash val="solid"/>
+                      <a:round/>
+                      <a:headEnd type="none" w="med" len="med"/>
+                      <a:tailEnd type="none" w="med" len="med"/>
+                    </a:lnB>
+                    <a:solidFill>
+                      <a:srgbClr val="FFFFFF"/>
+                    </a:solidFill>
+                  </a:tcPr>
+                </a:tc>
+                <a:tc>
+                  <a:txBody>
+                    <a:bodyPr/>
+                    <a:lstStyle/>
+                    <a:p>
+                      <a:pPr algn="l" indent="0" marL="0">
+                        <a:buNone/>
+                      </a:pPr>
+                      <a:r>
+                        <a:rPr lang="en-US" sz="800" dirty="0">
+                          <a:solidFill>
+                            <a:srgbClr val="1A1A1A"/>
+                          </a:solidFill>
+                          <a:latin typeface="Meiryo" pitchFamily="34" charset="0"/>
+                          <a:ea typeface="Meiryo" pitchFamily="34" charset="-122"/>
+                          <a:cs typeface="Meiryo" pitchFamily="34" charset="-120"/>
+                        </a:rPr>
+                        <a:t>○ 判断履歴</a:t>
+                      </a:r>
+                      <a:endParaRPr lang="en-US" sz="800" dirty="0">
+                        <a:latin typeface="Meiryo" charset="0"/>
+                        <a:ea typeface="Meiryo" charset="0"/>
+                        <a:cs typeface="Meiryo" charset="0"/>
+                      </a:endParaRPr>
+                    </a:p>
+                  </a:txBody>
+                  <a:tcPr marL="54864" marR="54864" marT="18288" marB="18288" anchor="ctr">
+                    <a:lnL w="0" cap="flat" cmpd="sng" algn="ctr">
+                      <a:noFill/>
+                    </a:lnL>
+                    <a:lnR w="0" cap="flat" cmpd="sng" algn="ctr">
+                      <a:noFill/>
+                    </a:lnR>
+                    <a:lnT w="0" cap="flat" cmpd="sng" algn="ctr">
+                      <a:noFill/>
+                    </a:lnT>
+                    <a:lnB w="9525" cap="flat" cmpd="sng" algn="ctr">
+                      <a:solidFill>
+                        <a:srgbClr val="BFBFBF"/>
+                      </a:solidFill>
+                      <a:prstDash val="solid"/>
+                      <a:round/>
+                      <a:headEnd type="none" w="med" len="med"/>
+                      <a:tailEnd type="none" w="med" len="med"/>
+                    </a:lnB>
+                    <a:solidFill>
+                      <a:srgbClr val="FFFFFF"/>
+                    </a:solidFill>
+                  </a:tcPr>
+                </a:tc>
+                <a:tc>
+                  <a:txBody>
+                    <a:bodyPr/>
+                    <a:lstStyle/>
+                    <a:p>
+                      <a:pPr algn="l" indent="0" marL="0">
+                        <a:buNone/>
+                      </a:pPr>
+                      <a:r>
+                        <a:rPr lang="en-US" sz="800" dirty="0">
+                          <a:solidFill>
+                            <a:srgbClr val="1A1A1A"/>
+                          </a:solidFill>
+                          <a:latin typeface="Meiryo" pitchFamily="34" charset="0"/>
+                          <a:ea typeface="Meiryo" pitchFamily="34" charset="-122"/>
+                          <a:cs typeface="Meiryo" pitchFamily="34" charset="-120"/>
+                        </a:rPr>
+                        <a:t>×</a:t>
+                      </a:r>
+                      <a:endParaRPr lang="en-US" sz="800" dirty="0">
+                        <a:latin typeface="Meiryo" charset="0"/>
+                        <a:ea typeface="Meiryo" charset="0"/>
+                        <a:cs typeface="Meiryo" charset="0"/>
+                      </a:endParaRPr>
+                    </a:p>
+                  </a:txBody>
+                  <a:tcPr marL="54864" marR="54864" marT="18288" marB="18288" anchor="ctr">
+                    <a:lnL w="0" cap="flat" cmpd="sng" algn="ctr">
+                      <a:noFill/>
+                    </a:lnL>
+                    <a:lnR w="0" cap="flat" cmpd="sng" algn="ctr">
+                      <a:noFill/>
+                    </a:lnR>
+                    <a:lnT w="0" cap="flat" cmpd="sng" algn="ctr">
+                      <a:noFill/>
+                    </a:lnT>
+                    <a:lnB w="9525" cap="flat" cmpd="sng" algn="ctr">
+                      <a:solidFill>
+                        <a:srgbClr val="BFBFBF"/>
+                      </a:solidFill>
+                      <a:prstDash val="solid"/>
+                      <a:round/>
+                      <a:headEnd type="none" w="med" len="med"/>
+                      <a:tailEnd type="none" w="med" len="med"/>
+                    </a:lnB>
+                    <a:solidFill>
+                      <a:srgbClr val="FFFFFF"/>
+                    </a:solidFill>
+                  </a:tcPr>
+                </a:tc>
+                <a:tc>
+                  <a:txBody>
+                    <a:bodyPr/>
+                    <a:lstStyle/>
+                    <a:p>
+                      <a:pPr algn="l" indent="0" marL="0">
+                        <a:buNone/>
+                      </a:pPr>
+                      <a:r>
+                        <a:rPr lang="en-US" sz="800" dirty="0">
+                          <a:solidFill>
+                            <a:srgbClr val="1A1A1A"/>
+                          </a:solidFill>
+                          <a:latin typeface="Meiryo" pitchFamily="34" charset="0"/>
+                          <a:ea typeface="Meiryo" pitchFamily="34" charset="-122"/>
+                          <a:cs typeface="Meiryo" pitchFamily="34" charset="-120"/>
+                        </a:rPr>
+                        <a:t>組立・図面</a:t>
+                      </a:r>
+                      <a:endParaRPr lang="en-US" sz="800" dirty="0">
+                        <a:latin typeface="Meiryo" charset="0"/>
+                        <a:ea typeface="Meiryo" charset="0"/>
+                        <a:cs typeface="Meiryo" charset="0"/>
+                      </a:endParaRPr>
+                    </a:p>
+                  </a:txBody>
+                  <a:tcPr marL="54864" marR="54864" marT="18288" marB="18288" anchor="ctr">
+                    <a:lnL w="0" cap="flat" cmpd="sng" algn="ctr">
+                      <a:noFill/>
+                    </a:lnL>
+                    <a:lnR w="0" cap="flat" cmpd="sng" algn="ctr">
+                      <a:noFill/>
+                    </a:lnR>
+                    <a:lnT w="0" cap="flat" cmpd="sng" algn="ctr">
+                      <a:noFill/>
+                    </a:lnT>
+                    <a:lnB w="9525" cap="flat" cmpd="sng" algn="ctr">
+                      <a:solidFill>
+                        <a:srgbClr val="BFBFBF"/>
+                      </a:solidFill>
+                      <a:prstDash val="solid"/>
+                      <a:round/>
+                      <a:headEnd type="none" w="med" len="med"/>
+                      <a:tailEnd type="none" w="med" len="med"/>
+                    </a:lnB>
+                    <a:solidFill>
+                      <a:srgbClr val="FFFFFF"/>
+                    </a:solidFill>
+                  </a:tcPr>
+                </a:tc>
+              </a:tr>
+              <a:tr h="246888">
+                <a:tc>
+                  <a:txBody>
+                    <a:bodyPr/>
+                    <a:lstStyle/>
+                    <a:p>
+                      <a:pPr algn="l" indent="0" marL="0">
+                        <a:buNone/>
+                      </a:pPr>
+                      <a:r>
+                        <a:rPr lang="en-US" sz="800" dirty="0">
+                          <a:solidFill>
+                            <a:srgbClr val="1A1A1A"/>
+                          </a:solidFill>
+                          <a:latin typeface="Meiryo" pitchFamily="34" charset="0"/>
+                          <a:ea typeface="Meiryo" pitchFamily="34" charset="-122"/>
+                          <a:cs typeface="Meiryo" pitchFamily="34" charset="-120"/>
+                        </a:rPr>
+                        <a:t>三菱総研 匠AI</a:t>
+                      </a:r>
+                      <a:endParaRPr lang="en-US" sz="800" dirty="0">
+                        <a:latin typeface="Meiryo" charset="0"/>
+                        <a:ea typeface="Meiryo" charset="0"/>
+                        <a:cs typeface="Meiryo" charset="0"/>
+                      </a:endParaRPr>
+                    </a:p>
+                  </a:txBody>
+                  <a:tcPr marL="54864" marR="54864" marT="18288" marB="18288" anchor="ctr">
+                    <a:lnL w="0" cap="flat" cmpd="sng" algn="ctr">
+                      <a:noFill/>
+                    </a:lnL>
+                    <a:lnR w="0" cap="flat" cmpd="sng" algn="ctr">
+                      <a:noFill/>
+                    </a:lnR>
+                    <a:lnT w="0" cap="flat" cmpd="sng" algn="ctr">
+                      <a:noFill/>
+                    </a:lnT>
+                    <a:lnB w="9525" cap="flat" cmpd="sng" algn="ctr">
+                      <a:solidFill>
+                        <a:srgbClr val="BFBFBF"/>
+                      </a:solidFill>
+                      <a:prstDash val="solid"/>
+                      <a:round/>
+                      <a:headEnd type="none" w="med" len="med"/>
+                      <a:tailEnd type="none" w="med" len="med"/>
+                    </a:lnB>
+                    <a:solidFill>
+                      <a:srgbClr val="FFFFFF"/>
+                    </a:solidFill>
+                  </a:tcPr>
+                </a:tc>
+                <a:tc>
+                  <a:txBody>
+                    <a:bodyPr/>
+                    <a:lstStyle/>
+                    <a:p>
+                      <a:pPr algn="l" indent="0" marL="0">
+                        <a:buNone/>
+                      </a:pPr>
+                      <a:r>
+                        <a:rPr lang="en-US" sz="800" dirty="0">
+                          <a:solidFill>
+                            <a:srgbClr val="1A1A1A"/>
+                          </a:solidFill>
+                          <a:latin typeface="Meiryo" pitchFamily="34" charset="0"/>
+                          <a:ea typeface="Meiryo" pitchFamily="34" charset="-122"/>
+                          <a:cs typeface="Meiryo" pitchFamily="34" charset="-120"/>
+                        </a:rPr>
+                        <a:t>○ コンサル型</a:t>
+                      </a:r>
+                      <a:endParaRPr lang="en-US" sz="800" dirty="0">
+                        <a:latin typeface="Meiryo" charset="0"/>
+                        <a:ea typeface="Meiryo" charset="0"/>
+                        <a:cs typeface="Meiryo" charset="0"/>
+                      </a:endParaRPr>
+                    </a:p>
+                  </a:txBody>
+                  <a:tcPr marL="54864" marR="54864" marT="18288" marB="18288" anchor="ctr">
+                    <a:lnL w="0" cap="flat" cmpd="sng" algn="ctr">
+                      <a:noFill/>
+                    </a:lnL>
+                    <a:lnR w="0" cap="flat" cmpd="sng" algn="ctr">
+                      <a:noFill/>
+                    </a:lnR>
+                    <a:lnT w="0" cap="flat" cmpd="sng" algn="ctr">
+                      <a:noFill/>
+                    </a:lnT>
+                    <a:lnB w="9525" cap="flat" cmpd="sng" algn="ctr">
+                      <a:solidFill>
+                        <a:srgbClr val="BFBFBF"/>
+                      </a:solidFill>
+                      <a:prstDash val="solid"/>
+                      <a:round/>
+                      <a:headEnd type="none" w="med" len="med"/>
+                      <a:tailEnd type="none" w="med" len="med"/>
+                    </a:lnB>
+                    <a:solidFill>
+                      <a:srgbClr val="FFFFFF"/>
+                    </a:solidFill>
+                  </a:tcPr>
+                </a:tc>
+                <a:tc>
+                  <a:txBody>
+                    <a:bodyPr/>
+                    <a:lstStyle/>
+                    <a:p>
+                      <a:pPr algn="l" indent="0" marL="0">
+                        <a:buNone/>
+                      </a:pPr>
+                      <a:r>
+                        <a:rPr lang="en-US" sz="800" dirty="0">
+                          <a:solidFill>
+                            <a:srgbClr val="1A1A1A"/>
+                          </a:solidFill>
+                          <a:latin typeface="Meiryo" pitchFamily="34" charset="0"/>
+                          <a:ea typeface="Meiryo" pitchFamily="34" charset="-122"/>
+                          <a:cs typeface="Meiryo" pitchFamily="34" charset="-120"/>
+                        </a:rPr>
+                        <a:t>×</a:t>
+                      </a:r>
+                      <a:endParaRPr lang="en-US" sz="800" dirty="0">
+                        <a:latin typeface="Meiryo" charset="0"/>
+                        <a:ea typeface="Meiryo" charset="0"/>
+                        <a:cs typeface="Meiryo" charset="0"/>
+                      </a:endParaRPr>
+                    </a:p>
+                  </a:txBody>
+                  <a:tcPr marL="54864" marR="54864" marT="18288" marB="18288" anchor="ctr">
+                    <a:lnL w="0" cap="flat" cmpd="sng" algn="ctr">
+                      <a:noFill/>
+                    </a:lnL>
+                    <a:lnR w="0" cap="flat" cmpd="sng" algn="ctr">
+                      <a:noFill/>
+                    </a:lnR>
+                    <a:lnT w="0" cap="flat" cmpd="sng" algn="ctr">
+                      <a:noFill/>
+                    </a:lnT>
+                    <a:lnB w="9525" cap="flat" cmpd="sng" algn="ctr">
+                      <a:solidFill>
+                        <a:srgbClr val="BFBFBF"/>
+                      </a:solidFill>
+                      <a:prstDash val="solid"/>
+                      <a:round/>
+                      <a:headEnd type="none" w="med" len="med"/>
+                      <a:tailEnd type="none" w="med" len="med"/>
+                    </a:lnB>
+                    <a:solidFill>
+                      <a:srgbClr val="FFFFFF"/>
+                    </a:solidFill>
+                  </a:tcPr>
+                </a:tc>
+                <a:tc>
+                  <a:txBody>
+                    <a:bodyPr/>
+                    <a:lstStyle/>
+                    <a:p>
+                      <a:pPr algn="l" indent="0" marL="0">
+                        <a:buNone/>
+                      </a:pPr>
+                      <a:r>
+                        <a:rPr lang="en-US" sz="800" dirty="0">
+                          <a:solidFill>
+                            <a:srgbClr val="1A1A1A"/>
+                          </a:solidFill>
+                          <a:latin typeface="Meiryo" pitchFamily="34" charset="0"/>
+                          <a:ea typeface="Meiryo" pitchFamily="34" charset="-122"/>
+                          <a:cs typeface="Meiryo" pitchFamily="34" charset="-120"/>
+                        </a:rPr>
+                        <a:t>個別案件</a:t>
+                      </a:r>
+                      <a:endParaRPr lang="en-US" sz="800" dirty="0">
+                        <a:latin typeface="Meiryo" charset="0"/>
+                        <a:ea typeface="Meiryo" charset="0"/>
+                        <a:cs typeface="Meiryo" charset="0"/>
+                      </a:endParaRPr>
+                    </a:p>
+                  </a:txBody>
+                  <a:tcPr marL="54864" marR="54864" marT="18288" marB="18288" anchor="ctr">
+                    <a:lnL w="0" cap="flat" cmpd="sng" algn="ctr">
+                      <a:noFill/>
+                    </a:lnL>
+                    <a:lnR w="0" cap="flat" cmpd="sng" algn="ctr">
+                      <a:noFill/>
+                    </a:lnR>
+                    <a:lnT w="0" cap="flat" cmpd="sng" algn="ctr">
+                      <a:noFill/>
+                    </a:lnT>
+                    <a:lnB w="9525" cap="flat" cmpd="sng" algn="ctr">
+                      <a:solidFill>
+                        <a:srgbClr val="BFBFBF"/>
+                      </a:solidFill>
+                      <a:prstDash val="solid"/>
+                      <a:round/>
+                      <a:headEnd type="none" w="med" len="med"/>
+                      <a:tailEnd type="none" w="med" len="med"/>
+                    </a:lnB>
+                    <a:solidFill>
+                      <a:srgbClr val="FFFFFF"/>
+                    </a:solidFill>
+                  </a:tcPr>
+                </a:tc>
+              </a:tr>
+              <a:tr h="246888">
+                <a:tc>
+                  <a:txBody>
+                    <a:bodyPr/>
+                    <a:lstStyle/>
+                    <a:p>
+                      <a:pPr algn="l" indent="0" marL="0">
+                        <a:buNone/>
+                      </a:pPr>
+                      <a:r>
+                        <a:rPr lang="en-US" sz="800" dirty="0">
+                          <a:solidFill>
+                            <a:srgbClr val="1A1A1A"/>
+                          </a:solidFill>
+                          <a:latin typeface="Meiryo" pitchFamily="34" charset="0"/>
+                          <a:ea typeface="Meiryo" pitchFamily="34" charset="-122"/>
+                          <a:cs typeface="Meiryo" pitchFamily="34" charset="-120"/>
+                        </a:rPr>
+                        <a:t>FRONTEO KIBIT</a:t>
+                      </a:r>
+                      <a:endParaRPr lang="en-US" sz="800" dirty="0">
+                        <a:latin typeface="Meiryo" charset="0"/>
+                        <a:ea typeface="Meiryo" charset="0"/>
+                        <a:cs typeface="Meiryo" charset="0"/>
+                      </a:endParaRPr>
+                    </a:p>
+                  </a:txBody>
+                  <a:tcPr marL="54864" marR="54864" marT="18288" marB="18288" anchor="ctr">
+                    <a:lnL w="0" cap="flat" cmpd="sng" algn="ctr">
+                      <a:noFill/>
+                    </a:lnL>
+                    <a:lnR w="0" cap="flat" cmpd="sng" algn="ctr">
+                      <a:noFill/>
+                    </a:lnR>
+                    <a:lnT w="0" cap="flat" cmpd="sng" algn="ctr">
+                      <a:noFill/>
+                    </a:lnT>
+                    <a:lnB w="9525" cap="flat" cmpd="sng" algn="ctr">
+                      <a:solidFill>
+                        <a:srgbClr val="BFBFBF"/>
+                      </a:solidFill>
+                      <a:prstDash val="solid"/>
+                      <a:round/>
+                      <a:headEnd type="none" w="med" len="med"/>
+                      <a:tailEnd type="none" w="med" len="med"/>
+                    </a:lnB>
+                    <a:solidFill>
+                      <a:srgbClr val="FFFFFF"/>
+                    </a:solidFill>
+                  </a:tcPr>
+                </a:tc>
+                <a:tc>
+                  <a:txBody>
+                    <a:bodyPr/>
+                    <a:lstStyle/>
+                    <a:p>
+                      <a:pPr algn="l" indent="0" marL="0">
+                        <a:buNone/>
+                      </a:pPr>
+                      <a:r>
+                        <a:rPr lang="en-US" sz="800" dirty="0">
+                          <a:solidFill>
+                            <a:srgbClr val="1A1A1A"/>
+                          </a:solidFill>
+                          <a:latin typeface="Meiryo" pitchFamily="34" charset="0"/>
+                          <a:ea typeface="Meiryo" pitchFamily="34" charset="-122"/>
+                          <a:cs typeface="Meiryo" pitchFamily="34" charset="-120"/>
+                        </a:rPr>
+                        <a:t>△ 既存文書</a:t>
+                      </a:r>
+                      <a:endParaRPr lang="en-US" sz="800" dirty="0">
+                        <a:latin typeface="Meiryo" charset="0"/>
+                        <a:ea typeface="Meiryo" charset="0"/>
+                        <a:cs typeface="Meiryo" charset="0"/>
+                      </a:endParaRPr>
+                    </a:p>
+                  </a:txBody>
+                  <a:tcPr marL="54864" marR="54864" marT="18288" marB="18288" anchor="ctr">
+                    <a:lnL w="0" cap="flat" cmpd="sng" algn="ctr">
+                      <a:noFill/>
+                    </a:lnL>
+                    <a:lnR w="0" cap="flat" cmpd="sng" algn="ctr">
+                      <a:noFill/>
+                    </a:lnR>
+                    <a:lnT w="0" cap="flat" cmpd="sng" algn="ctr">
+                      <a:noFill/>
+                    </a:lnT>
+                    <a:lnB w="9525" cap="flat" cmpd="sng" algn="ctr">
+                      <a:solidFill>
+                        <a:srgbClr val="BFBFBF"/>
+                      </a:solidFill>
+                      <a:prstDash val="solid"/>
+                      <a:round/>
+                      <a:headEnd type="none" w="med" len="med"/>
+                      <a:tailEnd type="none" w="med" len="med"/>
+                    </a:lnB>
+                    <a:solidFill>
+                      <a:srgbClr val="FFFFFF"/>
+                    </a:solidFill>
+                  </a:tcPr>
+                </a:tc>
+                <a:tc>
+                  <a:txBody>
+                    <a:bodyPr/>
+                    <a:lstStyle/>
+                    <a:p>
+                      <a:pPr algn="l" indent="0" marL="0">
+                        <a:buNone/>
+                      </a:pPr>
+                      <a:r>
+                        <a:rPr lang="en-US" sz="800" dirty="0">
+                          <a:solidFill>
+                            <a:srgbClr val="1A1A1A"/>
+                          </a:solidFill>
+                          <a:latin typeface="Meiryo" pitchFamily="34" charset="0"/>
+                          <a:ea typeface="Meiryo" pitchFamily="34" charset="-122"/>
+                          <a:cs typeface="Meiryo" pitchFamily="34" charset="-120"/>
+                        </a:rPr>
+                        <a:t>×</a:t>
+                      </a:r>
+                      <a:endParaRPr lang="en-US" sz="800" dirty="0">
+                        <a:latin typeface="Meiryo" charset="0"/>
+                        <a:ea typeface="Meiryo" charset="0"/>
+                        <a:cs typeface="Meiryo" charset="0"/>
+                      </a:endParaRPr>
+                    </a:p>
+                  </a:txBody>
+                  <a:tcPr marL="54864" marR="54864" marT="18288" marB="18288" anchor="ctr">
+                    <a:lnL w="0" cap="flat" cmpd="sng" algn="ctr">
+                      <a:noFill/>
+                    </a:lnL>
+                    <a:lnR w="0" cap="flat" cmpd="sng" algn="ctr">
+                      <a:noFill/>
+                    </a:lnR>
+                    <a:lnT w="0" cap="flat" cmpd="sng" algn="ctr">
+                      <a:noFill/>
+                    </a:lnT>
+                    <a:lnB w="9525" cap="flat" cmpd="sng" algn="ctr">
+                      <a:solidFill>
+                        <a:srgbClr val="BFBFBF"/>
+                      </a:solidFill>
+                      <a:prstDash val="solid"/>
+                      <a:round/>
+                      <a:headEnd type="none" w="med" len="med"/>
+                      <a:tailEnd type="none" w="med" len="med"/>
+                    </a:lnB>
+                    <a:solidFill>
+                      <a:srgbClr val="FFFFFF"/>
+                    </a:solidFill>
+                  </a:tcPr>
+                </a:tc>
+                <a:tc>
+                  <a:txBody>
+                    <a:bodyPr/>
+                    <a:lstStyle/>
+                    <a:p>
+                      <a:pPr algn="l" indent="0" marL="0">
+                        <a:buNone/>
+                      </a:pPr>
+                      <a:r>
+                        <a:rPr lang="en-US" sz="800" dirty="0">
+                          <a:solidFill>
+                            <a:srgbClr val="1A1A1A"/>
+                          </a:solidFill>
+                          <a:latin typeface="Meiryo" pitchFamily="34" charset="0"/>
+                          <a:ea typeface="Meiryo" pitchFamily="34" charset="-122"/>
+                          <a:cs typeface="Meiryo" pitchFamily="34" charset="-120"/>
+                        </a:rPr>
+                        <a:t>業種横断</a:t>
+                      </a:r>
+                      <a:endParaRPr lang="en-US" sz="800" dirty="0">
+                        <a:latin typeface="Meiryo" charset="0"/>
+                        <a:ea typeface="Meiryo" charset="0"/>
+                        <a:cs typeface="Meiryo" charset="0"/>
+                      </a:endParaRPr>
+                    </a:p>
+                  </a:txBody>
+                  <a:tcPr marL="54864" marR="54864" marT="18288" marB="18288" anchor="ctr">
+                    <a:lnL w="0" cap="flat" cmpd="sng" algn="ctr">
+                      <a:noFill/>
+                    </a:lnL>
+                    <a:lnR w="0" cap="flat" cmpd="sng" algn="ctr">
+                      <a:noFill/>
+                    </a:lnR>
+                    <a:lnT w="0" cap="flat" cmpd="sng" algn="ctr">
+                      <a:noFill/>
+                    </a:lnT>
+                    <a:lnB w="9525" cap="flat" cmpd="sng" algn="ctr">
+                      <a:solidFill>
+                        <a:srgbClr val="BFBFBF"/>
+                      </a:solidFill>
+                      <a:prstDash val="solid"/>
+                      <a:round/>
+                      <a:headEnd type="none" w="med" len="med"/>
+                      <a:tailEnd type="none" w="med" len="med"/>
+                    </a:lnB>
+                    <a:solidFill>
+                      <a:srgbClr val="FFFFFF"/>
+                    </a:solidFill>
+                  </a:tcPr>
+                </a:tc>
+              </a:tr>
+              <a:tr h="246888">
+                <a:tc>
+                  <a:txBody>
+                    <a:bodyPr/>
+                    <a:lstStyle/>
+                    <a:p>
+                      <a:pPr algn="l" indent="0" marL="0">
+                        <a:buNone/>
+                      </a:pPr>
+                      <a:r>
+                        <a:rPr lang="en-US" sz="800" dirty="0">
+                          <a:solidFill>
+                            <a:srgbClr val="1A1A1A"/>
+                          </a:solidFill>
+                          <a:latin typeface="Meiryo" pitchFamily="34" charset="0"/>
+                          <a:ea typeface="Meiryo" pitchFamily="34" charset="-122"/>
+                          <a:cs typeface="Meiryo" pitchFamily="34" charset="-120"/>
+                        </a:rPr>
+                        <a:t>tebiki／Teachme Biz</a:t>
+                      </a:r>
+                      <a:endParaRPr lang="en-US" sz="800" dirty="0">
+                        <a:latin typeface="Meiryo" charset="0"/>
+                        <a:ea typeface="Meiryo" charset="0"/>
+                        <a:cs typeface="Meiryo" charset="0"/>
+                      </a:endParaRPr>
+                    </a:p>
+                  </a:txBody>
+                  <a:tcPr marL="54864" marR="54864" marT="18288" marB="18288" anchor="ctr">
+                    <a:lnL w="0" cap="flat" cmpd="sng" algn="ctr">
+                      <a:noFill/>
+                    </a:lnL>
+                    <a:lnR w="0" cap="flat" cmpd="sng" algn="ctr">
+                      <a:noFill/>
+                    </a:lnR>
+                    <a:lnT w="0" cap="flat" cmpd="sng" algn="ctr">
+                      <a:noFill/>
+                    </a:lnT>
+                    <a:lnB w="9525" cap="flat" cmpd="sng" algn="ctr">
+                      <a:solidFill>
+                        <a:srgbClr val="BFBFBF"/>
+                      </a:solidFill>
+                      <a:prstDash val="solid"/>
+                      <a:round/>
+                      <a:headEnd type="none" w="med" len="med"/>
+                      <a:tailEnd type="none" w="med" len="med"/>
+                    </a:lnB>
+                    <a:solidFill>
+                      <a:srgbClr val="FFFFFF"/>
+                    </a:solidFill>
+                  </a:tcPr>
+                </a:tc>
+                <a:tc>
+                  <a:txBody>
+                    <a:bodyPr/>
+                    <a:lstStyle/>
+                    <a:p>
+                      <a:pPr algn="l" indent="0" marL="0">
+                        <a:buNone/>
+                      </a:pPr>
+                      <a:r>
+                        <a:rPr lang="en-US" sz="800" dirty="0">
+                          <a:solidFill>
+                            <a:srgbClr val="1A1A1A"/>
+                          </a:solidFill>
+                          <a:latin typeface="Meiryo" pitchFamily="34" charset="0"/>
+                          <a:ea typeface="Meiryo" pitchFamily="34" charset="-122"/>
+                          <a:cs typeface="Meiryo" pitchFamily="34" charset="-120"/>
+                        </a:rPr>
+                        <a:t>×</a:t>
+                      </a:r>
+                      <a:endParaRPr lang="en-US" sz="800" dirty="0">
+                        <a:latin typeface="Meiryo" charset="0"/>
+                        <a:ea typeface="Meiryo" charset="0"/>
+                        <a:cs typeface="Meiryo" charset="0"/>
+                      </a:endParaRPr>
+                    </a:p>
+                  </a:txBody>
+                  <a:tcPr marL="54864" marR="54864" marT="18288" marB="18288" anchor="ctr">
+                    <a:lnL w="0" cap="flat" cmpd="sng" algn="ctr">
+                      <a:noFill/>
+                    </a:lnL>
+                    <a:lnR w="0" cap="flat" cmpd="sng" algn="ctr">
+                      <a:noFill/>
+                    </a:lnR>
+                    <a:lnT w="0" cap="flat" cmpd="sng" algn="ctr">
+                      <a:noFill/>
+                    </a:lnT>
+                    <a:lnB w="9525" cap="flat" cmpd="sng" algn="ctr">
+                      <a:solidFill>
+                        <a:srgbClr val="BFBFBF"/>
+                      </a:solidFill>
+                      <a:prstDash val="solid"/>
+                      <a:round/>
+                      <a:headEnd type="none" w="med" len="med"/>
+                      <a:tailEnd type="none" w="med" len="med"/>
+                    </a:lnB>
+                    <a:solidFill>
+                      <a:srgbClr val="FFFFFF"/>
+                    </a:solidFill>
+                  </a:tcPr>
+                </a:tc>
+                <a:tc>
+                  <a:txBody>
+                    <a:bodyPr/>
+                    <a:lstStyle/>
+                    <a:p>
+                      <a:pPr algn="l" indent="0" marL="0">
+                        <a:buNone/>
+                      </a:pPr>
+                      <a:r>
+                        <a:rPr lang="en-US" sz="800" dirty="0">
+                          <a:solidFill>
+                            <a:srgbClr val="1A1A1A"/>
+                          </a:solidFill>
+                          <a:latin typeface="Meiryo" pitchFamily="34" charset="0"/>
+                          <a:ea typeface="Meiryo" pitchFamily="34" charset="-122"/>
+                          <a:cs typeface="Meiryo" pitchFamily="34" charset="-120"/>
+                        </a:rPr>
+                        <a:t>△ 器のみ</a:t>
+                      </a:r>
+                      <a:endParaRPr lang="en-US" sz="800" dirty="0">
+                        <a:latin typeface="Meiryo" charset="0"/>
+                        <a:ea typeface="Meiryo" charset="0"/>
+                        <a:cs typeface="Meiryo" charset="0"/>
+                      </a:endParaRPr>
+                    </a:p>
+                  </a:txBody>
+                  <a:tcPr marL="54864" marR="54864" marT="18288" marB="18288" anchor="ctr">
+                    <a:lnL w="0" cap="flat" cmpd="sng" algn="ctr">
+                      <a:noFill/>
+                    </a:lnL>
+                    <a:lnR w="0" cap="flat" cmpd="sng" algn="ctr">
+                      <a:noFill/>
+                    </a:lnR>
+                    <a:lnT w="0" cap="flat" cmpd="sng" algn="ctr">
+                      <a:noFill/>
+                    </a:lnT>
+                    <a:lnB w="9525" cap="flat" cmpd="sng" algn="ctr">
+                      <a:solidFill>
+                        <a:srgbClr val="BFBFBF"/>
+                      </a:solidFill>
+                      <a:prstDash val="solid"/>
+                      <a:round/>
+                      <a:headEnd type="none" w="med" len="med"/>
+                      <a:tailEnd type="none" w="med" len="med"/>
+                    </a:lnB>
+                    <a:solidFill>
+                      <a:srgbClr val="FFFFFF"/>
+                    </a:solidFill>
+                  </a:tcPr>
+                </a:tc>
+                <a:tc>
+                  <a:txBody>
+                    <a:bodyPr/>
+                    <a:lstStyle/>
+                    <a:p>
+                      <a:pPr algn="l" indent="0" marL="0">
+                        <a:buNone/>
+                      </a:pPr>
+                      <a:r>
+                        <a:rPr lang="en-US" sz="800" dirty="0">
+                          <a:solidFill>
+                            <a:srgbClr val="1A1A1A"/>
+                          </a:solidFill>
+                          <a:latin typeface="Meiryo" pitchFamily="34" charset="0"/>
+                          <a:ea typeface="Meiryo" pitchFamily="34" charset="-122"/>
+                          <a:cs typeface="Meiryo" pitchFamily="34" charset="-120"/>
+                        </a:rPr>
+                        <a:t>業種横断</a:t>
+                      </a:r>
+                      <a:endParaRPr lang="en-US" sz="800" dirty="0">
+                        <a:latin typeface="Meiryo" charset="0"/>
+                        <a:ea typeface="Meiryo" charset="0"/>
+                        <a:cs typeface="Meiryo" charset="0"/>
+                      </a:endParaRPr>
+                    </a:p>
+                  </a:txBody>
+                  <a:tcPr marL="54864" marR="54864" marT="18288" marB="18288" anchor="ctr">
+                    <a:lnL w="0" cap="flat" cmpd="sng" algn="ctr">
+                      <a:noFill/>
+                    </a:lnL>
+                    <a:lnR w="0" cap="flat" cmpd="sng" algn="ctr">
+                      <a:noFill/>
+                    </a:lnR>
+                    <a:lnT w="0" cap="flat" cmpd="sng" algn="ctr">
+                      <a:noFill/>
+                    </a:lnT>
+                    <a:lnB w="9525" cap="flat" cmpd="sng" algn="ctr">
+                      <a:solidFill>
+                        <a:srgbClr val="BFBFBF"/>
+                      </a:solidFill>
+                      <a:prstDash val="solid"/>
+                      <a:round/>
+                      <a:headEnd type="none" w="med" len="med"/>
+                      <a:tailEnd type="none" w="med" len="med"/>
+                    </a:lnB>
+                    <a:solidFill>
+                      <a:srgbClr val="FFFFFF"/>
+                    </a:solidFill>
+                  </a:tcPr>
+                </a:tc>
+              </a:tr>
+              <a:tr h="246888">
+                <a:tc>
+                  <a:txBody>
+                    <a:bodyPr/>
+                    <a:lstStyle/>
+                    <a:p>
+                      <a:pPr algn="l" indent="0" marL="0">
+                        <a:buNone/>
+                      </a:pPr>
+                      <a:r>
+                        <a:rPr lang="en-US" sz="800" b="1" dirty="0">
+                          <a:solidFill>
+                            <a:srgbClr val="1A1A1A"/>
+                          </a:solidFill>
+                          <a:latin typeface="Meiryo" pitchFamily="34" charset="0"/>
+                          <a:ea typeface="Meiryo" pitchFamily="34" charset="-122"/>
+                          <a:cs typeface="Meiryo" pitchFamily="34" charset="-120"/>
+                        </a:rPr>
+                        <a:t>三現ワークス</a:t>
+                      </a:r>
+                      <a:endParaRPr lang="en-US" sz="800" dirty="0">
+                        <a:latin typeface="Meiryo" charset="0"/>
+                        <a:ea typeface="Meiryo" charset="0"/>
+                        <a:cs typeface="Meiryo" charset="0"/>
+                      </a:endParaRPr>
+                    </a:p>
+                  </a:txBody>
+                  <a:tcPr marL="54864" marR="54864" marT="18288" marB="18288" anchor="ctr">
+                    <a:lnL w="0" cap="flat" cmpd="sng" algn="ctr">
+                      <a:noFill/>
+                    </a:lnL>
+                    <a:lnR w="0" cap="flat" cmpd="sng" algn="ctr">
+                      <a:noFill/>
+                    </a:lnR>
+                    <a:lnT w="19050" cap="flat" cmpd="sng" algn="ctr">
+                      <a:solidFill>
+                        <a:srgbClr val="1A1A1A"/>
+                      </a:solidFill>
+                      <a:prstDash val="solid"/>
+                      <a:round/>
+                      <a:headEnd type="none" w="med" len="med"/>
+                      <a:tailEnd type="none" w="med" len="med"/>
+                    </a:lnT>
+                    <a:lnB w="9525" cap="flat" cmpd="sng" algn="ctr">
+                      <a:solidFill>
+                        <a:srgbClr val="BFBFBF"/>
+                      </a:solidFill>
+                      <a:prstDash val="solid"/>
+                      <a:round/>
+                      <a:headEnd type="none" w="med" len="med"/>
+                      <a:tailEnd type="none" w="med" len="med"/>
+                    </a:lnB>
+                    <a:solidFill>
+                      <a:srgbClr val="FFFFFF"/>
+                    </a:solidFill>
+                  </a:tcPr>
+                </a:tc>
+                <a:tc>
+                  <a:txBody>
+                    <a:bodyPr/>
+                    <a:lstStyle/>
+                    <a:p>
+                      <a:pPr algn="l" indent="0" marL="0">
+                        <a:buNone/>
+                      </a:pPr>
+                      <a:r>
+                        <a:rPr lang="en-US" sz="800" b="1" dirty="0">
+                          <a:solidFill>
+                            <a:srgbClr val="1A1A1A"/>
+                          </a:solidFill>
+                          <a:latin typeface="Meiryo" pitchFamily="34" charset="0"/>
+                          <a:ea typeface="Meiryo" pitchFamily="34" charset="-122"/>
+                          <a:cs typeface="Meiryo" pitchFamily="34" charset="-120"/>
+                        </a:rPr>
+                        <a:t>○ 音声で一言</a:t>
+                      </a:r>
+                      <a:endParaRPr lang="en-US" sz="800" dirty="0">
+                        <a:latin typeface="Meiryo" charset="0"/>
+                        <a:ea typeface="Meiryo" charset="0"/>
+                        <a:cs typeface="Meiryo" charset="0"/>
+                      </a:endParaRPr>
+                    </a:p>
+                  </a:txBody>
+                  <a:tcPr marL="54864" marR="54864" marT="18288" marB="18288" anchor="ctr">
+                    <a:lnL w="0" cap="flat" cmpd="sng" algn="ctr">
+                      <a:noFill/>
+                    </a:lnL>
+                    <a:lnR w="0" cap="flat" cmpd="sng" algn="ctr">
+                      <a:noFill/>
+                    </a:lnR>
+                    <a:lnT w="19050" cap="flat" cmpd="sng" algn="ctr">
+                      <a:solidFill>
+                        <a:srgbClr val="1A1A1A"/>
+                      </a:solidFill>
+                      <a:prstDash val="solid"/>
+                      <a:round/>
+                      <a:headEnd type="none" w="med" len="med"/>
+                      <a:tailEnd type="none" w="med" len="med"/>
+                    </a:lnT>
+                    <a:lnB w="9525" cap="flat" cmpd="sng" algn="ctr">
+                      <a:solidFill>
+                        <a:srgbClr val="BFBFBF"/>
+                      </a:solidFill>
+                      <a:prstDash val="solid"/>
+                      <a:round/>
+                      <a:headEnd type="none" w="med" len="med"/>
+                      <a:tailEnd type="none" w="med" len="med"/>
+                    </a:lnB>
+                    <a:solidFill>
+                      <a:srgbClr val="FFFFFF"/>
+                    </a:solidFill>
+                  </a:tcPr>
+                </a:tc>
+                <a:tc>
+                  <a:txBody>
+                    <a:bodyPr/>
+                    <a:lstStyle/>
+                    <a:p>
+                      <a:pPr algn="l" indent="0" marL="0">
+                        <a:buNone/>
+                      </a:pPr>
+                      <a:r>
+                        <a:rPr lang="en-US" sz="800" b="1" dirty="0">
+                          <a:solidFill>
+                            <a:srgbClr val="1A1A1A"/>
+                          </a:solidFill>
+                          <a:latin typeface="Meiryo" pitchFamily="34" charset="0"/>
+                          <a:ea typeface="Meiryo" pitchFamily="34" charset="-122"/>
+                          <a:cs typeface="Meiryo" pitchFamily="34" charset="-120"/>
+                        </a:rPr>
+                        <a:t>○ 当社が制作</a:t>
+                      </a:r>
+                      <a:endParaRPr lang="en-US" sz="800" dirty="0">
+                        <a:latin typeface="Meiryo" charset="0"/>
+                        <a:ea typeface="Meiryo" charset="0"/>
+                        <a:cs typeface="Meiryo" charset="0"/>
+                      </a:endParaRPr>
+                    </a:p>
+                  </a:txBody>
+                  <a:tcPr marL="54864" marR="54864" marT="18288" marB="18288" anchor="ctr">
+                    <a:lnL w="0" cap="flat" cmpd="sng" algn="ctr">
+                      <a:noFill/>
+                    </a:lnL>
+                    <a:lnR w="0" cap="flat" cmpd="sng" algn="ctr">
+                      <a:noFill/>
+                    </a:lnR>
+                    <a:lnT w="19050" cap="flat" cmpd="sng" algn="ctr">
+                      <a:solidFill>
+                        <a:srgbClr val="1A1A1A"/>
+                      </a:solidFill>
+                      <a:prstDash val="solid"/>
+                      <a:round/>
+                      <a:headEnd type="none" w="med" len="med"/>
+                      <a:tailEnd type="none" w="med" len="med"/>
+                    </a:lnT>
+                    <a:lnB w="9525" cap="flat" cmpd="sng" algn="ctr">
+                      <a:solidFill>
+                        <a:srgbClr val="BFBFBF"/>
+                      </a:solidFill>
+                      <a:prstDash val="solid"/>
+                      <a:round/>
+                      <a:headEnd type="none" w="med" len="med"/>
+                      <a:tailEnd type="none" w="med" len="med"/>
+                    </a:lnB>
+                    <a:solidFill>
+                      <a:srgbClr val="FFFFFF"/>
+                    </a:solidFill>
+                  </a:tcPr>
+                </a:tc>
+                <a:tc>
+                  <a:txBody>
+                    <a:bodyPr/>
+                    <a:lstStyle/>
+                    <a:p>
+                      <a:pPr algn="l" indent="0" marL="0">
+                        <a:buNone/>
+                      </a:pPr>
+                      <a:r>
+                        <a:rPr lang="en-US" sz="800" b="1" dirty="0">
+                          <a:solidFill>
+                            <a:srgbClr val="1A1A1A"/>
+                          </a:solidFill>
+                          <a:latin typeface="Meiryo" pitchFamily="34" charset="0"/>
+                          <a:ea typeface="Meiryo" pitchFamily="34" charset="-122"/>
+                          <a:cs typeface="Meiryo" pitchFamily="34" charset="-120"/>
+                        </a:rPr>
+                        <a:t>連続工程</a:t>
+                      </a:r>
+                      <a:endParaRPr lang="en-US" sz="800" dirty="0">
+                        <a:latin typeface="Meiryo" charset="0"/>
+                        <a:ea typeface="Meiryo" charset="0"/>
+                        <a:cs typeface="Meiryo" charset="0"/>
+                      </a:endParaRPr>
+                    </a:p>
+                  </a:txBody>
+                  <a:tcPr marL="54864" marR="54864" marT="18288" marB="18288" anchor="ctr">
+                    <a:lnL w="0" cap="flat" cmpd="sng" algn="ctr">
+                      <a:noFill/>
+                    </a:lnL>
+                    <a:lnR w="0" cap="flat" cmpd="sng" algn="ctr">
+                      <a:noFill/>
+                    </a:lnR>
+                    <a:lnT w="19050" cap="flat" cmpd="sng" algn="ctr">
+                      <a:solidFill>
+                        <a:srgbClr val="1A1A1A"/>
+                      </a:solidFill>
+                      <a:prstDash val="solid"/>
+                      <a:round/>
+                      <a:headEnd type="none" w="med" len="med"/>
+                      <a:tailEnd type="none" w="med" len="med"/>
+                    </a:lnT>
+                    <a:lnB w="9525" cap="flat" cmpd="sng" algn="ctr">
+                      <a:solidFill>
+                        <a:srgbClr val="BFBFBF"/>
+                      </a:solidFill>
+                      <a:prstDash val="solid"/>
+                      <a:round/>
+                      <a:headEnd type="none" w="med" len="med"/>
+                      <a:tailEnd type="none" w="med" len="med"/>
+                    </a:lnB>
+                    <a:solidFill>
+                      <a:srgbClr val="FFFFFF"/>
+                    </a:solidFill>
+                  </a:tcPr>
+                </a:tc>
+              </a:tr>
+            </a:tbl>
+          </a:graphicData>
+        </a:graphic>
+      </p:graphicFrame>
+      <p:sp>
+        <p:nvSpPr>
+          <p:cNvPr id="29" name="threat"/>
           <p:cNvSpPr/>
           <p:nvPr/>
         </p:nvSpPr>
         <p:spPr>
           <a:xfrm>
-            <a:off x="4617720" y="1307592"/>
-            <a:ext cx="4160520" cy="0"/>
-          </a:xfrm>
-          <a:prstGeom prst="line">
-            <a:avLst/>
-          </a:prstGeom>
-          <a:noFill/>
-          <a:ln w="9525">
-            <a:solidFill>
-              <a:srgbClr val="BFBFBF"/>
-            </a:solidFill>
-            <a:prstDash val="solid"/>
-          </a:ln>
-        </p:spPr>
-      </p:sp>
-      <p:sp>
-        <p:nvSpPr>
-          <p:cNvPr id="29" name="Text 26"/>
-          <p:cNvSpPr txBox="1"/>
-          <p:nvPr/>
-        </p:nvSpPr>
-        <p:spPr>
-          <a:xfrm>
-            <a:off x="4617720" y="1307592"/>
-            <a:ext cx="1325880" cy="228600"/>
-          </a:xfrm>
-          <a:prstGeom prst="rect">
-            <a:avLst/>
-          </a:prstGeom>
-          <a:noFill/>
-          <a:ln/>
-        </p:spPr>
-        <p:txBody>
-          <a:bodyPr wrap="square" lIns="0" tIns="0" rIns="0" bIns="0" rtlCol="0" anchor="ctr"/>
-          <a:lstStyle/>
-          <a:p>
-            <a:pPr algn="l" indent="0" marL="0">
-              <a:lnSpc>
-                <a:spcPct val="115000"/>
-              </a:lnSpc>
-              <a:buNone/>
-            </a:pPr>
-            <a:r>
-              <a:rPr lang="en-US" sz="850" b="1" dirty="0">
-                <a:solidFill>
-                  <a:srgbClr val="1A1A1A"/>
-                </a:solidFill>
-                <a:latin typeface="Meiryo" pitchFamily="34" charset="0"/>
-                <a:ea typeface="Meiryo" pitchFamily="34" charset="-122"/>
-                <a:cs typeface="Meiryo" pitchFamily="34" charset="-120"/>
-              </a:rPr>
-              <a:t>ダイキン×日立</a:t>
-            </a:r>
-            <a:endParaRPr lang="en-US" sz="850" dirty="0"/>
-          </a:p>
-        </p:txBody>
-      </p:sp>
-      <p:sp>
-        <p:nvSpPr>
-          <p:cNvPr id="30" name="Text 27"/>
-          <p:cNvSpPr txBox="1"/>
-          <p:nvPr/>
-        </p:nvSpPr>
-        <p:spPr>
-          <a:xfrm>
-            <a:off x="5943600" y="1307592"/>
-            <a:ext cx="2468880" cy="228600"/>
-          </a:xfrm>
-          <a:prstGeom prst="rect">
-            <a:avLst/>
-          </a:prstGeom>
-          <a:noFill/>
-          <a:ln/>
-        </p:spPr>
-        <p:txBody>
-          <a:bodyPr wrap="square" lIns="0" tIns="0" rIns="0" bIns="0" rtlCol="0" anchor="ctr"/>
-          <a:lstStyle/>
-          <a:p>
-            <a:pPr algn="l" indent="0" marL="0">
-              <a:lnSpc>
-                <a:spcPct val="115000"/>
-              </a:lnSpc>
-              <a:buNone/>
-            </a:pPr>
-            <a:r>
-              <a:rPr lang="en-US" sz="800" dirty="0">
-                <a:solidFill>
-                  <a:srgbClr val="1A1A1A"/>
-                </a:solidFill>
-                <a:latin typeface="Meiryo" pitchFamily="34" charset="0"/>
-                <a:ea typeface="Meiryo" pitchFamily="34" charset="-122"/>
-                <a:cs typeface="Meiryo" pitchFamily="34" charset="-120"/>
-              </a:rPr>
-              <a:t>ろう付け技能をIoT・画像解析でデジタル化</a:t>
-            </a:r>
-            <a:endParaRPr lang="en-US" sz="800" dirty="0"/>
-          </a:p>
-        </p:txBody>
-      </p:sp>
-      <p:sp>
-        <p:nvSpPr>
-          <p:cNvPr id="31" name="Text 28"/>
-          <p:cNvSpPr txBox="1"/>
-          <p:nvPr/>
-        </p:nvSpPr>
-        <p:spPr>
-          <a:xfrm>
-            <a:off x="8412480" y="1307592"/>
-            <a:ext cx="365760" cy="228600"/>
-          </a:xfrm>
-          <a:prstGeom prst="rect">
-            <a:avLst/>
-          </a:prstGeom>
-          <a:noFill/>
-          <a:ln/>
-        </p:spPr>
-        <p:txBody>
-          <a:bodyPr wrap="square" lIns="0" tIns="0" rIns="0" bIns="0" rtlCol="0" anchor="ctr"/>
-          <a:lstStyle/>
-          <a:p>
-            <a:pPr algn="r" indent="0" marL="0">
-              <a:lnSpc>
-                <a:spcPct val="115000"/>
-              </a:lnSpc>
-              <a:buNone/>
-            </a:pPr>
-            <a:r>
-              <a:rPr lang="en-US" sz="800" dirty="0">
-                <a:solidFill>
-                  <a:srgbClr val="4D4D4D"/>
-                </a:solidFill>
-                <a:latin typeface="Meiryo" pitchFamily="34" charset="0"/>
-                <a:ea typeface="Meiryo" pitchFamily="34" charset="-122"/>
-                <a:cs typeface="Meiryo" pitchFamily="34" charset="-120"/>
-              </a:rPr>
-              <a:t>2017</a:t>
-            </a:r>
-            <a:endParaRPr lang="en-US" sz="800" dirty="0"/>
-          </a:p>
-        </p:txBody>
-      </p:sp>
-      <p:sp>
-        <p:nvSpPr>
-          <p:cNvPr id="32" name="Shape 29"/>
-          <p:cNvSpPr/>
-          <p:nvPr/>
-        </p:nvSpPr>
-        <p:spPr>
-          <a:xfrm>
-            <a:off x="4617720" y="1536192"/>
-            <a:ext cx="4160520" cy="0"/>
-          </a:xfrm>
-          <a:prstGeom prst="line">
-            <a:avLst/>
-          </a:prstGeom>
-          <a:noFill/>
-          <a:ln w="9525">
-            <a:solidFill>
-              <a:srgbClr val="BFBFBF"/>
-            </a:solidFill>
-            <a:prstDash val="solid"/>
-          </a:ln>
-        </p:spPr>
-      </p:sp>
-      <p:sp>
-        <p:nvSpPr>
-          <p:cNvPr id="33" name="Text 30"/>
-          <p:cNvSpPr txBox="1"/>
-          <p:nvPr/>
-        </p:nvSpPr>
-        <p:spPr>
-          <a:xfrm>
-            <a:off x="4617720" y="1536192"/>
-            <a:ext cx="1325880" cy="228600"/>
-          </a:xfrm>
-          <a:prstGeom prst="rect">
-            <a:avLst/>
-          </a:prstGeom>
-          <a:noFill/>
-          <a:ln/>
-        </p:spPr>
-        <p:txBody>
-          <a:bodyPr wrap="square" lIns="0" tIns="0" rIns="0" bIns="0" rtlCol="0" anchor="ctr"/>
-          <a:lstStyle/>
-          <a:p>
-            <a:pPr algn="l" indent="0" marL="0">
-              <a:lnSpc>
-                <a:spcPct val="115000"/>
-              </a:lnSpc>
-              <a:buNone/>
-            </a:pPr>
-            <a:r>
-              <a:rPr lang="en-US" sz="850" b="1" dirty="0">
-                <a:solidFill>
-                  <a:srgbClr val="1A1A1A"/>
-                </a:solidFill>
-                <a:latin typeface="Meiryo" pitchFamily="34" charset="0"/>
-                <a:ea typeface="Meiryo" pitchFamily="34" charset="-122"/>
-                <a:cs typeface="Meiryo" pitchFamily="34" charset="-120"/>
-              </a:rPr>
-              <a:t>住友ゴム×NEC</a:t>
-            </a:r>
-            <a:endParaRPr lang="en-US" sz="850" dirty="0"/>
-          </a:p>
-        </p:txBody>
-      </p:sp>
-      <p:sp>
-        <p:nvSpPr>
-          <p:cNvPr id="34" name="Text 31"/>
-          <p:cNvSpPr txBox="1"/>
-          <p:nvPr/>
-        </p:nvSpPr>
-        <p:spPr>
-          <a:xfrm>
-            <a:off x="5943600" y="1536192"/>
-            <a:ext cx="2468880" cy="228600"/>
-          </a:xfrm>
-          <a:prstGeom prst="rect">
-            <a:avLst/>
-          </a:prstGeom>
-          <a:noFill/>
-          <a:ln/>
-        </p:spPr>
-        <p:txBody>
-          <a:bodyPr wrap="square" lIns="0" tIns="0" rIns="0" bIns="0" rtlCol="0" anchor="ctr"/>
-          <a:lstStyle/>
-          <a:p>
-            <a:pPr algn="l" indent="0" marL="0">
-              <a:lnSpc>
-                <a:spcPct val="115000"/>
-              </a:lnSpc>
-              <a:buNone/>
-            </a:pPr>
-            <a:r>
-              <a:rPr lang="en-US" sz="800" dirty="0">
-                <a:solidFill>
-                  <a:srgbClr val="1A1A1A"/>
-                </a:solidFill>
-                <a:latin typeface="Meiryo" pitchFamily="34" charset="0"/>
-                <a:ea typeface="Meiryo" pitchFamily="34" charset="-122"/>
-                <a:cs typeface="Meiryo" pitchFamily="34" charset="-120"/>
-              </a:rPr>
-              <a:t>タイヤ設計の熟練者ノウハウをAI化</a:t>
-            </a:r>
-            <a:endParaRPr lang="en-US" sz="800" dirty="0"/>
-          </a:p>
-        </p:txBody>
-      </p:sp>
-      <p:sp>
-        <p:nvSpPr>
-          <p:cNvPr id="35" name="Text 32"/>
-          <p:cNvSpPr txBox="1"/>
-          <p:nvPr/>
-        </p:nvSpPr>
-        <p:spPr>
-          <a:xfrm>
-            <a:off x="8412480" y="1536192"/>
-            <a:ext cx="365760" cy="228600"/>
-          </a:xfrm>
-          <a:prstGeom prst="rect">
-            <a:avLst/>
-          </a:prstGeom>
-          <a:noFill/>
-          <a:ln/>
-        </p:spPr>
-        <p:txBody>
-          <a:bodyPr wrap="square" lIns="0" tIns="0" rIns="0" bIns="0" rtlCol="0" anchor="ctr"/>
-          <a:lstStyle/>
-          <a:p>
-            <a:pPr algn="r" indent="0" marL="0">
-              <a:lnSpc>
-                <a:spcPct val="115000"/>
-              </a:lnSpc>
-              <a:buNone/>
-            </a:pPr>
-            <a:r>
-              <a:rPr lang="en-US" sz="800" dirty="0">
-                <a:solidFill>
-                  <a:srgbClr val="4D4D4D"/>
-                </a:solidFill>
-                <a:latin typeface="Meiryo" pitchFamily="34" charset="0"/>
-                <a:ea typeface="Meiryo" pitchFamily="34" charset="-122"/>
-                <a:cs typeface="Meiryo" pitchFamily="34" charset="-120"/>
-              </a:rPr>
-              <a:t>2022</a:t>
-            </a:r>
-            <a:endParaRPr lang="en-US" sz="800" dirty="0"/>
-          </a:p>
-        </p:txBody>
-      </p:sp>
-      <p:sp>
-        <p:nvSpPr>
-          <p:cNvPr id="36" name="Shape 33"/>
-          <p:cNvSpPr/>
-          <p:nvPr/>
-        </p:nvSpPr>
-        <p:spPr>
-          <a:xfrm>
-            <a:off x="4617720" y="1764792"/>
-            <a:ext cx="4160520" cy="0"/>
-          </a:xfrm>
-          <a:prstGeom prst="line">
-            <a:avLst/>
-          </a:prstGeom>
-          <a:noFill/>
-          <a:ln w="9525">
-            <a:solidFill>
-              <a:srgbClr val="BFBFBF"/>
-            </a:solidFill>
-            <a:prstDash val="solid"/>
-          </a:ln>
-        </p:spPr>
-      </p:sp>
-      <p:sp>
-        <p:nvSpPr>
-          <p:cNvPr id="37" name="Text 34"/>
-          <p:cNvSpPr txBox="1"/>
-          <p:nvPr/>
-        </p:nvSpPr>
-        <p:spPr>
-          <a:xfrm>
-            <a:off x="4617720" y="1764792"/>
-            <a:ext cx="1325880" cy="228600"/>
-          </a:xfrm>
-          <a:prstGeom prst="rect">
-            <a:avLst/>
-          </a:prstGeom>
-          <a:noFill/>
-          <a:ln/>
-        </p:spPr>
-        <p:txBody>
-          <a:bodyPr wrap="square" lIns="0" tIns="0" rIns="0" bIns="0" rtlCol="0" anchor="ctr"/>
-          <a:lstStyle/>
-          <a:p>
-            <a:pPr algn="l" indent="0" marL="0">
-              <a:lnSpc>
-                <a:spcPct val="115000"/>
-              </a:lnSpc>
-              <a:buNone/>
-            </a:pPr>
-            <a:r>
-              <a:rPr lang="en-US" sz="850" b="1" dirty="0">
-                <a:solidFill>
-                  <a:srgbClr val="1A1A1A"/>
-                </a:solidFill>
-                <a:latin typeface="Meiryo" pitchFamily="34" charset="0"/>
-                <a:ea typeface="Meiryo" pitchFamily="34" charset="-122"/>
-                <a:cs typeface="Meiryo" pitchFamily="34" charset="-120"/>
-              </a:rPr>
-              <a:t>ライオン×NTTデータ</a:t>
-            </a:r>
-            <a:endParaRPr lang="en-US" sz="850" dirty="0"/>
-          </a:p>
-        </p:txBody>
-      </p:sp>
-      <p:sp>
-        <p:nvSpPr>
-          <p:cNvPr id="38" name="Text 35"/>
-          <p:cNvSpPr txBox="1"/>
-          <p:nvPr/>
-        </p:nvSpPr>
-        <p:spPr>
-          <a:xfrm>
-            <a:off x="5943600" y="1764792"/>
-            <a:ext cx="2468880" cy="228600"/>
-          </a:xfrm>
-          <a:prstGeom prst="rect">
-            <a:avLst/>
-          </a:prstGeom>
-          <a:noFill/>
-          <a:ln/>
-        </p:spPr>
-        <p:txBody>
-          <a:bodyPr wrap="square" lIns="0" tIns="0" rIns="0" bIns="0" rtlCol="0" anchor="ctr"/>
-          <a:lstStyle/>
-          <a:p>
-            <a:pPr algn="l" indent="0" marL="0">
-              <a:lnSpc>
-                <a:spcPct val="115000"/>
-              </a:lnSpc>
-              <a:buNone/>
-            </a:pPr>
-            <a:r>
-              <a:rPr lang="en-US" sz="800" dirty="0">
-                <a:solidFill>
-                  <a:srgbClr val="1A1A1A"/>
-                </a:solidFill>
-                <a:latin typeface="Meiryo" pitchFamily="34" charset="0"/>
-                <a:ea typeface="Meiryo" pitchFamily="34" charset="-122"/>
-                <a:cs typeface="Meiryo" pitchFamily="34" charset="-120"/>
-              </a:rPr>
-              <a:t>製造プロセスの勘所集を生成AIで検索</a:t>
-            </a:r>
-            <a:endParaRPr lang="en-US" sz="800" dirty="0"/>
-          </a:p>
-        </p:txBody>
-      </p:sp>
-      <p:sp>
-        <p:nvSpPr>
-          <p:cNvPr id="39" name="Text 36"/>
-          <p:cNvSpPr txBox="1"/>
-          <p:nvPr/>
-        </p:nvSpPr>
-        <p:spPr>
-          <a:xfrm>
-            <a:off x="8412480" y="1764792"/>
-            <a:ext cx="365760" cy="228600"/>
-          </a:xfrm>
-          <a:prstGeom prst="rect">
-            <a:avLst/>
-          </a:prstGeom>
-          <a:noFill/>
-          <a:ln/>
-        </p:spPr>
-        <p:txBody>
-          <a:bodyPr wrap="square" lIns="0" tIns="0" rIns="0" bIns="0" rtlCol="0" anchor="ctr"/>
-          <a:lstStyle/>
-          <a:p>
-            <a:pPr algn="r" indent="0" marL="0">
-              <a:lnSpc>
-                <a:spcPct val="115000"/>
-              </a:lnSpc>
-              <a:buNone/>
-            </a:pPr>
-            <a:r>
-              <a:rPr lang="en-US" sz="800" dirty="0">
-                <a:solidFill>
-                  <a:srgbClr val="4D4D4D"/>
-                </a:solidFill>
-                <a:latin typeface="Meiryo" pitchFamily="34" charset="0"/>
-                <a:ea typeface="Meiryo" pitchFamily="34" charset="-122"/>
-                <a:cs typeface="Meiryo" pitchFamily="34" charset="-120"/>
-              </a:rPr>
-              <a:t>2024</a:t>
-            </a:r>
-            <a:endParaRPr lang="en-US" sz="800" dirty="0"/>
-          </a:p>
-        </p:txBody>
-      </p:sp>
-      <p:sp>
-        <p:nvSpPr>
-          <p:cNvPr id="40" name="Shape 37"/>
-          <p:cNvSpPr/>
-          <p:nvPr/>
-        </p:nvSpPr>
-        <p:spPr>
-          <a:xfrm>
-            <a:off x="4617720" y="1993392"/>
-            <a:ext cx="4160520" cy="0"/>
-          </a:xfrm>
-          <a:prstGeom prst="line">
-            <a:avLst/>
-          </a:prstGeom>
-          <a:noFill/>
-          <a:ln w="9525">
-            <a:solidFill>
-              <a:srgbClr val="BFBFBF"/>
-            </a:solidFill>
-            <a:prstDash val="solid"/>
-          </a:ln>
-        </p:spPr>
-      </p:sp>
-      <p:sp>
-        <p:nvSpPr>
-          <p:cNvPr id="41" name="Text 38"/>
-          <p:cNvSpPr txBox="1"/>
-          <p:nvPr/>
-        </p:nvSpPr>
-        <p:spPr>
-          <a:xfrm>
-            <a:off x="4617720" y="1993392"/>
-            <a:ext cx="1325880" cy="228600"/>
-          </a:xfrm>
-          <a:prstGeom prst="rect">
-            <a:avLst/>
-          </a:prstGeom>
-          <a:noFill/>
-          <a:ln/>
-        </p:spPr>
-        <p:txBody>
-          <a:bodyPr wrap="square" lIns="0" tIns="0" rIns="0" bIns="0" rtlCol="0" anchor="ctr"/>
-          <a:lstStyle/>
-          <a:p>
-            <a:pPr algn="l" indent="0" marL="0">
-              <a:lnSpc>
-                <a:spcPct val="115000"/>
-              </a:lnSpc>
-              <a:buNone/>
-            </a:pPr>
-            <a:r>
-              <a:rPr lang="en-US" sz="850" b="1" dirty="0">
-                <a:solidFill>
-                  <a:srgbClr val="1A1A1A"/>
-                </a:solidFill>
-                <a:latin typeface="Meiryo" pitchFamily="34" charset="0"/>
-                <a:ea typeface="Meiryo" pitchFamily="34" charset="-122"/>
-                <a:cs typeface="Meiryo" pitchFamily="34" charset="-120"/>
-              </a:rPr>
-              <a:t>日立 大みか事業所</a:t>
-            </a:r>
-            <a:endParaRPr lang="en-US" sz="850" dirty="0"/>
-          </a:p>
-        </p:txBody>
-      </p:sp>
-      <p:sp>
-        <p:nvSpPr>
-          <p:cNvPr id="42" name="Text 39"/>
-          <p:cNvSpPr txBox="1"/>
-          <p:nvPr/>
-        </p:nvSpPr>
-        <p:spPr>
-          <a:xfrm>
-            <a:off x="5943600" y="1993392"/>
-            <a:ext cx="2468880" cy="228600"/>
-          </a:xfrm>
-          <a:prstGeom prst="rect">
-            <a:avLst/>
-          </a:prstGeom>
-          <a:noFill/>
-          <a:ln/>
-        </p:spPr>
-        <p:txBody>
-          <a:bodyPr wrap="square" lIns="0" tIns="0" rIns="0" bIns="0" rtlCol="0" anchor="ctr"/>
-          <a:lstStyle/>
-          <a:p>
-            <a:pPr algn="l" indent="0" marL="0">
-              <a:lnSpc>
-                <a:spcPct val="115000"/>
-              </a:lnSpc>
-              <a:buNone/>
-            </a:pPr>
-            <a:r>
-              <a:rPr lang="en-US" sz="800" dirty="0">
-                <a:solidFill>
-                  <a:srgbClr val="1A1A1A"/>
-                </a:solidFill>
-                <a:latin typeface="Meiryo" pitchFamily="34" charset="0"/>
-                <a:ea typeface="Meiryo" pitchFamily="34" charset="-122"/>
-                <a:cs typeface="Meiryo" pitchFamily="34" charset="-120"/>
-              </a:rPr>
-              <a:t>熟練者の知見で、事例検索を約9割短縮</a:t>
-            </a:r>
-            <a:endParaRPr lang="en-US" sz="800" dirty="0"/>
-          </a:p>
-        </p:txBody>
-      </p:sp>
-      <p:sp>
-        <p:nvSpPr>
-          <p:cNvPr id="43" name="Text 40"/>
-          <p:cNvSpPr txBox="1"/>
-          <p:nvPr/>
-        </p:nvSpPr>
-        <p:spPr>
-          <a:xfrm>
-            <a:off x="8412480" y="1993392"/>
-            <a:ext cx="365760" cy="228600"/>
-          </a:xfrm>
-          <a:prstGeom prst="rect">
-            <a:avLst/>
-          </a:prstGeom>
-          <a:noFill/>
-          <a:ln/>
-        </p:spPr>
-        <p:txBody>
-          <a:bodyPr wrap="square" lIns="0" tIns="0" rIns="0" bIns="0" rtlCol="0" anchor="ctr"/>
-          <a:lstStyle/>
-          <a:p>
-            <a:pPr algn="r" indent="0" marL="0">
-              <a:lnSpc>
-                <a:spcPct val="115000"/>
-              </a:lnSpc>
-              <a:buNone/>
-            </a:pPr>
-            <a:r>
-              <a:rPr lang="en-US" sz="800" dirty="0">
-                <a:solidFill>
-                  <a:srgbClr val="4D4D4D"/>
-                </a:solidFill>
-                <a:latin typeface="Meiryo" pitchFamily="34" charset="0"/>
-                <a:ea typeface="Meiryo" pitchFamily="34" charset="-122"/>
-                <a:cs typeface="Meiryo" pitchFamily="34" charset="-120"/>
-              </a:rPr>
-              <a:t>2025</a:t>
-            </a:r>
-            <a:endParaRPr lang="en-US" sz="800" dirty="0"/>
-          </a:p>
-        </p:txBody>
-      </p:sp>
-      <p:sp>
-        <p:nvSpPr>
-          <p:cNvPr id="44" name="Shape 41"/>
-          <p:cNvSpPr/>
-          <p:nvPr/>
-        </p:nvSpPr>
-        <p:spPr>
-          <a:xfrm>
-            <a:off x="4617720" y="2221992"/>
-            <a:ext cx="4160520" cy="0"/>
-          </a:xfrm>
-          <a:prstGeom prst="line">
-            <a:avLst/>
-          </a:prstGeom>
-          <a:noFill/>
-          <a:ln w="9525">
-            <a:solidFill>
-              <a:srgbClr val="BFBFBF"/>
-            </a:solidFill>
-            <a:prstDash val="solid"/>
-          </a:ln>
-        </p:spPr>
-      </p:sp>
-      <p:sp>
-        <p:nvSpPr>
-          <p:cNvPr id="45" name="Text 42"/>
-          <p:cNvSpPr txBox="1"/>
-          <p:nvPr/>
-        </p:nvSpPr>
-        <p:spPr>
-          <a:xfrm>
-            <a:off x="4617720" y="2221992"/>
-            <a:ext cx="1325880" cy="228600"/>
-          </a:xfrm>
-          <a:prstGeom prst="rect">
-            <a:avLst/>
-          </a:prstGeom>
-          <a:noFill/>
-          <a:ln/>
-        </p:spPr>
-        <p:txBody>
-          <a:bodyPr wrap="square" lIns="0" tIns="0" rIns="0" bIns="0" rtlCol="0" anchor="ctr"/>
-          <a:lstStyle/>
-          <a:p>
-            <a:pPr algn="l" indent="0" marL="0">
-              <a:lnSpc>
-                <a:spcPct val="115000"/>
-              </a:lnSpc>
-              <a:buNone/>
-            </a:pPr>
-            <a:r>
-              <a:rPr lang="en-US" sz="850" b="1" dirty="0">
-                <a:solidFill>
-                  <a:srgbClr val="1A1A1A"/>
-                </a:solidFill>
-                <a:latin typeface="Meiryo" pitchFamily="34" charset="0"/>
-                <a:ea typeface="Meiryo" pitchFamily="34" charset="-122"/>
-                <a:cs typeface="Meiryo" pitchFamily="34" charset="-120"/>
-              </a:rPr>
-              <a:t>川崎重工×NTTデータ</a:t>
-            </a:r>
-            <a:endParaRPr lang="en-US" sz="850" dirty="0"/>
-          </a:p>
-        </p:txBody>
-      </p:sp>
-      <p:sp>
-        <p:nvSpPr>
-          <p:cNvPr id="46" name="Text 43"/>
-          <p:cNvSpPr txBox="1"/>
-          <p:nvPr/>
-        </p:nvSpPr>
-        <p:spPr>
-          <a:xfrm>
-            <a:off x="5943600" y="2221992"/>
-            <a:ext cx="2468880" cy="228600"/>
-          </a:xfrm>
-          <a:prstGeom prst="rect">
-            <a:avLst/>
-          </a:prstGeom>
-          <a:noFill/>
-          <a:ln/>
-        </p:spPr>
-        <p:txBody>
-          <a:bodyPr wrap="square" lIns="0" tIns="0" rIns="0" bIns="0" rtlCol="0" anchor="ctr"/>
-          <a:lstStyle/>
-          <a:p>
-            <a:pPr algn="l" indent="0" marL="0">
-              <a:lnSpc>
-                <a:spcPct val="115000"/>
-              </a:lnSpc>
-              <a:buNone/>
-            </a:pPr>
-            <a:r>
-              <a:rPr lang="en-US" sz="800" dirty="0">
-                <a:solidFill>
-                  <a:srgbClr val="1A1A1A"/>
-                </a:solidFill>
-                <a:latin typeface="Meiryo" pitchFamily="34" charset="0"/>
-                <a:ea typeface="Meiryo" pitchFamily="34" charset="-122"/>
-                <a:cs typeface="Meiryo" pitchFamily="34" charset="-120"/>
-              </a:rPr>
-              <a:t>生成AIによる暗黙知伝承</a:t>
-            </a:r>
-            <a:endParaRPr lang="en-US" sz="800" dirty="0"/>
-          </a:p>
-        </p:txBody>
-      </p:sp>
-      <p:sp>
-        <p:nvSpPr>
-          <p:cNvPr id="47" name="Text 44"/>
-          <p:cNvSpPr txBox="1"/>
-          <p:nvPr/>
-        </p:nvSpPr>
-        <p:spPr>
-          <a:xfrm>
-            <a:off x="8412480" y="2221992"/>
-            <a:ext cx="365760" cy="228600"/>
-          </a:xfrm>
-          <a:prstGeom prst="rect">
-            <a:avLst/>
-          </a:prstGeom>
-          <a:noFill/>
-          <a:ln/>
-        </p:spPr>
-        <p:txBody>
-          <a:bodyPr wrap="square" lIns="0" tIns="0" rIns="0" bIns="0" rtlCol="0" anchor="ctr"/>
-          <a:lstStyle/>
-          <a:p>
-            <a:pPr algn="r" indent="0" marL="0">
-              <a:lnSpc>
-                <a:spcPct val="115000"/>
-              </a:lnSpc>
-              <a:buNone/>
-            </a:pPr>
-            <a:r>
-              <a:rPr lang="en-US" sz="800" dirty="0">
-                <a:solidFill>
-                  <a:srgbClr val="4D4D4D"/>
-                </a:solidFill>
-                <a:latin typeface="Meiryo" pitchFamily="34" charset="0"/>
-                <a:ea typeface="Meiryo" pitchFamily="34" charset="-122"/>
-                <a:cs typeface="Meiryo" pitchFamily="34" charset="-120"/>
-              </a:rPr>
-              <a:t>2025</a:t>
-            </a:r>
-            <a:endParaRPr lang="en-US" sz="800" dirty="0"/>
-          </a:p>
-        </p:txBody>
-      </p:sp>
-      <p:sp>
-        <p:nvSpPr>
-          <p:cNvPr id="48" name="Shape 45"/>
-          <p:cNvSpPr/>
-          <p:nvPr/>
-        </p:nvSpPr>
-        <p:spPr>
-          <a:xfrm>
-            <a:off x="4617720" y="2450592"/>
-            <a:ext cx="4160520" cy="0"/>
-          </a:xfrm>
-          <a:prstGeom prst="line">
-            <a:avLst/>
-          </a:prstGeom>
-          <a:noFill/>
-          <a:ln w="9525">
-            <a:solidFill>
-              <a:srgbClr val="BFBFBF"/>
-            </a:solidFill>
-            <a:prstDash val="solid"/>
-          </a:ln>
-        </p:spPr>
-      </p:sp>
-      <p:sp>
-        <p:nvSpPr>
-          <p:cNvPr id="49" name="precedent-summary"/>
-          <p:cNvSpPr/>
-          <p:nvPr/>
-        </p:nvSpPr>
-        <p:spPr>
-          <a:xfrm>
-            <a:off x="4617720" y="2514600"/>
-            <a:ext cx="4160520" cy="457200"/>
+            <a:off x="4526280" y="3145536"/>
+            <a:ext cx="4251960" cy="603504"/>
           </a:xfrm>
           <a:prstGeom prst="rect">
             <a:avLst/>
@@ -11583,14 +12403,14 @@
       </p:sp>
       <p:sp>
         <p:nvSpPr>
-          <p:cNvPr id="50" name="Text 47"/>
+          <p:cNvPr id="30" name="Text 26"/>
           <p:cNvSpPr txBox="1"/>
           <p:nvPr/>
         </p:nvSpPr>
         <p:spPr>
           <a:xfrm>
-            <a:off x="4727448" y="2514600"/>
-            <a:ext cx="3941064" cy="457200"/>
+            <a:off x="4636008" y="3145536"/>
+            <a:ext cx="4032504" cy="603504"/>
           </a:xfrm>
           <a:prstGeom prst="rect">
             <a:avLst/>
@@ -11606,6 +12426,9 @@
               <a:lnSpc>
                 <a:spcPct val="115000"/>
               </a:lnSpc>
+              <a:spcAft>
+                <a:spcPts val="200"/>
+              </a:spcAft>
               <a:buNone/>
             </a:pPr>
             <a:r>
@@ -11617,12 +12440,15 @@
                 <a:ea typeface="Meiryo" pitchFamily="34" charset="-122"/>
                 <a:cs typeface="Meiryo" pitchFamily="34" charset="-120"/>
               </a:rPr>
-              <a:t>共通点：</a:t>
-            </a:r>
-            <a:pPr algn="l" indent="0" marL="0">
-              <a:lnSpc>
-                <a:spcPct val="115000"/>
-              </a:lnSpc>
+              <a:t>最大の脅威：</a:t>
+            </a:r>
+            <a:pPr algn="l" indent="0" marL="0">
+              <a:lnSpc>
+                <a:spcPct val="115000"/>
+              </a:lnSpc>
+              <a:spcAft>
+                <a:spcPts val="200"/>
+              </a:spcAft>
               <a:buNone/>
             </a:pPr>
             <a:r>
@@ -11634,22 +12460,65 @@
                 <a:ea typeface="Meiryo" pitchFamily="34" charset="-122"/>
                 <a:cs typeface="Meiryo" pitchFamily="34" charset="-120"/>
               </a:rPr>
-              <a:t>大手が大手SIerと個別開発。中堅の工場には予算も人手も届かない。電力インフラでは、古河電工がスマートグラスでの技術伝承を構想する段階</a:t>
+              <a:t>CADDiが連続工程に降りてくること。課題認識は同じ（「製造業の叡智の8割以上は暗黙知」）</a:t>
             </a:r>
             <a:endParaRPr lang="en-US" sz="850" dirty="0"/>
           </a:p>
-        </p:txBody>
-      </p:sp>
-      <p:sp>
-        <p:nvSpPr>
-          <p:cNvPr id="51" name="Text 48"/>
+          <a:p>
+            <a:pPr algn="l" indent="0" marL="0">
+              <a:lnSpc>
+                <a:spcPct val="115000"/>
+              </a:lnSpc>
+              <a:spcAft>
+                <a:spcPts val="200"/>
+              </a:spcAft>
+              <a:buNone/>
+            </a:pPr>
+            <a:r>
+              <a:rPr lang="en-US" sz="850" b="1" dirty="0">
+                <a:solidFill>
+                  <a:srgbClr val="FFFFFF"/>
+                </a:solidFill>
+                <a:latin typeface="Meiryo" pitchFamily="34" charset="0"/>
+                <a:ea typeface="Meiryo" pitchFamily="34" charset="-122"/>
+                <a:cs typeface="Meiryo" pitchFamily="34" charset="-120"/>
+              </a:rPr>
+              <a:t>防御線：</a:t>
+            </a:r>
+            <a:pPr algn="l" indent="0" marL="0">
+              <a:lnSpc>
+                <a:spcPct val="115000"/>
+              </a:lnSpc>
+              <a:spcAft>
+                <a:spcPts val="200"/>
+              </a:spcAft>
+              <a:buNone/>
+            </a:pPr>
+            <a:r>
+              <a:rPr lang="en-US" sz="850" dirty="0">
+                <a:solidFill>
+                  <a:srgbClr val="FFFFFF"/>
+                </a:solidFill>
+                <a:latin typeface="Meiryo" pitchFamily="34" charset="0"/>
+                <a:ea typeface="Meiryo" pitchFamily="34" charset="-122"/>
+                <a:cs typeface="Meiryo" pitchFamily="34" charset="-120"/>
+              </a:rPr>
+              <a:t>図面に現れない現場処置の蓄積と、現場で監修できる人</a:t>
+            </a:r>
+            <a:endParaRPr lang="en-US" sz="850" dirty="0"/>
+          </a:p>
+        </p:txBody>
+      </p:sp>
+      <p:sp>
+        <p:nvSpPr>
+          <p:cNvPr id="31" name="Text 27"/>
           <p:cNvSpPr txBox="1"/>
           <p:nvPr/>
         </p:nvSpPr>
         <p:spPr>
           <a:xfrm>
-            <a:off x="4617720" y="3063240"/>
-            <a:ext cx="4160520" cy="237744"/>
+            <a:off x="4526280" y="3822192"/>
+            <a:ext cx="4251960" cy="457200"/>
           </a:xfrm>
           <a:prstGeom prst="rect">
             <a:avLst/>
@@ -11665,10 +12534,13 @@
               <a:lnSpc>
                 <a:spcPct val="115000"/>
               </a:lnSpc>
-              <a:buNone/>
-            </a:pPr>
-            <a:r>
-              <a:rPr lang="en-US" sz="1050" b="1" dirty="0">
+              <a:spcAft>
+                <a:spcPts val="200"/>
+              </a:spcAft>
+              <a:buNone/>
+            </a:pPr>
+            <a:r>
+              <a:rPr lang="en-US" sz="850" b="1" dirty="0">
                 <a:solidFill>
                   <a:srgbClr val="1A1A1A"/>
                 </a:solidFill>
@@ -11676,42 +12548,85 @@
                 <a:ea typeface="Meiryo" pitchFamily="34" charset="-122"/>
                 <a:cs typeface="Meiryo" pitchFamily="34" charset="-120"/>
               </a:rPr>
-              <a:t>STP と競争戦略</a:t>
-            </a:r>
-            <a:endParaRPr lang="en-US" sz="1050" dirty="0"/>
-          </a:p>
-        </p:txBody>
-      </p:sp>
-      <p:sp>
-        <p:nvSpPr>
-          <p:cNvPr id="52" name="Shape 49"/>
-          <p:cNvSpPr/>
-          <p:nvPr/>
-        </p:nvSpPr>
-        <p:spPr>
-          <a:xfrm>
-            <a:off x="4617720" y="3328416"/>
-            <a:ext cx="274320" cy="201168"/>
-          </a:xfrm>
-          <a:prstGeom prst="rect">
-            <a:avLst/>
-          </a:prstGeom>
-          <a:solidFill>
-            <a:srgbClr val="1A1A1A"/>
-          </a:solidFill>
-          <a:ln/>
-        </p:spPr>
-      </p:sp>
-      <p:sp>
-        <p:nvSpPr>
-          <p:cNvPr id="53" name="Text 50"/>
+              <a:t>STP：</a:t>
+            </a:r>
+            <a:pPr algn="l" indent="0" marL="0">
+              <a:lnSpc>
+                <a:spcPct val="115000"/>
+              </a:lnSpc>
+              <a:spcAft>
+                <a:spcPts val="200"/>
+              </a:spcAft>
+              <a:buNone/>
+            </a:pPr>
+            <a:r>
+              <a:rPr lang="en-US" sz="850" dirty="0">
+                <a:solidFill>
+                  <a:srgbClr val="1A1A1A"/>
+                </a:solidFill>
+                <a:latin typeface="Meiryo" pitchFamily="34" charset="0"/>
+                <a:ea typeface="Meiryo" pitchFamily="34" charset="-122"/>
+                <a:cs typeface="Meiryo" pitchFamily="34" charset="-120"/>
+              </a:rPr>
+              <a:t>工程の形（連続／組立／施工）×規模で区分し、中堅の電線工場を狙う</a:t>
+            </a:r>
+            <a:endParaRPr lang="en-US" sz="850" dirty="0"/>
+          </a:p>
+          <a:p>
+            <a:pPr algn="l" indent="0" marL="0">
+              <a:lnSpc>
+                <a:spcPct val="115000"/>
+              </a:lnSpc>
+              <a:spcAft>
+                <a:spcPts val="200"/>
+              </a:spcAft>
+              <a:buNone/>
+            </a:pPr>
+            <a:r>
+              <a:rPr lang="en-US" sz="850" b="1" dirty="0">
+                <a:solidFill>
+                  <a:srgbClr val="1A1A1A"/>
+                </a:solidFill>
+                <a:latin typeface="Meiryo" pitchFamily="34" charset="0"/>
+                <a:ea typeface="Meiryo" pitchFamily="34" charset="-122"/>
+                <a:cs typeface="Meiryo" pitchFamily="34" charset="-120"/>
+              </a:rPr>
+              <a:t>競争戦略：</a:t>
+            </a:r>
+            <a:pPr algn="l" indent="0" marL="0">
+              <a:lnSpc>
+                <a:spcPct val="115000"/>
+              </a:lnSpc>
+              <a:spcAft>
+                <a:spcPts val="200"/>
+              </a:spcAft>
+              <a:buNone/>
+            </a:pPr>
+            <a:r>
+              <a:rPr lang="en-US" sz="850" dirty="0">
+                <a:solidFill>
+                  <a:srgbClr val="1A1A1A"/>
+                </a:solidFill>
+                <a:latin typeface="Meiryo" pitchFamily="34" charset="0"/>
+                <a:ea typeface="Meiryo" pitchFamily="34" charset="-122"/>
+                <a:cs typeface="Meiryo" pitchFamily="34" charset="-120"/>
+              </a:rPr>
+              <a:t>ニッチャー（コトラー）×差別化集中（ポーター）。大手の内製は個別開発で中堅に届かない</a:t>
+            </a:r>
+            <a:endParaRPr lang="en-US" sz="850" dirty="0"/>
+          </a:p>
+        </p:txBody>
+      </p:sp>
+      <p:sp>
+        <p:nvSpPr>
+          <p:cNvPr id="32" name="Text 28"/>
           <p:cNvSpPr txBox="1"/>
           <p:nvPr/>
         </p:nvSpPr>
         <p:spPr>
           <a:xfrm>
-            <a:off x="4617720" y="3328416"/>
-            <a:ext cx="274320" cy="201168"/>
+            <a:off x="365760" y="4553712"/>
+            <a:ext cx="8412480" cy="256032"/>
           </a:xfrm>
           <a:prstGeom prst="rect">
             <a:avLst/>
@@ -11720,298 +12635,6 @@
           <a:ln/>
         </p:spPr>
         <p:txBody>
-          <a:bodyPr wrap="square" lIns="0" tIns="0" rIns="0" bIns="0" rtlCol="0" anchor="ctr"/>
-          <a:lstStyle/>
-          <a:p>
-            <a:pPr algn="ctr" indent="0" marL="0">
-              <a:lnSpc>
-                <a:spcPct val="115000"/>
-              </a:lnSpc>
-              <a:buNone/>
-            </a:pPr>
-            <a:r>
-              <a:rPr lang="en-US" sz="900" b="1" dirty="0">
-                <a:solidFill>
-                  <a:srgbClr val="FFFFFF"/>
-                </a:solidFill>
-                <a:latin typeface="Meiryo" pitchFamily="34" charset="0"/>
-                <a:ea typeface="Meiryo" pitchFamily="34" charset="-122"/>
-                <a:cs typeface="Meiryo" pitchFamily="34" charset="-120"/>
-              </a:rPr>
-              <a:t>S</a:t>
-            </a:r>
-            <a:endParaRPr lang="en-US" sz="900" dirty="0"/>
-          </a:p>
-        </p:txBody>
-      </p:sp>
-      <p:sp>
-        <p:nvSpPr>
-          <p:cNvPr id="54" name="Text 51"/>
-          <p:cNvSpPr txBox="1"/>
-          <p:nvPr/>
-        </p:nvSpPr>
-        <p:spPr>
-          <a:xfrm>
-            <a:off x="4983480" y="3300984"/>
-            <a:ext cx="3794760" cy="256032"/>
-          </a:xfrm>
-          <a:prstGeom prst="rect">
-            <a:avLst/>
-          </a:prstGeom>
-          <a:noFill/>
-          <a:ln/>
-        </p:spPr>
-        <p:txBody>
-          <a:bodyPr wrap="square" lIns="0" tIns="0" rIns="0" bIns="0" rtlCol="0" anchor="ctr"/>
-          <a:lstStyle/>
-          <a:p>
-            <a:pPr algn="l" indent="0" marL="0">
-              <a:lnSpc>
-                <a:spcPct val="115000"/>
-              </a:lnSpc>
-              <a:buNone/>
-            </a:pPr>
-            <a:r>
-              <a:rPr lang="en-US" sz="850" dirty="0">
-                <a:solidFill>
-                  <a:srgbClr val="1A1A1A"/>
-                </a:solidFill>
-                <a:latin typeface="Meiryo" pitchFamily="34" charset="0"/>
-                <a:ea typeface="Meiryo" pitchFamily="34" charset="-122"/>
-                <a:cs typeface="Meiryo" pitchFamily="34" charset="-120"/>
-              </a:rPr>
-              <a:t>製造業を工程と規模で区分：大手（内製できる）／中堅（できない）</a:t>
-            </a:r>
-            <a:endParaRPr lang="en-US" sz="850" dirty="0"/>
-          </a:p>
-        </p:txBody>
-      </p:sp>
-      <p:sp>
-        <p:nvSpPr>
-          <p:cNvPr id="55" name="Shape 52"/>
-          <p:cNvSpPr/>
-          <p:nvPr/>
-        </p:nvSpPr>
-        <p:spPr>
-          <a:xfrm>
-            <a:off x="4617720" y="3593592"/>
-            <a:ext cx="274320" cy="201168"/>
-          </a:xfrm>
-          <a:prstGeom prst="rect">
-            <a:avLst/>
-          </a:prstGeom>
-          <a:solidFill>
-            <a:srgbClr val="1A1A1A"/>
-          </a:solidFill>
-          <a:ln/>
-        </p:spPr>
-      </p:sp>
-      <p:sp>
-        <p:nvSpPr>
-          <p:cNvPr id="56" name="Text 53"/>
-          <p:cNvSpPr txBox="1"/>
-          <p:nvPr/>
-        </p:nvSpPr>
-        <p:spPr>
-          <a:xfrm>
-            <a:off x="4617720" y="3593592"/>
-            <a:ext cx="274320" cy="201168"/>
-          </a:xfrm>
-          <a:prstGeom prst="rect">
-            <a:avLst/>
-          </a:prstGeom>
-          <a:noFill/>
-          <a:ln/>
-        </p:spPr>
-        <p:txBody>
-          <a:bodyPr wrap="square" lIns="0" tIns="0" rIns="0" bIns="0" rtlCol="0" anchor="ctr"/>
-          <a:lstStyle/>
-          <a:p>
-            <a:pPr algn="ctr" indent="0" marL="0">
-              <a:lnSpc>
-                <a:spcPct val="115000"/>
-              </a:lnSpc>
-              <a:buNone/>
-            </a:pPr>
-            <a:r>
-              <a:rPr lang="en-US" sz="900" b="1" dirty="0">
-                <a:solidFill>
-                  <a:srgbClr val="FFFFFF"/>
-                </a:solidFill>
-                <a:latin typeface="Meiryo" pitchFamily="34" charset="0"/>
-                <a:ea typeface="Meiryo" pitchFamily="34" charset="-122"/>
-                <a:cs typeface="Meiryo" pitchFamily="34" charset="-120"/>
-              </a:rPr>
-              <a:t>T</a:t>
-            </a:r>
-            <a:endParaRPr lang="en-US" sz="900" dirty="0"/>
-          </a:p>
-        </p:txBody>
-      </p:sp>
-      <p:sp>
-        <p:nvSpPr>
-          <p:cNvPr id="57" name="Text 54"/>
-          <p:cNvSpPr txBox="1"/>
-          <p:nvPr/>
-        </p:nvSpPr>
-        <p:spPr>
-          <a:xfrm>
-            <a:off x="4983480" y="3566160"/>
-            <a:ext cx="3794760" cy="256032"/>
-          </a:xfrm>
-          <a:prstGeom prst="rect">
-            <a:avLst/>
-          </a:prstGeom>
-          <a:noFill/>
-          <a:ln/>
-        </p:spPr>
-        <p:txBody>
-          <a:bodyPr wrap="square" lIns="0" tIns="0" rIns="0" bIns="0" rtlCol="0" anchor="ctr"/>
-          <a:lstStyle/>
-          <a:p>
-            <a:pPr algn="l" indent="0" marL="0">
-              <a:lnSpc>
-                <a:spcPct val="115000"/>
-              </a:lnSpc>
-              <a:buNone/>
-            </a:pPr>
-            <a:r>
-              <a:rPr lang="en-US" sz="850" dirty="0">
-                <a:solidFill>
-                  <a:srgbClr val="1A1A1A"/>
-                </a:solidFill>
-                <a:latin typeface="Meiryo" pitchFamily="34" charset="0"/>
-                <a:ea typeface="Meiryo" pitchFamily="34" charset="-122"/>
-                <a:cs typeface="Meiryo" pitchFamily="34" charset="-120"/>
-              </a:rPr>
-              <a:t>中堅の電線・ケーブル工場。熟練者の判断が品質を左右する</a:t>
-            </a:r>
-            <a:endParaRPr lang="en-US" sz="850" dirty="0"/>
-          </a:p>
-        </p:txBody>
-      </p:sp>
-      <p:sp>
-        <p:nvSpPr>
-          <p:cNvPr id="58" name="Shape 55"/>
-          <p:cNvSpPr/>
-          <p:nvPr/>
-        </p:nvSpPr>
-        <p:spPr>
-          <a:xfrm>
-            <a:off x="4617720" y="3858768"/>
-            <a:ext cx="274320" cy="201168"/>
-          </a:xfrm>
-          <a:prstGeom prst="rect">
-            <a:avLst/>
-          </a:prstGeom>
-          <a:solidFill>
-            <a:srgbClr val="1A1A1A"/>
-          </a:solidFill>
-          <a:ln/>
-        </p:spPr>
-      </p:sp>
-      <p:sp>
-        <p:nvSpPr>
-          <p:cNvPr id="59" name="Text 56"/>
-          <p:cNvSpPr txBox="1"/>
-          <p:nvPr/>
-        </p:nvSpPr>
-        <p:spPr>
-          <a:xfrm>
-            <a:off x="4617720" y="3858768"/>
-            <a:ext cx="274320" cy="201168"/>
-          </a:xfrm>
-          <a:prstGeom prst="rect">
-            <a:avLst/>
-          </a:prstGeom>
-          <a:noFill/>
-          <a:ln/>
-        </p:spPr>
-        <p:txBody>
-          <a:bodyPr wrap="square" lIns="0" tIns="0" rIns="0" bIns="0" rtlCol="0" anchor="ctr"/>
-          <a:lstStyle/>
-          <a:p>
-            <a:pPr algn="ctr" indent="0" marL="0">
-              <a:lnSpc>
-                <a:spcPct val="115000"/>
-              </a:lnSpc>
-              <a:buNone/>
-            </a:pPr>
-            <a:r>
-              <a:rPr lang="en-US" sz="900" b="1" dirty="0">
-                <a:solidFill>
-                  <a:srgbClr val="FFFFFF"/>
-                </a:solidFill>
-                <a:latin typeface="Meiryo" pitchFamily="34" charset="0"/>
-                <a:ea typeface="Meiryo" pitchFamily="34" charset="-122"/>
-                <a:cs typeface="Meiryo" pitchFamily="34" charset="-120"/>
-              </a:rPr>
-              <a:t>P</a:t>
-            </a:r>
-            <a:endParaRPr lang="en-US" sz="900" dirty="0"/>
-          </a:p>
-        </p:txBody>
-      </p:sp>
-      <p:sp>
-        <p:nvSpPr>
-          <p:cNvPr id="60" name="Text 57"/>
-          <p:cNvSpPr txBox="1"/>
-          <p:nvPr/>
-        </p:nvSpPr>
-        <p:spPr>
-          <a:xfrm>
-            <a:off x="4983480" y="3831336"/>
-            <a:ext cx="3794760" cy="256032"/>
-          </a:xfrm>
-          <a:prstGeom prst="rect">
-            <a:avLst/>
-          </a:prstGeom>
-          <a:noFill/>
-          <a:ln/>
-        </p:spPr>
-        <p:txBody>
-          <a:bodyPr wrap="square" lIns="0" tIns="0" rIns="0" bIns="0" rtlCol="0" anchor="ctr"/>
-          <a:lstStyle/>
-          <a:p>
-            <a:pPr algn="l" indent="0" marL="0">
-              <a:lnSpc>
-                <a:spcPct val="115000"/>
-              </a:lnSpc>
-              <a:buNone/>
-            </a:pPr>
-            <a:r>
-              <a:rPr lang="en-US" sz="850" dirty="0">
-                <a:solidFill>
-                  <a:srgbClr val="1A1A1A"/>
-                </a:solidFill>
-                <a:latin typeface="Meiryo" pitchFamily="34" charset="0"/>
-                <a:ea typeface="Meiryo" pitchFamily="34" charset="-122"/>
-                <a:cs typeface="Meiryo" pitchFamily="34" charset="-120"/>
-              </a:rPr>
-              <a:t>大手の内製と同じことを、教材制作込みのサービスで中堅に届ける</a:t>
-            </a:r>
-            <a:endParaRPr lang="en-US" sz="850" dirty="0"/>
-          </a:p>
-        </p:txBody>
-      </p:sp>
-      <p:sp>
-        <p:nvSpPr>
-          <p:cNvPr id="61" name="Text 58"/>
-          <p:cNvSpPr txBox="1"/>
-          <p:nvPr/>
-        </p:nvSpPr>
-        <p:spPr>
-          <a:xfrm>
-            <a:off x="4617720" y="4123944"/>
-            <a:ext cx="4160520" cy="329184"/>
-          </a:xfrm>
-          <a:prstGeom prst="rect">
-            <a:avLst/>
-          </a:prstGeom>
-          <a:noFill/>
-          <a:ln/>
-        </p:spPr>
-        <p:txBody>
           <a:bodyPr wrap="square" lIns="0" tIns="0" rIns="0" bIns="0" rtlCol="0" anchor="t"/>
           <a:lstStyle/>
           <a:p>
@@ -12019,126 +12642,18 @@
               <a:lnSpc>
                 <a:spcPct val="115000"/>
               </a:lnSpc>
-              <a:spcAft>
-                <a:spcPts val="100"/>
-              </a:spcAft>
-              <a:buNone/>
-            </a:pPr>
-            <a:r>
-              <a:rPr lang="en-US" sz="850" b="1" dirty="0">
-                <a:solidFill>
-                  <a:srgbClr val="1A1A1A"/>
-                </a:solidFill>
-                <a:latin typeface="Meiryo" pitchFamily="34" charset="0"/>
-                <a:ea typeface="Meiryo" pitchFamily="34" charset="-122"/>
-                <a:cs typeface="Meiryo" pitchFamily="34" charset="-120"/>
-              </a:rPr>
-              <a:t>競争戦略：</a:t>
-            </a:r>
-            <a:pPr algn="l" indent="0" marL="0">
-              <a:lnSpc>
-                <a:spcPct val="115000"/>
-              </a:lnSpc>
-              <a:spcAft>
-                <a:spcPts val="100"/>
-              </a:spcAft>
-              <a:buNone/>
-            </a:pPr>
-            <a:r>
-              <a:rPr lang="en-US" sz="850" dirty="0">
-                <a:solidFill>
-                  <a:srgbClr val="1A1A1A"/>
-                </a:solidFill>
-                <a:latin typeface="Meiryo" pitchFamily="34" charset="0"/>
-                <a:ea typeface="Meiryo" pitchFamily="34" charset="-122"/>
-                <a:cs typeface="Meiryo" pitchFamily="34" charset="-120"/>
-              </a:rPr>
-              <a:t>ニッチャー（コトラー）×差別化集中（ポーター）</a:t>
-            </a:r>
-            <a:endParaRPr lang="en-US" sz="850" dirty="0"/>
-          </a:p>
-          <a:p>
-            <a:pPr algn="l" indent="0" marL="0">
-              <a:lnSpc>
-                <a:spcPct val="115000"/>
-              </a:lnSpc>
-              <a:spcAft>
-                <a:spcPts val="100"/>
-              </a:spcAft>
-              <a:buNone/>
-            </a:pPr>
-            <a:r>
-              <a:rPr lang="en-US" sz="850" b="1" dirty="0">
-                <a:solidFill>
-                  <a:srgbClr val="1A1A1A"/>
-                </a:solidFill>
-                <a:latin typeface="Meiryo" pitchFamily="34" charset="0"/>
-                <a:ea typeface="Meiryo" pitchFamily="34" charset="-122"/>
-                <a:cs typeface="Meiryo" pitchFamily="34" charset="-120"/>
-              </a:rPr>
-              <a:t>弱み：</a:t>
-            </a:r>
-            <a:pPr algn="l" indent="0" marL="0">
-              <a:lnSpc>
-                <a:spcPct val="115000"/>
-              </a:lnSpc>
-              <a:spcAft>
-                <a:spcPts val="100"/>
-              </a:spcAft>
-              <a:buNone/>
-            </a:pPr>
-            <a:r>
-              <a:rPr lang="en-US" sz="850" dirty="0">
-                <a:solidFill>
-                  <a:srgbClr val="1A1A1A"/>
-                </a:solidFill>
-                <a:latin typeface="Meiryo" pitchFamily="34" charset="0"/>
-                <a:ea typeface="Meiryo" pitchFamily="34" charset="-122"/>
-                <a:cs typeface="Meiryo" pitchFamily="34" charset="-120"/>
-              </a:rPr>
-              <a:t>製造現場の実務経験が浅い／営業・資金調達が未経験</a:t>
-            </a:r>
-            <a:endParaRPr lang="en-US" sz="850" dirty="0"/>
-          </a:p>
-        </p:txBody>
-      </p:sp>
-      <p:sp>
-        <p:nvSpPr>
-          <p:cNvPr id="62" name="Text 59"/>
-          <p:cNvSpPr txBox="1"/>
-          <p:nvPr/>
-        </p:nvSpPr>
-        <p:spPr>
-          <a:xfrm>
-            <a:off x="365760" y="4535424"/>
-            <a:ext cx="8412480" cy="310896"/>
-          </a:xfrm>
-          <a:prstGeom prst="rect">
-            <a:avLst/>
-          </a:prstGeom>
-          <a:noFill/>
-          <a:ln/>
-        </p:spPr>
-        <p:txBody>
-          <a:bodyPr wrap="square" lIns="0" tIns="0" rIns="0" bIns="0" rtlCol="0" anchor="t"/>
-          <a:lstStyle/>
-          <a:p>
-            <a:pPr algn="l" indent="0" marL="0">
-              <a:lnSpc>
-                <a:spcPct val="115000"/>
-              </a:lnSpc>
               <a:buNone/>
             </a:pPr>
             <a:r>
               <a:rPr lang="en-US" sz="800" dirty="0">
                 <a:solidFill>
-                  <a:srgbClr val="4D4D4D"/>
-                </a:solidFill>
-                <a:latin typeface="Meiryo" pitchFamily="34" charset="0"/>
-                <a:ea typeface="Meiryo" pitchFamily="34" charset="-122"/>
-                <a:cs typeface="Meiryo" pitchFamily="34" charset="-120"/>
-              </a:rPr>
-              <a:t>出典：日立製作所・ダイキン工業（2017年9月）、NEC（2022年11月）、ライオン・NTTデータ（2024年6月）、日立（2025年6月）、NTTデータ（2025年12月）、MONOist 古河電工インタビュー（2021年3月）。※電力インフラに公開事例が見当たらないことは、存在しないことを意味しない</a:t>
+                  <a:srgbClr val="8C8C8C"/>
+                </a:solidFill>
+                <a:latin typeface="Meiryo" pitchFamily="34" charset="0"/>
+                <a:ea typeface="Meiryo" pitchFamily="34" charset="-122"/>
+                <a:cs typeface="Meiryo" pitchFamily="34" charset="-120"/>
+              </a:rPr>
+              <a:t>出典：各社公表資料（Airion 2025年7月、キャディ 2026年8月6日、三菱総合研究所、FRONTEO、tebiki、スタディスト）。詳細と大手の内製事例は補足資料</a:t>
             </a:r>
             <a:endParaRPr lang="en-US" sz="800" dirty="0"/>
           </a:p>
@@ -18217,7 +18732,7 @@
                 <a:ea typeface="Meiryo" pitchFamily="34" charset="-122"/>
                 <a:cs typeface="Meiryo" pitchFamily="34" charset="-120"/>
               </a:rPr>
-              <a:t>大手SIer・ロボットベンダーの参入</a:t>
+              <a:t>CADDiなど大手基盤の連続工程参入</a:t>
             </a:r>
             <a:endParaRPr lang="en-US" sz="1400" dirty="0"/>
           </a:p>
@@ -18237,7 +18752,7 @@
                 <a:ea typeface="Meiryo" pitchFamily="34" charset="-122"/>
                 <a:cs typeface="Meiryo" pitchFamily="34" charset="-120"/>
               </a:rPr>
-              <a:t>→ 蓄積した判断記録が障壁。機能は模倣可能、現場の履歴は移設不能</a:t>
+              <a:t>→ 図面に現れない現場処置の蓄積と監修人材が障壁</a:t>
             </a:r>
             <a:endParaRPr lang="en-US" sz="1400" dirty="0"/>
           </a:p>

</xml_diff>

<commit_message>
Center the solution on smart glasses with automatic reporting
Slide 3 now records conversation and images automatically through
smart glasses, overlays drawings and work procedures on the real
equipment to show differences, sends progress reports to managers
automatically, and still delivers training content afterwards. The
roadmap adds GLASS (drawing/procedure overlay) and folds reporting
into the base product. Slide 5 adds AR work-support vendors, and the
ROI note ties the 6 h/month saving to report writing. Q&A on
recording consent and device cost goes in the supplementary note.

Co-Authored-By: Claude Opus 5.5 <noreply@anthropic.com>
Claude-Session: https://claude.ai/code/session_01Lvjvqoc8h4yHt4F4M6n1V9
</commit_message>
<xml_diff>
--- a/deck/セルフマネジメント課題_事業構想プレゼン.pptx
+++ b/deck/セルフマネジメント課題_事業構想プレゼン.pptx
@@ -2225,8 +2225,8 @@
             <a:r>
               <a:rPr lang="en-US" dirty="0"/>
               <a:t>【2:00 - 3:30】
-要約：引退した熟練者が隣で教えてくれる現場をつくる。差別化は、教材にして届けること
-設問①、解決策です。目指すのは、引退した熟練者が隣で教えてくれるような現場です。熟練者は、異常に対処したらタブレットに音声で一言残すだけです。構造化を現場に求めない設計で、これは国の人工知能基本計画の方針とも一致します。生成AIがそれを条件・処置・理由に分けて事例にします。ただ、記録と整理はすでに他社も手がけており、当社の差別化にはなりません。差別化は三つ目です。指導役が足りない事業所は59.5%、育成の時間がない事業所は47.4%あります。貯めたデータから教材を作る作業が現場に残ると、使われません。だから当社が、連続工程の勘どころを研修資料、通勤中に聞ける音声番組、短い動画にして届けます。教材化は初年度から提供し、その後、危険箇所の表示、3Dの仮想工場、音声での作図と渡し方を増やします。技術は作らない部分を決めています。音声記録やAIの構造化は汎用技術を使い、自前開発は工程データとの紐づけと教材化の手順に集中します。</a:t>
+要約：引退した熟練者が隣で教えてくれる現場を、スマートグラスでつくる
+設問①、解決策です。目指すのは、引退した熟練者が隣で教えてくれるような現場で、その道具がスマートグラスです。一つ目、記録は自動です。作業中の会話と、作業対象の画像をグラスが常時収録します。熟練者は記録のために何もしなくてよい。構造化を現場に求めない設計で、国の人工知能基本計画の方針とも一致します。二つ目、生成AIが会話と画像から、条件・処置・理由を取り出し、ロットや設備のデータ、図面と紐づけます。三つ目、渡す相手は三つです。若手には、グラス越しに図面や作業手順を現物に重ね、違いがあれば知らせます。管理者には、会話と画像から作業内容を判定し、進捗を自動で報告します。日報を書く手間が減り、報告が早くなり、管理者は現場を見に行かなくても状況が分かります。そして後からは、勘どころを音声番組や動画、研修資料にして当社が作って届けます。指導役が足りない事業所は59.5%、育成の時間がない事業所は47.4%あるからです。端末は市販のものを使い、当社は中身とアプリに集中します。常時収録は、作業時間と作業エリアに限り、本人の同意のもとで行います。</a:t>
             </a:r>
             <a:endParaRPr lang="en-US" dirty="0"/>
           </a:p>
@@ -2316,7 +2316,7 @@
               <a:rPr lang="en-US" dirty="0"/>
               <a:t>【3:30 - 4:40】
 要約：顧客は1拠点あたり年300万円を払い、約2か月で元を取る
-次に、お金の流れです。お客様の工場1拠点が毎年払うのは、アプリと基盤の利用料100万円、記録するラインの数に応じた登録料100万円、そして教材制作や危険表示など選んだ機能の料金100万円、合わせて年300万円です。初年度だけ、当社の担当者が現場に入る導入支援200万円が加わり、500万円になります。お客様から見ると、右のグラフのとおり、対象者100名の拠点で毎月240万円分の工数が浮き、約2.1か月で500万円を上回ります。ただし月6時間の削減は、建設業の書類電子化の実績を当てはめた仮定です。当社から見ると、利用料は粗利率85%で毎年積み上がり、導入支援は粗利率40%で一度きりです。お客様が増えるほど、利用料が積み上がっていく構造です。</a:t>
+次に、お金の流れです。お客様の工場1拠点が毎年払うのは、アプリと基盤の利用料100万円、記録するラインの数に応じた登録料100万円、そして教材制作や危険表示など選んだ機能の料金100万円、合わせて年300万円です。初年度だけ、当社の担当者が現場に入る導入支援200万円が加わり、500万円になります。お客様から見ると、右のグラフのとおり、対象者100名の拠点で毎月240万円分の工数が浮き、約2.1か月で500万円を上回ります。浮く工数の中心は、日報や進捗報告といった書類作業で、グラスの自動報告で置き換わる部分です。月6時間という値は、建設業の書類電子化の実績を当てはめた仮定です。当社から見ると、利用料は粗利率85%で毎年積み上がり、導入支援は粗利率40%で一度きりです。なお、スマートグラス端末の費用はこの試算に含めていません。</a:t>
             </a:r>
             <a:endParaRPr lang="en-US" dirty="0"/>
           </a:p>
@@ -2406,7 +2406,7 @@
               <a:rPr lang="en-US" dirty="0"/>
               <a:t>【4:40 - 5:50】
 要約：「貯める」会社は現れた。当社は「渡す」で分かれる
-最初に自分で自分に突きつけた問いが三つありました。コンサルと何が違うのか、同じことをしている会社はないのか、大手が降りてきたらどうするのか、です。調べると、判断の理由を扱う会社はすでに現れています。東大発のAirionは、ベテランとAIの対話で知識を構造化します。キャディのCADDiは、設計意図や判断履歴をデータ化しています。正直に言えば、貯める部分は当社とほぼ同じ設計です。これは、この課題に市場があることの証明だと考えています。分かれるのは渡す部分です。どの会社も、貯めたものを教材にして届けるところまではやっていません。また、CADDiの対象は組立の製造業で、扱うのは図面とBOMです。電線のような連続工程の現場処置は、図面には現れません。最大の脅威は、CADDiが連続工程に降りてくることです。防御線は、図面に現れない現場処置の蓄積と、現場で監修できる人です。</a:t>
+最初に自分で自分に突きつけた問いが三つありました。コンサルと何が違うのか、同じことをしている会社はないのか、大手が降りてきたらどうするのか、です。調べると、判断の理由を扱う会社はすでに現れています。東大発のAirionは、ベテランとAIの対話で知識を構造化します。キャディのCADDiは、設計意図や判断履歴をデータ化しています。スマートグラスで手順を表示するAR作業支援も各社にあります。正直に言えば、それぞれの部品は他社にもあります。分かれるのは組み合わせと対象です。連続工程の現場で、会話から自動で貯め、現物に重ねてその場で渡し、さらに教材にまでする会社はまだありません。CADDiの対象は組立の製造業で、扱うのは図面とBOMです。電線のような連続工程の現場処置は、図面には現れません。最大の脅威は、CADDiが連続工程に降りてくることです。防御線は、図面に現れない現場処置の蓄積と、現場で監修できる人です。</a:t>
             </a:r>
             <a:endParaRPr lang="en-US" dirty="0"/>
           </a:p>
@@ -5452,7 +5452,7 @@
                 <a:ea typeface="Meiryo" pitchFamily="34" charset="-122"/>
                 <a:cs typeface="Meiryo" pitchFamily="34" charset="-120"/>
               </a:rPr>
-              <a:t>記録と整理は手段。差別化は③：連続工程の勘どころを、研修資料・音声番組・動画にして当社が届ける</a:t>
+              <a:t>スマートグラスで、記録と報告は自動に。図面と手順は現物に重ねて照合し、教材は当社が作る</a:t>
             </a:r>
             <a:endParaRPr lang="en-US" sz="1200" dirty="0"/>
           </a:p>
@@ -5467,7 +5467,7 @@
         <p:spPr>
           <a:xfrm>
             <a:off x="365760" y="1024128"/>
-            <a:ext cx="2578608" cy="1371600"/>
+            <a:ext cx="2578608" cy="1463040"/>
           </a:xfrm>
           <a:prstGeom prst="rect">
             <a:avLst/>
@@ -5539,7 +5539,7 @@
                 <a:ea typeface="Meiryo" pitchFamily="34" charset="-122"/>
                 <a:cs typeface="Meiryo" pitchFamily="34" charset="-120"/>
               </a:rPr>
-              <a:t>① 記録する</a:t>
+              <a:t>① 自動で記録</a:t>
             </a:r>
             <a:pPr algn="l" indent="0" marL="0">
               <a:lnSpc>
@@ -5556,7 +5556,7 @@
                 <a:ea typeface="Meiryo" pitchFamily="34" charset="-122"/>
                 <a:cs typeface="Meiryo" pitchFamily="34" charset="-120"/>
               </a:rPr>
-              <a:t>　熟練者</a:t>
+              <a:t>　スマートグラス</a:t>
             </a:r>
             <a:endParaRPr lang="en-US" sz="1100" dirty="0"/>
           </a:p>
@@ -5571,7 +5571,7 @@
         <p:spPr>
           <a:xfrm>
             <a:off x="475488" y="1353312"/>
-            <a:ext cx="2359152" cy="603504"/>
+            <a:ext cx="2359152" cy="786384"/>
           </a:xfrm>
           <a:prstGeom prst="rect">
             <a:avLst/>
@@ -5598,7 +5598,7 @@
                 <a:ea typeface="Meiryo" pitchFamily="34" charset="-122"/>
                 <a:cs typeface="Meiryo" pitchFamily="34" charset="-120"/>
               </a:rPr>
-              <a:t>異常に対処したら、タブレットに音声で一言残す。例「湿度が高いので温度を2℃下げた」</a:t>
+              <a:t>作業中の会話と、作業対象の画像を常時収録。熟練者は何もしなくてよい</a:t>
             </a:r>
             <a:endParaRPr lang="en-US" sz="950" dirty="0"/>
           </a:p>
@@ -5612,7 +5612,7 @@
         </p:nvSpPr>
         <p:spPr>
           <a:xfrm>
-            <a:off x="475488" y="2029968"/>
+            <a:off x="475488" y="2157984"/>
             <a:ext cx="2359152" cy="310896"/>
           </a:xfrm>
           <a:prstGeom prst="rect">
@@ -5657,7 +5657,7 @@
                 <a:ea typeface="Meiryo" pitchFamily="34" charset="-122"/>
                 <a:cs typeface="Meiryo" pitchFamily="34" charset="-120"/>
               </a:rPr>
-              <a:t>記録アプリ（音声）。構造化を現場に求めない (1)</a:t>
+              <a:t>市販のスマートグラス。構造化を現場に求めない (1)</a:t>
             </a:r>
             <a:endParaRPr lang="en-US" sz="850" dirty="0"/>
           </a:p>
@@ -5671,7 +5671,7 @@
         </p:nvSpPr>
         <p:spPr>
           <a:xfrm>
-            <a:off x="2944368" y="1545336"/>
+            <a:off x="2944368" y="1591056"/>
             <a:ext cx="338328" cy="329184"/>
           </a:xfrm>
           <a:prstGeom prst="rect">
@@ -5714,7 +5714,7 @@
         <p:spPr>
           <a:xfrm>
             <a:off x="3282696" y="1024128"/>
-            <a:ext cx="2578608" cy="1371600"/>
+            <a:ext cx="2578608" cy="1463040"/>
           </a:xfrm>
           <a:prstGeom prst="rect">
             <a:avLst/>
@@ -5818,7 +5818,7 @@
         <p:spPr>
           <a:xfrm>
             <a:off x="3392424" y="1353312"/>
-            <a:ext cx="2359152" cy="603504"/>
+            <a:ext cx="2359152" cy="786384"/>
           </a:xfrm>
           <a:prstGeom prst="rect">
             <a:avLst/>
@@ -5845,7 +5845,7 @@
                 <a:ea typeface="Meiryo" pitchFamily="34" charset="-122"/>
                 <a:cs typeface="Meiryo" pitchFamily="34" charset="-120"/>
               </a:rPr>
-              <a:t>一言を「条件・処置・理由」に分けて文章化し、ロット・設備データと紐づけて事例にする</a:t>
+              <a:t>会話と画像から「条件・処置・理由」を取り出し、ロット・設備データ・図面と紐づける</a:t>
             </a:r>
             <a:endParaRPr lang="en-US" sz="950" dirty="0"/>
           </a:p>
@@ -5859,7 +5859,7 @@
         </p:nvSpPr>
         <p:spPr>
           <a:xfrm>
-            <a:off x="3392424" y="2029968"/>
+            <a:off x="3392424" y="2157984"/>
             <a:ext cx="2359152" cy="310896"/>
           </a:xfrm>
           <a:prstGeom prst="rect">
@@ -5918,7 +5918,7 @@
         </p:nvSpPr>
         <p:spPr>
           <a:xfrm>
-            <a:off x="5861304" y="1545336"/>
+            <a:off x="5861304" y="1591056"/>
             <a:ext cx="338328" cy="329184"/>
           </a:xfrm>
           <a:prstGeom prst="rect">
@@ -5961,7 +5961,7 @@
         <p:spPr>
           <a:xfrm>
             <a:off x="6199632" y="1024128"/>
-            <a:ext cx="2578608" cy="1371600"/>
+            <a:ext cx="2578608" cy="1463040"/>
           </a:xfrm>
           <a:prstGeom prst="rect">
             <a:avLst/>
@@ -6033,7 +6033,7 @@
                 <a:ea typeface="Meiryo" pitchFamily="34" charset="-122"/>
                 <a:cs typeface="Meiryo" pitchFamily="34" charset="-120"/>
               </a:rPr>
-              <a:t>③ 教材にして渡す</a:t>
+              <a:t>③ 渡す</a:t>
             </a:r>
             <a:pPr algn="l" indent="0" marL="0">
               <a:lnSpc>
@@ -6050,7 +6050,7 @@
                 <a:ea typeface="Meiryo" pitchFamily="34" charset="-122"/>
                 <a:cs typeface="Meiryo" pitchFamily="34" charset="-120"/>
               </a:rPr>
-              <a:t>　当社</a:t>
+              <a:t>　若手・管理者</a:t>
             </a:r>
             <a:endParaRPr lang="en-US" sz="1100" dirty="0"/>
           </a:p>
@@ -6065,7 +6065,7 @@
         <p:spPr>
           <a:xfrm>
             <a:off x="6309360" y="1353312"/>
-            <a:ext cx="2359152" cy="603504"/>
+            <a:ext cx="2359152" cy="786384"/>
           </a:xfrm>
           <a:prstGeom prst="rect">
             <a:avLst/>
@@ -6081,10 +6081,13 @@
               <a:lnSpc>
                 <a:spcPct val="115000"/>
               </a:lnSpc>
-              <a:buNone/>
-            </a:pPr>
-            <a:r>
-              <a:rPr lang="en-US" sz="950" dirty="0">
+              <a:spcAft>
+                <a:spcPts val="200"/>
+              </a:spcAft>
+              <a:buNone/>
+            </a:pPr>
+            <a:r>
+              <a:rPr lang="en-US" sz="850" dirty="0">
                 <a:solidFill>
                   <a:srgbClr val="1A1A1A"/>
                 </a:solidFill>
@@ -6092,9 +6095,55 @@
                 <a:ea typeface="Meiryo" pitchFamily="34" charset="-122"/>
                 <a:cs typeface="Meiryo" pitchFamily="34" charset="-120"/>
               </a:rPr>
-              <a:t>指導役が足りず（59.5%）、育成の時間もない（47.4%）(2)。だから教材は当社が作って届ける</a:t>
-            </a:r>
-            <a:endParaRPr lang="en-US" sz="950" dirty="0"/>
+              <a:t>若手へ：図面・手順を現物に重ね、差異を表示</a:t>
+            </a:r>
+            <a:endParaRPr lang="en-US" sz="850" dirty="0"/>
+          </a:p>
+          <a:p>
+            <a:pPr algn="l" indent="0" marL="0">
+              <a:lnSpc>
+                <a:spcPct val="115000"/>
+              </a:lnSpc>
+              <a:spcAft>
+                <a:spcPts val="200"/>
+              </a:spcAft>
+              <a:buNone/>
+            </a:pPr>
+            <a:r>
+              <a:rPr lang="en-US" sz="850" dirty="0">
+                <a:solidFill>
+                  <a:srgbClr val="1A1A1A"/>
+                </a:solidFill>
+                <a:latin typeface="Meiryo" pitchFamily="34" charset="0"/>
+                <a:ea typeface="Meiryo" pitchFamily="34" charset="-122"/>
+                <a:cs typeface="Meiryo" pitchFamily="34" charset="-120"/>
+              </a:rPr>
+              <a:t>管理者へ：作業を判定し、進捗を自動で報告</a:t>
+            </a:r>
+            <a:endParaRPr lang="en-US" sz="850" dirty="0"/>
+          </a:p>
+          <a:p>
+            <a:pPr algn="l" indent="0" marL="0">
+              <a:lnSpc>
+                <a:spcPct val="115000"/>
+              </a:lnSpc>
+              <a:spcAft>
+                <a:spcPts val="200"/>
+              </a:spcAft>
+              <a:buNone/>
+            </a:pPr>
+            <a:r>
+              <a:rPr lang="en-US" sz="850" dirty="0">
+                <a:solidFill>
+                  <a:srgbClr val="1A1A1A"/>
+                </a:solidFill>
+                <a:latin typeface="Meiryo" pitchFamily="34" charset="0"/>
+                <a:ea typeface="Meiryo" pitchFamily="34" charset="-122"/>
+                <a:cs typeface="Meiryo" pitchFamily="34" charset="-120"/>
+              </a:rPr>
+              <a:t>後から：教材を当社が制作 (2)</a:t>
+            </a:r>
+            <a:endParaRPr lang="en-US" sz="850" dirty="0"/>
           </a:p>
         </p:txBody>
       </p:sp>
@@ -6106,7 +6155,7 @@
         </p:nvSpPr>
         <p:spPr>
           <a:xfrm>
-            <a:off x="6309360" y="2029968"/>
+            <a:off x="6309360" y="2157984"/>
             <a:ext cx="2359152" cy="310896"/>
           </a:xfrm>
           <a:prstGeom prst="rect">
@@ -6151,7 +6200,7 @@
                 <a:ea typeface="Meiryo" pitchFamily="34" charset="-122"/>
                 <a:cs typeface="Meiryo" pitchFamily="34" charset="-120"/>
               </a:rPr>
-              <a:t>生成AIで台本→当社が監修→配信</a:t>
+              <a:t>グラス表示・自動報告・当社の監修</a:t>
             </a:r>
             <a:endParaRPr lang="en-US" sz="850" dirty="0"/>
           </a:p>
@@ -6165,7 +6214,7 @@
         </p:nvSpPr>
         <p:spPr>
           <a:xfrm>
-            <a:off x="365760" y="2542032"/>
+            <a:off x="365760" y="2578608"/>
             <a:ext cx="4572000" cy="219456"/>
           </a:xfrm>
           <a:prstGeom prst="rect">
@@ -6193,7 +6242,7 @@
                 <a:ea typeface="Meiryo" pitchFamily="34" charset="-122"/>
                 <a:cs typeface="Meiryo" pitchFamily="34" charset="-120"/>
               </a:rPr>
-              <a:t>渡し方を増やす（製品戦略：教材化を初年度から、追加機能は年1本ずつ）</a:t>
+              <a:t>渡し方を増やす（製品戦略：収録と教材化を初年度から、追加機能は年1本ずつ）</a:t>
             </a:r>
             <a:endParaRPr lang="en-US" sz="950" dirty="0"/>
           </a:p>
@@ -6207,7 +6256,7 @@
         </p:nvSpPr>
         <p:spPr>
           <a:xfrm>
-            <a:off x="365760" y="2788920"/>
+            <a:off x="365760" y="2825496"/>
             <a:ext cx="4572000" cy="0"/>
           </a:xfrm>
           <a:prstGeom prst="line">
@@ -6230,7 +6279,7 @@
         </p:nvSpPr>
         <p:spPr>
           <a:xfrm>
-            <a:off x="402336" y="2788920"/>
+            <a:off x="402336" y="2825496"/>
             <a:ext cx="420624" cy="228600"/>
           </a:xfrm>
           <a:prstGeom prst="rect">
@@ -6272,7 +6321,7 @@
         </p:nvSpPr>
         <p:spPr>
           <a:xfrm>
-            <a:off x="822960" y="2788920"/>
+            <a:off x="822960" y="2825496"/>
             <a:ext cx="621792" cy="228600"/>
           </a:xfrm>
           <a:prstGeom prst="rect">
@@ -6314,7 +6363,7 @@
         </p:nvSpPr>
         <p:spPr>
           <a:xfrm>
-            <a:off x="1444752" y="2788920"/>
+            <a:off x="1444752" y="2825496"/>
             <a:ext cx="603504" cy="228600"/>
           </a:xfrm>
           <a:prstGeom prst="rect">
@@ -6342,7 +6391,7 @@
                 <a:ea typeface="Meiryo" pitchFamily="34" charset="-122"/>
                 <a:cs typeface="Meiryo" pitchFamily="34" charset="-120"/>
               </a:rPr>
-              <a:t>画面</a:t>
+              <a:t>収録・報告</a:t>
             </a:r>
             <a:endParaRPr lang="en-US" sz="800" dirty="0"/>
           </a:p>
@@ -6356,7 +6405,7 @@
         </p:nvSpPr>
         <p:spPr>
           <a:xfrm>
-            <a:off x="2048256" y="2788920"/>
+            <a:off x="2048256" y="2825496"/>
             <a:ext cx="2468880" cy="228600"/>
           </a:xfrm>
           <a:prstGeom prst="rect">
@@ -6384,7 +6433,7 @@
                 <a:ea typeface="Meiryo" pitchFamily="34" charset="-122"/>
                 <a:cs typeface="Meiryo" pitchFamily="34" charset="-120"/>
               </a:rPr>
-              <a:t>記録・過去事例の検索（全顧客）</a:t>
+              <a:t>常時収録、進捗の自動報告、事例検索</a:t>
             </a:r>
             <a:endParaRPr lang="en-US" sz="800" dirty="0"/>
           </a:p>
@@ -6398,7 +6447,7 @@
         </p:nvSpPr>
         <p:spPr>
           <a:xfrm>
-            <a:off x="4517136" y="2788920"/>
+            <a:off x="4517136" y="2825496"/>
             <a:ext cx="384048" cy="228600"/>
           </a:xfrm>
           <a:prstGeom prst="rect">
@@ -6440,7 +6489,7 @@
         </p:nvSpPr>
         <p:spPr>
           <a:xfrm>
-            <a:off x="365760" y="3017520"/>
+            <a:off x="365760" y="3054096"/>
             <a:ext cx="4572000" cy="0"/>
           </a:xfrm>
           <a:prstGeom prst="line">
@@ -6463,7 +6512,7 @@
         </p:nvSpPr>
         <p:spPr>
           <a:xfrm>
-            <a:off x="402336" y="3017520"/>
+            <a:off x="402336" y="3054096"/>
             <a:ext cx="420624" cy="228600"/>
           </a:xfrm>
           <a:prstGeom prst="rect">
@@ -6505,7 +6554,7 @@
         </p:nvSpPr>
         <p:spPr>
           <a:xfrm>
-            <a:off x="822960" y="3017520"/>
+            <a:off x="822960" y="3054096"/>
             <a:ext cx="621792" cy="228600"/>
           </a:xfrm>
           <a:prstGeom prst="rect">
@@ -6547,7 +6596,7 @@
         </p:nvSpPr>
         <p:spPr>
           <a:xfrm>
-            <a:off x="1444752" y="3017520"/>
+            <a:off x="1444752" y="3054096"/>
             <a:ext cx="603504" cy="228600"/>
           </a:xfrm>
           <a:prstGeom prst="rect">
@@ -6589,7 +6638,7 @@
         </p:nvSpPr>
         <p:spPr>
           <a:xfrm>
-            <a:off x="2048256" y="3017520"/>
+            <a:off x="2048256" y="3054096"/>
             <a:ext cx="2468880" cy="228600"/>
           </a:xfrm>
           <a:prstGeom prst="rect">
@@ -6631,7 +6680,7 @@
         </p:nvSpPr>
         <p:spPr>
           <a:xfrm>
-            <a:off x="4517136" y="3017520"/>
+            <a:off x="4517136" y="3054096"/>
             <a:ext cx="384048" cy="228600"/>
           </a:xfrm>
           <a:prstGeom prst="rect">
@@ -6673,7 +6722,7 @@
         </p:nvSpPr>
         <p:spPr>
           <a:xfrm>
-            <a:off x="365760" y="3246120"/>
+            <a:off x="365760" y="3282696"/>
             <a:ext cx="4572000" cy="0"/>
           </a:xfrm>
           <a:prstGeom prst="line">
@@ -6696,7 +6745,7 @@
         </p:nvSpPr>
         <p:spPr>
           <a:xfrm>
-            <a:off x="402336" y="3246120"/>
+            <a:off x="402336" y="3282696"/>
             <a:ext cx="420624" cy="228600"/>
           </a:xfrm>
           <a:prstGeom prst="rect">
@@ -6738,7 +6787,7 @@
         </p:nvSpPr>
         <p:spPr>
           <a:xfrm>
-            <a:off x="822960" y="3246120"/>
+            <a:off x="822960" y="3282696"/>
             <a:ext cx="621792" cy="228600"/>
           </a:xfrm>
           <a:prstGeom prst="rect">
@@ -6780,7 +6829,7 @@
         </p:nvSpPr>
         <p:spPr>
           <a:xfrm>
-            <a:off x="1444752" y="3246120"/>
+            <a:off x="1444752" y="3282696"/>
             <a:ext cx="603504" cy="228600"/>
           </a:xfrm>
           <a:prstGeom prst="rect">
@@ -6822,7 +6871,7 @@
         </p:nvSpPr>
         <p:spPr>
           <a:xfrm>
-            <a:off x="2048256" y="3246120"/>
+            <a:off x="2048256" y="3282696"/>
             <a:ext cx="2468880" cy="228600"/>
           </a:xfrm>
           <a:prstGeom prst="rect">
@@ -6850,7 +6899,7 @@
                 <a:ea typeface="Meiryo" pitchFamily="34" charset="-122"/>
                 <a:cs typeface="Meiryo" pitchFamily="34" charset="-120"/>
               </a:rPr>
-              <a:t>手順書を開くと過去の事故・ヒヤリ地点を表示</a:t>
+              <a:t>危険箇所・過去のヒヤリ地点をグラスに表示</a:t>
             </a:r>
             <a:endParaRPr lang="en-US" sz="800" dirty="0"/>
           </a:p>
@@ -6864,7 +6913,7 @@
         </p:nvSpPr>
         <p:spPr>
           <a:xfrm>
-            <a:off x="4517136" y="3246120"/>
+            <a:off x="4517136" y="3282696"/>
             <a:ext cx="384048" cy="228600"/>
           </a:xfrm>
           <a:prstGeom prst="rect">
@@ -6906,7 +6955,7 @@
         </p:nvSpPr>
         <p:spPr>
           <a:xfrm>
-            <a:off x="365760" y="3474720"/>
+            <a:off x="365760" y="3511296"/>
             <a:ext cx="4572000" cy="0"/>
           </a:xfrm>
           <a:prstGeom prst="line">
@@ -6929,7 +6978,7 @@
         </p:nvSpPr>
         <p:spPr>
           <a:xfrm>
-            <a:off x="402336" y="3474720"/>
+            <a:off x="402336" y="3511296"/>
             <a:ext cx="420624" cy="228600"/>
           </a:xfrm>
           <a:prstGeom prst="rect">
@@ -6971,7 +7020,7 @@
         </p:nvSpPr>
         <p:spPr>
           <a:xfrm>
-            <a:off x="822960" y="3474720"/>
+            <a:off x="822960" y="3511296"/>
             <a:ext cx="621792" cy="228600"/>
           </a:xfrm>
           <a:prstGeom prst="rect">
@@ -6999,7 +7048,7 @@
                 <a:ea typeface="Meiryo" pitchFamily="34" charset="-122"/>
                 <a:cs typeface="Meiryo" pitchFamily="34" charset="-120"/>
               </a:rPr>
-              <a:t>TWIN</a:t>
+              <a:t>GLASS</a:t>
             </a:r>
             <a:endParaRPr lang="en-US" sz="850" dirty="0"/>
           </a:p>
@@ -7013,7 +7062,7 @@
         </p:nvSpPr>
         <p:spPr>
           <a:xfrm>
-            <a:off x="1444752" y="3474720"/>
+            <a:off x="1444752" y="3511296"/>
             <a:ext cx="603504" cy="228600"/>
           </a:xfrm>
           <a:prstGeom prst="rect">
@@ -7041,7 +7090,7 @@
                 <a:ea typeface="Meiryo" pitchFamily="34" charset="-122"/>
                 <a:cs typeface="Meiryo" pitchFamily="34" charset="-120"/>
               </a:rPr>
-              <a:t>3D</a:t>
+              <a:t>照合</a:t>
             </a:r>
             <a:endParaRPr lang="en-US" sz="800" dirty="0"/>
           </a:p>
@@ -7055,7 +7104,7 @@
         </p:nvSpPr>
         <p:spPr>
           <a:xfrm>
-            <a:off x="2048256" y="3474720"/>
+            <a:off x="2048256" y="3511296"/>
             <a:ext cx="2468880" cy="228600"/>
           </a:xfrm>
           <a:prstGeom prst="rect">
@@ -7083,7 +7132,7 @@
                 <a:ea typeface="Meiryo" pitchFamily="34" charset="-122"/>
                 <a:cs typeface="Meiryo" pitchFamily="34" charset="-120"/>
               </a:rPr>
-              <a:t>3D仮想工場でレイアウト・ラインの流れを試算</a:t>
+              <a:t>図面・作業手順を現物に重ね、差異を検出</a:t>
             </a:r>
             <a:endParaRPr lang="en-US" sz="800" dirty="0"/>
           </a:p>
@@ -7097,7 +7146,7 @@
         </p:nvSpPr>
         <p:spPr>
           <a:xfrm>
-            <a:off x="4517136" y="3474720"/>
+            <a:off x="4517136" y="3511296"/>
             <a:ext cx="384048" cy="228600"/>
           </a:xfrm>
           <a:prstGeom prst="rect">
@@ -7139,7 +7188,7 @@
         </p:nvSpPr>
         <p:spPr>
           <a:xfrm>
-            <a:off x="365760" y="3703320"/>
+            <a:off x="365760" y="3739896"/>
             <a:ext cx="4572000" cy="0"/>
           </a:xfrm>
           <a:prstGeom prst="line">
@@ -7162,7 +7211,7 @@
         </p:nvSpPr>
         <p:spPr>
           <a:xfrm>
-            <a:off x="402336" y="3703320"/>
+            <a:off x="402336" y="3739896"/>
             <a:ext cx="420624" cy="228600"/>
           </a:xfrm>
           <a:prstGeom prst="rect">
@@ -7204,7 +7253,7 @@
         </p:nvSpPr>
         <p:spPr>
           <a:xfrm>
-            <a:off x="822960" y="3703320"/>
+            <a:off x="822960" y="3739896"/>
             <a:ext cx="621792" cy="228600"/>
           </a:xfrm>
           <a:prstGeom prst="rect">
@@ -7232,7 +7281,7 @@
                 <a:ea typeface="Meiryo" pitchFamily="34" charset="-122"/>
                 <a:cs typeface="Meiryo" pitchFamily="34" charset="-120"/>
               </a:rPr>
-              <a:t>DRAW</a:t>
+              <a:t>TWIN</a:t>
             </a:r>
             <a:endParaRPr lang="en-US" sz="850" dirty="0"/>
           </a:p>
@@ -7246,7 +7295,7 @@
         </p:nvSpPr>
         <p:spPr>
           <a:xfrm>
-            <a:off x="1444752" y="3703320"/>
+            <a:off x="1444752" y="3739896"/>
             <a:ext cx="603504" cy="228600"/>
           </a:xfrm>
           <a:prstGeom prst="rect">
@@ -7274,7 +7323,7 @@
                 <a:ea typeface="Meiryo" pitchFamily="34" charset="-122"/>
                 <a:cs typeface="Meiryo" pitchFamily="34" charset="-120"/>
               </a:rPr>
-              <a:t>図面</a:t>
+              <a:t>3D</a:t>
             </a:r>
             <a:endParaRPr lang="en-US" sz="800" dirty="0"/>
           </a:p>
@@ -7288,7 +7337,7 @@
         </p:nvSpPr>
         <p:spPr>
           <a:xfrm>
-            <a:off x="2048256" y="3703320"/>
+            <a:off x="2048256" y="3739896"/>
             <a:ext cx="2468880" cy="228600"/>
           </a:xfrm>
           <a:prstGeom prst="rect">
@@ -7316,7 +7365,7 @@
                 <a:ea typeface="Meiryo" pitchFamily="34" charset="-122"/>
                 <a:cs typeface="Meiryo" pitchFamily="34" charset="-120"/>
               </a:rPr>
-              <a:t>登録したパターンを音声指示でCAD作図</a:t>
+              <a:t>設備の内部構造・工場全体を3Dで再現</a:t>
             </a:r>
             <a:endParaRPr lang="en-US" sz="800" dirty="0"/>
           </a:p>
@@ -7330,7 +7379,7 @@
         </p:nvSpPr>
         <p:spPr>
           <a:xfrm>
-            <a:off x="4517136" y="3703320"/>
+            <a:off x="4517136" y="3739896"/>
             <a:ext cx="384048" cy="228600"/>
           </a:xfrm>
           <a:prstGeom prst="rect">
@@ -7372,27 +7421,7 @@
         </p:nvSpPr>
         <p:spPr>
           <a:xfrm>
-            <a:off x="365760" y="3931920"/>
-            <a:ext cx="4572000" cy="228600"/>
-          </a:xfrm>
-          <a:prstGeom prst="rect">
-            <a:avLst/>
-          </a:prstGeom>
-          <a:solidFill>
-            <a:srgbClr val="F2F2F2"/>
-          </a:solidFill>
-          <a:ln/>
-        </p:spPr>
-      </p:sp>
-      <p:sp>
-        <p:nvSpPr>
-          <p:cNvPr id="54" name="Shape 51"/>
-          <p:cNvSpPr/>
-          <p:nvPr/>
-        </p:nvSpPr>
-        <p:spPr>
-          <a:xfrm>
-            <a:off x="365760" y="3931920"/>
+            <a:off x="365760" y="3968496"/>
             <a:ext cx="4572000" cy="0"/>
           </a:xfrm>
           <a:prstGeom prst="line">
@@ -7409,14 +7438,56 @@
       </p:sp>
       <p:sp>
         <p:nvSpPr>
+          <p:cNvPr id="54" name="Text 51"/>
+          <p:cNvSpPr txBox="1"/>
+          <p:nvPr/>
+        </p:nvSpPr>
+        <p:spPr>
+          <a:xfrm>
+            <a:off x="402336" y="3968496"/>
+            <a:ext cx="420624" cy="228600"/>
+          </a:xfrm>
+          <a:prstGeom prst="rect">
+            <a:avLst/>
+          </a:prstGeom>
+          <a:noFill/>
+          <a:ln/>
+        </p:spPr>
+        <p:txBody>
+          <a:bodyPr wrap="square" lIns="0" tIns="0" rIns="0" bIns="0" rtlCol="0" anchor="ctr"/>
+          <a:lstStyle/>
+          <a:p>
+            <a:pPr algn="l" indent="0" marL="0">
+              <a:lnSpc>
+                <a:spcPct val="115000"/>
+              </a:lnSpc>
+              <a:buNone/>
+            </a:pPr>
+            <a:r>
+              <a:rPr lang="en-US" sz="800" dirty="0">
+                <a:solidFill>
+                  <a:srgbClr val="4D4D4D"/>
+                </a:solidFill>
+                <a:latin typeface="Meiryo" pitchFamily="34" charset="0"/>
+                <a:ea typeface="Meiryo" pitchFamily="34" charset="-122"/>
+                <a:cs typeface="Meiryo" pitchFamily="34" charset="-120"/>
+              </a:rPr>
+              <a:t>5年目</a:t>
+            </a:r>
+            <a:endParaRPr lang="en-US" sz="800" dirty="0"/>
+          </a:p>
+        </p:txBody>
+      </p:sp>
+      <p:sp>
+        <p:nvSpPr>
           <p:cNvPr id="55" name="Text 52"/>
           <p:cNvSpPr txBox="1"/>
           <p:nvPr/>
         </p:nvSpPr>
         <p:spPr>
           <a:xfrm>
-            <a:off x="402336" y="3931920"/>
-            <a:ext cx="420624" cy="228600"/>
+            <a:off x="822960" y="3968496"/>
+            <a:ext cx="621792" cy="228600"/>
           </a:xfrm>
           <a:prstGeom prst="rect">
             <a:avLst/>
@@ -7435,17 +7506,17 @@
               <a:buNone/>
             </a:pPr>
             <a:r>
-              <a:rPr lang="en-US" sz="800" dirty="0">
-                <a:solidFill>
-                  <a:srgbClr val="4D4D4D"/>
-                </a:solidFill>
-                <a:latin typeface="Meiryo" pitchFamily="34" charset="0"/>
-                <a:ea typeface="Meiryo" pitchFamily="34" charset="-122"/>
-                <a:cs typeface="Meiryo" pitchFamily="34" charset="-120"/>
-              </a:rPr>
-              <a:t>研究</a:t>
-            </a:r>
-            <a:endParaRPr lang="en-US" sz="800" dirty="0"/>
+              <a:rPr lang="en-US" sz="850" b="1" dirty="0">
+                <a:solidFill>
+                  <a:srgbClr val="1A1A1A"/>
+                </a:solidFill>
+                <a:latin typeface="Meiryo" pitchFamily="34" charset="0"/>
+                <a:ea typeface="Meiryo" pitchFamily="34" charset="-122"/>
+                <a:cs typeface="Meiryo" pitchFamily="34" charset="-120"/>
+              </a:rPr>
+              <a:t>DRAW</a:t>
+            </a:r>
+            <a:endParaRPr lang="en-US" sz="850" dirty="0"/>
           </a:p>
         </p:txBody>
       </p:sp>
@@ -7457,8 +7528,8 @@
         </p:nvSpPr>
         <p:spPr>
           <a:xfrm>
-            <a:off x="822960" y="3931920"/>
-            <a:ext cx="621792" cy="228600"/>
+            <a:off x="1444752" y="3968496"/>
+            <a:ext cx="603504" cy="228600"/>
           </a:xfrm>
           <a:prstGeom prst="rect">
             <a:avLst/>
@@ -7477,17 +7548,17 @@
               <a:buNone/>
             </a:pPr>
             <a:r>
-              <a:rPr lang="en-US" sz="850" b="1" dirty="0">
-                <a:solidFill>
-                  <a:srgbClr val="1A1A1A"/>
-                </a:solidFill>
-                <a:latin typeface="Meiryo" pitchFamily="34" charset="0"/>
-                <a:ea typeface="Meiryo" pitchFamily="34" charset="-122"/>
-                <a:cs typeface="Meiryo" pitchFamily="34" charset="-120"/>
-              </a:rPr>
-              <a:t>HAPTIC</a:t>
-            </a:r>
-            <a:endParaRPr lang="en-US" sz="850" dirty="0"/>
+              <a:rPr lang="en-US" sz="800" dirty="0">
+                <a:solidFill>
+                  <a:srgbClr val="4D4D4D"/>
+                </a:solidFill>
+                <a:latin typeface="Meiryo" pitchFamily="34" charset="0"/>
+                <a:ea typeface="Meiryo" pitchFamily="34" charset="-122"/>
+                <a:cs typeface="Meiryo" pitchFamily="34" charset="-120"/>
+              </a:rPr>
+              <a:t>図面</a:t>
+            </a:r>
+            <a:endParaRPr lang="en-US" sz="800" dirty="0"/>
           </a:p>
         </p:txBody>
       </p:sp>
@@ -7499,8 +7570,8 @@
         </p:nvSpPr>
         <p:spPr>
           <a:xfrm>
-            <a:off x="1444752" y="3931920"/>
-            <a:ext cx="603504" cy="228600"/>
+            <a:off x="2048256" y="3968496"/>
+            <a:ext cx="2468880" cy="228600"/>
           </a:xfrm>
           <a:prstGeom prst="rect">
             <a:avLst/>
@@ -7521,13 +7592,13 @@
             <a:r>
               <a:rPr lang="en-US" sz="800" dirty="0">
                 <a:solidFill>
-                  <a:srgbClr val="4D4D4D"/>
-                </a:solidFill>
-                <a:latin typeface="Meiryo" pitchFamily="34" charset="0"/>
-                <a:ea typeface="Meiryo" pitchFamily="34" charset="-122"/>
-                <a:cs typeface="Meiryo" pitchFamily="34" charset="-120"/>
-              </a:rPr>
-              <a:t>触覚</a:t>
+                  <a:srgbClr val="1A1A1A"/>
+                </a:solidFill>
+                <a:latin typeface="Meiryo" pitchFamily="34" charset="0"/>
+                <a:ea typeface="Meiryo" pitchFamily="34" charset="-122"/>
+                <a:cs typeface="Meiryo" pitchFamily="34" charset="-120"/>
+              </a:rPr>
+              <a:t>登録したパターンを音声指示でCAD作図</a:t>
             </a:r>
             <a:endParaRPr lang="en-US" sz="800" dirty="0"/>
           </a:p>
@@ -7541,8 +7612,8 @@
         </p:nvSpPr>
         <p:spPr>
           <a:xfrm>
-            <a:off x="2048256" y="3931920"/>
-            <a:ext cx="2468880" cy="228600"/>
+            <a:off x="4517136" y="3968496"/>
+            <a:ext cx="384048" cy="228600"/>
           </a:xfrm>
           <a:prstGeom prst="rect">
             <a:avLst/>
@@ -7554,7 +7625,7 @@
           <a:bodyPr wrap="square" lIns="0" tIns="0" rIns="0" bIns="0" rtlCol="0" anchor="ctr"/>
           <a:lstStyle/>
           <a:p>
-            <a:pPr algn="l" indent="0" marL="0">
+            <a:pPr algn="r" indent="0" marL="0">
               <a:lnSpc>
                 <a:spcPct val="115000"/>
               </a:lnSpc>
@@ -7569,7 +7640,7 @@
                 <a:ea typeface="Meiryo" pitchFamily="34" charset="-122"/>
                 <a:cs typeface="Meiryo" pitchFamily="34" charset="-120"/>
               </a:rPr>
-              <a:t>力加減を体験できる訓練シミュレーター</a:t>
+              <a:t>製品</a:t>
             </a:r>
             <a:endParaRPr lang="en-US" sz="800" dirty="0"/>
           </a:p>
@@ -7577,55 +7648,13 @@
       </p:sp>
       <p:sp>
         <p:nvSpPr>
-          <p:cNvPr id="59" name="Text 56"/>
-          <p:cNvSpPr txBox="1"/>
-          <p:nvPr/>
-        </p:nvSpPr>
-        <p:spPr>
-          <a:xfrm>
-            <a:off x="4517136" y="3931920"/>
-            <a:ext cx="384048" cy="228600"/>
-          </a:xfrm>
-          <a:prstGeom prst="rect">
-            <a:avLst/>
-          </a:prstGeom>
-          <a:noFill/>
-          <a:ln/>
-        </p:spPr>
-        <p:txBody>
-          <a:bodyPr wrap="square" lIns="0" tIns="0" rIns="0" bIns="0" rtlCol="0" anchor="ctr"/>
-          <a:lstStyle/>
-          <a:p>
-            <a:pPr algn="r" indent="0" marL="0">
-              <a:lnSpc>
-                <a:spcPct val="115000"/>
-              </a:lnSpc>
-              <a:buNone/>
-            </a:pPr>
-            <a:r>
-              <a:rPr lang="en-US" sz="800" b="1" dirty="0">
-                <a:solidFill>
-                  <a:srgbClr val="1A1A1A"/>
-                </a:solidFill>
-                <a:latin typeface="Meiryo" pitchFamily="34" charset="0"/>
-                <a:ea typeface="Meiryo" pitchFamily="34" charset="-122"/>
-                <a:cs typeface="Meiryo" pitchFamily="34" charset="-120"/>
-              </a:rPr>
-              <a:t>R&amp;D</a:t>
-            </a:r>
-            <a:endParaRPr lang="en-US" sz="800" dirty="0"/>
-          </a:p>
-        </p:txBody>
-      </p:sp>
-      <p:sp>
-        <p:nvSpPr>
-          <p:cNvPr id="60" name="Shape 57"/>
+          <p:cNvPr id="59" name="Shape 56"/>
           <p:cNvSpPr/>
           <p:nvPr/>
         </p:nvSpPr>
         <p:spPr>
           <a:xfrm>
-            <a:off x="365760" y="4160520"/>
+            <a:off x="365760" y="4197096"/>
             <a:ext cx="4572000" cy="228600"/>
           </a:xfrm>
           <a:prstGeom prst="rect">
@@ -7639,13 +7668,13 @@
       </p:sp>
       <p:sp>
         <p:nvSpPr>
-          <p:cNvPr id="61" name="Shape 58"/>
+          <p:cNvPr id="60" name="Shape 57"/>
           <p:cNvSpPr/>
           <p:nvPr/>
         </p:nvSpPr>
         <p:spPr>
           <a:xfrm>
-            <a:off x="365760" y="4160520"/>
+            <a:off x="365760" y="4197096"/>
             <a:ext cx="4572000" cy="0"/>
           </a:xfrm>
           <a:prstGeom prst="line">
@@ -7662,14 +7691,56 @@
       </p:sp>
       <p:sp>
         <p:nvSpPr>
+          <p:cNvPr id="61" name="Text 58"/>
+          <p:cNvSpPr txBox="1"/>
+          <p:nvPr/>
+        </p:nvSpPr>
+        <p:spPr>
+          <a:xfrm>
+            <a:off x="402336" y="4197096"/>
+            <a:ext cx="420624" cy="228600"/>
+          </a:xfrm>
+          <a:prstGeom prst="rect">
+            <a:avLst/>
+          </a:prstGeom>
+          <a:noFill/>
+          <a:ln/>
+        </p:spPr>
+        <p:txBody>
+          <a:bodyPr wrap="square" lIns="0" tIns="0" rIns="0" bIns="0" rtlCol="0" anchor="ctr"/>
+          <a:lstStyle/>
+          <a:p>
+            <a:pPr algn="l" indent="0" marL="0">
+              <a:lnSpc>
+                <a:spcPct val="115000"/>
+              </a:lnSpc>
+              <a:buNone/>
+            </a:pPr>
+            <a:r>
+              <a:rPr lang="en-US" sz="800" dirty="0">
+                <a:solidFill>
+                  <a:srgbClr val="4D4D4D"/>
+                </a:solidFill>
+                <a:latin typeface="Meiryo" pitchFamily="34" charset="0"/>
+                <a:ea typeface="Meiryo" pitchFamily="34" charset="-122"/>
+                <a:cs typeface="Meiryo" pitchFamily="34" charset="-120"/>
+              </a:rPr>
+              <a:t>研究</a:t>
+            </a:r>
+            <a:endParaRPr lang="en-US" sz="800" dirty="0"/>
+          </a:p>
+        </p:txBody>
+      </p:sp>
+      <p:sp>
+        <p:nvSpPr>
           <p:cNvPr id="62" name="Text 59"/>
           <p:cNvSpPr txBox="1"/>
           <p:nvPr/>
         </p:nvSpPr>
         <p:spPr>
           <a:xfrm>
-            <a:off x="402336" y="4160520"/>
-            <a:ext cx="420624" cy="228600"/>
+            <a:off x="822960" y="4197096"/>
+            <a:ext cx="621792" cy="228600"/>
           </a:xfrm>
           <a:prstGeom prst="rect">
             <a:avLst/>
@@ -7688,17 +7759,17 @@
               <a:buNone/>
             </a:pPr>
             <a:r>
-              <a:rPr lang="en-US" sz="800" dirty="0">
-                <a:solidFill>
-                  <a:srgbClr val="4D4D4D"/>
-                </a:solidFill>
-                <a:latin typeface="Meiryo" pitchFamily="34" charset="0"/>
-                <a:ea typeface="Meiryo" pitchFamily="34" charset="-122"/>
-                <a:cs typeface="Meiryo" pitchFamily="34" charset="-120"/>
-              </a:rPr>
-              <a:t>研究</a:t>
-            </a:r>
-            <a:endParaRPr lang="en-US" sz="800" dirty="0"/>
+              <a:rPr lang="en-US" sz="850" b="1" dirty="0">
+                <a:solidFill>
+                  <a:srgbClr val="1A1A1A"/>
+                </a:solidFill>
+                <a:latin typeface="Meiryo" pitchFamily="34" charset="0"/>
+                <a:ea typeface="Meiryo" pitchFamily="34" charset="-122"/>
+                <a:cs typeface="Meiryo" pitchFamily="34" charset="-120"/>
+              </a:rPr>
+              <a:t>HAPTIC</a:t>
+            </a:r>
+            <a:endParaRPr lang="en-US" sz="850" dirty="0"/>
           </a:p>
         </p:txBody>
       </p:sp>
@@ -7710,8 +7781,8 @@
         </p:nvSpPr>
         <p:spPr>
           <a:xfrm>
-            <a:off x="822960" y="4160520"/>
-            <a:ext cx="621792" cy="228600"/>
+            <a:off x="1444752" y="4197096"/>
+            <a:ext cx="603504" cy="228600"/>
           </a:xfrm>
           <a:prstGeom prst="rect">
             <a:avLst/>
@@ -7730,17 +7801,17 @@
               <a:buNone/>
             </a:pPr>
             <a:r>
-              <a:rPr lang="en-US" sz="850" b="1" dirty="0">
-                <a:solidFill>
-                  <a:srgbClr val="1A1A1A"/>
-                </a:solidFill>
-                <a:latin typeface="Meiryo" pitchFamily="34" charset="0"/>
-                <a:ea typeface="Meiryo" pitchFamily="34" charset="-122"/>
-                <a:cs typeface="Meiryo" pitchFamily="34" charset="-120"/>
-              </a:rPr>
-              <a:t>FLOW</a:t>
-            </a:r>
-            <a:endParaRPr lang="en-US" sz="850" dirty="0"/>
+              <a:rPr lang="en-US" sz="800" dirty="0">
+                <a:solidFill>
+                  <a:srgbClr val="4D4D4D"/>
+                </a:solidFill>
+                <a:latin typeface="Meiryo" pitchFamily="34" charset="0"/>
+                <a:ea typeface="Meiryo" pitchFamily="34" charset="-122"/>
+                <a:cs typeface="Meiryo" pitchFamily="34" charset="-120"/>
+              </a:rPr>
+              <a:t>触覚・機械</a:t>
+            </a:r>
+            <a:endParaRPr lang="en-US" sz="800" dirty="0"/>
           </a:p>
         </p:txBody>
       </p:sp>
@@ -7752,8 +7823,8 @@
         </p:nvSpPr>
         <p:spPr>
           <a:xfrm>
-            <a:off x="1444752" y="4160520"/>
-            <a:ext cx="603504" cy="228600"/>
+            <a:off x="2048256" y="4197096"/>
+            <a:ext cx="2468880" cy="228600"/>
           </a:xfrm>
           <a:prstGeom prst="rect">
             <a:avLst/>
@@ -7774,13 +7845,13 @@
             <a:r>
               <a:rPr lang="en-US" sz="800" dirty="0">
                 <a:solidFill>
-                  <a:srgbClr val="4D4D4D"/>
-                </a:solidFill>
-                <a:latin typeface="Meiryo" pitchFamily="34" charset="0"/>
-                <a:ea typeface="Meiryo" pitchFamily="34" charset="-122"/>
-                <a:cs typeface="Meiryo" pitchFamily="34" charset="-120"/>
-              </a:rPr>
-              <a:t>機械</a:t>
+                  <a:srgbClr val="1A1A1A"/>
+                </a:solidFill>
+                <a:latin typeface="Meiryo" pitchFamily="34" charset="0"/>
+                <a:ea typeface="Meiryo" pitchFamily="34" charset="-122"/>
+                <a:cs typeface="Meiryo" pitchFamily="34" charset="-120"/>
+              </a:rPr>
+              <a:t>力加減の訓練シミュレーター／ロボット連携</a:t>
             </a:r>
             <a:endParaRPr lang="en-US" sz="800" dirty="0"/>
           </a:p>
@@ -7794,8 +7865,8 @@
         </p:nvSpPr>
         <p:spPr>
           <a:xfrm>
-            <a:off x="2048256" y="4160520"/>
-            <a:ext cx="2468880" cy="228600"/>
+            <a:off x="4517136" y="4197096"/>
+            <a:ext cx="384048" cy="228600"/>
           </a:xfrm>
           <a:prstGeom prst="rect">
             <a:avLst/>
@@ -7807,14 +7878,14 @@
           <a:bodyPr wrap="square" lIns="0" tIns="0" rIns="0" bIns="0" rtlCol="0" anchor="ctr"/>
           <a:lstStyle/>
           <a:p>
-            <a:pPr algn="l" indent="0" marL="0">
-              <a:lnSpc>
-                <a:spcPct val="115000"/>
-              </a:lnSpc>
-              <a:buNone/>
-            </a:pPr>
-            <a:r>
-              <a:rPr lang="en-US" sz="800" dirty="0">
+            <a:pPr algn="r" indent="0" marL="0">
+              <a:lnSpc>
+                <a:spcPct val="115000"/>
+              </a:lnSpc>
+              <a:buNone/>
+            </a:pPr>
+            <a:r>
+              <a:rPr lang="en-US" sz="800" b="1" dirty="0">
                 <a:solidFill>
                   <a:srgbClr val="1A1A1A"/>
                 </a:solidFill>
@@ -7822,7 +7893,7 @@
                 <a:ea typeface="Meiryo" pitchFamily="34" charset="-122"/>
                 <a:cs typeface="Meiryo" pitchFamily="34" charset="-120"/>
               </a:rPr>
-              <a:t>搬送ロボット・検査AIへ条件を直接渡す</a:t>
+              <a:t>R&amp;D</a:t>
             </a:r>
             <a:endParaRPr lang="en-US" sz="800" dirty="0"/>
           </a:p>
@@ -7830,55 +7901,13 @@
       </p:sp>
       <p:sp>
         <p:nvSpPr>
-          <p:cNvPr id="66" name="Text 63"/>
-          <p:cNvSpPr txBox="1"/>
-          <p:nvPr/>
-        </p:nvSpPr>
-        <p:spPr>
-          <a:xfrm>
-            <a:off x="4517136" y="4160520"/>
-            <a:ext cx="384048" cy="228600"/>
-          </a:xfrm>
-          <a:prstGeom prst="rect">
-            <a:avLst/>
-          </a:prstGeom>
-          <a:noFill/>
-          <a:ln/>
-        </p:spPr>
-        <p:txBody>
-          <a:bodyPr wrap="square" lIns="0" tIns="0" rIns="0" bIns="0" rtlCol="0" anchor="ctr"/>
-          <a:lstStyle/>
-          <a:p>
-            <a:pPr algn="r" indent="0" marL="0">
-              <a:lnSpc>
-                <a:spcPct val="115000"/>
-              </a:lnSpc>
-              <a:buNone/>
-            </a:pPr>
-            <a:r>
-              <a:rPr lang="en-US" sz="800" b="1" dirty="0">
-                <a:solidFill>
-                  <a:srgbClr val="1A1A1A"/>
-                </a:solidFill>
-                <a:latin typeface="Meiryo" pitchFamily="34" charset="0"/>
-                <a:ea typeface="Meiryo" pitchFamily="34" charset="-122"/>
-                <a:cs typeface="Meiryo" pitchFamily="34" charset="-120"/>
-              </a:rPr>
-              <a:t>R&amp;D</a:t>
-            </a:r>
-            <a:endParaRPr lang="en-US" sz="800" dirty="0"/>
-          </a:p>
-        </p:txBody>
-      </p:sp>
-      <p:sp>
-        <p:nvSpPr>
-          <p:cNvPr id="67" name="Shape 64"/>
+          <p:cNvPr id="66" name="Shape 63"/>
           <p:cNvSpPr/>
           <p:nvPr/>
         </p:nvSpPr>
         <p:spPr>
           <a:xfrm>
-            <a:off x="365760" y="4389120"/>
+            <a:off x="365760" y="4425696"/>
             <a:ext cx="4572000" cy="0"/>
           </a:xfrm>
           <a:prstGeom prst="line">
@@ -7895,13 +7924,13 @@
       </p:sp>
       <p:sp>
         <p:nvSpPr>
-          <p:cNvPr id="68" name="rnd"/>
+          <p:cNvPr id="67" name="rnd"/>
           <p:cNvSpPr/>
           <p:nvPr/>
         </p:nvSpPr>
         <p:spPr>
           <a:xfrm>
-            <a:off x="5120640" y="2542032"/>
+            <a:off x="5120640" y="2578608"/>
             <a:ext cx="3657600" cy="1207008"/>
           </a:xfrm>
           <a:prstGeom prst="rect">
@@ -7915,55 +7944,55 @@
       </p:sp>
       <p:sp>
         <p:nvSpPr>
+          <p:cNvPr id="68" name="Text 65"/>
+          <p:cNvSpPr txBox="1"/>
+          <p:nvPr/>
+        </p:nvSpPr>
+        <p:spPr>
+          <a:xfrm>
+            <a:off x="5230368" y="2624328"/>
+            <a:ext cx="3438144" cy="237744"/>
+          </a:xfrm>
+          <a:prstGeom prst="rect">
+            <a:avLst/>
+          </a:prstGeom>
+          <a:noFill/>
+          <a:ln/>
+        </p:spPr>
+        <p:txBody>
+          <a:bodyPr wrap="square" lIns="0" tIns="0" rIns="0" bIns="0" rtlCol="0" anchor="t"/>
+          <a:lstStyle/>
+          <a:p>
+            <a:pPr algn="l" indent="0" marL="0">
+              <a:lnSpc>
+                <a:spcPct val="115000"/>
+              </a:lnSpc>
+              <a:buNone/>
+            </a:pPr>
+            <a:r>
+              <a:rPr lang="en-US" sz="1050" b="1" dirty="0">
+                <a:solidFill>
+                  <a:srgbClr val="FFFFFF"/>
+                </a:solidFill>
+                <a:latin typeface="Meiryo" pitchFamily="34" charset="0"/>
+                <a:ea typeface="Meiryo" pitchFamily="34" charset="-122"/>
+                <a:cs typeface="Meiryo" pitchFamily="34" charset="-120"/>
+              </a:rPr>
+              <a:t>R&amp;D戦略（技術開発）</a:t>
+            </a:r>
+            <a:endParaRPr lang="en-US" sz="1050" dirty="0"/>
+          </a:p>
+        </p:txBody>
+      </p:sp>
+      <p:sp>
+        <p:nvSpPr>
           <p:cNvPr id="69" name="Text 66"/>
           <p:cNvSpPr txBox="1"/>
           <p:nvPr/>
         </p:nvSpPr>
         <p:spPr>
           <a:xfrm>
-            <a:off x="5230368" y="2587752"/>
-            <a:ext cx="3438144" cy="237744"/>
-          </a:xfrm>
-          <a:prstGeom prst="rect">
-            <a:avLst/>
-          </a:prstGeom>
-          <a:noFill/>
-          <a:ln/>
-        </p:spPr>
-        <p:txBody>
-          <a:bodyPr wrap="square" lIns="0" tIns="0" rIns="0" bIns="0" rtlCol="0" anchor="t"/>
-          <a:lstStyle/>
-          <a:p>
-            <a:pPr algn="l" indent="0" marL="0">
-              <a:lnSpc>
-                <a:spcPct val="115000"/>
-              </a:lnSpc>
-              <a:buNone/>
-            </a:pPr>
-            <a:r>
-              <a:rPr lang="en-US" sz="1050" b="1" dirty="0">
-                <a:solidFill>
-                  <a:srgbClr val="FFFFFF"/>
-                </a:solidFill>
-                <a:latin typeface="Meiryo" pitchFamily="34" charset="0"/>
-                <a:ea typeface="Meiryo" pitchFamily="34" charset="-122"/>
-                <a:cs typeface="Meiryo" pitchFamily="34" charset="-120"/>
-              </a:rPr>
-              <a:t>R&amp;D戦略（技術開発）</a:t>
-            </a:r>
-            <a:endParaRPr lang="en-US" sz="1050" dirty="0"/>
-          </a:p>
-        </p:txBody>
-      </p:sp>
-      <p:sp>
-        <p:nvSpPr>
-          <p:cNvPr id="70" name="Text 67"/>
-          <p:cNvSpPr txBox="1"/>
-          <p:nvPr/>
-        </p:nvSpPr>
-        <p:spPr>
-          <a:xfrm>
-            <a:off x="5230368" y="2834640"/>
+            <a:off x="5230368" y="2871216"/>
             <a:ext cx="3438144" cy="896112"/>
           </a:xfrm>
           <a:prstGeom prst="rect">
@@ -8100,7 +8129,7 @@
                 <a:ea typeface="Meiryo" pitchFamily="34" charset="-122"/>
                 <a:cs typeface="Meiryo" pitchFamily="34" charset="-120"/>
               </a:rPr>
-              <a:t>CAD・3D・触覚デバイスはベンダー・大学と共同研究</a:t>
+              <a:t>スマートグラス端末・CAD・3D・触覚はメーカー・大学と</a:t>
             </a:r>
             <a:endParaRPr lang="en-US" sz="850" dirty="0"/>
           </a:p>
@@ -8151,13 +8180,13 @@
       </p:sp>
       <p:sp>
         <p:nvSpPr>
-          <p:cNvPr id="71" name="onboarding"/>
+          <p:cNvPr id="70" name="onboarding"/>
           <p:cNvSpPr/>
           <p:nvPr/>
         </p:nvSpPr>
         <p:spPr>
           <a:xfrm>
-            <a:off x="5120640" y="3840480"/>
+            <a:off x="5120640" y="3877056"/>
             <a:ext cx="3657600" cy="658368"/>
           </a:xfrm>
           <a:prstGeom prst="rect">
@@ -8171,14 +8200,56 @@
       </p:sp>
       <p:sp>
         <p:nvSpPr>
+          <p:cNvPr id="71" name="Text 68"/>
+          <p:cNvSpPr txBox="1"/>
+          <p:nvPr/>
+        </p:nvSpPr>
+        <p:spPr>
+          <a:xfrm>
+            <a:off x="5230368" y="3913632"/>
+            <a:ext cx="3438144" cy="237744"/>
+          </a:xfrm>
+          <a:prstGeom prst="rect">
+            <a:avLst/>
+          </a:prstGeom>
+          <a:noFill/>
+          <a:ln/>
+        </p:spPr>
+        <p:txBody>
+          <a:bodyPr wrap="square" lIns="0" tIns="0" rIns="0" bIns="0" rtlCol="0" anchor="t"/>
+          <a:lstStyle/>
+          <a:p>
+            <a:pPr algn="l" indent="0" marL="0">
+              <a:lnSpc>
+                <a:spcPct val="115000"/>
+              </a:lnSpc>
+              <a:buNone/>
+            </a:pPr>
+            <a:r>
+              <a:rPr lang="en-US" sz="1000" b="1" dirty="0">
+                <a:solidFill>
+                  <a:srgbClr val="1A1A1A"/>
+                </a:solidFill>
+                <a:latin typeface="Meiryo" pitchFamily="34" charset="0"/>
+                <a:ea typeface="Meiryo" pitchFamily="34" charset="-122"/>
+                <a:cs typeface="Meiryo" pitchFamily="34" charset="-120"/>
+              </a:rPr>
+              <a:t>道具以外：導入支援（初年度・約2か月）</a:t>
+            </a:r>
+            <a:endParaRPr lang="en-US" sz="1000" dirty="0"/>
+          </a:p>
+        </p:txBody>
+      </p:sp>
+      <p:sp>
+        <p:nvSpPr>
           <p:cNvPr id="72" name="Text 69"/>
           <p:cNvSpPr txBox="1"/>
           <p:nvPr/>
         </p:nvSpPr>
         <p:spPr>
           <a:xfrm>
-            <a:off x="5230368" y="3877056"/>
-            <a:ext cx="3438144" cy="237744"/>
+            <a:off x="5230368" y="4151376"/>
+            <a:ext cx="3438144" cy="365760"/>
           </a:xfrm>
           <a:prstGeom prst="rect">
             <a:avLst/>
@@ -8197,7 +8268,7 @@
               <a:buNone/>
             </a:pPr>
             <a:r>
-              <a:rPr lang="en-US" sz="1000" b="1" dirty="0">
+              <a:rPr lang="en-US" sz="850" dirty="0">
                 <a:solidFill>
                   <a:srgbClr val="1A1A1A"/>
                 </a:solidFill>
@@ -8205,9 +8276,9 @@
                 <a:ea typeface="Meiryo" pitchFamily="34" charset="-122"/>
                 <a:cs typeface="Meiryo" pitchFamily="34" charset="-120"/>
               </a:rPr>
-              <a:t>道具以外：導入支援（初年度・約2か月）</a:t>
-            </a:r>
-            <a:endParaRPr lang="en-US" sz="1000" dirty="0"/>
+              <a:t>当社の担当者が現場に入り、熟練者への聞き取り・帳票の移行・現場研修まで行う</a:t>
+            </a:r>
+            <a:endParaRPr lang="en-US" sz="850" dirty="0"/>
           </a:p>
         </p:txBody>
       </p:sp>
@@ -8219,8 +8290,8 @@
         </p:nvSpPr>
         <p:spPr>
           <a:xfrm>
-            <a:off x="5230368" y="4114800"/>
-            <a:ext cx="3438144" cy="365760"/>
+            <a:off x="365760" y="4517136"/>
+            <a:ext cx="8412480" cy="274320"/>
           </a:xfrm>
           <a:prstGeom prst="rect">
             <a:avLst/>
@@ -8239,48 +8310,6 @@
               <a:buNone/>
             </a:pPr>
             <a:r>
-              <a:rPr lang="en-US" sz="850" dirty="0">
-                <a:solidFill>
-                  <a:srgbClr val="1A1A1A"/>
-                </a:solidFill>
-                <a:latin typeface="Meiryo" pitchFamily="34" charset="0"/>
-                <a:ea typeface="Meiryo" pitchFamily="34" charset="-122"/>
-                <a:cs typeface="Meiryo" pitchFamily="34" charset="-120"/>
-              </a:rPr>
-              <a:t>当社の担当者が現場に入り、熟練者への聞き取り・帳票の移行・現場研修まで行う</a:t>
-            </a:r>
-            <a:endParaRPr lang="en-US" sz="850" dirty="0"/>
-          </a:p>
-        </p:txBody>
-      </p:sp>
-      <p:sp>
-        <p:nvSpPr>
-          <p:cNvPr id="74" name="Text 71"/>
-          <p:cNvSpPr txBox="1"/>
-          <p:nvPr/>
-        </p:nvSpPr>
-        <p:spPr>
-          <a:xfrm>
-            <a:off x="365760" y="4517136"/>
-            <a:ext cx="8412480" cy="274320"/>
-          </a:xfrm>
-          <a:prstGeom prst="rect">
-            <a:avLst/>
-          </a:prstGeom>
-          <a:noFill/>
-          <a:ln/>
-        </p:spPr>
-        <p:txBody>
-          <a:bodyPr wrap="square" lIns="0" tIns="0" rIns="0" bIns="0" rtlCol="0" anchor="t"/>
-          <a:lstStyle/>
-          <a:p>
-            <a:pPr algn="l" indent="0" marL="0">
-              <a:lnSpc>
-                <a:spcPct val="115000"/>
-              </a:lnSpc>
-              <a:buNone/>
-            </a:pPr>
-            <a:r>
               <a:rPr lang="en-US" sz="800" dirty="0">
                 <a:solidFill>
                   <a:srgbClr val="8C8C8C"/>
@@ -8289,7 +8318,7 @@
                 <a:ea typeface="Meiryo" pitchFamily="34" charset="-122"/>
                 <a:cs typeface="Meiryo" pitchFamily="34" charset="-120"/>
               </a:rPr>
-              <a:t>(1) 内閣府「人工知能基本計画」（令和8年7月14日 閣議決定）「完全なデータの構造化をしない形での現場データの活用を推進する」　(2) 厚生労働省「令和6年度 能力開発基本調査」（2025年6月公表）。R&amp;D行は製品化前の売上を計画に含めない</a:t>
+              <a:t>(1) 内閣府「人工知能基本計画」（令和8年7月14日 閣議決定）「完全なデータの構造化をしない形での現場データの活用を推進する」　(2) 指導役不足59.5%・育成時間なし47.4%：厚生労働省「令和6年度 能力開発基本調査」（2025年6月公表）。常時収録は作業時間・作業エリアに限り、本人同意のもとで行う</a:t>
             </a:r>
             <a:endParaRPr lang="en-US" sz="800" dirty="0"/>
           </a:p>
@@ -9961,7 +9990,7 @@
                 <a:ea typeface="Meiryo" pitchFamily="34" charset="-122"/>
                 <a:cs typeface="Meiryo" pitchFamily="34" charset="-120"/>
               </a:rPr>
-              <a:t>横軸は経過月数。時間単価4,000円（780万円÷1,950h）×月6h×100名＝月240万円。月6hは建設業の書類電子化実績を準用した仮定。年300万円は顧客効果の約1割（価値基準価格）</a:t>
+              <a:t>横軸は経過月数。時間単価4,000円（780万円÷1,950h）×月6h×100名＝月240万円。月6hは日報・進捗報告などの書類作業の削減分で、建設業の書類電子化実績（月6.5h）を準用した仮定</a:t>
             </a:r>
             <a:endParaRPr lang="en-US" sz="800" dirty="0"/>
           </a:p>
@@ -10118,7 +10147,7 @@
                 <a:ea typeface="Meiryo" pitchFamily="34" charset="-122"/>
                 <a:cs typeface="Meiryo" pitchFamily="34" charset="-120"/>
               </a:rPr>
-              <a:t>判断の理由を扱う会社は現れた。連続工程の現場処置を、教材にして届ける会社はまだない</a:t>
+              <a:t>判断の理由を扱う会社は現れた。連続工程の現場で、現物に重ねて渡し、教材にまでする会社はまだない</a:t>
             </a:r>
             <a:endParaRPr lang="en-US" sz="1200" dirty="0"/>
           </a:p>
@@ -10536,13 +10565,13 @@
       </p:sp>
       <p:sp>
         <p:nvSpPr>
-          <p:cNvPr id="17" name="pos-CADDi（組立・図面）"/>
+          <p:cNvPr id="17" name="pos-AR作業支援"/>
           <p:cNvSpPr/>
           <p:nvPr/>
         </p:nvSpPr>
         <p:spPr>
           <a:xfrm>
-            <a:off x="2666390" y="1613916"/>
+            <a:off x="1799539" y="2428646"/>
             <a:ext cx="137160" cy="137160"/>
           </a:xfrm>
           <a:prstGeom prst="ellipse">
@@ -10567,7 +10596,7 @@
         </p:nvSpPr>
         <p:spPr>
           <a:xfrm>
-            <a:off x="2840126" y="1581912"/>
+            <a:off x="208483" y="2396642"/>
             <a:ext cx="1554480" cy="201168"/>
           </a:xfrm>
           <a:prstGeom prst="rect">
@@ -10580,7 +10609,7 @@
           <a:bodyPr wrap="square" lIns="0" tIns="0" rIns="0" bIns="0" rtlCol="0" anchor="ctr"/>
           <a:lstStyle/>
           <a:p>
-            <a:pPr algn="l" indent="0" marL="0">
+            <a:pPr algn="r" indent="0" marL="0">
               <a:lnSpc>
                 <a:spcPct val="115000"/>
               </a:lnSpc>
@@ -10595,7 +10624,7 @@
                 <a:ea typeface="Meiryo" pitchFamily="34" charset="-122"/>
                 <a:cs typeface="Meiryo" pitchFamily="34" charset="-120"/>
               </a:rPr>
-              <a:t>CADDi（組立・図面）</a:t>
+              <a:t>AR作業支援</a:t>
             </a:r>
             <a:endParaRPr lang="en-US" sz="800" dirty="0"/>
           </a:p>
@@ -10603,13 +10632,13 @@
       </p:sp>
       <p:sp>
         <p:nvSpPr>
-          <p:cNvPr id="19" name="pos-Airion（貯めるまで）"/>
+          <p:cNvPr id="19" name="pos-CADDi（組立・図面）"/>
           <p:cNvSpPr/>
           <p:nvPr/>
         </p:nvSpPr>
         <p:spPr>
           <a:xfrm>
-            <a:off x="3099816" y="2255825"/>
+            <a:off x="2666390" y="1613916"/>
             <a:ext cx="137160" cy="137160"/>
           </a:xfrm>
           <a:prstGeom prst="ellipse">
@@ -10634,6 +10663,73 @@
         </p:nvSpPr>
         <p:spPr>
           <a:xfrm>
+            <a:off x="2840126" y="1581912"/>
+            <a:ext cx="1554480" cy="201168"/>
+          </a:xfrm>
+          <a:prstGeom prst="rect">
+            <a:avLst/>
+          </a:prstGeom>
+          <a:noFill/>
+          <a:ln/>
+        </p:spPr>
+        <p:txBody>
+          <a:bodyPr wrap="square" lIns="0" tIns="0" rIns="0" bIns="0" rtlCol="0" anchor="ctr"/>
+          <a:lstStyle/>
+          <a:p>
+            <a:pPr algn="l" indent="0" marL="0">
+              <a:lnSpc>
+                <a:spcPct val="115000"/>
+              </a:lnSpc>
+              <a:buNone/>
+            </a:pPr>
+            <a:r>
+              <a:rPr lang="en-US" sz="800" dirty="0">
+                <a:solidFill>
+                  <a:srgbClr val="1A1A1A"/>
+                </a:solidFill>
+                <a:latin typeface="Meiryo" pitchFamily="34" charset="0"/>
+                <a:ea typeface="Meiryo" pitchFamily="34" charset="-122"/>
+                <a:cs typeface="Meiryo" pitchFamily="34" charset="-120"/>
+              </a:rPr>
+              <a:t>CADDi（組立・図面）</a:t>
+            </a:r>
+            <a:endParaRPr lang="en-US" sz="800" dirty="0"/>
+          </a:p>
+        </p:txBody>
+      </p:sp>
+      <p:sp>
+        <p:nvSpPr>
+          <p:cNvPr id="21" name="pos-Airion（貯めるまで）"/>
+          <p:cNvSpPr/>
+          <p:nvPr/>
+        </p:nvSpPr>
+        <p:spPr>
+          <a:xfrm>
+            <a:off x="3099816" y="2255825"/>
+            <a:ext cx="137160" cy="137160"/>
+          </a:xfrm>
+          <a:prstGeom prst="ellipse">
+            <a:avLst/>
+          </a:prstGeom>
+          <a:solidFill>
+            <a:srgbClr val="FFFFFF"/>
+          </a:solidFill>
+          <a:ln w="15875">
+            <a:solidFill>
+              <a:srgbClr val="1A1A1A"/>
+            </a:solidFill>
+            <a:prstDash val="solid"/>
+          </a:ln>
+        </p:spPr>
+      </p:sp>
+      <p:sp>
+        <p:nvSpPr>
+          <p:cNvPr id="22" name="Text 19"/>
+          <p:cNvSpPr txBox="1"/>
+          <p:nvPr/>
+        </p:nvSpPr>
+        <p:spPr>
+          <a:xfrm>
             <a:off x="3273552" y="2223821"/>
             <a:ext cx="1554480" cy="201168"/>
           </a:xfrm>
@@ -10670,7 +10766,7 @@
       </p:sp>
       <p:sp>
         <p:nvSpPr>
-          <p:cNvPr id="21" name="pos-三現ワークス"/>
+          <p:cNvPr id="23" name="pos-三現ワークス"/>
           <p:cNvSpPr/>
           <p:nvPr/>
         </p:nvSpPr>
@@ -10695,7 +10791,7 @@
       </p:sp>
       <p:sp>
         <p:nvSpPr>
-          <p:cNvPr id="22" name="Text 19"/>
+          <p:cNvPr id="24" name="Text 21"/>
           <p:cNvSpPr txBox="1"/>
           <p:nvPr/>
         </p:nvSpPr>
@@ -10737,7 +10833,7 @@
       </p:sp>
       <p:sp>
         <p:nvSpPr>
-          <p:cNvPr id="23" name="pos-三菱総研 匠AI"/>
+          <p:cNvPr id="25" name="pos-三菱総研 匠AI"/>
           <p:cNvSpPr/>
           <p:nvPr/>
         </p:nvSpPr>
@@ -10762,7 +10858,7 @@
       </p:sp>
       <p:sp>
         <p:nvSpPr>
-          <p:cNvPr id="24" name="Text 21"/>
+          <p:cNvPr id="26" name="Text 23"/>
           <p:cNvSpPr txBox="1"/>
           <p:nvPr/>
         </p:nvSpPr>
@@ -10804,7 +10900,7 @@
       </p:sp>
       <p:sp>
         <p:nvSpPr>
-          <p:cNvPr id="25" name="pos-社内の熟練者（属人）"/>
+          <p:cNvPr id="27" name="pos-社内の熟練者（属人）"/>
           <p:cNvSpPr/>
           <p:nvPr/>
         </p:nvSpPr>
@@ -10829,7 +10925,7 @@
       </p:sp>
       <p:sp>
         <p:nvSpPr>
-          <p:cNvPr id="26" name="Text 23"/>
+          <p:cNvPr id="28" name="Text 25"/>
           <p:cNvSpPr txBox="1"/>
           <p:nvPr/>
         </p:nvSpPr>
@@ -10871,7 +10967,7 @@
       </p:sp>
       <p:sp>
         <p:nvSpPr>
-          <p:cNvPr id="27" name="Text 24"/>
+          <p:cNvPr id="29" name="Text 26"/>
           <p:cNvSpPr txBox="1"/>
           <p:nvPr/>
         </p:nvSpPr>
@@ -12161,6 +12257,208 @@
                         <a:buNone/>
                       </a:pPr>
                       <a:r>
+                        <a:rPr lang="en-US" sz="800" dirty="0">
+                          <a:solidFill>
+                            <a:srgbClr val="1A1A1A"/>
+                          </a:solidFill>
+                          <a:latin typeface="Meiryo" pitchFamily="34" charset="0"/>
+                          <a:ea typeface="Meiryo" pitchFamily="34" charset="-122"/>
+                          <a:cs typeface="Meiryo" pitchFamily="34" charset="-120"/>
+                        </a:rPr>
+                        <a:t>AR作業支援（各社）</a:t>
+                      </a:r>
+                      <a:endParaRPr lang="en-US" sz="800" dirty="0">
+                        <a:latin typeface="Meiryo" charset="0"/>
+                        <a:ea typeface="Meiryo" charset="0"/>
+                        <a:cs typeface="Meiryo" charset="0"/>
+                      </a:endParaRPr>
+                    </a:p>
+                  </a:txBody>
+                  <a:tcPr marL="54864" marR="54864" marT="18288" marB="18288" anchor="ctr">
+                    <a:lnL w="0" cap="flat" cmpd="sng" algn="ctr">
+                      <a:noFill/>
+                    </a:lnL>
+                    <a:lnR w="0" cap="flat" cmpd="sng" algn="ctr">
+                      <a:noFill/>
+                    </a:lnR>
+                    <a:lnT w="0" cap="flat" cmpd="sng" algn="ctr">
+                      <a:noFill/>
+                    </a:lnT>
+                    <a:lnB w="9525" cap="flat" cmpd="sng" algn="ctr">
+                      <a:solidFill>
+                        <a:srgbClr val="BFBFBF"/>
+                      </a:solidFill>
+                      <a:prstDash val="solid"/>
+                      <a:round/>
+                      <a:headEnd type="none" w="med" len="med"/>
+                      <a:tailEnd type="none" w="med" len="med"/>
+                    </a:lnB>
+                    <a:solidFill>
+                      <a:srgbClr val="FFFFFF"/>
+                    </a:solidFill>
+                  </a:tcPr>
+                </a:tc>
+                <a:tc>
+                  <a:txBody>
+                    <a:bodyPr/>
+                    <a:lstStyle/>
+                    <a:p>
+                      <a:pPr algn="l" indent="0" marL="0">
+                        <a:buNone/>
+                      </a:pPr>
+                      <a:r>
+                        <a:rPr lang="en-US" sz="800" dirty="0">
+                          <a:solidFill>
+                            <a:srgbClr val="1A1A1A"/>
+                          </a:solidFill>
+                          <a:latin typeface="Meiryo" pitchFamily="34" charset="0"/>
+                          <a:ea typeface="Meiryo" pitchFamily="34" charset="-122"/>
+                          <a:cs typeface="Meiryo" pitchFamily="34" charset="-120"/>
+                        </a:rPr>
+                        <a:t>×</a:t>
+                      </a:r>
+                      <a:endParaRPr lang="en-US" sz="800" dirty="0">
+                        <a:latin typeface="Meiryo" charset="0"/>
+                        <a:ea typeface="Meiryo" charset="0"/>
+                        <a:cs typeface="Meiryo" charset="0"/>
+                      </a:endParaRPr>
+                    </a:p>
+                  </a:txBody>
+                  <a:tcPr marL="54864" marR="54864" marT="18288" marB="18288" anchor="ctr">
+                    <a:lnL w="0" cap="flat" cmpd="sng" algn="ctr">
+                      <a:noFill/>
+                    </a:lnL>
+                    <a:lnR w="0" cap="flat" cmpd="sng" algn="ctr">
+                      <a:noFill/>
+                    </a:lnR>
+                    <a:lnT w="0" cap="flat" cmpd="sng" algn="ctr">
+                      <a:noFill/>
+                    </a:lnT>
+                    <a:lnB w="9525" cap="flat" cmpd="sng" algn="ctr">
+                      <a:solidFill>
+                        <a:srgbClr val="BFBFBF"/>
+                      </a:solidFill>
+                      <a:prstDash val="solid"/>
+                      <a:round/>
+                      <a:headEnd type="none" w="med" len="med"/>
+                      <a:tailEnd type="none" w="med" len="med"/>
+                    </a:lnB>
+                    <a:solidFill>
+                      <a:srgbClr val="FFFFFF"/>
+                    </a:solidFill>
+                  </a:tcPr>
+                </a:tc>
+                <a:tc>
+                  <a:txBody>
+                    <a:bodyPr/>
+                    <a:lstStyle/>
+                    <a:p>
+                      <a:pPr algn="l" indent="0" marL="0">
+                        <a:buNone/>
+                      </a:pPr>
+                      <a:r>
+                        <a:rPr lang="en-US" sz="800" dirty="0">
+                          <a:solidFill>
+                            <a:srgbClr val="1A1A1A"/>
+                          </a:solidFill>
+                          <a:latin typeface="Meiryo" pitchFamily="34" charset="0"/>
+                          <a:ea typeface="Meiryo" pitchFamily="34" charset="-122"/>
+                          <a:cs typeface="Meiryo" pitchFamily="34" charset="-120"/>
+                        </a:rPr>
+                        <a:t>△ 手順表示</a:t>
+                      </a:r>
+                      <a:endParaRPr lang="en-US" sz="800" dirty="0">
+                        <a:latin typeface="Meiryo" charset="0"/>
+                        <a:ea typeface="Meiryo" charset="0"/>
+                        <a:cs typeface="Meiryo" charset="0"/>
+                      </a:endParaRPr>
+                    </a:p>
+                  </a:txBody>
+                  <a:tcPr marL="54864" marR="54864" marT="18288" marB="18288" anchor="ctr">
+                    <a:lnL w="0" cap="flat" cmpd="sng" algn="ctr">
+                      <a:noFill/>
+                    </a:lnL>
+                    <a:lnR w="0" cap="flat" cmpd="sng" algn="ctr">
+                      <a:noFill/>
+                    </a:lnR>
+                    <a:lnT w="0" cap="flat" cmpd="sng" algn="ctr">
+                      <a:noFill/>
+                    </a:lnT>
+                    <a:lnB w="9525" cap="flat" cmpd="sng" algn="ctr">
+                      <a:solidFill>
+                        <a:srgbClr val="BFBFBF"/>
+                      </a:solidFill>
+                      <a:prstDash val="solid"/>
+                      <a:round/>
+                      <a:headEnd type="none" w="med" len="med"/>
+                      <a:tailEnd type="none" w="med" len="med"/>
+                    </a:lnB>
+                    <a:solidFill>
+                      <a:srgbClr val="FFFFFF"/>
+                    </a:solidFill>
+                  </a:tcPr>
+                </a:tc>
+                <a:tc>
+                  <a:txBody>
+                    <a:bodyPr/>
+                    <a:lstStyle/>
+                    <a:p>
+                      <a:pPr algn="l" indent="0" marL="0">
+                        <a:buNone/>
+                      </a:pPr>
+                      <a:r>
+                        <a:rPr lang="en-US" sz="800" dirty="0">
+                          <a:solidFill>
+                            <a:srgbClr val="1A1A1A"/>
+                          </a:solidFill>
+                          <a:latin typeface="Meiryo" pitchFamily="34" charset="0"/>
+                          <a:ea typeface="Meiryo" pitchFamily="34" charset="-122"/>
+                          <a:cs typeface="Meiryo" pitchFamily="34" charset="-120"/>
+                        </a:rPr>
+                        <a:t>業種横断</a:t>
+                      </a:r>
+                      <a:endParaRPr lang="en-US" sz="800" dirty="0">
+                        <a:latin typeface="Meiryo" charset="0"/>
+                        <a:ea typeface="Meiryo" charset="0"/>
+                        <a:cs typeface="Meiryo" charset="0"/>
+                      </a:endParaRPr>
+                    </a:p>
+                  </a:txBody>
+                  <a:tcPr marL="54864" marR="54864" marT="18288" marB="18288" anchor="ctr">
+                    <a:lnL w="0" cap="flat" cmpd="sng" algn="ctr">
+                      <a:noFill/>
+                    </a:lnL>
+                    <a:lnR w="0" cap="flat" cmpd="sng" algn="ctr">
+                      <a:noFill/>
+                    </a:lnR>
+                    <a:lnT w="0" cap="flat" cmpd="sng" algn="ctr">
+                      <a:noFill/>
+                    </a:lnT>
+                    <a:lnB w="9525" cap="flat" cmpd="sng" algn="ctr">
+                      <a:solidFill>
+                        <a:srgbClr val="BFBFBF"/>
+                      </a:solidFill>
+                      <a:prstDash val="solid"/>
+                      <a:round/>
+                      <a:headEnd type="none" w="med" len="med"/>
+                      <a:tailEnd type="none" w="med" len="med"/>
+                    </a:lnB>
+                    <a:solidFill>
+                      <a:srgbClr val="FFFFFF"/>
+                    </a:solidFill>
+                  </a:tcPr>
+                </a:tc>
+              </a:tr>
+              <a:tr h="246888">
+                <a:tc>
+                  <a:txBody>
+                    <a:bodyPr/>
+                    <a:lstStyle/>
+                    <a:p>
+                      <a:pPr algn="l" indent="0" marL="0">
+                        <a:buNone/>
+                      </a:pPr>
+                      <a:r>
                         <a:rPr lang="en-US" sz="800" b="1" dirty="0">
                           <a:solidFill>
                             <a:srgbClr val="1A1A1A"/>
@@ -12225,7 +12523,7 @@
                           <a:ea typeface="Meiryo" pitchFamily="34" charset="-122"/>
                           <a:cs typeface="Meiryo" pitchFamily="34" charset="-120"/>
                         </a:rPr>
-                        <a:t>○ 音声で一言</a:t>
+                        <a:t>○ 常時収録</a:t>
                       </a:r>
                       <a:endParaRPr lang="en-US" sz="800" dirty="0">
                         <a:latin typeface="Meiryo" charset="0"/>
@@ -12281,7 +12579,7 @@
                           <a:ea typeface="Meiryo" pitchFamily="34" charset="-122"/>
                           <a:cs typeface="Meiryo" pitchFamily="34" charset="-120"/>
                         </a:rPr>
-                        <a:t>○ 当社が制作</a:t>
+                        <a:t>○ 現物照合＋教材</a:t>
                       </a:r>
                       <a:endParaRPr lang="en-US" sz="800" dirty="0">
                         <a:latin typeface="Meiryo" charset="0"/>
@@ -12383,13 +12681,13 @@
       </p:graphicFrame>
       <p:sp>
         <p:nvSpPr>
-          <p:cNvPr id="29" name="threat"/>
+          <p:cNvPr id="31" name="threat"/>
           <p:cNvSpPr/>
           <p:nvPr/>
         </p:nvSpPr>
         <p:spPr>
           <a:xfrm>
-            <a:off x="4526280" y="3145536"/>
+            <a:off x="4526280" y="3374136"/>
             <a:ext cx="4251960" cy="603504"/>
           </a:xfrm>
           <a:prstGeom prst="rect">
@@ -12403,13 +12701,13 @@
       </p:sp>
       <p:sp>
         <p:nvSpPr>
-          <p:cNvPr id="30" name="Text 26"/>
+          <p:cNvPr id="32" name="Text 28"/>
           <p:cNvSpPr txBox="1"/>
           <p:nvPr/>
         </p:nvSpPr>
         <p:spPr>
           <a:xfrm>
-            <a:off x="4636008" y="3145536"/>
+            <a:off x="4636008" y="3374136"/>
             <a:ext cx="4032504" cy="603504"/>
           </a:xfrm>
           <a:prstGeom prst="rect">
@@ -12511,14 +12809,14 @@
       </p:sp>
       <p:sp>
         <p:nvSpPr>
-          <p:cNvPr id="31" name="Text 27"/>
+          <p:cNvPr id="33" name="Text 29"/>
           <p:cNvSpPr txBox="1"/>
           <p:nvPr/>
         </p:nvSpPr>
         <p:spPr>
           <a:xfrm>
-            <a:off x="4526280" y="3822192"/>
-            <a:ext cx="4251960" cy="457200"/>
+            <a:off x="4526280" y="4014216"/>
+            <a:ext cx="4251960" cy="420624"/>
           </a:xfrm>
           <a:prstGeom prst="rect">
             <a:avLst/>
@@ -12535,12 +12833,12 @@
                 <a:spcPct val="115000"/>
               </a:lnSpc>
               <a:spcAft>
-                <a:spcPts val="200"/>
+                <a:spcPts val="100"/>
               </a:spcAft>
               <a:buNone/>
             </a:pPr>
             <a:r>
-              <a:rPr lang="en-US" sz="850" b="1" dirty="0">
+              <a:rPr lang="en-US" sz="800" b="1" dirty="0">
                 <a:solidFill>
                   <a:srgbClr val="1A1A1A"/>
                 </a:solidFill>
@@ -12555,12 +12853,12 @@
                 <a:spcPct val="115000"/>
               </a:lnSpc>
               <a:spcAft>
-                <a:spcPts val="200"/>
+                <a:spcPts val="100"/>
               </a:spcAft>
               <a:buNone/>
             </a:pPr>
             <a:r>
-              <a:rPr lang="en-US" sz="850" dirty="0">
+              <a:rPr lang="en-US" sz="800" dirty="0">
                 <a:solidFill>
                   <a:srgbClr val="1A1A1A"/>
                 </a:solidFill>
@@ -12570,7 +12868,7 @@
               </a:rPr>
               <a:t>工程の形（連続／組立／施工）×規模で区分し、中堅の電線工場を狙う</a:t>
             </a:r>
-            <a:endParaRPr lang="en-US" sz="850" dirty="0"/>
+            <a:endParaRPr lang="en-US" sz="800" dirty="0"/>
           </a:p>
           <a:p>
             <a:pPr algn="l" indent="0" marL="0">
@@ -12578,12 +12876,12 @@
                 <a:spcPct val="115000"/>
               </a:lnSpc>
               <a:spcAft>
-                <a:spcPts val="200"/>
+                <a:spcPts val="100"/>
               </a:spcAft>
               <a:buNone/>
             </a:pPr>
             <a:r>
-              <a:rPr lang="en-US" sz="850" b="1" dirty="0">
+              <a:rPr lang="en-US" sz="800" b="1" dirty="0">
                 <a:solidFill>
                   <a:srgbClr val="1A1A1A"/>
                 </a:solidFill>
@@ -12598,12 +12896,12 @@
                 <a:spcPct val="115000"/>
               </a:lnSpc>
               <a:spcAft>
-                <a:spcPts val="200"/>
+                <a:spcPts val="100"/>
               </a:spcAft>
               <a:buNone/>
             </a:pPr>
             <a:r>
-              <a:rPr lang="en-US" sz="850" dirty="0">
+              <a:rPr lang="en-US" sz="800" dirty="0">
                 <a:solidFill>
                   <a:srgbClr val="1A1A1A"/>
                 </a:solidFill>
@@ -12613,20 +12911,20 @@
               </a:rPr>
               <a:t>ニッチャー（コトラー）×差別化集中（ポーター）。大手の内製は個別開発で中堅に届かない</a:t>
             </a:r>
-            <a:endParaRPr lang="en-US" sz="850" dirty="0"/>
-          </a:p>
-        </p:txBody>
-      </p:sp>
-      <p:sp>
-        <p:nvSpPr>
-          <p:cNvPr id="32" name="Text 28"/>
+            <a:endParaRPr lang="en-US" sz="800" dirty="0"/>
+          </a:p>
+        </p:txBody>
+      </p:sp>
+      <p:sp>
+        <p:nvSpPr>
+          <p:cNvPr id="34" name="Text 30"/>
           <p:cNvSpPr txBox="1"/>
           <p:nvPr/>
         </p:nvSpPr>
         <p:spPr>
           <a:xfrm>
-            <a:off x="365760" y="4553712"/>
-            <a:ext cx="8412480" cy="256032"/>
+            <a:off x="365760" y="4608576"/>
+            <a:ext cx="8412480" cy="219456"/>
           </a:xfrm>
           <a:prstGeom prst="rect">
             <a:avLst/>

</xml_diff>

<commit_message>
Frame the solution as a 3-stage path to physical AI
Slide 3 now starts from continuous first-person video and conversation
(smart glasses or helmet cameras): stage 1 automates records, photo
extraction and daily reports so supervisors can check remotely;
stage 2 checks work against drawings and procedures and generates
step-by-step explainer videos; stage 3 trains AI on the accumulated
work data for robots. The R&D box now says the value is understanding,
not recording: field-experienced people label what matters and keep
the review loop running. The supplementary note maps the referenced
physical-AI article to the design.

Co-Authored-By: Claude Opus 5.5 <noreply@anthropic.com>
Claude-Session: https://claude.ai/code/session_01Lvjvqoc8h4yHt4F4M6n1V9
</commit_message>
<xml_diff>
--- a/deck/セルフマネジメント課題_事業構想プレゼン.pptx
+++ b/deck/セルフマネジメント課題_事業構想プレゼン.pptx
@@ -2225,8 +2225,8 @@
             <a:r>
               <a:rPr lang="en-US" dirty="0"/>
               <a:t>【2:00 - 3:30】
-要約：引退した熟練者が隣で教えてくれる現場を、スマートグラスでつくる
-設問①、解決策です。目指すのは、引退した熟練者が隣で教えてくれるような現場で、その道具がスマートグラスです。一つ目、記録は自動です。作業中の会話と、作業対象の画像をグラスが常時収録します。熟練者は記録のために何もしなくてよい。構造化を現場に求めない設計で、国の人工知能基本計画の方針とも一致します。二つ目、生成AIが会話と画像から、条件・処置・理由を取り出し、ロットや設備のデータ、図面と紐づけます。三つ目、渡す相手は三つです。若手には、グラス越しに図面や作業手順を現物に重ね、違いがあれば知らせます。管理者には、会話と画像から作業内容を判定し、進捗を自動で報告します。日報を書く手間が減り、報告が早くなり、管理者は現場を見に行かなくても状況が分かります。そして後からは、勘どころを音声番組や動画、研修資料にして当社が作って届けます。指導役が足りない事業所は59.5%、育成の時間がない事業所は47.4%あるからです。端末は市販のものを使い、当社は中身とアプリに集中します。常時収録は、作業時間と作業エリアに限り、本人の同意のもとで行います。</a:t>
+要約：一人称の作業データを撮り続け、報告を自動にし、人とAIの教材にする
+設問①、解決策です。目指すのは、引退した熟練者が隣で教えてくれるような現場です。道具はスマートグラスやヘルメットカメラです。作業者の一人称の動画と会話を、常に撮り続けます。記録のために写真を撮ったり、入力したりする必要はありません。生成AIが映像と会話から、条件・処置・理由を取り出し、ロットや設備のデータ、図面と紐づけます。使い道は三つです。若手には、図面や作業手順を現物に重ねて、違いを知らせます。管理者には、報告書の手順に沿って写真を抜き出し、当日の作業報告書を自動で作ります。現場代理人が立会に行けなくても、遠隔で確認できます。そして後からは、勘どころを教材にして当社が届けます。これを3段階で進めます。まず記録と報告の自動化、次に図面との照合と品質管理、手順ごとの解説動画の自動生成。最後に、蓄積した一人称の動画で作業そのものをAIに学ばせ、ロボットに渡すフィジカルAIへ進みます。ここで大事なのは、記録することと理解することは違う、という点です。映像のどの場面が重要かを見分けられるのは、現場を知る人です。当社は、現場経験者が映像に意味を付け、人のレビューで学習を回し続ける仕組みを作ります。常時収録は、作業時間と作業エリアに限り、本人の同意のもとで行います。</a:t>
             </a:r>
             <a:endParaRPr lang="en-US" dirty="0"/>
           </a:p>
@@ -5452,7 +5452,7 @@
                 <a:ea typeface="Meiryo" pitchFamily="34" charset="-122"/>
                 <a:cs typeface="Meiryo" pitchFamily="34" charset="-120"/>
               </a:rPr>
-              <a:t>スマートグラスで、記録と報告は自動に。図面と手順は現物に重ねて照合し、教材は当社が作る</a:t>
+              <a:t>一人称の動画と会話を撮り続け、報告は自動に。データは人の教材になり、やがてフィジカルAIの先生になる</a:t>
             </a:r>
             <a:endParaRPr lang="en-US" sz="1200" dirty="0"/>
           </a:p>
@@ -5466,8 +5466,8 @@
         </p:nvSpPr>
         <p:spPr>
           <a:xfrm>
-            <a:off x="365760" y="1024128"/>
-            <a:ext cx="2578608" cy="1463040"/>
+            <a:off x="365760" y="1005840"/>
+            <a:ext cx="2578608" cy="1298448"/>
           </a:xfrm>
           <a:prstGeom prst="rect">
             <a:avLst/>
@@ -5491,7 +5491,7 @@
         </p:nvSpPr>
         <p:spPr>
           <a:xfrm>
-            <a:off x="365760" y="1024128"/>
+            <a:off x="365760" y="1005840"/>
             <a:ext cx="2578608" cy="274320"/>
           </a:xfrm>
           <a:prstGeom prst="rect">
@@ -5511,7 +5511,7 @@
         </p:nvSpPr>
         <p:spPr>
           <a:xfrm>
-            <a:off x="475488" y="1024128"/>
+            <a:off x="475488" y="1005840"/>
             <a:ext cx="2359152" cy="274320"/>
           </a:xfrm>
           <a:prstGeom prst="rect">
@@ -5556,7 +5556,7 @@
                 <a:ea typeface="Meiryo" pitchFamily="34" charset="-122"/>
                 <a:cs typeface="Meiryo" pitchFamily="34" charset="-120"/>
               </a:rPr>
-              <a:t>　スマートグラス</a:t>
+              <a:t>　グラス・カメラ</a:t>
             </a:r>
             <a:endParaRPr lang="en-US" sz="1100" dirty="0"/>
           </a:p>
@@ -5570,8 +5570,8 @@
         </p:nvSpPr>
         <p:spPr>
           <a:xfrm>
-            <a:off x="475488" y="1353312"/>
-            <a:ext cx="2359152" cy="786384"/>
+            <a:off x="475488" y="1335024"/>
+            <a:ext cx="2359152" cy="621792"/>
           </a:xfrm>
           <a:prstGeom prst="rect">
             <a:avLst/>
@@ -5598,7 +5598,7 @@
                 <a:ea typeface="Meiryo" pitchFamily="34" charset="-122"/>
                 <a:cs typeface="Meiryo" pitchFamily="34" charset="-120"/>
               </a:rPr>
-              <a:t>作業中の会話と、作業対象の画像を常時収録。熟練者は何もしなくてよい</a:t>
+              <a:t>作業者の一人称動画と会話を常時収録。記録のための撮影や入力は不要</a:t>
             </a:r>
             <a:endParaRPr lang="en-US" sz="950" dirty="0"/>
           </a:p>
@@ -5612,7 +5612,7 @@
         </p:nvSpPr>
         <p:spPr>
           <a:xfrm>
-            <a:off x="475488" y="2157984"/>
+            <a:off x="475488" y="1965960"/>
             <a:ext cx="2359152" cy="310896"/>
           </a:xfrm>
           <a:prstGeom prst="rect">
@@ -5657,7 +5657,7 @@
                 <a:ea typeface="Meiryo" pitchFamily="34" charset="-122"/>
                 <a:cs typeface="Meiryo" pitchFamily="34" charset="-120"/>
               </a:rPr>
-              <a:t>市販のスマートグラス。構造化を現場に求めない (1)</a:t>
+              <a:t>市販の端末。構造化を現場に求めない (1)</a:t>
             </a:r>
             <a:endParaRPr lang="en-US" sz="850" dirty="0"/>
           </a:p>
@@ -5671,7 +5671,7 @@
         </p:nvSpPr>
         <p:spPr>
           <a:xfrm>
-            <a:off x="2944368" y="1591056"/>
+            <a:off x="2944368" y="1490472"/>
             <a:ext cx="338328" cy="329184"/>
           </a:xfrm>
           <a:prstGeom prst="rect">
@@ -5713,8 +5713,8 @@
         </p:nvSpPr>
         <p:spPr>
           <a:xfrm>
-            <a:off x="3282696" y="1024128"/>
-            <a:ext cx="2578608" cy="1463040"/>
+            <a:off x="3282696" y="1005840"/>
+            <a:ext cx="2578608" cy="1298448"/>
           </a:xfrm>
           <a:prstGeom prst="rect">
             <a:avLst/>
@@ -5738,7 +5738,7 @@
         </p:nvSpPr>
         <p:spPr>
           <a:xfrm>
-            <a:off x="3282696" y="1024128"/>
+            <a:off x="3282696" y="1005840"/>
             <a:ext cx="2578608" cy="274320"/>
           </a:xfrm>
           <a:prstGeom prst="rect">
@@ -5758,7 +5758,7 @@
         </p:nvSpPr>
         <p:spPr>
           <a:xfrm>
-            <a:off x="3392424" y="1024128"/>
+            <a:off x="3392424" y="1005840"/>
             <a:ext cx="2359152" cy="274320"/>
           </a:xfrm>
           <a:prstGeom prst="rect">
@@ -5817,8 +5817,8 @@
         </p:nvSpPr>
         <p:spPr>
           <a:xfrm>
-            <a:off x="3392424" y="1353312"/>
-            <a:ext cx="2359152" cy="786384"/>
+            <a:off x="3392424" y="1335024"/>
+            <a:ext cx="2359152" cy="621792"/>
           </a:xfrm>
           <a:prstGeom prst="rect">
             <a:avLst/>
@@ -5845,7 +5845,7 @@
                 <a:ea typeface="Meiryo" pitchFamily="34" charset="-122"/>
                 <a:cs typeface="Meiryo" pitchFamily="34" charset="-120"/>
               </a:rPr>
-              <a:t>会話と画像から「条件・処置・理由」を取り出し、ロット・設備データ・図面と紐づける</a:t>
+              <a:t>映像と会話から「条件・処置・理由」を取り出し、ロット・設備データ・図面と紐づける</a:t>
             </a:r>
             <a:endParaRPr lang="en-US" sz="950" dirty="0"/>
           </a:p>
@@ -5859,7 +5859,7 @@
         </p:nvSpPr>
         <p:spPr>
           <a:xfrm>
-            <a:off x="3392424" y="2157984"/>
+            <a:off x="3392424" y="1965960"/>
             <a:ext cx="2359152" cy="310896"/>
           </a:xfrm>
           <a:prstGeom prst="rect">
@@ -5918,7 +5918,7 @@
         </p:nvSpPr>
         <p:spPr>
           <a:xfrm>
-            <a:off x="5861304" y="1591056"/>
+            <a:off x="5861304" y="1490472"/>
             <a:ext cx="338328" cy="329184"/>
           </a:xfrm>
           <a:prstGeom prst="rect">
@@ -5960,8 +5960,8 @@
         </p:nvSpPr>
         <p:spPr>
           <a:xfrm>
-            <a:off x="6199632" y="1024128"/>
-            <a:ext cx="2578608" cy="1463040"/>
+            <a:off x="6199632" y="1005840"/>
+            <a:ext cx="2578608" cy="1298448"/>
           </a:xfrm>
           <a:prstGeom prst="rect">
             <a:avLst/>
@@ -5985,7 +5985,7 @@
         </p:nvSpPr>
         <p:spPr>
           <a:xfrm>
-            <a:off x="6199632" y="1024128"/>
+            <a:off x="6199632" y="1005840"/>
             <a:ext cx="2578608" cy="274320"/>
           </a:xfrm>
           <a:prstGeom prst="rect">
@@ -6005,7 +6005,7 @@
         </p:nvSpPr>
         <p:spPr>
           <a:xfrm>
-            <a:off x="6309360" y="1024128"/>
+            <a:off x="6309360" y="1005840"/>
             <a:ext cx="2359152" cy="274320"/>
           </a:xfrm>
           <a:prstGeom prst="rect">
@@ -6064,8 +6064,8 @@
         </p:nvSpPr>
         <p:spPr>
           <a:xfrm>
-            <a:off x="6309360" y="1353312"/>
-            <a:ext cx="2359152" cy="786384"/>
+            <a:off x="6309360" y="1335024"/>
+            <a:ext cx="2359152" cy="621792"/>
           </a:xfrm>
           <a:prstGeom prst="rect">
             <a:avLst/>
@@ -6118,7 +6118,7 @@
                 <a:ea typeface="Meiryo" pitchFamily="34" charset="-122"/>
                 <a:cs typeface="Meiryo" pitchFamily="34" charset="-120"/>
               </a:rPr>
-              <a:t>管理者へ：作業を判定し、進捗を自動で報告</a:t>
+              <a:t>管理者へ：写真を抽出し、報告書を自動作成</a:t>
             </a:r>
             <a:endParaRPr lang="en-US" sz="850" dirty="0"/>
           </a:p>
@@ -6155,7 +6155,7 @@
         </p:nvSpPr>
         <p:spPr>
           <a:xfrm>
-            <a:off x="6309360" y="2157984"/>
+            <a:off x="6309360" y="1965960"/>
             <a:ext cx="2359152" cy="310896"/>
           </a:xfrm>
           <a:prstGeom prst="rect">
@@ -6214,7 +6214,7 @@
         </p:nvSpPr>
         <p:spPr>
           <a:xfrm>
-            <a:off x="365760" y="2578608"/>
+            <a:off x="365760" y="2395728"/>
             <a:ext cx="4572000" cy="219456"/>
           </a:xfrm>
           <a:prstGeom prst="rect">
@@ -6242,7 +6242,7 @@
                 <a:ea typeface="Meiryo" pitchFamily="34" charset="-122"/>
                 <a:cs typeface="Meiryo" pitchFamily="34" charset="-120"/>
               </a:rPr>
-              <a:t>渡し方を増やす（製品戦略：収録と教材化を初年度から、追加機能は年1本ずつ）</a:t>
+              <a:t>3段階で進化する（製品戦略：記録と報告から始め、フィジカルAIへ）</a:t>
             </a:r>
             <a:endParaRPr lang="en-US" sz="950" dirty="0"/>
           </a:p>
@@ -6250,19 +6250,21 @@
       </p:sp>
       <p:sp>
         <p:nvSpPr>
-          <p:cNvPr id="23" name="Shape 20"/>
+          <p:cNvPr id="23" name="stage-1"/>
           <p:cNvSpPr/>
           <p:nvPr/>
         </p:nvSpPr>
         <p:spPr>
           <a:xfrm>
-            <a:off x="365760" y="2825496"/>
-            <a:ext cx="4572000" cy="0"/>
-          </a:xfrm>
-          <a:prstGeom prst="line">
-            <a:avLst/>
-          </a:prstGeom>
-          <a:noFill/>
+            <a:off x="365760" y="2651760"/>
+            <a:ext cx="1463040" cy="1847088"/>
+          </a:xfrm>
+          <a:prstGeom prst="rect">
+            <a:avLst/>
+          </a:prstGeom>
+          <a:solidFill>
+            <a:srgbClr val="FFFFFF"/>
+          </a:solidFill>
           <a:ln w="9525">
             <a:solidFill>
               <a:srgbClr val="BFBFBF"/>
@@ -6273,14 +6275,34 @@
       </p:sp>
       <p:sp>
         <p:nvSpPr>
-          <p:cNvPr id="24" name="Text 21"/>
+          <p:cNvPr id="24" name="Shape 21"/>
+          <p:cNvSpPr/>
+          <p:nvPr/>
+        </p:nvSpPr>
+        <p:spPr>
+          <a:xfrm>
+            <a:off x="365760" y="2651760"/>
+            <a:ext cx="1463040" cy="402336"/>
+          </a:xfrm>
+          <a:prstGeom prst="rect">
+            <a:avLst/>
+          </a:prstGeom>
+          <a:solidFill>
+            <a:srgbClr val="1A1A1A"/>
+          </a:solidFill>
+          <a:ln/>
+        </p:spPr>
+      </p:sp>
+      <p:sp>
+        <p:nvSpPr>
+          <p:cNvPr id="25" name="Text 22"/>
           <p:cNvSpPr txBox="1"/>
           <p:nvPr/>
         </p:nvSpPr>
         <p:spPr>
           <a:xfrm>
-            <a:off x="402336" y="2825496"/>
-            <a:ext cx="420624" cy="228600"/>
+            <a:off x="438912" y="2670048"/>
+            <a:ext cx="1316736" cy="365760"/>
           </a:xfrm>
           <a:prstGeom prst="rect">
             <a:avLst/>
@@ -6301,28 +6323,48 @@
             <a:r>
               <a:rPr lang="en-US" sz="800" dirty="0">
                 <a:solidFill>
-                  <a:srgbClr val="4D4D4D"/>
-                </a:solidFill>
-                <a:latin typeface="Meiryo" pitchFamily="34" charset="0"/>
-                <a:ea typeface="Meiryo" pitchFamily="34" charset="-122"/>
-                <a:cs typeface="Meiryo" pitchFamily="34" charset="-120"/>
-              </a:rPr>
-              <a:t>1年目</a:t>
-            </a:r>
-            <a:endParaRPr lang="en-US" sz="800" dirty="0"/>
+                  <a:srgbClr val="FFFFFF"/>
+                </a:solidFill>
+                <a:latin typeface="Meiryo" pitchFamily="34" charset="0"/>
+                <a:ea typeface="Meiryo" pitchFamily="34" charset="-122"/>
+                <a:cs typeface="Meiryo" pitchFamily="34" charset="-120"/>
+              </a:rPr>
+              <a:t>段階1　1〜2年目</a:t>
+            </a:r>
+            <a:endParaRPr lang="en-US" sz="1400" dirty="0"/>
+          </a:p>
+          <a:p>
+            <a:pPr algn="l" indent="0" marL="0">
+              <a:lnSpc>
+                <a:spcPct val="115000"/>
+              </a:lnSpc>
+              <a:buNone/>
+            </a:pPr>
+            <a:r>
+              <a:rPr lang="en-US" sz="950" b="1" dirty="0">
+                <a:solidFill>
+                  <a:srgbClr val="FFFFFF"/>
+                </a:solidFill>
+                <a:latin typeface="Meiryo" pitchFamily="34" charset="0"/>
+                <a:ea typeface="Meiryo" pitchFamily="34" charset="-122"/>
+                <a:cs typeface="Meiryo" pitchFamily="34" charset="-120"/>
+              </a:rPr>
+              <a:t>記録と報告を自動に</a:t>
+            </a:r>
+            <a:endParaRPr lang="en-US" sz="1400" dirty="0"/>
           </a:p>
         </p:txBody>
       </p:sp>
       <p:sp>
         <p:nvSpPr>
-          <p:cNvPr id="25" name="Text 22"/>
+          <p:cNvPr id="26" name="Text 23"/>
           <p:cNvSpPr txBox="1"/>
           <p:nvPr/>
         </p:nvSpPr>
         <p:spPr>
           <a:xfrm>
-            <a:off x="822960" y="2825496"/>
-            <a:ext cx="621792" cy="228600"/>
+            <a:off x="438912" y="3108960"/>
+            <a:ext cx="1316736" cy="1024128"/>
           </a:xfrm>
           <a:prstGeom prst="rect">
             <a:avLst/>
@@ -6331,17 +6373,20 @@
           <a:ln/>
         </p:spPr>
         <p:txBody>
-          <a:bodyPr wrap="square" lIns="0" tIns="0" rIns="0" bIns="0" rtlCol="0" anchor="ctr"/>
+          <a:bodyPr wrap="square" lIns="0" tIns="0" rIns="0" bIns="0" rtlCol="0" anchor="t"/>
           <a:lstStyle/>
           <a:p>
             <a:pPr algn="l" indent="0" marL="0">
               <a:lnSpc>
                 <a:spcPct val="115000"/>
               </a:lnSpc>
-              <a:buNone/>
-            </a:pPr>
-            <a:r>
-              <a:rPr lang="en-US" sz="850" b="1" dirty="0">
+              <a:spcAft>
+                <a:spcPts val="100"/>
+              </a:spcAft>
+              <a:buNone/>
+            </a:pPr>
+            <a:r>
+              <a:rPr lang="en-US" sz="800" dirty="0">
                 <a:solidFill>
                   <a:srgbClr val="1A1A1A"/>
                 </a:solidFill>
@@ -6349,22 +6394,68 @@
                 <a:ea typeface="Meiryo" pitchFamily="34" charset="-122"/>
                 <a:cs typeface="Meiryo" pitchFamily="34" charset="-120"/>
               </a:rPr>
-              <a:t>基盤</a:t>
-            </a:r>
-            <a:endParaRPr lang="en-US" sz="850" dirty="0"/>
+              <a:t>・一人称動画と会話を常時収録。写真撮影は不要</a:t>
+            </a:r>
+            <a:endParaRPr lang="en-US" sz="800" dirty="0"/>
+          </a:p>
+          <a:p>
+            <a:pPr algn="l" indent="0" marL="0">
+              <a:lnSpc>
+                <a:spcPct val="115000"/>
+              </a:lnSpc>
+              <a:spcAft>
+                <a:spcPts val="100"/>
+              </a:spcAft>
+              <a:buNone/>
+            </a:pPr>
+            <a:r>
+              <a:rPr lang="en-US" sz="800" dirty="0">
+                <a:solidFill>
+                  <a:srgbClr val="1A1A1A"/>
+                </a:solidFill>
+                <a:latin typeface="Meiryo" pitchFamily="34" charset="0"/>
+                <a:ea typeface="Meiryo" pitchFamily="34" charset="-122"/>
+                <a:cs typeface="Meiryo" pitchFamily="34" charset="-120"/>
+              </a:rPr>
+              <a:t>・報告書の手順に沿って写真を抽出し、日報を自動作成</a:t>
+            </a:r>
+            <a:endParaRPr lang="en-US" sz="800" dirty="0"/>
+          </a:p>
+          <a:p>
+            <a:pPr algn="l" indent="0" marL="0">
+              <a:lnSpc>
+                <a:spcPct val="115000"/>
+              </a:lnSpc>
+              <a:spcAft>
+                <a:spcPts val="100"/>
+              </a:spcAft>
+              <a:buNone/>
+            </a:pPr>
+            <a:r>
+              <a:rPr lang="en-US" sz="800" dirty="0">
+                <a:solidFill>
+                  <a:srgbClr val="1A1A1A"/>
+                </a:solidFill>
+                <a:latin typeface="Meiryo" pitchFamily="34" charset="0"/>
+                <a:ea typeface="Meiryo" pitchFamily="34" charset="-122"/>
+                <a:cs typeface="Meiryo" pitchFamily="34" charset="-120"/>
+              </a:rPr>
+              <a:t>・立会できなくても遠隔で確認</a:t>
+            </a:r>
+            <a:endParaRPr lang="en-US" sz="800" dirty="0"/>
           </a:p>
         </p:txBody>
       </p:sp>
       <p:sp>
         <p:nvSpPr>
-          <p:cNvPr id="26" name="Text 23"/>
+          <p:cNvPr id="27" name="Text 24"/>
           <p:cNvSpPr txBox="1"/>
           <p:nvPr/>
         </p:nvSpPr>
         <p:spPr>
           <a:xfrm>
-            <a:off x="1444752" y="2825496"/>
-            <a:ext cx="603504" cy="228600"/>
+            <a:off x="438912" y="4151376"/>
+            <a:ext cx="1316736" cy="310896"/>
           </a:xfrm>
           <a:prstGeom prst="rect">
             <a:avLst/>
@@ -6373,7 +6464,7 @@
           <a:ln/>
         </p:spPr>
         <p:txBody>
-          <a:bodyPr wrap="square" lIns="0" tIns="0" rIns="0" bIns="0" rtlCol="0" anchor="ctr"/>
+          <a:bodyPr wrap="square" lIns="0" tIns="0" rIns="0" bIns="0" rtlCol="0" anchor="t"/>
           <a:lstStyle/>
           <a:p>
             <a:pPr algn="l" indent="0" marL="0">
@@ -6383,7 +6474,7 @@
               <a:buNone/>
             </a:pPr>
             <a:r>
-              <a:rPr lang="en-US" sz="800" dirty="0">
+              <a:rPr lang="en-US" sz="800" b="1" dirty="0">
                 <a:solidFill>
                   <a:srgbClr val="4D4D4D"/>
                 </a:solidFill>
@@ -6391,7 +6482,7 @@
                 <a:ea typeface="Meiryo" pitchFamily="34" charset="-122"/>
                 <a:cs typeface="Meiryo" pitchFamily="34" charset="-120"/>
               </a:rPr>
-              <a:t>収録・報告</a:t>
+              <a:t>基盤・KNACK（教材）</a:t>
             </a:r>
             <a:endParaRPr lang="en-US" sz="800" dirty="0"/>
           </a:p>
@@ -6399,103 +6490,21 @@
       </p:sp>
       <p:sp>
         <p:nvSpPr>
-          <p:cNvPr id="27" name="Text 24"/>
-          <p:cNvSpPr txBox="1"/>
-          <p:nvPr/>
-        </p:nvSpPr>
-        <p:spPr>
-          <a:xfrm>
-            <a:off x="2048256" y="2825496"/>
-            <a:ext cx="2468880" cy="228600"/>
-          </a:xfrm>
-          <a:prstGeom prst="rect">
-            <a:avLst/>
-          </a:prstGeom>
-          <a:noFill/>
-          <a:ln/>
-        </p:spPr>
-        <p:txBody>
-          <a:bodyPr wrap="square" lIns="0" tIns="0" rIns="0" bIns="0" rtlCol="0" anchor="ctr"/>
-          <a:lstStyle/>
-          <a:p>
-            <a:pPr algn="l" indent="0" marL="0">
-              <a:lnSpc>
-                <a:spcPct val="115000"/>
-              </a:lnSpc>
-              <a:buNone/>
-            </a:pPr>
-            <a:r>
-              <a:rPr lang="en-US" sz="800" dirty="0">
-                <a:solidFill>
-                  <a:srgbClr val="1A1A1A"/>
-                </a:solidFill>
-                <a:latin typeface="Meiryo" pitchFamily="34" charset="0"/>
-                <a:ea typeface="Meiryo" pitchFamily="34" charset="-122"/>
-                <a:cs typeface="Meiryo" pitchFamily="34" charset="-120"/>
-              </a:rPr>
-              <a:t>常時収録、進捗の自動報告、事例検索</a:t>
-            </a:r>
-            <a:endParaRPr lang="en-US" sz="800" dirty="0"/>
-          </a:p>
-        </p:txBody>
-      </p:sp>
-      <p:sp>
-        <p:nvSpPr>
-          <p:cNvPr id="28" name="Text 25"/>
-          <p:cNvSpPr txBox="1"/>
-          <p:nvPr/>
-        </p:nvSpPr>
-        <p:spPr>
-          <a:xfrm>
-            <a:off x="4517136" y="2825496"/>
-            <a:ext cx="384048" cy="228600"/>
-          </a:xfrm>
-          <a:prstGeom prst="rect">
-            <a:avLst/>
-          </a:prstGeom>
-          <a:noFill/>
-          <a:ln/>
-        </p:spPr>
-        <p:txBody>
-          <a:bodyPr wrap="square" lIns="0" tIns="0" rIns="0" bIns="0" rtlCol="0" anchor="ctr"/>
-          <a:lstStyle/>
-          <a:p>
-            <a:pPr algn="r" indent="0" marL="0">
-              <a:lnSpc>
-                <a:spcPct val="115000"/>
-              </a:lnSpc>
-              <a:buNone/>
-            </a:pPr>
-            <a:r>
-              <a:rPr lang="en-US" sz="800" dirty="0">
-                <a:solidFill>
-                  <a:srgbClr val="1A1A1A"/>
-                </a:solidFill>
-                <a:latin typeface="Meiryo" pitchFamily="34" charset="0"/>
-                <a:ea typeface="Meiryo" pitchFamily="34" charset="-122"/>
-                <a:cs typeface="Meiryo" pitchFamily="34" charset="-120"/>
-              </a:rPr>
-              <a:t>製品</a:t>
-            </a:r>
-            <a:endParaRPr lang="en-US" sz="800" dirty="0"/>
-          </a:p>
-        </p:txBody>
-      </p:sp>
-      <p:sp>
-        <p:nvSpPr>
-          <p:cNvPr id="29" name="Shape 26"/>
+          <p:cNvPr id="28" name="stage-2"/>
           <p:cNvSpPr/>
           <p:nvPr/>
         </p:nvSpPr>
         <p:spPr>
           <a:xfrm>
-            <a:off x="365760" y="3054096"/>
-            <a:ext cx="4572000" cy="0"/>
-          </a:xfrm>
-          <a:prstGeom prst="line">
-            <a:avLst/>
-          </a:prstGeom>
-          <a:noFill/>
+            <a:off x="1920240" y="2651760"/>
+            <a:ext cx="1463040" cy="1847088"/>
+          </a:xfrm>
+          <a:prstGeom prst="rect">
+            <a:avLst/>
+          </a:prstGeom>
+          <a:solidFill>
+            <a:srgbClr val="FFFFFF"/>
+          </a:solidFill>
           <a:ln w="9525">
             <a:solidFill>
               <a:srgbClr val="BFBFBF"/>
@@ -6506,14 +6515,34 @@
       </p:sp>
       <p:sp>
         <p:nvSpPr>
+          <p:cNvPr id="29" name="Shape 26"/>
+          <p:cNvSpPr/>
+          <p:nvPr/>
+        </p:nvSpPr>
+        <p:spPr>
+          <a:xfrm>
+            <a:off x="1920240" y="2651760"/>
+            <a:ext cx="1463040" cy="402336"/>
+          </a:xfrm>
+          <a:prstGeom prst="rect">
+            <a:avLst/>
+          </a:prstGeom>
+          <a:solidFill>
+            <a:srgbClr val="1A1A1A"/>
+          </a:solidFill>
+          <a:ln/>
+        </p:spPr>
+      </p:sp>
+      <p:sp>
+        <p:nvSpPr>
           <p:cNvPr id="30" name="Text 27"/>
           <p:cNvSpPr txBox="1"/>
           <p:nvPr/>
         </p:nvSpPr>
         <p:spPr>
           <a:xfrm>
-            <a:off x="402336" y="3054096"/>
-            <a:ext cx="420624" cy="228600"/>
+            <a:off x="1993392" y="2670048"/>
+            <a:ext cx="1316736" cy="365760"/>
           </a:xfrm>
           <a:prstGeom prst="rect">
             <a:avLst/>
@@ -6534,15 +6563,35 @@
             <a:r>
               <a:rPr lang="en-US" sz="800" dirty="0">
                 <a:solidFill>
-                  <a:srgbClr val="4D4D4D"/>
-                </a:solidFill>
-                <a:latin typeface="Meiryo" pitchFamily="34" charset="0"/>
-                <a:ea typeface="Meiryo" pitchFamily="34" charset="-122"/>
-                <a:cs typeface="Meiryo" pitchFamily="34" charset="-120"/>
-              </a:rPr>
-              <a:t>1年目</a:t>
-            </a:r>
-            <a:endParaRPr lang="en-US" sz="800" dirty="0"/>
+                  <a:srgbClr val="FFFFFF"/>
+                </a:solidFill>
+                <a:latin typeface="Meiryo" pitchFamily="34" charset="0"/>
+                <a:ea typeface="Meiryo" pitchFamily="34" charset="-122"/>
+                <a:cs typeface="Meiryo" pitchFamily="34" charset="-120"/>
+              </a:rPr>
+              <a:t>段階2　3〜4年目</a:t>
+            </a:r>
+            <a:endParaRPr lang="en-US" sz="1400" dirty="0"/>
+          </a:p>
+          <a:p>
+            <a:pPr algn="l" indent="0" marL="0">
+              <a:lnSpc>
+                <a:spcPct val="115000"/>
+              </a:lnSpc>
+              <a:buNone/>
+            </a:pPr>
+            <a:r>
+              <a:rPr lang="en-US" sz="950" b="1" dirty="0">
+                <a:solidFill>
+                  <a:srgbClr val="FFFFFF"/>
+                </a:solidFill>
+                <a:latin typeface="Meiryo" pitchFamily="34" charset="0"/>
+                <a:ea typeface="Meiryo" pitchFamily="34" charset="-122"/>
+                <a:cs typeface="Meiryo" pitchFamily="34" charset="-120"/>
+              </a:rPr>
+              <a:t>照合して品質を守る</a:t>
+            </a:r>
+            <a:endParaRPr lang="en-US" sz="1400" dirty="0"/>
           </a:p>
         </p:txBody>
       </p:sp>
@@ -6554,8 +6603,8 @@
         </p:nvSpPr>
         <p:spPr>
           <a:xfrm>
-            <a:off x="822960" y="3054096"/>
-            <a:ext cx="621792" cy="228600"/>
+            <a:off x="1993392" y="3108960"/>
+            <a:ext cx="1316736" cy="1024128"/>
           </a:xfrm>
           <a:prstGeom prst="rect">
             <a:avLst/>
@@ -6564,17 +6613,20 @@
           <a:ln/>
         </p:spPr>
         <p:txBody>
-          <a:bodyPr wrap="square" lIns="0" tIns="0" rIns="0" bIns="0" rtlCol="0" anchor="ctr"/>
+          <a:bodyPr wrap="square" lIns="0" tIns="0" rIns="0" bIns="0" rtlCol="0" anchor="t"/>
           <a:lstStyle/>
           <a:p>
             <a:pPr algn="l" indent="0" marL="0">
               <a:lnSpc>
                 <a:spcPct val="115000"/>
               </a:lnSpc>
-              <a:buNone/>
-            </a:pPr>
-            <a:r>
-              <a:rPr lang="en-US" sz="850" b="1" dirty="0">
+              <a:spcAft>
+                <a:spcPts val="100"/>
+              </a:spcAft>
+              <a:buNone/>
+            </a:pPr>
+            <a:r>
+              <a:rPr lang="en-US" sz="800" dirty="0">
                 <a:solidFill>
                   <a:srgbClr val="1A1A1A"/>
                 </a:solidFill>
@@ -6582,9 +6634,55 @@
                 <a:ea typeface="Meiryo" pitchFamily="34" charset="-122"/>
                 <a:cs typeface="Meiryo" pitchFamily="34" charset="-120"/>
               </a:rPr>
-              <a:t>KNACK</a:t>
-            </a:r>
-            <a:endParaRPr lang="en-US" sz="850" dirty="0"/>
+              <a:t>・図面・手順と現物を照合し差異を検出</a:t>
+            </a:r>
+            <a:endParaRPr lang="en-US" sz="800" dirty="0"/>
+          </a:p>
+          <a:p>
+            <a:pPr algn="l" indent="0" marL="0">
+              <a:lnSpc>
+                <a:spcPct val="115000"/>
+              </a:lnSpc>
+              <a:spcAft>
+                <a:spcPts val="100"/>
+              </a:spcAft>
+              <a:buNone/>
+            </a:pPr>
+            <a:r>
+              <a:rPr lang="en-US" sz="800" dirty="0">
+                <a:solidFill>
+                  <a:srgbClr val="1A1A1A"/>
+                </a:solidFill>
+                <a:latin typeface="Meiryo" pitchFamily="34" charset="0"/>
+                <a:ea typeface="Meiryo" pitchFamily="34" charset="-122"/>
+                <a:cs typeface="Meiryo" pitchFamily="34" charset="-120"/>
+              </a:rPr>
+              <a:t>・手順ミスを履歴で後追い確認</a:t>
+            </a:r>
+            <a:endParaRPr lang="en-US" sz="800" dirty="0"/>
+          </a:p>
+          <a:p>
+            <a:pPr algn="l" indent="0" marL="0">
+              <a:lnSpc>
+                <a:spcPct val="115000"/>
+              </a:lnSpc>
+              <a:spcAft>
+                <a:spcPts val="100"/>
+              </a:spcAft>
+              <a:buNone/>
+            </a:pPr>
+            <a:r>
+              <a:rPr lang="en-US" sz="800" dirty="0">
+                <a:solidFill>
+                  <a:srgbClr val="1A1A1A"/>
+                </a:solidFill>
+                <a:latin typeface="Meiryo" pitchFamily="34" charset="0"/>
+                <a:ea typeface="Meiryo" pitchFamily="34" charset="-122"/>
+                <a:cs typeface="Meiryo" pitchFamily="34" charset="-120"/>
+              </a:rPr>
+              <a:t>・手順ごとの解説動画をAIが生成</a:t>
+            </a:r>
+            <a:endParaRPr lang="en-US" sz="800" dirty="0"/>
           </a:p>
         </p:txBody>
       </p:sp>
@@ -6596,8 +6694,8 @@
         </p:nvSpPr>
         <p:spPr>
           <a:xfrm>
-            <a:off x="1444752" y="3054096"/>
-            <a:ext cx="603504" cy="228600"/>
+            <a:off x="1993392" y="4151376"/>
+            <a:ext cx="1316736" cy="310896"/>
           </a:xfrm>
           <a:prstGeom prst="rect">
             <a:avLst/>
@@ -6606,7 +6704,7 @@
           <a:ln/>
         </p:spPr>
         <p:txBody>
-          <a:bodyPr wrap="square" lIns="0" tIns="0" rIns="0" bIns="0" rtlCol="0" anchor="ctr"/>
+          <a:bodyPr wrap="square" lIns="0" tIns="0" rIns="0" bIns="0" rtlCol="0" anchor="t"/>
           <a:lstStyle/>
           <a:p>
             <a:pPr algn="l" indent="0" marL="0">
@@ -6616,7 +6714,7 @@
               <a:buNone/>
             </a:pPr>
             <a:r>
-              <a:rPr lang="en-US" sz="800" dirty="0">
+              <a:rPr lang="en-US" sz="800" b="1" dirty="0">
                 <a:solidFill>
                   <a:srgbClr val="4D4D4D"/>
                 </a:solidFill>
@@ -6624,7 +6722,7 @@
                 <a:ea typeface="Meiryo" pitchFamily="34" charset="-122"/>
                 <a:cs typeface="Meiryo" pitchFamily="34" charset="-120"/>
               </a:rPr>
-              <a:t>教材</a:t>
+              <a:t>SAFE・GLASS・TWIN・DRAW</a:t>
             </a:r>
             <a:endParaRPr lang="en-US" sz="800" dirty="0"/>
           </a:p>
@@ -6632,103 +6730,21 @@
       </p:sp>
       <p:sp>
         <p:nvSpPr>
-          <p:cNvPr id="33" name="Text 30"/>
-          <p:cNvSpPr txBox="1"/>
-          <p:nvPr/>
-        </p:nvSpPr>
-        <p:spPr>
-          <a:xfrm>
-            <a:off x="2048256" y="3054096"/>
-            <a:ext cx="2468880" cy="228600"/>
-          </a:xfrm>
-          <a:prstGeom prst="rect">
-            <a:avLst/>
-          </a:prstGeom>
-          <a:noFill/>
-          <a:ln/>
-        </p:spPr>
-        <p:txBody>
-          <a:bodyPr wrap="square" lIns="0" tIns="0" rIns="0" bIns="0" rtlCol="0" anchor="ctr"/>
-          <a:lstStyle/>
-          <a:p>
-            <a:pPr algn="l" indent="0" marL="0">
-              <a:lnSpc>
-                <a:spcPct val="115000"/>
-              </a:lnSpc>
-              <a:buNone/>
-            </a:pPr>
-            <a:r>
-              <a:rPr lang="en-US" sz="800" dirty="0">
-                <a:solidFill>
-                  <a:srgbClr val="1A1A1A"/>
-                </a:solidFill>
-                <a:latin typeface="Meiryo" pitchFamily="34" charset="0"/>
-                <a:ea typeface="Meiryo" pitchFamily="34" charset="-122"/>
-                <a:cs typeface="Meiryo" pitchFamily="34" charset="-120"/>
-              </a:rPr>
-              <a:t>勘どころの音声番組・動画・研修資料を制作</a:t>
-            </a:r>
-            <a:endParaRPr lang="en-US" sz="800" dirty="0"/>
-          </a:p>
-        </p:txBody>
-      </p:sp>
-      <p:sp>
-        <p:nvSpPr>
-          <p:cNvPr id="34" name="Text 31"/>
-          <p:cNvSpPr txBox="1"/>
-          <p:nvPr/>
-        </p:nvSpPr>
-        <p:spPr>
-          <a:xfrm>
-            <a:off x="4517136" y="3054096"/>
-            <a:ext cx="384048" cy="228600"/>
-          </a:xfrm>
-          <a:prstGeom prst="rect">
-            <a:avLst/>
-          </a:prstGeom>
-          <a:noFill/>
-          <a:ln/>
-        </p:spPr>
-        <p:txBody>
-          <a:bodyPr wrap="square" lIns="0" tIns="0" rIns="0" bIns="0" rtlCol="0" anchor="ctr"/>
-          <a:lstStyle/>
-          <a:p>
-            <a:pPr algn="r" indent="0" marL="0">
-              <a:lnSpc>
-                <a:spcPct val="115000"/>
-              </a:lnSpc>
-              <a:buNone/>
-            </a:pPr>
-            <a:r>
-              <a:rPr lang="en-US" sz="800" dirty="0">
-                <a:solidFill>
-                  <a:srgbClr val="1A1A1A"/>
-                </a:solidFill>
-                <a:latin typeface="Meiryo" pitchFamily="34" charset="0"/>
-                <a:ea typeface="Meiryo" pitchFamily="34" charset="-122"/>
-                <a:cs typeface="Meiryo" pitchFamily="34" charset="-120"/>
-              </a:rPr>
-              <a:t>製品</a:t>
-            </a:r>
-            <a:endParaRPr lang="en-US" sz="800" dirty="0"/>
-          </a:p>
-        </p:txBody>
-      </p:sp>
-      <p:sp>
-        <p:nvSpPr>
-          <p:cNvPr id="35" name="Shape 32"/>
+          <p:cNvPr id="33" name="stage-3"/>
           <p:cNvSpPr/>
           <p:nvPr/>
         </p:nvSpPr>
         <p:spPr>
           <a:xfrm>
-            <a:off x="365760" y="3282696"/>
-            <a:ext cx="4572000" cy="0"/>
-          </a:xfrm>
-          <a:prstGeom prst="line">
-            <a:avLst/>
-          </a:prstGeom>
-          <a:noFill/>
+            <a:off x="3474720" y="2651760"/>
+            <a:ext cx="1463040" cy="1847088"/>
+          </a:xfrm>
+          <a:prstGeom prst="rect">
+            <a:avLst/>
+          </a:prstGeom>
+          <a:solidFill>
+            <a:srgbClr val="F2F2F2"/>
+          </a:solidFill>
           <a:ln w="9525">
             <a:solidFill>
               <a:srgbClr val="BFBFBF"/>
@@ -6739,14 +6755,34 @@
       </p:sp>
       <p:sp>
         <p:nvSpPr>
-          <p:cNvPr id="36" name="Text 33"/>
+          <p:cNvPr id="34" name="Shape 31"/>
+          <p:cNvSpPr/>
+          <p:nvPr/>
+        </p:nvSpPr>
+        <p:spPr>
+          <a:xfrm>
+            <a:off x="3474720" y="2651760"/>
+            <a:ext cx="1463040" cy="402336"/>
+          </a:xfrm>
+          <a:prstGeom prst="rect">
+            <a:avLst/>
+          </a:prstGeom>
+          <a:solidFill>
+            <a:srgbClr val="1A1A1A"/>
+          </a:solidFill>
+          <a:ln/>
+        </p:spPr>
+      </p:sp>
+      <p:sp>
+        <p:nvSpPr>
+          <p:cNvPr id="35" name="Text 32"/>
           <p:cNvSpPr txBox="1"/>
           <p:nvPr/>
         </p:nvSpPr>
         <p:spPr>
           <a:xfrm>
-            <a:off x="402336" y="3282696"/>
-            <a:ext cx="420624" cy="228600"/>
+            <a:off x="3547872" y="2670048"/>
+            <a:ext cx="1316736" cy="365760"/>
           </a:xfrm>
           <a:prstGeom prst="rect">
             <a:avLst/>
@@ -6767,13 +6803,124 @@
             <a:r>
               <a:rPr lang="en-US" sz="800" dirty="0">
                 <a:solidFill>
-                  <a:srgbClr val="4D4D4D"/>
-                </a:solidFill>
-                <a:latin typeface="Meiryo" pitchFamily="34" charset="0"/>
-                <a:ea typeface="Meiryo" pitchFamily="34" charset="-122"/>
-                <a:cs typeface="Meiryo" pitchFamily="34" charset="-120"/>
-              </a:rPr>
-              <a:t>2年目</a:t>
+                  <a:srgbClr val="FFFFFF"/>
+                </a:solidFill>
+                <a:latin typeface="Meiryo" pitchFamily="34" charset="0"/>
+                <a:ea typeface="Meiryo" pitchFamily="34" charset="-122"/>
+                <a:cs typeface="Meiryo" pitchFamily="34" charset="-120"/>
+              </a:rPr>
+              <a:t>段階3　5年目〜</a:t>
+            </a:r>
+            <a:endParaRPr lang="en-US" sz="1400" dirty="0"/>
+          </a:p>
+          <a:p>
+            <a:pPr algn="l" indent="0" marL="0">
+              <a:lnSpc>
+                <a:spcPct val="115000"/>
+              </a:lnSpc>
+              <a:buNone/>
+            </a:pPr>
+            <a:r>
+              <a:rPr lang="en-US" sz="950" b="1" dirty="0">
+                <a:solidFill>
+                  <a:srgbClr val="FFFFFF"/>
+                </a:solidFill>
+                <a:latin typeface="Meiryo" pitchFamily="34" charset="0"/>
+                <a:ea typeface="Meiryo" pitchFamily="34" charset="-122"/>
+                <a:cs typeface="Meiryo" pitchFamily="34" charset="-120"/>
+              </a:rPr>
+              <a:t>作業をAIが学ぶ</a:t>
+            </a:r>
+            <a:endParaRPr lang="en-US" sz="1400" dirty="0"/>
+          </a:p>
+        </p:txBody>
+      </p:sp>
+      <p:sp>
+        <p:nvSpPr>
+          <p:cNvPr id="36" name="Text 33"/>
+          <p:cNvSpPr txBox="1"/>
+          <p:nvPr/>
+        </p:nvSpPr>
+        <p:spPr>
+          <a:xfrm>
+            <a:off x="3547872" y="3108960"/>
+            <a:ext cx="1316736" cy="1024128"/>
+          </a:xfrm>
+          <a:prstGeom prst="rect">
+            <a:avLst/>
+          </a:prstGeom>
+          <a:noFill/>
+          <a:ln/>
+        </p:spPr>
+        <p:txBody>
+          <a:bodyPr wrap="square" lIns="0" tIns="0" rIns="0" bIns="0" rtlCol="0" anchor="t"/>
+          <a:lstStyle/>
+          <a:p>
+            <a:pPr algn="l" indent="0" marL="0">
+              <a:lnSpc>
+                <a:spcPct val="115000"/>
+              </a:lnSpc>
+              <a:spcAft>
+                <a:spcPts val="100"/>
+              </a:spcAft>
+              <a:buNone/>
+            </a:pPr>
+            <a:r>
+              <a:rPr lang="en-US" sz="800" dirty="0">
+                <a:solidFill>
+                  <a:srgbClr val="1A1A1A"/>
+                </a:solidFill>
+                <a:latin typeface="Meiryo" pitchFamily="34" charset="0"/>
+                <a:ea typeface="Meiryo" pitchFamily="34" charset="-122"/>
+                <a:cs typeface="Meiryo" pitchFamily="34" charset="-120"/>
+              </a:rPr>
+              <a:t>・蓄積した一人称動画で作業をAIが学習</a:t>
+            </a:r>
+            <a:endParaRPr lang="en-US" sz="800" dirty="0"/>
+          </a:p>
+          <a:p>
+            <a:pPr algn="l" indent="0" marL="0">
+              <a:lnSpc>
+                <a:spcPct val="115000"/>
+              </a:lnSpc>
+              <a:spcAft>
+                <a:spcPts val="100"/>
+              </a:spcAft>
+              <a:buNone/>
+            </a:pPr>
+            <a:r>
+              <a:rPr lang="en-US" sz="800" dirty="0">
+                <a:solidFill>
+                  <a:srgbClr val="1A1A1A"/>
+                </a:solidFill>
+                <a:latin typeface="Meiryo" pitchFamily="34" charset="0"/>
+                <a:ea typeface="Meiryo" pitchFamily="34" charset="-122"/>
+                <a:cs typeface="Meiryo" pitchFamily="34" charset="-120"/>
+              </a:rPr>
+              <a:t>・学んだ手順をロボット・検査AIへ</a:t>
+            </a:r>
+            <a:endParaRPr lang="en-US" sz="800" dirty="0"/>
+          </a:p>
+          <a:p>
+            <a:pPr algn="l" indent="0" marL="0">
+              <a:lnSpc>
+                <a:spcPct val="115000"/>
+              </a:lnSpc>
+              <a:spcAft>
+                <a:spcPts val="100"/>
+              </a:spcAft>
+              <a:buNone/>
+            </a:pPr>
+            <a:r>
+              <a:rPr lang="en-US" sz="800" dirty="0">
+                <a:solidFill>
+                  <a:srgbClr val="1A1A1A"/>
+                </a:solidFill>
+                <a:latin typeface="Meiryo" pitchFamily="34" charset="0"/>
+                <a:ea typeface="Meiryo" pitchFamily="34" charset="-122"/>
+                <a:cs typeface="Meiryo" pitchFamily="34" charset="-120"/>
+              </a:rPr>
+              <a:t>・力加減は触覚シミュレーターで訓練</a:t>
             </a:r>
             <a:endParaRPr lang="en-US" sz="800" dirty="0"/>
           </a:p>
@@ -6787,8 +6934,8 @@
         </p:nvSpPr>
         <p:spPr>
           <a:xfrm>
-            <a:off x="822960" y="3282696"/>
-            <a:ext cx="621792" cy="228600"/>
+            <a:off x="3547872" y="4151376"/>
+            <a:ext cx="1316736" cy="310896"/>
           </a:xfrm>
           <a:prstGeom prst="rect">
             <a:avLst/>
@@ -6797,7 +6944,7 @@
           <a:ln/>
         </p:spPr>
         <p:txBody>
-          <a:bodyPr wrap="square" lIns="0" tIns="0" rIns="0" bIns="0" rtlCol="0" anchor="ctr"/>
+          <a:bodyPr wrap="square" lIns="0" tIns="0" rIns="0" bIns="0" rtlCol="0" anchor="t"/>
           <a:lstStyle/>
           <a:p>
             <a:pPr algn="l" indent="0" marL="0">
@@ -6807,30 +6954,50 @@
               <a:buNone/>
             </a:pPr>
             <a:r>
-              <a:rPr lang="en-US" sz="850" b="1" dirty="0">
-                <a:solidFill>
-                  <a:srgbClr val="1A1A1A"/>
-                </a:solidFill>
-                <a:latin typeface="Meiryo" pitchFamily="34" charset="0"/>
-                <a:ea typeface="Meiryo" pitchFamily="34" charset="-122"/>
-                <a:cs typeface="Meiryo" pitchFamily="34" charset="-120"/>
-              </a:rPr>
-              <a:t>SAFE</a:t>
-            </a:r>
-            <a:endParaRPr lang="en-US" sz="850" dirty="0"/>
+              <a:rPr lang="en-US" sz="800" b="1" dirty="0">
+                <a:solidFill>
+                  <a:srgbClr val="4D4D4D"/>
+                </a:solidFill>
+                <a:latin typeface="Meiryo" pitchFamily="34" charset="0"/>
+                <a:ea typeface="Meiryo" pitchFamily="34" charset="-122"/>
+                <a:cs typeface="Meiryo" pitchFamily="34" charset="-120"/>
+              </a:rPr>
+              <a:t>HAPTIC・FLOW（R&amp;D）</a:t>
+            </a:r>
+            <a:endParaRPr lang="en-US" sz="800" dirty="0"/>
           </a:p>
         </p:txBody>
       </p:sp>
       <p:sp>
         <p:nvSpPr>
-          <p:cNvPr id="38" name="Text 35"/>
+          <p:cNvPr id="38" name="rnd"/>
+          <p:cNvSpPr/>
+          <p:nvPr/>
+        </p:nvSpPr>
+        <p:spPr>
+          <a:xfrm>
+            <a:off x="5120640" y="2395728"/>
+            <a:ext cx="3657600" cy="1371600"/>
+          </a:xfrm>
+          <a:prstGeom prst="rect">
+            <a:avLst/>
+          </a:prstGeom>
+          <a:solidFill>
+            <a:srgbClr val="1A1A1A"/>
+          </a:solidFill>
+          <a:ln/>
+        </p:spPr>
+      </p:sp>
+      <p:sp>
+        <p:nvSpPr>
+          <p:cNvPr id="39" name="Text 36"/>
           <p:cNvSpPr txBox="1"/>
           <p:nvPr/>
         </p:nvSpPr>
         <p:spPr>
           <a:xfrm>
-            <a:off x="1444752" y="3282696"/>
-            <a:ext cx="603504" cy="228600"/>
+            <a:off x="5230368" y="2441448"/>
+            <a:ext cx="3438144" cy="237744"/>
           </a:xfrm>
           <a:prstGeom prst="rect">
             <a:avLst/>
@@ -6839,7 +7006,7 @@
           <a:ln/>
         </p:spPr>
         <p:txBody>
-          <a:bodyPr wrap="square" lIns="0" tIns="0" rIns="0" bIns="0" rtlCol="0" anchor="ctr"/>
+          <a:bodyPr wrap="square" lIns="0" tIns="0" rIns="0" bIns="0" rtlCol="0" anchor="t"/>
           <a:lstStyle/>
           <a:p>
             <a:pPr algn="l" indent="0" marL="0">
@@ -6849,30 +7016,30 @@
               <a:buNone/>
             </a:pPr>
             <a:r>
-              <a:rPr lang="en-US" sz="800" dirty="0">
-                <a:solidFill>
-                  <a:srgbClr val="4D4D4D"/>
-                </a:solidFill>
-                <a:latin typeface="Meiryo" pitchFamily="34" charset="0"/>
-                <a:ea typeface="Meiryo" pitchFamily="34" charset="-122"/>
-                <a:cs typeface="Meiryo" pitchFamily="34" charset="-120"/>
-              </a:rPr>
-              <a:t>警告</a:t>
-            </a:r>
-            <a:endParaRPr lang="en-US" sz="800" dirty="0"/>
+              <a:rPr lang="en-US" sz="1050" b="1" dirty="0">
+                <a:solidFill>
+                  <a:srgbClr val="FFFFFF"/>
+                </a:solidFill>
+                <a:latin typeface="Meiryo" pitchFamily="34" charset="0"/>
+                <a:ea typeface="Meiryo" pitchFamily="34" charset="-122"/>
+                <a:cs typeface="Meiryo" pitchFamily="34" charset="-120"/>
+              </a:rPr>
+              <a:t>R&amp;D戦略：記録ではなく「理解」をつくる</a:t>
+            </a:r>
+            <a:endParaRPr lang="en-US" sz="1050" dirty="0"/>
           </a:p>
         </p:txBody>
       </p:sp>
       <p:sp>
         <p:nvSpPr>
-          <p:cNvPr id="39" name="Text 36"/>
+          <p:cNvPr id="40" name="Text 37"/>
           <p:cNvSpPr txBox="1"/>
           <p:nvPr/>
         </p:nvSpPr>
         <p:spPr>
           <a:xfrm>
-            <a:off x="2048256" y="3282696"/>
-            <a:ext cx="2468880" cy="228600"/>
+            <a:off x="5230368" y="2688336"/>
+            <a:ext cx="3438144" cy="1042416"/>
           </a:xfrm>
           <a:prstGeom prst="rect">
             <a:avLst/>
@@ -6881,781 +7048,172 @@
           <a:ln/>
         </p:spPr>
         <p:txBody>
-          <a:bodyPr wrap="square" lIns="0" tIns="0" rIns="0" bIns="0" rtlCol="0" anchor="ctr"/>
+          <a:bodyPr wrap="square" lIns="0" tIns="0" rIns="0" bIns="0" rtlCol="0" anchor="t"/>
           <a:lstStyle/>
           <a:p>
             <a:pPr algn="l" indent="0" marL="0">
               <a:lnSpc>
                 <a:spcPct val="115000"/>
               </a:lnSpc>
-              <a:buNone/>
-            </a:pPr>
-            <a:r>
-              <a:rPr lang="en-US" sz="800" dirty="0">
-                <a:solidFill>
-                  <a:srgbClr val="1A1A1A"/>
-                </a:solidFill>
-                <a:latin typeface="Meiryo" pitchFamily="34" charset="0"/>
-                <a:ea typeface="Meiryo" pitchFamily="34" charset="-122"/>
-                <a:cs typeface="Meiryo" pitchFamily="34" charset="-120"/>
-              </a:rPr>
-              <a:t>危険箇所・過去のヒヤリ地点をグラスに表示</a:t>
-            </a:r>
-            <a:endParaRPr lang="en-US" sz="800" dirty="0"/>
+              <a:spcAft>
+                <a:spcPts val="200"/>
+              </a:spcAft>
+              <a:buNone/>
+            </a:pPr>
+            <a:r>
+              <a:rPr lang="en-US" sz="850" dirty="0">
+                <a:solidFill>
+                  <a:srgbClr val="FFFFFF"/>
+                </a:solidFill>
+                <a:latin typeface="Meiryo" pitchFamily="34" charset="0"/>
+                <a:ea typeface="Meiryo" pitchFamily="34" charset="-122"/>
+                <a:cs typeface="Meiryo" pitchFamily="34" charset="-120"/>
+              </a:rPr>
+              <a:t>記録と理解は違う。どの場面が重要かを見分けられるのは、現場を知る人</a:t>
+            </a:r>
+            <a:endParaRPr lang="en-US" sz="850" dirty="0"/>
+          </a:p>
+          <a:p>
+            <a:pPr algn="l" indent="0" marL="0">
+              <a:lnSpc>
+                <a:spcPct val="115000"/>
+              </a:lnSpc>
+              <a:spcAft>
+                <a:spcPts val="200"/>
+              </a:spcAft>
+              <a:buNone/>
+            </a:pPr>
+            <a:r>
+              <a:rPr lang="en-US" sz="850" b="1" dirty="0">
+                <a:solidFill>
+                  <a:srgbClr val="FFFFFF"/>
+                </a:solidFill>
+                <a:latin typeface="Meiryo" pitchFamily="34" charset="0"/>
+                <a:ea typeface="Meiryo" pitchFamily="34" charset="-122"/>
+                <a:cs typeface="Meiryo" pitchFamily="34" charset="-120"/>
+              </a:rPr>
+              <a:t>作らない：</a:t>
+            </a:r>
+            <a:pPr algn="l" indent="0" marL="0">
+              <a:lnSpc>
+                <a:spcPct val="115000"/>
+              </a:lnSpc>
+              <a:spcAft>
+                <a:spcPts val="200"/>
+              </a:spcAft>
+              <a:buNone/>
+            </a:pPr>
+            <a:r>
+              <a:rPr lang="en-US" sz="850" dirty="0">
+                <a:solidFill>
+                  <a:srgbClr val="FFFFFF"/>
+                </a:solidFill>
+                <a:latin typeface="Meiryo" pitchFamily="34" charset="0"/>
+                <a:ea typeface="Meiryo" pitchFamily="34" charset="-122"/>
+                <a:cs typeface="Meiryo" pitchFamily="34" charset="-120"/>
+              </a:rPr>
+              <a:t>映像・音声の記録とAI構造化は汎用技術</a:t>
+            </a:r>
+            <a:endParaRPr lang="en-US" sz="850" dirty="0"/>
+          </a:p>
+          <a:p>
+            <a:pPr algn="l" indent="0" marL="0">
+              <a:lnSpc>
+                <a:spcPct val="115000"/>
+              </a:lnSpc>
+              <a:spcAft>
+                <a:spcPts val="200"/>
+              </a:spcAft>
+              <a:buNone/>
+            </a:pPr>
+            <a:r>
+              <a:rPr lang="en-US" sz="850" b="1" dirty="0">
+                <a:solidFill>
+                  <a:srgbClr val="FFFFFF"/>
+                </a:solidFill>
+                <a:latin typeface="Meiryo" pitchFamily="34" charset="0"/>
+                <a:ea typeface="Meiryo" pitchFamily="34" charset="-122"/>
+                <a:cs typeface="Meiryo" pitchFamily="34" charset="-120"/>
+              </a:rPr>
+              <a:t>作る：</a:t>
+            </a:r>
+            <a:pPr algn="l" indent="0" marL="0">
+              <a:lnSpc>
+                <a:spcPct val="115000"/>
+              </a:lnSpc>
+              <a:spcAft>
+                <a:spcPts val="200"/>
+              </a:spcAft>
+              <a:buNone/>
+            </a:pPr>
+            <a:r>
+              <a:rPr lang="en-US" sz="850" dirty="0">
+                <a:solidFill>
+                  <a:srgbClr val="FFFFFF"/>
+                </a:solidFill>
+                <a:latin typeface="Meiryo" pitchFamily="34" charset="0"/>
+                <a:ea typeface="Meiryo" pitchFamily="34" charset="-122"/>
+                <a:cs typeface="Meiryo" pitchFamily="34" charset="-120"/>
+              </a:rPr>
+              <a:t>現場経験者が映像に意味（手順・重要場面）を付け、人のレビューで学習を回し続ける仕組み</a:t>
+            </a:r>
+            <a:endParaRPr lang="en-US" sz="850" dirty="0"/>
+          </a:p>
+          <a:p>
+            <a:pPr algn="l" indent="0" marL="0">
+              <a:lnSpc>
+                <a:spcPct val="115000"/>
+              </a:lnSpc>
+              <a:spcAft>
+                <a:spcPts val="200"/>
+              </a:spcAft>
+              <a:buNone/>
+            </a:pPr>
+            <a:r>
+              <a:rPr lang="en-US" sz="850" b="1" dirty="0">
+                <a:solidFill>
+                  <a:srgbClr val="FFFFFF"/>
+                </a:solidFill>
+                <a:latin typeface="Meiryo" pitchFamily="34" charset="0"/>
+                <a:ea typeface="Meiryo" pitchFamily="34" charset="-122"/>
+                <a:cs typeface="Meiryo" pitchFamily="34" charset="-120"/>
+              </a:rPr>
+              <a:t>組む：</a:t>
+            </a:r>
+            <a:pPr algn="l" indent="0" marL="0">
+              <a:lnSpc>
+                <a:spcPct val="115000"/>
+              </a:lnSpc>
+              <a:spcAft>
+                <a:spcPts val="200"/>
+              </a:spcAft>
+              <a:buNone/>
+            </a:pPr>
+            <a:r>
+              <a:rPr lang="en-US" sz="850" dirty="0">
+                <a:solidFill>
+                  <a:srgbClr val="FFFFFF"/>
+                </a:solidFill>
+                <a:latin typeface="Meiryo" pitchFamily="34" charset="0"/>
+                <a:ea typeface="Meiryo" pitchFamily="34" charset="-122"/>
+                <a:cs typeface="Meiryo" pitchFamily="34" charset="-120"/>
+              </a:rPr>
+              <a:t>グラス・ヘルメットカメラ・CAD・3Dはメーカー・大学と</a:t>
+            </a:r>
+            <a:endParaRPr lang="en-US" sz="850" dirty="0"/>
           </a:p>
         </p:txBody>
       </p:sp>
       <p:sp>
         <p:nvSpPr>
-          <p:cNvPr id="40" name="Text 37"/>
-          <p:cNvSpPr txBox="1"/>
-          <p:nvPr/>
-        </p:nvSpPr>
-        <p:spPr>
-          <a:xfrm>
-            <a:off x="4517136" y="3282696"/>
-            <a:ext cx="384048" cy="228600"/>
-          </a:xfrm>
-          <a:prstGeom prst="rect">
-            <a:avLst/>
-          </a:prstGeom>
-          <a:noFill/>
-          <a:ln/>
-        </p:spPr>
-        <p:txBody>
-          <a:bodyPr wrap="square" lIns="0" tIns="0" rIns="0" bIns="0" rtlCol="0" anchor="ctr"/>
-          <a:lstStyle/>
-          <a:p>
-            <a:pPr algn="r" indent="0" marL="0">
-              <a:lnSpc>
-                <a:spcPct val="115000"/>
-              </a:lnSpc>
-              <a:buNone/>
-            </a:pPr>
-            <a:r>
-              <a:rPr lang="en-US" sz="800" dirty="0">
-                <a:solidFill>
-                  <a:srgbClr val="1A1A1A"/>
-                </a:solidFill>
-                <a:latin typeface="Meiryo" pitchFamily="34" charset="0"/>
-                <a:ea typeface="Meiryo" pitchFamily="34" charset="-122"/>
-                <a:cs typeface="Meiryo" pitchFamily="34" charset="-120"/>
-              </a:rPr>
-              <a:t>製品</a:t>
-            </a:r>
-            <a:endParaRPr lang="en-US" sz="800" dirty="0"/>
-          </a:p>
-        </p:txBody>
-      </p:sp>
-      <p:sp>
-        <p:nvSpPr>
-          <p:cNvPr id="41" name="Shape 38"/>
+          <p:cNvPr id="41" name="onboarding"/>
           <p:cNvSpPr/>
           <p:nvPr/>
         </p:nvSpPr>
         <p:spPr>
           <a:xfrm>
-            <a:off x="365760" y="3511296"/>
-            <a:ext cx="4572000" cy="0"/>
-          </a:xfrm>
-          <a:prstGeom prst="line">
-            <a:avLst/>
-          </a:prstGeom>
-          <a:noFill/>
-          <a:ln w="9525">
-            <a:solidFill>
-              <a:srgbClr val="BFBFBF"/>
-            </a:solidFill>
-            <a:prstDash val="solid"/>
-          </a:ln>
-        </p:spPr>
-      </p:sp>
-      <p:sp>
-        <p:nvSpPr>
-          <p:cNvPr id="42" name="Text 39"/>
-          <p:cNvSpPr txBox="1"/>
-          <p:nvPr/>
-        </p:nvSpPr>
-        <p:spPr>
-          <a:xfrm>
-            <a:off x="402336" y="3511296"/>
-            <a:ext cx="420624" cy="228600"/>
-          </a:xfrm>
-          <a:prstGeom prst="rect">
-            <a:avLst/>
-          </a:prstGeom>
-          <a:noFill/>
-          <a:ln/>
-        </p:spPr>
-        <p:txBody>
-          <a:bodyPr wrap="square" lIns="0" tIns="0" rIns="0" bIns="0" rtlCol="0" anchor="ctr"/>
-          <a:lstStyle/>
-          <a:p>
-            <a:pPr algn="l" indent="0" marL="0">
-              <a:lnSpc>
-                <a:spcPct val="115000"/>
-              </a:lnSpc>
-              <a:buNone/>
-            </a:pPr>
-            <a:r>
-              <a:rPr lang="en-US" sz="800" dirty="0">
-                <a:solidFill>
-                  <a:srgbClr val="4D4D4D"/>
-                </a:solidFill>
-                <a:latin typeface="Meiryo" pitchFamily="34" charset="0"/>
-                <a:ea typeface="Meiryo" pitchFamily="34" charset="-122"/>
-                <a:cs typeface="Meiryo" pitchFamily="34" charset="-120"/>
-              </a:rPr>
-              <a:t>3年目</a:t>
-            </a:r>
-            <a:endParaRPr lang="en-US" sz="800" dirty="0"/>
-          </a:p>
-        </p:txBody>
-      </p:sp>
-      <p:sp>
-        <p:nvSpPr>
-          <p:cNvPr id="43" name="Text 40"/>
-          <p:cNvSpPr txBox="1"/>
-          <p:nvPr/>
-        </p:nvSpPr>
-        <p:spPr>
-          <a:xfrm>
-            <a:off x="822960" y="3511296"/>
-            <a:ext cx="621792" cy="228600"/>
-          </a:xfrm>
-          <a:prstGeom prst="rect">
-            <a:avLst/>
-          </a:prstGeom>
-          <a:noFill/>
-          <a:ln/>
-        </p:spPr>
-        <p:txBody>
-          <a:bodyPr wrap="square" lIns="0" tIns="0" rIns="0" bIns="0" rtlCol="0" anchor="ctr"/>
-          <a:lstStyle/>
-          <a:p>
-            <a:pPr algn="l" indent="0" marL="0">
-              <a:lnSpc>
-                <a:spcPct val="115000"/>
-              </a:lnSpc>
-              <a:buNone/>
-            </a:pPr>
-            <a:r>
-              <a:rPr lang="en-US" sz="850" b="1" dirty="0">
-                <a:solidFill>
-                  <a:srgbClr val="1A1A1A"/>
-                </a:solidFill>
-                <a:latin typeface="Meiryo" pitchFamily="34" charset="0"/>
-                <a:ea typeface="Meiryo" pitchFamily="34" charset="-122"/>
-                <a:cs typeface="Meiryo" pitchFamily="34" charset="-120"/>
-              </a:rPr>
-              <a:t>GLASS</a:t>
-            </a:r>
-            <a:endParaRPr lang="en-US" sz="850" dirty="0"/>
-          </a:p>
-        </p:txBody>
-      </p:sp>
-      <p:sp>
-        <p:nvSpPr>
-          <p:cNvPr id="44" name="Text 41"/>
-          <p:cNvSpPr txBox="1"/>
-          <p:nvPr/>
-        </p:nvSpPr>
-        <p:spPr>
-          <a:xfrm>
-            <a:off x="1444752" y="3511296"/>
-            <a:ext cx="603504" cy="228600"/>
-          </a:xfrm>
-          <a:prstGeom prst="rect">
-            <a:avLst/>
-          </a:prstGeom>
-          <a:noFill/>
-          <a:ln/>
-        </p:spPr>
-        <p:txBody>
-          <a:bodyPr wrap="square" lIns="0" tIns="0" rIns="0" bIns="0" rtlCol="0" anchor="ctr"/>
-          <a:lstStyle/>
-          <a:p>
-            <a:pPr algn="l" indent="0" marL="0">
-              <a:lnSpc>
-                <a:spcPct val="115000"/>
-              </a:lnSpc>
-              <a:buNone/>
-            </a:pPr>
-            <a:r>
-              <a:rPr lang="en-US" sz="800" dirty="0">
-                <a:solidFill>
-                  <a:srgbClr val="4D4D4D"/>
-                </a:solidFill>
-                <a:latin typeface="Meiryo" pitchFamily="34" charset="0"/>
-                <a:ea typeface="Meiryo" pitchFamily="34" charset="-122"/>
-                <a:cs typeface="Meiryo" pitchFamily="34" charset="-120"/>
-              </a:rPr>
-              <a:t>照合</a:t>
-            </a:r>
-            <a:endParaRPr lang="en-US" sz="800" dirty="0"/>
-          </a:p>
-        </p:txBody>
-      </p:sp>
-      <p:sp>
-        <p:nvSpPr>
-          <p:cNvPr id="45" name="Text 42"/>
-          <p:cNvSpPr txBox="1"/>
-          <p:nvPr/>
-        </p:nvSpPr>
-        <p:spPr>
-          <a:xfrm>
-            <a:off x="2048256" y="3511296"/>
-            <a:ext cx="2468880" cy="228600"/>
-          </a:xfrm>
-          <a:prstGeom prst="rect">
-            <a:avLst/>
-          </a:prstGeom>
-          <a:noFill/>
-          <a:ln/>
-        </p:spPr>
-        <p:txBody>
-          <a:bodyPr wrap="square" lIns="0" tIns="0" rIns="0" bIns="0" rtlCol="0" anchor="ctr"/>
-          <a:lstStyle/>
-          <a:p>
-            <a:pPr algn="l" indent="0" marL="0">
-              <a:lnSpc>
-                <a:spcPct val="115000"/>
-              </a:lnSpc>
-              <a:buNone/>
-            </a:pPr>
-            <a:r>
-              <a:rPr lang="en-US" sz="800" dirty="0">
-                <a:solidFill>
-                  <a:srgbClr val="1A1A1A"/>
-                </a:solidFill>
-                <a:latin typeface="Meiryo" pitchFamily="34" charset="0"/>
-                <a:ea typeface="Meiryo" pitchFamily="34" charset="-122"/>
-                <a:cs typeface="Meiryo" pitchFamily="34" charset="-120"/>
-              </a:rPr>
-              <a:t>図面・作業手順を現物に重ね、差異を検出</a:t>
-            </a:r>
-            <a:endParaRPr lang="en-US" sz="800" dirty="0"/>
-          </a:p>
-        </p:txBody>
-      </p:sp>
-      <p:sp>
-        <p:nvSpPr>
-          <p:cNvPr id="46" name="Text 43"/>
-          <p:cNvSpPr txBox="1"/>
-          <p:nvPr/>
-        </p:nvSpPr>
-        <p:spPr>
-          <a:xfrm>
-            <a:off x="4517136" y="3511296"/>
-            <a:ext cx="384048" cy="228600"/>
-          </a:xfrm>
-          <a:prstGeom prst="rect">
-            <a:avLst/>
-          </a:prstGeom>
-          <a:noFill/>
-          <a:ln/>
-        </p:spPr>
-        <p:txBody>
-          <a:bodyPr wrap="square" lIns="0" tIns="0" rIns="0" bIns="0" rtlCol="0" anchor="ctr"/>
-          <a:lstStyle/>
-          <a:p>
-            <a:pPr algn="r" indent="0" marL="0">
-              <a:lnSpc>
-                <a:spcPct val="115000"/>
-              </a:lnSpc>
-              <a:buNone/>
-            </a:pPr>
-            <a:r>
-              <a:rPr lang="en-US" sz="800" dirty="0">
-                <a:solidFill>
-                  <a:srgbClr val="1A1A1A"/>
-                </a:solidFill>
-                <a:latin typeface="Meiryo" pitchFamily="34" charset="0"/>
-                <a:ea typeface="Meiryo" pitchFamily="34" charset="-122"/>
-                <a:cs typeface="Meiryo" pitchFamily="34" charset="-120"/>
-              </a:rPr>
-              <a:t>製品</a:t>
-            </a:r>
-            <a:endParaRPr lang="en-US" sz="800" dirty="0"/>
-          </a:p>
-        </p:txBody>
-      </p:sp>
-      <p:sp>
-        <p:nvSpPr>
-          <p:cNvPr id="47" name="Shape 44"/>
-          <p:cNvSpPr/>
-          <p:nvPr/>
-        </p:nvSpPr>
-        <p:spPr>
-          <a:xfrm>
-            <a:off x="365760" y="3739896"/>
-            <a:ext cx="4572000" cy="0"/>
-          </a:xfrm>
-          <a:prstGeom prst="line">
-            <a:avLst/>
-          </a:prstGeom>
-          <a:noFill/>
-          <a:ln w="9525">
-            <a:solidFill>
-              <a:srgbClr val="BFBFBF"/>
-            </a:solidFill>
-            <a:prstDash val="solid"/>
-          </a:ln>
-        </p:spPr>
-      </p:sp>
-      <p:sp>
-        <p:nvSpPr>
-          <p:cNvPr id="48" name="Text 45"/>
-          <p:cNvSpPr txBox="1"/>
-          <p:nvPr/>
-        </p:nvSpPr>
-        <p:spPr>
-          <a:xfrm>
-            <a:off x="402336" y="3739896"/>
-            <a:ext cx="420624" cy="228600"/>
-          </a:xfrm>
-          <a:prstGeom prst="rect">
-            <a:avLst/>
-          </a:prstGeom>
-          <a:noFill/>
-          <a:ln/>
-        </p:spPr>
-        <p:txBody>
-          <a:bodyPr wrap="square" lIns="0" tIns="0" rIns="0" bIns="0" rtlCol="0" anchor="ctr"/>
-          <a:lstStyle/>
-          <a:p>
-            <a:pPr algn="l" indent="0" marL="0">
-              <a:lnSpc>
-                <a:spcPct val="115000"/>
-              </a:lnSpc>
-              <a:buNone/>
-            </a:pPr>
-            <a:r>
-              <a:rPr lang="en-US" sz="800" dirty="0">
-                <a:solidFill>
-                  <a:srgbClr val="4D4D4D"/>
-                </a:solidFill>
-                <a:latin typeface="Meiryo" pitchFamily="34" charset="0"/>
-                <a:ea typeface="Meiryo" pitchFamily="34" charset="-122"/>
-                <a:cs typeface="Meiryo" pitchFamily="34" charset="-120"/>
-              </a:rPr>
-              <a:t>4年目</a:t>
-            </a:r>
-            <a:endParaRPr lang="en-US" sz="800" dirty="0"/>
-          </a:p>
-        </p:txBody>
-      </p:sp>
-      <p:sp>
-        <p:nvSpPr>
-          <p:cNvPr id="49" name="Text 46"/>
-          <p:cNvSpPr txBox="1"/>
-          <p:nvPr/>
-        </p:nvSpPr>
-        <p:spPr>
-          <a:xfrm>
-            <a:off x="822960" y="3739896"/>
-            <a:ext cx="621792" cy="228600"/>
-          </a:xfrm>
-          <a:prstGeom prst="rect">
-            <a:avLst/>
-          </a:prstGeom>
-          <a:noFill/>
-          <a:ln/>
-        </p:spPr>
-        <p:txBody>
-          <a:bodyPr wrap="square" lIns="0" tIns="0" rIns="0" bIns="0" rtlCol="0" anchor="ctr"/>
-          <a:lstStyle/>
-          <a:p>
-            <a:pPr algn="l" indent="0" marL="0">
-              <a:lnSpc>
-                <a:spcPct val="115000"/>
-              </a:lnSpc>
-              <a:buNone/>
-            </a:pPr>
-            <a:r>
-              <a:rPr lang="en-US" sz="850" b="1" dirty="0">
-                <a:solidFill>
-                  <a:srgbClr val="1A1A1A"/>
-                </a:solidFill>
-                <a:latin typeface="Meiryo" pitchFamily="34" charset="0"/>
-                <a:ea typeface="Meiryo" pitchFamily="34" charset="-122"/>
-                <a:cs typeface="Meiryo" pitchFamily="34" charset="-120"/>
-              </a:rPr>
-              <a:t>TWIN</a:t>
-            </a:r>
-            <a:endParaRPr lang="en-US" sz="850" dirty="0"/>
-          </a:p>
-        </p:txBody>
-      </p:sp>
-      <p:sp>
-        <p:nvSpPr>
-          <p:cNvPr id="50" name="Text 47"/>
-          <p:cNvSpPr txBox="1"/>
-          <p:nvPr/>
-        </p:nvSpPr>
-        <p:spPr>
-          <a:xfrm>
-            <a:off x="1444752" y="3739896"/>
-            <a:ext cx="603504" cy="228600"/>
-          </a:xfrm>
-          <a:prstGeom prst="rect">
-            <a:avLst/>
-          </a:prstGeom>
-          <a:noFill/>
-          <a:ln/>
-        </p:spPr>
-        <p:txBody>
-          <a:bodyPr wrap="square" lIns="0" tIns="0" rIns="0" bIns="0" rtlCol="0" anchor="ctr"/>
-          <a:lstStyle/>
-          <a:p>
-            <a:pPr algn="l" indent="0" marL="0">
-              <a:lnSpc>
-                <a:spcPct val="115000"/>
-              </a:lnSpc>
-              <a:buNone/>
-            </a:pPr>
-            <a:r>
-              <a:rPr lang="en-US" sz="800" dirty="0">
-                <a:solidFill>
-                  <a:srgbClr val="4D4D4D"/>
-                </a:solidFill>
-                <a:latin typeface="Meiryo" pitchFamily="34" charset="0"/>
-                <a:ea typeface="Meiryo" pitchFamily="34" charset="-122"/>
-                <a:cs typeface="Meiryo" pitchFamily="34" charset="-120"/>
-              </a:rPr>
-              <a:t>3D</a:t>
-            </a:r>
-            <a:endParaRPr lang="en-US" sz="800" dirty="0"/>
-          </a:p>
-        </p:txBody>
-      </p:sp>
-      <p:sp>
-        <p:nvSpPr>
-          <p:cNvPr id="51" name="Text 48"/>
-          <p:cNvSpPr txBox="1"/>
-          <p:nvPr/>
-        </p:nvSpPr>
-        <p:spPr>
-          <a:xfrm>
-            <a:off x="2048256" y="3739896"/>
-            <a:ext cx="2468880" cy="228600"/>
-          </a:xfrm>
-          <a:prstGeom prst="rect">
-            <a:avLst/>
-          </a:prstGeom>
-          <a:noFill/>
-          <a:ln/>
-        </p:spPr>
-        <p:txBody>
-          <a:bodyPr wrap="square" lIns="0" tIns="0" rIns="0" bIns="0" rtlCol="0" anchor="ctr"/>
-          <a:lstStyle/>
-          <a:p>
-            <a:pPr algn="l" indent="0" marL="0">
-              <a:lnSpc>
-                <a:spcPct val="115000"/>
-              </a:lnSpc>
-              <a:buNone/>
-            </a:pPr>
-            <a:r>
-              <a:rPr lang="en-US" sz="800" dirty="0">
-                <a:solidFill>
-                  <a:srgbClr val="1A1A1A"/>
-                </a:solidFill>
-                <a:latin typeface="Meiryo" pitchFamily="34" charset="0"/>
-                <a:ea typeface="Meiryo" pitchFamily="34" charset="-122"/>
-                <a:cs typeface="Meiryo" pitchFamily="34" charset="-120"/>
-              </a:rPr>
-              <a:t>設備の内部構造・工場全体を3Dで再現</a:t>
-            </a:r>
-            <a:endParaRPr lang="en-US" sz="800" dirty="0"/>
-          </a:p>
-        </p:txBody>
-      </p:sp>
-      <p:sp>
-        <p:nvSpPr>
-          <p:cNvPr id="52" name="Text 49"/>
-          <p:cNvSpPr txBox="1"/>
-          <p:nvPr/>
-        </p:nvSpPr>
-        <p:spPr>
-          <a:xfrm>
-            <a:off x="4517136" y="3739896"/>
-            <a:ext cx="384048" cy="228600"/>
-          </a:xfrm>
-          <a:prstGeom prst="rect">
-            <a:avLst/>
-          </a:prstGeom>
-          <a:noFill/>
-          <a:ln/>
-        </p:spPr>
-        <p:txBody>
-          <a:bodyPr wrap="square" lIns="0" tIns="0" rIns="0" bIns="0" rtlCol="0" anchor="ctr"/>
-          <a:lstStyle/>
-          <a:p>
-            <a:pPr algn="r" indent="0" marL="0">
-              <a:lnSpc>
-                <a:spcPct val="115000"/>
-              </a:lnSpc>
-              <a:buNone/>
-            </a:pPr>
-            <a:r>
-              <a:rPr lang="en-US" sz="800" dirty="0">
-                <a:solidFill>
-                  <a:srgbClr val="1A1A1A"/>
-                </a:solidFill>
-                <a:latin typeface="Meiryo" pitchFamily="34" charset="0"/>
-                <a:ea typeface="Meiryo" pitchFamily="34" charset="-122"/>
-                <a:cs typeface="Meiryo" pitchFamily="34" charset="-120"/>
-              </a:rPr>
-              <a:t>製品</a:t>
-            </a:r>
-            <a:endParaRPr lang="en-US" sz="800" dirty="0"/>
-          </a:p>
-        </p:txBody>
-      </p:sp>
-      <p:sp>
-        <p:nvSpPr>
-          <p:cNvPr id="53" name="Shape 50"/>
-          <p:cNvSpPr/>
-          <p:nvPr/>
-        </p:nvSpPr>
-        <p:spPr>
-          <a:xfrm>
-            <a:off x="365760" y="3968496"/>
-            <a:ext cx="4572000" cy="0"/>
-          </a:xfrm>
-          <a:prstGeom prst="line">
-            <a:avLst/>
-          </a:prstGeom>
-          <a:noFill/>
-          <a:ln w="9525">
-            <a:solidFill>
-              <a:srgbClr val="BFBFBF"/>
-            </a:solidFill>
-            <a:prstDash val="solid"/>
-          </a:ln>
-        </p:spPr>
-      </p:sp>
-      <p:sp>
-        <p:nvSpPr>
-          <p:cNvPr id="54" name="Text 51"/>
-          <p:cNvSpPr txBox="1"/>
-          <p:nvPr/>
-        </p:nvSpPr>
-        <p:spPr>
-          <a:xfrm>
-            <a:off x="402336" y="3968496"/>
-            <a:ext cx="420624" cy="228600"/>
-          </a:xfrm>
-          <a:prstGeom prst="rect">
-            <a:avLst/>
-          </a:prstGeom>
-          <a:noFill/>
-          <a:ln/>
-        </p:spPr>
-        <p:txBody>
-          <a:bodyPr wrap="square" lIns="0" tIns="0" rIns="0" bIns="0" rtlCol="0" anchor="ctr"/>
-          <a:lstStyle/>
-          <a:p>
-            <a:pPr algn="l" indent="0" marL="0">
-              <a:lnSpc>
-                <a:spcPct val="115000"/>
-              </a:lnSpc>
-              <a:buNone/>
-            </a:pPr>
-            <a:r>
-              <a:rPr lang="en-US" sz="800" dirty="0">
-                <a:solidFill>
-                  <a:srgbClr val="4D4D4D"/>
-                </a:solidFill>
-                <a:latin typeface="Meiryo" pitchFamily="34" charset="0"/>
-                <a:ea typeface="Meiryo" pitchFamily="34" charset="-122"/>
-                <a:cs typeface="Meiryo" pitchFamily="34" charset="-120"/>
-              </a:rPr>
-              <a:t>5年目</a:t>
-            </a:r>
-            <a:endParaRPr lang="en-US" sz="800" dirty="0"/>
-          </a:p>
-        </p:txBody>
-      </p:sp>
-      <p:sp>
-        <p:nvSpPr>
-          <p:cNvPr id="55" name="Text 52"/>
-          <p:cNvSpPr txBox="1"/>
-          <p:nvPr/>
-        </p:nvSpPr>
-        <p:spPr>
-          <a:xfrm>
-            <a:off x="822960" y="3968496"/>
-            <a:ext cx="621792" cy="228600"/>
-          </a:xfrm>
-          <a:prstGeom prst="rect">
-            <a:avLst/>
-          </a:prstGeom>
-          <a:noFill/>
-          <a:ln/>
-        </p:spPr>
-        <p:txBody>
-          <a:bodyPr wrap="square" lIns="0" tIns="0" rIns="0" bIns="0" rtlCol="0" anchor="ctr"/>
-          <a:lstStyle/>
-          <a:p>
-            <a:pPr algn="l" indent="0" marL="0">
-              <a:lnSpc>
-                <a:spcPct val="115000"/>
-              </a:lnSpc>
-              <a:buNone/>
-            </a:pPr>
-            <a:r>
-              <a:rPr lang="en-US" sz="850" b="1" dirty="0">
-                <a:solidFill>
-                  <a:srgbClr val="1A1A1A"/>
-                </a:solidFill>
-                <a:latin typeface="Meiryo" pitchFamily="34" charset="0"/>
-                <a:ea typeface="Meiryo" pitchFamily="34" charset="-122"/>
-                <a:cs typeface="Meiryo" pitchFamily="34" charset="-120"/>
-              </a:rPr>
-              <a:t>DRAW</a:t>
-            </a:r>
-            <a:endParaRPr lang="en-US" sz="850" dirty="0"/>
-          </a:p>
-        </p:txBody>
-      </p:sp>
-      <p:sp>
-        <p:nvSpPr>
-          <p:cNvPr id="56" name="Text 53"/>
-          <p:cNvSpPr txBox="1"/>
-          <p:nvPr/>
-        </p:nvSpPr>
-        <p:spPr>
-          <a:xfrm>
-            <a:off x="1444752" y="3968496"/>
-            <a:ext cx="603504" cy="228600"/>
-          </a:xfrm>
-          <a:prstGeom prst="rect">
-            <a:avLst/>
-          </a:prstGeom>
-          <a:noFill/>
-          <a:ln/>
-        </p:spPr>
-        <p:txBody>
-          <a:bodyPr wrap="square" lIns="0" tIns="0" rIns="0" bIns="0" rtlCol="0" anchor="ctr"/>
-          <a:lstStyle/>
-          <a:p>
-            <a:pPr algn="l" indent="0" marL="0">
-              <a:lnSpc>
-                <a:spcPct val="115000"/>
-              </a:lnSpc>
-              <a:buNone/>
-            </a:pPr>
-            <a:r>
-              <a:rPr lang="en-US" sz="800" dirty="0">
-                <a:solidFill>
-                  <a:srgbClr val="4D4D4D"/>
-                </a:solidFill>
-                <a:latin typeface="Meiryo" pitchFamily="34" charset="0"/>
-                <a:ea typeface="Meiryo" pitchFamily="34" charset="-122"/>
-                <a:cs typeface="Meiryo" pitchFamily="34" charset="-120"/>
-              </a:rPr>
-              <a:t>図面</a:t>
-            </a:r>
-            <a:endParaRPr lang="en-US" sz="800" dirty="0"/>
-          </a:p>
-        </p:txBody>
-      </p:sp>
-      <p:sp>
-        <p:nvSpPr>
-          <p:cNvPr id="57" name="Text 54"/>
-          <p:cNvSpPr txBox="1"/>
-          <p:nvPr/>
-        </p:nvSpPr>
-        <p:spPr>
-          <a:xfrm>
-            <a:off x="2048256" y="3968496"/>
-            <a:ext cx="2468880" cy="228600"/>
-          </a:xfrm>
-          <a:prstGeom prst="rect">
-            <a:avLst/>
-          </a:prstGeom>
-          <a:noFill/>
-          <a:ln/>
-        </p:spPr>
-        <p:txBody>
-          <a:bodyPr wrap="square" lIns="0" tIns="0" rIns="0" bIns="0" rtlCol="0" anchor="ctr"/>
-          <a:lstStyle/>
-          <a:p>
-            <a:pPr algn="l" indent="0" marL="0">
-              <a:lnSpc>
-                <a:spcPct val="115000"/>
-              </a:lnSpc>
-              <a:buNone/>
-            </a:pPr>
-            <a:r>
-              <a:rPr lang="en-US" sz="800" dirty="0">
-                <a:solidFill>
-                  <a:srgbClr val="1A1A1A"/>
-                </a:solidFill>
-                <a:latin typeface="Meiryo" pitchFamily="34" charset="0"/>
-                <a:ea typeface="Meiryo" pitchFamily="34" charset="-122"/>
-                <a:cs typeface="Meiryo" pitchFamily="34" charset="-120"/>
-              </a:rPr>
-              <a:t>登録したパターンを音声指示でCAD作図</a:t>
-            </a:r>
-            <a:endParaRPr lang="en-US" sz="800" dirty="0"/>
-          </a:p>
-        </p:txBody>
-      </p:sp>
-      <p:sp>
-        <p:nvSpPr>
-          <p:cNvPr id="58" name="Text 55"/>
-          <p:cNvSpPr txBox="1"/>
-          <p:nvPr/>
-        </p:nvSpPr>
-        <p:spPr>
-          <a:xfrm>
-            <a:off x="4517136" y="3968496"/>
-            <a:ext cx="384048" cy="228600"/>
-          </a:xfrm>
-          <a:prstGeom prst="rect">
-            <a:avLst/>
-          </a:prstGeom>
-          <a:noFill/>
-          <a:ln/>
-        </p:spPr>
-        <p:txBody>
-          <a:bodyPr wrap="square" lIns="0" tIns="0" rIns="0" bIns="0" rtlCol="0" anchor="ctr"/>
-          <a:lstStyle/>
-          <a:p>
-            <a:pPr algn="r" indent="0" marL="0">
-              <a:lnSpc>
-                <a:spcPct val="115000"/>
-              </a:lnSpc>
-              <a:buNone/>
-            </a:pPr>
-            <a:r>
-              <a:rPr lang="en-US" sz="800" dirty="0">
-                <a:solidFill>
-                  <a:srgbClr val="1A1A1A"/>
-                </a:solidFill>
-                <a:latin typeface="Meiryo" pitchFamily="34" charset="0"/>
-                <a:ea typeface="Meiryo" pitchFamily="34" charset="-122"/>
-                <a:cs typeface="Meiryo" pitchFamily="34" charset="-120"/>
-              </a:rPr>
-              <a:t>製品</a:t>
-            </a:r>
-            <a:endParaRPr lang="en-US" sz="800" dirty="0"/>
-          </a:p>
-        </p:txBody>
-      </p:sp>
-      <p:sp>
-        <p:nvSpPr>
-          <p:cNvPr id="59" name="Shape 56"/>
-          <p:cNvSpPr/>
-          <p:nvPr/>
-        </p:nvSpPr>
-        <p:spPr>
-          <a:xfrm>
-            <a:off x="365760" y="4197096"/>
-            <a:ext cx="4572000" cy="228600"/>
+            <a:off x="5120640" y="3858768"/>
+            <a:ext cx="3657600" cy="530352"/>
           </a:xfrm>
           <a:prstGeom prst="rect">
             <a:avLst/>
@@ -7668,37 +7226,14 @@
       </p:sp>
       <p:sp>
         <p:nvSpPr>
-          <p:cNvPr id="60" name="Shape 57"/>
-          <p:cNvSpPr/>
-          <p:nvPr/>
-        </p:nvSpPr>
-        <p:spPr>
-          <a:xfrm>
-            <a:off x="365760" y="4197096"/>
-            <a:ext cx="4572000" cy="0"/>
-          </a:xfrm>
-          <a:prstGeom prst="line">
-            <a:avLst/>
-          </a:prstGeom>
-          <a:noFill/>
-          <a:ln w="9525">
-            <a:solidFill>
-              <a:srgbClr val="BFBFBF"/>
-            </a:solidFill>
-            <a:prstDash val="solid"/>
-          </a:ln>
-        </p:spPr>
-      </p:sp>
-      <p:sp>
-        <p:nvSpPr>
-          <p:cNvPr id="61" name="Text 58"/>
+          <p:cNvPr id="42" name="Text 39"/>
           <p:cNvSpPr txBox="1"/>
           <p:nvPr/>
         </p:nvSpPr>
         <p:spPr>
           <a:xfrm>
-            <a:off x="402336" y="4197096"/>
-            <a:ext cx="420624" cy="228600"/>
+            <a:off x="5230368" y="3858768"/>
+            <a:ext cx="3438144" cy="530352"/>
           </a:xfrm>
           <a:prstGeom prst="rect">
             <a:avLst/>
@@ -7717,574 +7252,43 @@
               <a:buNone/>
             </a:pPr>
             <a:r>
-              <a:rPr lang="en-US" sz="800" dirty="0">
-                <a:solidFill>
-                  <a:srgbClr val="4D4D4D"/>
-                </a:solidFill>
-                <a:latin typeface="Meiryo" pitchFamily="34" charset="0"/>
-                <a:ea typeface="Meiryo" pitchFamily="34" charset="-122"/>
-                <a:cs typeface="Meiryo" pitchFamily="34" charset="-120"/>
-              </a:rPr>
-              <a:t>研究</a:t>
-            </a:r>
-            <a:endParaRPr lang="en-US" sz="800" dirty="0"/>
+              <a:rPr lang="en-US" sz="950" b="1" dirty="0">
+                <a:solidFill>
+                  <a:srgbClr val="1A1A1A"/>
+                </a:solidFill>
+                <a:latin typeface="Meiryo" pitchFamily="34" charset="0"/>
+                <a:ea typeface="Meiryo" pitchFamily="34" charset="-122"/>
+                <a:cs typeface="Meiryo" pitchFamily="34" charset="-120"/>
+              </a:rPr>
+              <a:t>道具以外：導入支援（初年度・約2か月）</a:t>
+            </a:r>
+            <a:endParaRPr lang="en-US" sz="850" dirty="0"/>
+          </a:p>
+          <a:p>
+            <a:pPr algn="l" indent="0" marL="0">
+              <a:lnSpc>
+                <a:spcPct val="115000"/>
+              </a:lnSpc>
+              <a:buNone/>
+            </a:pPr>
+            <a:r>
+              <a:rPr lang="en-US" sz="850" dirty="0">
+                <a:solidFill>
+                  <a:srgbClr val="1A1A1A"/>
+                </a:solidFill>
+                <a:latin typeface="Meiryo" pitchFamily="34" charset="0"/>
+                <a:ea typeface="Meiryo" pitchFamily="34" charset="-122"/>
+                <a:cs typeface="Meiryo" pitchFamily="34" charset="-120"/>
+              </a:rPr>
+              <a:t>当社の担当者が現場に入り、聞き取り・帳票の移行・研修まで行う</a:t>
+            </a:r>
+            <a:endParaRPr lang="en-US" sz="850" dirty="0"/>
           </a:p>
         </p:txBody>
       </p:sp>
       <p:sp>
         <p:nvSpPr>
-          <p:cNvPr id="62" name="Text 59"/>
-          <p:cNvSpPr txBox="1"/>
-          <p:nvPr/>
-        </p:nvSpPr>
-        <p:spPr>
-          <a:xfrm>
-            <a:off x="822960" y="4197096"/>
-            <a:ext cx="621792" cy="228600"/>
-          </a:xfrm>
-          <a:prstGeom prst="rect">
-            <a:avLst/>
-          </a:prstGeom>
-          <a:noFill/>
-          <a:ln/>
-        </p:spPr>
-        <p:txBody>
-          <a:bodyPr wrap="square" lIns="0" tIns="0" rIns="0" bIns="0" rtlCol="0" anchor="ctr"/>
-          <a:lstStyle/>
-          <a:p>
-            <a:pPr algn="l" indent="0" marL="0">
-              <a:lnSpc>
-                <a:spcPct val="115000"/>
-              </a:lnSpc>
-              <a:buNone/>
-            </a:pPr>
-            <a:r>
-              <a:rPr lang="en-US" sz="850" b="1" dirty="0">
-                <a:solidFill>
-                  <a:srgbClr val="1A1A1A"/>
-                </a:solidFill>
-                <a:latin typeface="Meiryo" pitchFamily="34" charset="0"/>
-                <a:ea typeface="Meiryo" pitchFamily="34" charset="-122"/>
-                <a:cs typeface="Meiryo" pitchFamily="34" charset="-120"/>
-              </a:rPr>
-              <a:t>HAPTIC</a:t>
-            </a:r>
-            <a:endParaRPr lang="en-US" sz="850" dirty="0"/>
-          </a:p>
-        </p:txBody>
-      </p:sp>
-      <p:sp>
-        <p:nvSpPr>
-          <p:cNvPr id="63" name="Text 60"/>
-          <p:cNvSpPr txBox="1"/>
-          <p:nvPr/>
-        </p:nvSpPr>
-        <p:spPr>
-          <a:xfrm>
-            <a:off x="1444752" y="4197096"/>
-            <a:ext cx="603504" cy="228600"/>
-          </a:xfrm>
-          <a:prstGeom prst="rect">
-            <a:avLst/>
-          </a:prstGeom>
-          <a:noFill/>
-          <a:ln/>
-        </p:spPr>
-        <p:txBody>
-          <a:bodyPr wrap="square" lIns="0" tIns="0" rIns="0" bIns="0" rtlCol="0" anchor="ctr"/>
-          <a:lstStyle/>
-          <a:p>
-            <a:pPr algn="l" indent="0" marL="0">
-              <a:lnSpc>
-                <a:spcPct val="115000"/>
-              </a:lnSpc>
-              <a:buNone/>
-            </a:pPr>
-            <a:r>
-              <a:rPr lang="en-US" sz="800" dirty="0">
-                <a:solidFill>
-                  <a:srgbClr val="4D4D4D"/>
-                </a:solidFill>
-                <a:latin typeface="Meiryo" pitchFamily="34" charset="0"/>
-                <a:ea typeface="Meiryo" pitchFamily="34" charset="-122"/>
-                <a:cs typeface="Meiryo" pitchFamily="34" charset="-120"/>
-              </a:rPr>
-              <a:t>触覚・機械</a:t>
-            </a:r>
-            <a:endParaRPr lang="en-US" sz="800" dirty="0"/>
-          </a:p>
-        </p:txBody>
-      </p:sp>
-      <p:sp>
-        <p:nvSpPr>
-          <p:cNvPr id="64" name="Text 61"/>
-          <p:cNvSpPr txBox="1"/>
-          <p:nvPr/>
-        </p:nvSpPr>
-        <p:spPr>
-          <a:xfrm>
-            <a:off x="2048256" y="4197096"/>
-            <a:ext cx="2468880" cy="228600"/>
-          </a:xfrm>
-          <a:prstGeom prst="rect">
-            <a:avLst/>
-          </a:prstGeom>
-          <a:noFill/>
-          <a:ln/>
-        </p:spPr>
-        <p:txBody>
-          <a:bodyPr wrap="square" lIns="0" tIns="0" rIns="0" bIns="0" rtlCol="0" anchor="ctr"/>
-          <a:lstStyle/>
-          <a:p>
-            <a:pPr algn="l" indent="0" marL="0">
-              <a:lnSpc>
-                <a:spcPct val="115000"/>
-              </a:lnSpc>
-              <a:buNone/>
-            </a:pPr>
-            <a:r>
-              <a:rPr lang="en-US" sz="800" dirty="0">
-                <a:solidFill>
-                  <a:srgbClr val="1A1A1A"/>
-                </a:solidFill>
-                <a:latin typeface="Meiryo" pitchFamily="34" charset="0"/>
-                <a:ea typeface="Meiryo" pitchFamily="34" charset="-122"/>
-                <a:cs typeface="Meiryo" pitchFamily="34" charset="-120"/>
-              </a:rPr>
-              <a:t>力加減の訓練シミュレーター／ロボット連携</a:t>
-            </a:r>
-            <a:endParaRPr lang="en-US" sz="800" dirty="0"/>
-          </a:p>
-        </p:txBody>
-      </p:sp>
-      <p:sp>
-        <p:nvSpPr>
-          <p:cNvPr id="65" name="Text 62"/>
-          <p:cNvSpPr txBox="1"/>
-          <p:nvPr/>
-        </p:nvSpPr>
-        <p:spPr>
-          <a:xfrm>
-            <a:off x="4517136" y="4197096"/>
-            <a:ext cx="384048" cy="228600"/>
-          </a:xfrm>
-          <a:prstGeom prst="rect">
-            <a:avLst/>
-          </a:prstGeom>
-          <a:noFill/>
-          <a:ln/>
-        </p:spPr>
-        <p:txBody>
-          <a:bodyPr wrap="square" lIns="0" tIns="0" rIns="0" bIns="0" rtlCol="0" anchor="ctr"/>
-          <a:lstStyle/>
-          <a:p>
-            <a:pPr algn="r" indent="0" marL="0">
-              <a:lnSpc>
-                <a:spcPct val="115000"/>
-              </a:lnSpc>
-              <a:buNone/>
-            </a:pPr>
-            <a:r>
-              <a:rPr lang="en-US" sz="800" b="1" dirty="0">
-                <a:solidFill>
-                  <a:srgbClr val="1A1A1A"/>
-                </a:solidFill>
-                <a:latin typeface="Meiryo" pitchFamily="34" charset="0"/>
-                <a:ea typeface="Meiryo" pitchFamily="34" charset="-122"/>
-                <a:cs typeface="Meiryo" pitchFamily="34" charset="-120"/>
-              </a:rPr>
-              <a:t>R&amp;D</a:t>
-            </a:r>
-            <a:endParaRPr lang="en-US" sz="800" dirty="0"/>
-          </a:p>
-        </p:txBody>
-      </p:sp>
-      <p:sp>
-        <p:nvSpPr>
-          <p:cNvPr id="66" name="Shape 63"/>
-          <p:cNvSpPr/>
-          <p:nvPr/>
-        </p:nvSpPr>
-        <p:spPr>
-          <a:xfrm>
-            <a:off x="365760" y="4425696"/>
-            <a:ext cx="4572000" cy="0"/>
-          </a:xfrm>
-          <a:prstGeom prst="line">
-            <a:avLst/>
-          </a:prstGeom>
-          <a:noFill/>
-          <a:ln w="9525">
-            <a:solidFill>
-              <a:srgbClr val="BFBFBF"/>
-            </a:solidFill>
-            <a:prstDash val="solid"/>
-          </a:ln>
-        </p:spPr>
-      </p:sp>
-      <p:sp>
-        <p:nvSpPr>
-          <p:cNvPr id="67" name="rnd"/>
-          <p:cNvSpPr/>
-          <p:nvPr/>
-        </p:nvSpPr>
-        <p:spPr>
-          <a:xfrm>
-            <a:off x="5120640" y="2578608"/>
-            <a:ext cx="3657600" cy="1207008"/>
-          </a:xfrm>
-          <a:prstGeom prst="rect">
-            <a:avLst/>
-          </a:prstGeom>
-          <a:solidFill>
-            <a:srgbClr val="1A1A1A"/>
-          </a:solidFill>
-          <a:ln/>
-        </p:spPr>
-      </p:sp>
-      <p:sp>
-        <p:nvSpPr>
-          <p:cNvPr id="68" name="Text 65"/>
-          <p:cNvSpPr txBox="1"/>
-          <p:nvPr/>
-        </p:nvSpPr>
-        <p:spPr>
-          <a:xfrm>
-            <a:off x="5230368" y="2624328"/>
-            <a:ext cx="3438144" cy="237744"/>
-          </a:xfrm>
-          <a:prstGeom prst="rect">
-            <a:avLst/>
-          </a:prstGeom>
-          <a:noFill/>
-          <a:ln/>
-        </p:spPr>
-        <p:txBody>
-          <a:bodyPr wrap="square" lIns="0" tIns="0" rIns="0" bIns="0" rtlCol="0" anchor="t"/>
-          <a:lstStyle/>
-          <a:p>
-            <a:pPr algn="l" indent="0" marL="0">
-              <a:lnSpc>
-                <a:spcPct val="115000"/>
-              </a:lnSpc>
-              <a:buNone/>
-            </a:pPr>
-            <a:r>
-              <a:rPr lang="en-US" sz="1050" b="1" dirty="0">
-                <a:solidFill>
-                  <a:srgbClr val="FFFFFF"/>
-                </a:solidFill>
-                <a:latin typeface="Meiryo" pitchFamily="34" charset="0"/>
-                <a:ea typeface="Meiryo" pitchFamily="34" charset="-122"/>
-                <a:cs typeface="Meiryo" pitchFamily="34" charset="-120"/>
-              </a:rPr>
-              <a:t>R&amp;D戦略（技術開発）</a:t>
-            </a:r>
-            <a:endParaRPr lang="en-US" sz="1050" dirty="0"/>
-          </a:p>
-        </p:txBody>
-      </p:sp>
-      <p:sp>
-        <p:nvSpPr>
-          <p:cNvPr id="69" name="Text 66"/>
-          <p:cNvSpPr txBox="1"/>
-          <p:nvPr/>
-        </p:nvSpPr>
-        <p:spPr>
-          <a:xfrm>
-            <a:off x="5230368" y="2871216"/>
-            <a:ext cx="3438144" cy="896112"/>
-          </a:xfrm>
-          <a:prstGeom prst="rect">
-            <a:avLst/>
-          </a:prstGeom>
-          <a:noFill/>
-          <a:ln/>
-        </p:spPr>
-        <p:txBody>
-          <a:bodyPr wrap="square" lIns="0" tIns="0" rIns="0" bIns="0" rtlCol="0" anchor="t"/>
-          <a:lstStyle/>
-          <a:p>
-            <a:pPr algn="l" indent="0" marL="0">
-              <a:lnSpc>
-                <a:spcPct val="115000"/>
-              </a:lnSpc>
-              <a:spcAft>
-                <a:spcPts val="100"/>
-              </a:spcAft>
-              <a:buNone/>
-            </a:pPr>
-            <a:r>
-              <a:rPr lang="en-US" sz="850" b="1" dirty="0">
-                <a:solidFill>
-                  <a:srgbClr val="FFFFFF"/>
-                </a:solidFill>
-                <a:latin typeface="Meiryo" pitchFamily="34" charset="0"/>
-                <a:ea typeface="Meiryo" pitchFamily="34" charset="-122"/>
-                <a:cs typeface="Meiryo" pitchFamily="34" charset="-120"/>
-              </a:rPr>
-              <a:t>作らない：</a:t>
-            </a:r>
-            <a:pPr algn="l" indent="0" marL="0">
-              <a:lnSpc>
-                <a:spcPct val="115000"/>
-              </a:lnSpc>
-              <a:spcAft>
-                <a:spcPts val="100"/>
-              </a:spcAft>
-              <a:buNone/>
-            </a:pPr>
-            <a:r>
-              <a:rPr lang="en-US" sz="850" dirty="0">
-                <a:solidFill>
-                  <a:srgbClr val="FFFFFF"/>
-                </a:solidFill>
-                <a:latin typeface="Meiryo" pitchFamily="34" charset="0"/>
-                <a:ea typeface="Meiryo" pitchFamily="34" charset="-122"/>
-                <a:cs typeface="Meiryo" pitchFamily="34" charset="-120"/>
-              </a:rPr>
-              <a:t>音声記録・AI構造化は汎用技術。自前開発は最小限</a:t>
-            </a:r>
-            <a:endParaRPr lang="en-US" sz="850" dirty="0"/>
-          </a:p>
-          <a:p>
-            <a:pPr algn="l" indent="0" marL="0">
-              <a:lnSpc>
-                <a:spcPct val="115000"/>
-              </a:lnSpc>
-              <a:spcAft>
-                <a:spcPts val="100"/>
-              </a:spcAft>
-              <a:buNone/>
-            </a:pPr>
-            <a:r>
-              <a:rPr lang="en-US" sz="850" b="1" dirty="0">
-                <a:solidFill>
-                  <a:srgbClr val="FFFFFF"/>
-                </a:solidFill>
-                <a:latin typeface="Meiryo" pitchFamily="34" charset="0"/>
-                <a:ea typeface="Meiryo" pitchFamily="34" charset="-122"/>
-                <a:cs typeface="Meiryo" pitchFamily="34" charset="-120"/>
-              </a:rPr>
-              <a:t>作る：</a:t>
-            </a:r>
-            <a:pPr algn="l" indent="0" marL="0">
-              <a:lnSpc>
-                <a:spcPct val="115000"/>
-              </a:lnSpc>
-              <a:spcAft>
-                <a:spcPts val="100"/>
-              </a:spcAft>
-              <a:buNone/>
-            </a:pPr>
-            <a:r>
-              <a:rPr lang="en-US" sz="850" dirty="0">
-                <a:solidFill>
-                  <a:srgbClr val="FFFFFF"/>
-                </a:solidFill>
-                <a:latin typeface="Meiryo" pitchFamily="34" charset="0"/>
-                <a:ea typeface="Meiryo" pitchFamily="34" charset="-122"/>
-                <a:cs typeface="Meiryo" pitchFamily="34" charset="-120"/>
-              </a:rPr>
-              <a:t>連続工程の工程データとの紐づけ、教材化の手順</a:t>
-            </a:r>
-            <a:endParaRPr lang="en-US" sz="850" dirty="0"/>
-          </a:p>
-          <a:p>
-            <a:pPr algn="l" indent="0" marL="0">
-              <a:lnSpc>
-                <a:spcPct val="115000"/>
-              </a:lnSpc>
-              <a:spcAft>
-                <a:spcPts val="100"/>
-              </a:spcAft>
-              <a:buNone/>
-            </a:pPr>
-            <a:r>
-              <a:rPr lang="en-US" sz="850" b="1" dirty="0">
-                <a:solidFill>
-                  <a:srgbClr val="FFFFFF"/>
-                </a:solidFill>
-                <a:latin typeface="Meiryo" pitchFamily="34" charset="0"/>
-                <a:ea typeface="Meiryo" pitchFamily="34" charset="-122"/>
-                <a:cs typeface="Meiryo" pitchFamily="34" charset="-120"/>
-              </a:rPr>
-              <a:t>組む：</a:t>
-            </a:r>
-            <a:pPr algn="l" indent="0" marL="0">
-              <a:lnSpc>
-                <a:spcPct val="115000"/>
-              </a:lnSpc>
-              <a:spcAft>
-                <a:spcPts val="100"/>
-              </a:spcAft>
-              <a:buNone/>
-            </a:pPr>
-            <a:r>
-              <a:rPr lang="en-US" sz="850" dirty="0">
-                <a:solidFill>
-                  <a:srgbClr val="FFFFFF"/>
-                </a:solidFill>
-                <a:latin typeface="Meiryo" pitchFamily="34" charset="0"/>
-                <a:ea typeface="Meiryo" pitchFamily="34" charset="-122"/>
-                <a:cs typeface="Meiryo" pitchFamily="34" charset="-120"/>
-              </a:rPr>
-              <a:t>スマートグラス端末・CAD・3D・触覚はメーカー・大学と</a:t>
-            </a:r>
-            <a:endParaRPr lang="en-US" sz="850" dirty="0"/>
-          </a:p>
-          <a:p>
-            <a:pPr algn="l" indent="0" marL="0">
-              <a:lnSpc>
-                <a:spcPct val="115000"/>
-              </a:lnSpc>
-              <a:spcAft>
-                <a:spcPts val="100"/>
-              </a:spcAft>
-              <a:buNone/>
-            </a:pPr>
-            <a:r>
-              <a:rPr lang="en-US" sz="850" b="1" dirty="0">
-                <a:solidFill>
-                  <a:srgbClr val="FFFFFF"/>
-                </a:solidFill>
-                <a:latin typeface="Meiryo" pitchFamily="34" charset="0"/>
-                <a:ea typeface="Meiryo" pitchFamily="34" charset="-122"/>
-                <a:cs typeface="Meiryo" pitchFamily="34" charset="-120"/>
-              </a:rPr>
-              <a:t>試作済み：</a:t>
-            </a:r>
-            <a:pPr algn="l" indent="0" marL="0">
-              <a:lnSpc>
-                <a:spcPct val="115000"/>
-              </a:lnSpc>
-              <a:spcAft>
-                <a:spcPts val="100"/>
-              </a:spcAft>
-              <a:buNone/>
-            </a:pPr>
-            <a:r>
-              <a:rPr lang="en-US" sz="850" dirty="0">
-                <a:solidFill>
-                  <a:srgbClr val="FFFFFF"/>
-                </a:solidFill>
-                <a:latin typeface="Meiryo" pitchFamily="34" charset="0"/>
-                <a:ea typeface="Meiryo" pitchFamily="34" charset="-122"/>
-                <a:cs typeface="Meiryo" pitchFamily="34" charset="-120"/>
-              </a:rPr>
-              <a:t>ニュース要約→音声合成→ポッドキャスト自動配信を個人で実装</a:t>
-            </a:r>
-            <a:endParaRPr lang="en-US" sz="850" dirty="0"/>
-          </a:p>
-        </p:txBody>
-      </p:sp>
-      <p:sp>
-        <p:nvSpPr>
-          <p:cNvPr id="70" name="onboarding"/>
-          <p:cNvSpPr/>
-          <p:nvPr/>
-        </p:nvSpPr>
-        <p:spPr>
-          <a:xfrm>
-            <a:off x="5120640" y="3877056"/>
-            <a:ext cx="3657600" cy="658368"/>
-          </a:xfrm>
-          <a:prstGeom prst="rect">
-            <a:avLst/>
-          </a:prstGeom>
-          <a:solidFill>
-            <a:srgbClr val="F2F2F2"/>
-          </a:solidFill>
-          <a:ln/>
-        </p:spPr>
-      </p:sp>
-      <p:sp>
-        <p:nvSpPr>
-          <p:cNvPr id="71" name="Text 68"/>
-          <p:cNvSpPr txBox="1"/>
-          <p:nvPr/>
-        </p:nvSpPr>
-        <p:spPr>
-          <a:xfrm>
-            <a:off x="5230368" y="3913632"/>
-            <a:ext cx="3438144" cy="237744"/>
-          </a:xfrm>
-          <a:prstGeom prst="rect">
-            <a:avLst/>
-          </a:prstGeom>
-          <a:noFill/>
-          <a:ln/>
-        </p:spPr>
-        <p:txBody>
-          <a:bodyPr wrap="square" lIns="0" tIns="0" rIns="0" bIns="0" rtlCol="0" anchor="t"/>
-          <a:lstStyle/>
-          <a:p>
-            <a:pPr algn="l" indent="0" marL="0">
-              <a:lnSpc>
-                <a:spcPct val="115000"/>
-              </a:lnSpc>
-              <a:buNone/>
-            </a:pPr>
-            <a:r>
-              <a:rPr lang="en-US" sz="1000" b="1" dirty="0">
-                <a:solidFill>
-                  <a:srgbClr val="1A1A1A"/>
-                </a:solidFill>
-                <a:latin typeface="Meiryo" pitchFamily="34" charset="0"/>
-                <a:ea typeface="Meiryo" pitchFamily="34" charset="-122"/>
-                <a:cs typeface="Meiryo" pitchFamily="34" charset="-120"/>
-              </a:rPr>
-              <a:t>道具以外：導入支援（初年度・約2か月）</a:t>
-            </a:r>
-            <a:endParaRPr lang="en-US" sz="1000" dirty="0"/>
-          </a:p>
-        </p:txBody>
-      </p:sp>
-      <p:sp>
-        <p:nvSpPr>
-          <p:cNvPr id="72" name="Text 69"/>
-          <p:cNvSpPr txBox="1"/>
-          <p:nvPr/>
-        </p:nvSpPr>
-        <p:spPr>
-          <a:xfrm>
-            <a:off x="5230368" y="4151376"/>
-            <a:ext cx="3438144" cy="365760"/>
-          </a:xfrm>
-          <a:prstGeom prst="rect">
-            <a:avLst/>
-          </a:prstGeom>
-          <a:noFill/>
-          <a:ln/>
-        </p:spPr>
-        <p:txBody>
-          <a:bodyPr wrap="square" lIns="0" tIns="0" rIns="0" bIns="0" rtlCol="0" anchor="t"/>
-          <a:lstStyle/>
-          <a:p>
-            <a:pPr algn="l" indent="0" marL="0">
-              <a:lnSpc>
-                <a:spcPct val="115000"/>
-              </a:lnSpc>
-              <a:buNone/>
-            </a:pPr>
-            <a:r>
-              <a:rPr lang="en-US" sz="850" dirty="0">
-                <a:solidFill>
-                  <a:srgbClr val="1A1A1A"/>
-                </a:solidFill>
-                <a:latin typeface="Meiryo" pitchFamily="34" charset="0"/>
-                <a:ea typeface="Meiryo" pitchFamily="34" charset="-122"/>
-                <a:cs typeface="Meiryo" pitchFamily="34" charset="-120"/>
-              </a:rPr>
-              <a:t>当社の担当者が現場に入り、熟練者への聞き取り・帳票の移行・現場研修まで行う</a:t>
-            </a:r>
-            <a:endParaRPr lang="en-US" sz="850" dirty="0"/>
-          </a:p>
-        </p:txBody>
-      </p:sp>
-      <p:sp>
-        <p:nvSpPr>
-          <p:cNvPr id="73" name="Text 70"/>
+          <p:cNvPr id="43" name="Text 40"/>
           <p:cNvSpPr txBox="1"/>
           <p:nvPr/>
         </p:nvSpPr>

</xml_diff>

<commit_message>
Rename the company to KANTSUGI (カンツギ／勘継) with a kintsugi-seam logo
- build_kantsugi_logo.js: AR viewfinder cube with a copper kintsugi seam, color/mono/reverse and tagline lockups
- Decks, Q&A, scripts and demo renamed from 三現ワークス / GEN³ Works; files renamed to カンツギ_事業計画書_*
- Self-management deck rebuilt with the new name and logo

Co-Authored-By: Claude Opus 5.5 <noreply@anthropic.com>
Claude-Session: https://claude.ai/code/session_01Lvjvqoc8h4yHt4F4M6n1V9
</commit_message>
<xml_diff>
--- a/deck/セルフマネジメント課題_事業構想プレゼン.pptx
+++ b/deck/セルフマネジメント課題_事業構想プレゼン.pptx
@@ -2046,7 +2046,7 @@
               <a:rPr lang="en-US" dirty="0"/>
               <a:t>【0:00 - 0:50】
 要約：人が減っても現場が迷わず回る仕組みをつくり、日本の品質を支える現場の勘を遺産として残す（設問③）
-株式会社三現ワークスの事業構想を発表します。三現とは、現場・現物・現実のことです。メイド・イン・ジャパンの品質を支えてきたのは、現場の熟練者の勘です。その勘は、記録に残らないまま、退職とともに失われつつあります。この会社の存在意義は「現場の勘を、次の担い手へ。」です。使命は、熟練者の勘を言葉にし、教材と仕組みで次の人へ渡すこと。5年後には85の拠点で、勘どころが教材として残っている状態を目指します。今年7月に閣議決定された国の人工知能基本計画も、暗黙知が豊富な現場へのAIの実装を推進すると明記しています。この会社は、その現場の側に立ちます。</a:t>
+株式会社カンツギの事業構想を発表します。カンツギは「勘を継ぐ」。金継ぎのように、途切れそうな現場の勘をデータで継ぎます。メイド・イン・ジャパンの品質を支えてきたのは、現場の熟練者の勘です。その勘は、記録に残らないまま、退職とともに失われつつあります。この会社の存在意義は「現場の勘を、次の担い手へ。」です。使命は、熟練者の勘を言葉にし、教材と仕組みで次の人へ渡すこと。5年後には85の拠点で、勘どころが教材として残っている状態を目指します。今年7月に閣議決定された国の人工知能基本計画も、暗黙知が豊富な現場へのAIの実装を推進すると明記しています。この会社は、その現場の側に立ちます。</a:t>
             </a:r>
             <a:endParaRPr lang="en-US" dirty="0"/>
           </a:p>
@@ -3460,7 +3460,7 @@
                 <a:ea typeface="Meiryo" pitchFamily="34" charset="-122"/>
                 <a:cs typeface="Meiryo" pitchFamily="34" charset="-120"/>
               </a:rPr>
-              <a:t>株式会社三現ワークス（事業構想）</a:t>
+              <a:t>株式会社カンツギ（事業構想）</a:t>
             </a:r>
             <a:endParaRPr lang="en-US" sz="1100" dirty="0"/>
           </a:p>
@@ -3502,7 +3502,7 @@
                 <a:ea typeface="Meiryo" pitchFamily="34" charset="-122"/>
                 <a:cs typeface="Meiryo" pitchFamily="34" charset="-120"/>
               </a:rPr>
-              <a:t>三現＝現場・現物・現実</a:t>
+              <a:t>勘継＝金継ぎのように現場の勘を継ぐ</a:t>
             </a:r>
             <a:endParaRPr lang="en-US" sz="950" dirty="0"/>
           </a:p>
@@ -9770,7 +9770,7 @@
       </p:sp>
       <p:sp>
         <p:nvSpPr>
-          <p:cNvPr id="23" name="pos-三現ワークス"/>
+          <p:cNvPr id="23" name="pos-カンツギ"/>
           <p:cNvSpPr/>
           <p:nvPr/>
         </p:nvSpPr>
@@ -9829,7 +9829,7 @@
                 <a:ea typeface="Meiryo" pitchFamily="34" charset="-122"/>
                 <a:cs typeface="Meiryo" pitchFamily="34" charset="-120"/>
               </a:rPr>
-              <a:t>三現ワークス</a:t>
+              <a:t>カンツギ</a:t>
             </a:r>
             <a:endParaRPr lang="en-US" sz="1000" dirty="0"/>
           </a:p>
@@ -11471,7 +11471,7 @@
                           <a:ea typeface="Meiryo" pitchFamily="34" charset="-122"/>
                           <a:cs typeface="Meiryo" pitchFamily="34" charset="-120"/>
                         </a:rPr>
-                        <a:t>三現ワークス</a:t>
+                        <a:t>カンツギ</a:t>
                       </a:r>
                       <a:endParaRPr lang="en-US" sz="800" dirty="0">
                         <a:latin typeface="Meiryo" charset="0"/>

</xml_diff>